<commit_message>
Add CLICX logo to top right of all slides
Co-Authored-By: Claude Opus 5.5 <noreply@anthropic.com>
Claude-Session: https://claude.ai/code/session_01PMn7aLX79upLSj9P26uPyP
</commit_message>
<xml_diff>
--- a/clicx_insights/CLICX_Customer_Insights.pptx
+++ b/clicx_insights/CLICX_Customer_Insights.pptx
@@ -118,42 +118,42 @@
   <p:extLst>
     <p:ext uri="{521415D9-36F7-43E2-AB2F-B90AF26B5E84}">
       <p14:sectionLst xmlns:p14="http://schemas.microsoft.com/office/powerpoint/2010/main">
-        <p14:section name="Opening" id="{9cba2449-68dd-7d54-d4ef-943e38f3fd1e}">
+        <p14:section name="Opening" id="{1d25efcd-67c2-ad1c-a948-85ec9b711072}">
           <p14:sldIdLst>
             <p14:sldId id="256"/>
             <p14:sldId id="257"/>
           </p14:sldIdLst>
         </p14:section>
-        <p14:section name="Q1 Source of customers" id="{02daa7b8-8aa4-afa5-6308-9e9b823bcc7d}">
+        <p14:section name="Q1 Source of customers" id="{8c3b2144-8936-1741-a0dd-b7635fd5c25e}">
           <p14:sldIdLst>
             <p14:sldId id="258"/>
           </p14:sldIdLst>
         </p14:section>
-        <p14:section name="Q2 Personas vs plan" id="{a7d53e06-32e7-0ab3-3137-041910750813}">
+        <p14:section name="Q2 Personas vs plan" id="{06d3f926-8902-f163-d56c-2fc5d9f97ccf}">
           <p14:sldIdLst>
             <p14:sldId id="259"/>
             <p14:sldId id="260"/>
             <p14:sldId id="261"/>
           </p14:sldIdLst>
         </p14:section>
-        <p14:section name="Q3 Persona x product" id="{c8becdb7-ef7d-aaa9-ebcc-e22ffd12572d}">
+        <p14:section name="Q3 Persona x product" id="{ee005ade-b9a5-4b78-68c6-9e03a6b0c1e1}">
           <p14:sldIdLst>
             <p14:sldId id="262"/>
           </p14:sldIdLst>
         </p14:section>
-        <p14:section name="Q4 Active vs inactive" id="{ec32e897-7734-817a-11c2-71f753b57496}">
+        <p14:section name="Q4 Active vs inactive" id="{7e54bc5c-6d20-b780-8e09-a58a634914c6}">
           <p14:sldIdLst>
             <p14:sldId id="263"/>
             <p14:sldId id="264"/>
           </p14:sldIdLst>
         </p14:section>
-        <p14:section name="Q5 KTB cannibalization" id="{fbd3f12f-169d-facd-ba4e-7d43d43ddff2}">
+        <p14:section name="Q5 KTB cannibalization" id="{d3046aa7-1210-5689-775a-a7611817bdf6}">
           <p14:sldIdLst>
             <p14:sldId id="265"/>
             <p14:sldId id="266"/>
           </p14:sldIdLst>
         </p14:section>
-        <p14:section name="Implications" id="{0e192905-2cd0-fc4d-0dbc-4bfea37936f5}">
+        <p14:section name="Implications" id="{cde45141-5d06-b24b-5e6f-5d19835a068b}">
           <p14:sldIdLst>
             <p14:sldId id="267"/>
           </p14:sldIdLst>
@@ -8549,6 +8549,30 @@
           </a:p>
         </p:txBody>
       </p:sp>
+      <p:pic>
+        <p:nvPicPr>
+          <p:cNvPr id="6" name="Image 0" descr="CLICX logo">    </p:cNvPr>
+          <p:cNvPicPr>
+            <a:picLocks noChangeAspect="1"/>
+          </p:cNvPicPr>
+          <p:nvPr/>
+        </p:nvPicPr>
+        <p:blipFill>
+          <a:blip r:embed="rId1"/>
+          <a:stretch>
+            <a:fillRect/>
+          </a:stretch>
+        </p:blipFill>
+        <p:spPr>
+          <a:xfrm>
+            <a:off x="10177272" y="457200"/>
+            <a:ext cx="1554480" cy="389534"/>
+          </a:xfrm>
+          <a:prstGeom prst="rect">
+            <a:avLst/>
+          </a:prstGeom>
+        </p:spPr>
+      </p:pic>
     </p:spTree>
   </p:cSld>
   <p:clrMapOvr>
@@ -8737,42 +8761,30 @@
           </a:p>
         </p:txBody>
       </p:sp>
-      <p:sp>
-        <p:nvSpPr>
-          <p:cNvPr id="6" name="Text 0"/>
-          <p:cNvSpPr/>
+      <p:pic>
+        <p:nvPicPr>
+          <p:cNvPr id="6" name="Image 0" descr="CLICX logo">    </p:cNvPr>
+          <p:cNvPicPr>
+            <a:picLocks noChangeAspect="1"/>
+          </p:cNvPicPr>
           <p:nvPr/>
-        </p:nvSpPr>
-        <p:spPr>
-          <a:xfrm>
-            <a:off x="8503920" y="274320"/>
-            <a:ext cx="3227832" cy="274320"/>
+        </p:nvPicPr>
+        <p:blipFill>
+          <a:blip r:embed="rId1"/>
+          <a:stretch>
+            <a:fillRect/>
+          </a:stretch>
+        </p:blipFill>
+        <p:spPr>
+          <a:xfrm>
+            <a:off x="10634472" y="182880"/>
+            <a:ext cx="1097280" cy="274320"/>
           </a:xfrm>
           <a:prstGeom prst="rect">
             <a:avLst/>
           </a:prstGeom>
-          <a:noFill/>
-          <a:ln/>
-        </p:spPr>
-        <p:txBody>
-          <a:bodyPr wrap="square" lIns="0" tIns="0" rIns="0" bIns="0" rtlCol="0" anchor="ctr"/>
-          <a:lstStyle/>
-          <a:p>
-            <a:pPr algn="r" indent="0" marL="0">
-              <a:buNone/>
-            </a:pPr>
-            <a:r>
-              <a:rPr lang="en-US" sz="1000" dirty="0">
-                <a:solidFill>
-                  <a:srgbClr val="6E7C87"/>
-                </a:solidFill>
-              </a:rPr>
-              <a:t>CLICX customer insights</a:t>
-            </a:r>
-            <a:endParaRPr lang="en-US" sz="1000" dirty="0"/>
-          </a:p>
-        </p:txBody>
-      </p:sp>
+        </p:spPr>
+      </p:pic>
       <p:sp>
         <p:nvSpPr>
           <p:cNvPr id="25" name="Slide Number Placeholder 0"/>

</xml_diff>

<commit_message>
Plain-language rewrite and shorter footnotes for insights deck
Co-Authored-By: Claude Opus 5.5 <noreply@anthropic.com>
Claude-Session: https://claude.ai/code/session_01PMn7aLX79upLSj9P26uPyP
</commit_message>
<xml_diff>
--- a/clicx_insights/CLICX_Customer_Insights.pptx
+++ b/clicx_insights/CLICX_Customer_Insights.pptx
@@ -118,42 +118,42 @@
   <p:extLst>
     <p:ext uri="{521415D9-36F7-43E2-AB2F-B90AF26B5E84}">
       <p14:sectionLst xmlns:p14="http://schemas.microsoft.com/office/powerpoint/2010/main">
-        <p14:section name="Opening" id="{ecf9b345-b360-b76f-8308-5ebe9713e526}">
+        <p14:section name="Opening" id="{c5e80fb1-e75b-ec72-77c0-186d6ad0dd4c}">
           <p14:sldIdLst>
             <p14:sldId id="256"/>
             <p14:sldId id="257"/>
           </p14:sldIdLst>
         </p14:section>
-        <p14:section name="Q1 Source of customers" id="{1ddc115e-936f-fdf5-1582-32279bf8adc9}">
+        <p14:section name="Q1 Source of customers" id="{ec3e2830-c1a6-3cc9-bcc4-03b625baa6fa}">
           <p14:sldIdLst>
             <p14:sldId id="258"/>
           </p14:sldIdLst>
         </p14:section>
-        <p14:section name="Q2 Personas vs plan" id="{9a18a8cf-bbbb-dad9-9fab-47635097e142}">
+        <p14:section name="Q2 Who our customers are" id="{7416bd3a-0ba0-5b83-65b5-b7d9dc67e7cc}">
           <p14:sldIdLst>
             <p14:sldId id="259"/>
             <p14:sldId id="260"/>
             <p14:sldId id="261"/>
           </p14:sldIdLst>
         </p14:section>
-        <p14:section name="Q3 Persona x product" id="{34f6598d-bec5-3869-c195-7b68d54952dc}">
+        <p14:section name="Q3 What they come for" id="{3a31202b-5f9b-f73a-d1b3-0f3b5404401c}">
           <p14:sldIdLst>
             <p14:sldId id="262"/>
           </p14:sldIdLst>
         </p14:section>
-        <p14:section name="Q4 Active vs inactive" id="{4cd19472-a3c7-4eff-c2a4-e187a8f1ba70}">
+        <p14:section name="Q4 Active vs inactive" id="{8d40ba38-22c2-480d-f6c9-f54d72c0352a}">
           <p14:sldIdLst>
             <p14:sldId id="263"/>
             <p14:sldId id="264"/>
           </p14:sldIdLst>
         </p14:section>
-        <p14:section name="Q5 KTB cannibalization" id="{1414f63f-68cf-b842-89e8-f51d4d957216}">
+        <p14:section name="Q5 Impact on KTB" id="{9caae850-46f5-33ff-d5e3-4ede0601b78e}">
           <p14:sldIdLst>
             <p14:sldId id="265"/>
             <p14:sldId id="266"/>
           </p14:sldIdLst>
         </p14:section>
-        <p14:section name="Implications" id="{a2104faf-23e5-d1e6-23b4-02f4b251c3f4}">
+        <p14:section name="What to do next" id="{002ce402-de67-71f0-5cee-93599700181e}">
           <p14:sldIdLst>
             <p14:sldId id="267"/>
           </p14:sldIdLst>
@@ -193,7 +193,7 @@
                 </a:solidFill>
                 <a:latin typeface="+mn-lt"/>
               </a:rPr>
-              <a:t>Share of CLICX customers who are also a partner's customer, %</a:t>
+              <a:t>% of CLICX customers who are also with each partner (many are with more than one)</a:t>
             </a:r>
           </a:p>
         </c:rich>
@@ -293,13 +293,13 @@
                 <c:ptCount val="3"/>
                 <c:lvl>
                   <c:pt idx="0">
-                    <c:v>KTB customers</c:v>
+                    <c:v>Also a KTB customer</c:v>
                   </c:pt>
                   <c:pt idx="1">
-                    <c:v>AIS customers</c:v>
+                    <c:v>Also an AIS customer</c:v>
                   </c:pt>
                   <c:pt idx="2">
-                    <c:v>OR customers</c:v>
+                    <c:v>Also an OR customer</c:v>
                   </c:pt>
                 </c:lvl>
               </c:multiLvlStrCache>
@@ -486,7 +486,7 @@
                 </a:solidFill>
                 <a:latin typeface="+mn-lt"/>
               </a:rPr>
-              <a:t>CLICX penetration of each KTB group, %</a:t>
+              <a:t>% of each KTB group who joined CLICX</a:t>
             </a:r>
           </a:p>
         </c:rich>
@@ -510,7 +510,7 @@
               <c:strCache>
                 <c:ptCount val="1"/>
                 <c:pt idx="0">
-                  <c:v>Penetration</c:v>
+                  <c:v>Joined CLICX</c:v>
                 </c:pt>
               </c:strCache>
             </c:strRef>
@@ -597,16 +597,16 @@
                 <c:ptCount val="4"/>
                 <c:lvl>
                   <c:pt idx="0">
-                    <c:v>KTB-loyal</c:v>
+                    <c:v>Loyal to KTB</c:v>
                   </c:pt>
                   <c:pt idx="1">
-                    <c:v>Shared wallet</c:v>
+                    <c:v>KTB and others</c:v>
                   </c:pt>
                   <c:pt idx="2">
-                    <c:v>Competitor-loyal</c:v>
+                    <c:v>Other banks</c:v>
                   </c:pt>
                   <c:pt idx="3">
-                    <c:v>KTB-inactive</c:v>
+                    <c:v>Stopped KTB</c:v>
                   </c:pt>
                 </c:lvl>
               </c:multiLvlStrCache>
@@ -795,7 +795,7 @@
                 </a:solidFill>
                 <a:latin typeface="+mn-lt"/>
               </a:rPr>
-              <a:t>CLICX lending outside KTB's Jai-pump loan, K customers</a:t>
+              <a:t>CLICX lending that KTB's Jai-pump loan does not cover, thousand customers</a:t>
             </a:r>
           </a:p>
         </c:rich>
@@ -895,13 +895,13 @@
                 <c:ptCount val="3"/>
                 <c:lvl>
                   <c:pt idx="0">
-                    <c:v>Borrowers with no Jai-pump loan</c:v>
+                    <c:v>Our borrowers with no KTB loan</c:v>
                   </c:pt>
                   <c:pt idx="1">
-                    <c:v>Applicants rejected by Jai-pump</c:v>
+                    <c:v>Turned down by KTB, applied to us</c:v>
                   </c:pt>
                   <c:pt idx="2">
-                    <c:v>Borrowers rejected by Jai-pump</c:v>
+                    <c:v>Turned down by KTB, got our loan</c:v>
                   </c:pt>
                 </c:lvl>
               </c:multiLvlStrCache>
@@ -1087,7 +1087,7 @@
                 </a:solidFill>
                 <a:latin typeface="+mn-lt"/>
               </a:rPr>
-              <a:t>Persona mix: consortium base vs CLICX customers, %</a:t>
+              <a:t>Customer type: all partner customers vs CLICX customers, %</a:t>
             </a:r>
           </a:p>
         </c:rich>
@@ -1111,7 +1111,7 @@
               <c:strCache>
                 <c:ptCount val="1"/>
                 <c:pt idx="0">
-                  <c:v>Share of consortium base (49.5M)</c:v>
+                  <c:v>Share of all partner customers (49.5M)</c:v>
                 </c:pt>
               </c:strCache>
             </c:strRef>
@@ -1154,16 +1154,16 @@
                 <c:ptCount val="4"/>
                 <c:lvl>
                   <c:pt idx="0">
-                    <c:v>Tech-Savvy (8.5% pen.)</c:v>
+                    <c:v>Tech-savvy (8.5% joined)</c:v>
                   </c:pt>
                   <c:pt idx="1">
-                    <c:v>Single-Bank (4.1% pen.)</c:v>
+                    <c:v>One-bank users (4.1%)</c:v>
                   </c:pt>
                   <c:pt idx="2">
-                    <c:v>Multiple-Bank (2.4% pen.)</c:v>
+                    <c:v>Multi-bank users (2.4%)</c:v>
                   </c:pt>
                   <c:pt idx="3">
-                    <c:v>Unknown (2.0% pen.)</c:v>
+                    <c:v>Unknown (2.0%)</c:v>
                   </c:pt>
                 </c:lvl>
               </c:multiLvlStrCache>
@@ -1243,16 +1243,16 @@
                 <c:ptCount val="4"/>
                 <c:lvl>
                   <c:pt idx="0">
-                    <c:v>Tech-Savvy (8.5% pen.)</c:v>
+                    <c:v>Tech-savvy (8.5% joined)</c:v>
                   </c:pt>
                   <c:pt idx="1">
-                    <c:v>Single-Bank (4.1% pen.)</c:v>
+                    <c:v>One-bank users (4.1%)</c:v>
                   </c:pt>
                   <c:pt idx="2">
-                    <c:v>Multiple-Bank (2.4% pen.)</c:v>
+                    <c:v>Multi-bank users (2.4%)</c:v>
                   </c:pt>
                   <c:pt idx="3">
-                    <c:v>Unknown (2.0% pen.)</c:v>
+                    <c:v>Unknown (2.0%)</c:v>
                   </c:pt>
                 </c:lvl>
               </c:multiLvlStrCache>
@@ -1461,7 +1461,7 @@
                 </a:solidFill>
                 <a:latin typeface="+mn-lt"/>
               </a:rPr>
-              <a:t>Age mix: consortium base vs CLICX customers, %</a:t>
+              <a:t>Age: all partner customers vs CLICX customers, %</a:t>
             </a:r>
           </a:p>
         </c:rich>
@@ -1485,7 +1485,7 @@
               <c:strCache>
                 <c:ptCount val="1"/>
                 <c:pt idx="0">
-                  <c:v>Share of consortium base (known age, 44.8M)</c:v>
+                  <c:v>Share of partner customers (age known)</c:v>
                 </c:pt>
               </c:strCache>
             </c:strRef>
@@ -1610,7 +1610,7 @@
               <c:strCache>
                 <c:ptCount val="1"/>
                 <c:pt idx="0">
-                  <c:v>Share of CLICX customers (1.87M)</c:v>
+                  <c:v>Share of CLICX customers</c:v>
                 </c:pt>
               </c:strCache>
             </c:strRef>
@@ -1907,7 +1907,7 @@
                 </a:solidFill>
                 <a:latin typeface="+mn-lt"/>
               </a:rPr>
-              <a:t>CLICX penetration of captive base by occupation, % (CLICX customers)</a:t>
+              <a:t>% of partner customers in each job who joined CLICX (number of CLICX customers)</a:t>
             </a:r>
           </a:p>
         </c:rich>
@@ -1931,7 +1931,7 @@
               <c:strCache>
                 <c:ptCount val="1"/>
                 <c:pt idx="0">
-                  <c:v>Penetration</c:v>
+                  <c:v>Joined CLICX</c:v>
                 </c:pt>
               </c:strCache>
             </c:strRef>
@@ -2043,19 +2043,19 @@
                     <c:v>Freelancer (232K)</c:v>
                   </c:pt>
                   <c:pt idx="1">
-                    <c:v>Rider / Driver (66K)</c:v>
+                    <c:v>Rider / driver (66K)</c:v>
                   </c:pt>
                   <c:pt idx="2">
-                    <c:v>Blue collar (401K)</c:v>
+                    <c:v>Manual worker (401K)</c:v>
                   </c:pt>
                   <c:pt idx="3">
-                    <c:v>White collar (700K)</c:v>
+                    <c:v>Office worker (700K)</c:v>
                   </c:pt>
                   <c:pt idx="4">
-                    <c:v>Merchant (293K)</c:v>
+                    <c:v>Shop owner (293K)</c:v>
                   </c:pt>
                   <c:pt idx="5">
-                    <c:v>Others (129K)</c:v>
+                    <c:v>Unknown (129K)</c:v>
                   </c:pt>
                 </c:lvl>
               </c:multiLvlStrCache>
@@ -2250,7 +2250,7 @@
                 </a:solidFill>
                 <a:latin typeface="+mn-lt"/>
               </a:rPr>
-              <a:t>What each occupation actually uses, % of its CLICX customers</a:t>
+              <a:t>What each job type actually uses, % of its CLICX customers</a:t>
             </a:r>
           </a:p>
         </c:rich>
@@ -2274,7 +2274,7 @@
               <c:strCache>
                 <c:ptCount val="1"/>
                 <c:pt idx="0">
-                  <c:v>Loan booked</c:v>
+                  <c:v>Got a loan</c:v>
                 </c:pt>
               </c:strCache>
             </c:strRef>
@@ -2317,19 +2317,19 @@
                 <c:ptCount val="5"/>
                 <c:lvl>
                   <c:pt idx="0">
-                    <c:v>White collar</c:v>
+                    <c:v>Office worker</c:v>
                   </c:pt>
                   <c:pt idx="1">
-                    <c:v>Merchant</c:v>
+                    <c:v>Shop owner</c:v>
                   </c:pt>
                   <c:pt idx="2">
-                    <c:v>Blue collar</c:v>
+                    <c:v>Manual worker</c:v>
                   </c:pt>
                   <c:pt idx="3">
                     <c:v>Freelancer</c:v>
                   </c:pt>
                   <c:pt idx="4">
-                    <c:v>Rider / Driver</c:v>
+                    <c:v>Rider / driver</c:v>
                   </c:pt>
                 </c:lvl>
               </c:multiLvlStrCache>
@@ -2369,7 +2369,7 @@
               <c:strCache>
                 <c:ptCount val="1"/>
                 <c:pt idx="0">
-                  <c:v>Deposit &gt; 0</c:v>
+                  <c:v>Keeps money in CLICX</c:v>
                 </c:pt>
               </c:strCache>
             </c:strRef>
@@ -2412,19 +2412,19 @@
                 <c:ptCount val="5"/>
                 <c:lvl>
                   <c:pt idx="0">
-                    <c:v>White collar</c:v>
+                    <c:v>Office worker</c:v>
                   </c:pt>
                   <c:pt idx="1">
-                    <c:v>Merchant</c:v>
+                    <c:v>Shop owner</c:v>
                   </c:pt>
                   <c:pt idx="2">
-                    <c:v>Blue collar</c:v>
+                    <c:v>Manual worker</c:v>
                   </c:pt>
                   <c:pt idx="3">
                     <c:v>Freelancer</c:v>
                   </c:pt>
                   <c:pt idx="4">
-                    <c:v>Rider / Driver</c:v>
+                    <c:v>Rider / driver</c:v>
                   </c:pt>
                 </c:lvl>
               </c:multiLvlStrCache>
@@ -2464,7 +2464,7 @@
               <c:strCache>
                 <c:ptCount val="1"/>
                 <c:pt idx="0">
-                  <c:v>Payment (Sep)</c:v>
+                  <c:v>Paid with CLICX in Sep</c:v>
                 </c:pt>
               </c:strCache>
             </c:strRef>
@@ -2507,19 +2507,19 @@
                 <c:ptCount val="5"/>
                 <c:lvl>
                   <c:pt idx="0">
-                    <c:v>White collar</c:v>
+                    <c:v>Office worker</c:v>
                   </c:pt>
                   <c:pt idx="1">
-                    <c:v>Merchant</c:v>
+                    <c:v>Shop owner</c:v>
                   </c:pt>
                   <c:pt idx="2">
-                    <c:v>Blue collar</c:v>
+                    <c:v>Manual worker</c:v>
                   </c:pt>
                   <c:pt idx="3">
                     <c:v>Freelancer</c:v>
                   </c:pt>
                   <c:pt idx="4">
-                    <c:v>Rider / Driver</c:v>
+                    <c:v>Rider / driver</c:v>
                   </c:pt>
                 </c:lvl>
               </c:multiLvlStrCache>
@@ -2731,7 +2731,7 @@
                 </a:solidFill>
                 <a:latin typeface="+mn-lt"/>
               </a:rPr>
-              <a:t>Occupation mix: active vs inactive CLICX customers, %</a:t>
+              <a:t>Job type of active vs inactive customers, %</a:t>
             </a:r>
           </a:p>
         </c:rich>
@@ -2755,7 +2755,7 @@
               <c:strCache>
                 <c:ptCount val="1"/>
                 <c:pt idx="0">
-                  <c:v>Share of active customers (358K)</c:v>
+                  <c:v>Active customers (358K)</c:v>
                 </c:pt>
               </c:strCache>
             </c:strRef>
@@ -2798,22 +2798,22 @@
                 <c:ptCount val="6"/>
                 <c:lvl>
                   <c:pt idx="0">
-                    <c:v>White collar (23% active)</c:v>
+                    <c:v>Office worker (23% active)</c:v>
                   </c:pt>
                   <c:pt idx="1">
-                    <c:v>Merchant (23%)</c:v>
+                    <c:v>Shop owner (23%)</c:v>
                   </c:pt>
                   <c:pt idx="2">
-                    <c:v>Blue collar (16%)</c:v>
+                    <c:v>Manual worker (16%)</c:v>
                   </c:pt>
                   <c:pt idx="3">
                     <c:v>Freelancer (18%)</c:v>
                   </c:pt>
                   <c:pt idx="4">
-                    <c:v>Rider / Driver (15%)</c:v>
+                    <c:v>Rider / driver (15%)</c:v>
                   </c:pt>
                   <c:pt idx="5">
-                    <c:v>Others (8%)</c:v>
+                    <c:v>Unknown job (8%)</c:v>
                   </c:pt>
                 </c:lvl>
               </c:multiLvlStrCache>
@@ -2856,7 +2856,7 @@
               <c:strCache>
                 <c:ptCount val="1"/>
                 <c:pt idx="0">
-                  <c:v>Share of inactive customers (1,462K)</c:v>
+                  <c:v>Inactive customers (1.46M)</c:v>
                 </c:pt>
               </c:strCache>
             </c:strRef>
@@ -2899,22 +2899,22 @@
                 <c:ptCount val="6"/>
                 <c:lvl>
                   <c:pt idx="0">
-                    <c:v>White collar (23% active)</c:v>
+                    <c:v>Office worker (23% active)</c:v>
                   </c:pt>
                   <c:pt idx="1">
-                    <c:v>Merchant (23%)</c:v>
+                    <c:v>Shop owner (23%)</c:v>
                   </c:pt>
                   <c:pt idx="2">
-                    <c:v>Blue collar (16%)</c:v>
+                    <c:v>Manual worker (16%)</c:v>
                   </c:pt>
                   <c:pt idx="3">
                     <c:v>Freelancer (18%)</c:v>
                   </c:pt>
                   <c:pt idx="4">
-                    <c:v>Rider / Driver (15%)</c:v>
+                    <c:v>Rider / driver (15%)</c:v>
                   </c:pt>
                   <c:pt idx="5">
-                    <c:v>Others (8%)</c:v>
+                    <c:v>Unknown job (8%)</c:v>
                   </c:pt>
                 </c:lvl>
               </c:multiLvlStrCache>
@@ -3129,7 +3129,7 @@
                 </a:solidFill>
                 <a:latin typeface="+mn-lt"/>
               </a:rPr>
-              <a:t>CLICX active rate by AIS segment, %</a:t>
+              <a:t>% active in CLICX, by type of AIS customer</a:t>
             </a:r>
           </a:p>
         </c:rich>
@@ -3153,7 +3153,7 @@
               <c:strCache>
                 <c:ptCount val="1"/>
                 <c:pt idx="0">
-                  <c:v>CLICX active rate</c:v>
+                  <c:v>Active in CLICX</c:v>
                 </c:pt>
               </c:strCache>
             </c:strRef>
@@ -3273,25 +3273,25 @@
                 <c:ptCount val="7"/>
                 <c:lvl>
                   <c:pt idx="0">
-                    <c:v>FBB only</c:v>
+                    <c:v>Home internet only</c:v>
                   </c:pt>
                   <c:pt idx="1">
-                    <c:v>Post-paid</c:v>
+                    <c:v>Monthly phone bill</c:v>
                   </c:pt>
                   <c:pt idx="2">
-                    <c:v>Prepaid PPU</c:v>
+                    <c:v>Prepaid, pay-per-use</c:v>
                   </c:pt>
                   <c:pt idx="3">
-                    <c:v>Prepaid zero-ARPU</c:v>
+                    <c:v>Prepaid, little spend</c:v>
                   </c:pt>
                   <c:pt idx="4">
-                    <c:v>Prepaid recurring</c:v>
+                    <c:v>Prepaid, regular top-up</c:v>
                   </c:pt>
                   <c:pt idx="5">
-                    <c:v>Prepaid non-recurring</c:v>
+                    <c:v>Prepaid, occasional top-up</c:v>
                   </c:pt>
                   <c:pt idx="6">
-                    <c:v>AIS inactive</c:v>
+                    <c:v>Stopped using AIS</c:v>
                   </c:pt>
                 </c:lvl>
               </c:multiLvlStrCache>
@@ -3489,7 +3489,7 @@
                 </a:solidFill>
                 <a:latin typeface="+mn-lt"/>
               </a:rPr>
-              <a:t>Customers paying through CLICX, by product status, %</a:t>
+              <a:t>% who pay with CLICX</a:t>
             </a:r>
           </a:p>
         </c:rich>
@@ -3513,7 +3513,7 @@
               <c:strCache>
                 <c:ptCount val="1"/>
                 <c:pt idx="0">
-                  <c:v>Paying in CLICX</c:v>
+                  <c:v>Pays with CLICX</c:v>
                 </c:pt>
               </c:strCache>
             </c:strRef>
@@ -3589,13 +3589,13 @@
                 <c:ptCount val="3"/>
                 <c:lvl>
                   <c:pt idx="0">
-                    <c:v>Loan booked (11%)</c:v>
+                    <c:v>Got a loan</c:v>
                   </c:pt>
                   <c:pt idx="1">
-                    <c:v>Deposit, never rejected (22%)</c:v>
+                    <c:v>Never turned down</c:v>
                   </c:pt>
                   <c:pt idx="2">
-                    <c:v>Deposit, ever rejected (67%)</c:v>
+                    <c:v>Turned down for a loan</c:v>
                   </c:pt>
                 </c:lvl>
               </c:multiLvlStrCache>
@@ -3781,7 +3781,7 @@
                 </a:solidFill>
                 <a:latin typeface="+mn-lt"/>
               </a:rPr>
-              <a:t>Share of 1.65M KTB x CLICX customers, %</a:t>
+              <a:t>Customers we share with KTB, by how they use KTB, %</a:t>
             </a:r>
           </a:p>
         </c:rich>
@@ -3805,7 +3805,7 @@
               <c:strCache>
                 <c:ptCount val="1"/>
                 <c:pt idx="0">
-                  <c:v>Share of overlap</c:v>
+                  <c:v>Share of shared customers</c:v>
                 </c:pt>
               </c:strCache>
             </c:strRef>
@@ -3892,16 +3892,16 @@
                 <c:ptCount val="4"/>
                 <c:lvl>
                   <c:pt idx="0">
-                    <c:v>KTB-loyal (at risk)</c:v>
+                    <c:v>Loyal to KTB (at risk)</c:v>
                   </c:pt>
                   <c:pt idx="1">
-                    <c:v>Shared wallet</c:v>
+                    <c:v>Uses KTB and other banks</c:v>
                   </c:pt>
                   <c:pt idx="2">
-                    <c:v>Competitor-loyal (win-back)</c:v>
+                    <c:v>Loyal to other banks (won back)</c:v>
                   </c:pt>
                   <c:pt idx="3">
-                    <c:v>KTB-inactive (reactivated)</c:v>
+                    <c:v>Stopped using KTB (brought back)</c:v>
                   </c:pt>
                 </c:lvl>
               </c:multiLvlStrCache>
@@ -5862,8 +5862,8 @@
         </p:nvSpPr>
         <p:spPr>
           <a:xfrm>
-            <a:off x="457200" y="6236208"/>
-            <a:ext cx="10241280" cy="411480"/>
+            <a:off x="457200" y="6327648"/>
+            <a:ext cx="10241280" cy="274320"/>
           </a:xfrm>
           <a:prstGeom prst="rect">
             <a:avLst/>
@@ -6417,7 +6417,7 @@
                   <a:schemeClr val="accent6"/>
                 </a:solidFill>
               </a:rPr>
-              <a:t>Five questions on where 1.8M CLICX customers come from, who they are, what they use, who stays active, and whether CLICX cannibalizes KTB</a:t>
+              <a:t>Five simple questions about our first 1.8 million customers: where they come from, who they are, what they use, who keeps using us, and whether we take customers away from KTB</a:t>
             </a:r>
             <a:endParaRPr lang="en-US" sz="1800" dirty="0"/>
           </a:p>
@@ -6518,7 +6518,7 @@
                   <a:schemeClr val="accent1"/>
                 </a:solidFill>
               </a:rPr>
-              <a:t>Q5  |  KTB CANNIBALIZATION  (1/2)</a:t>
+              <a:t>Q5  |  IMPACT ON KTB  (1/2)</a:t>
             </a:r>
             <a:endParaRPr lang="en-US" sz="1100" dirty="0"/>
           </a:p>
@@ -6556,7 +6556,7 @@
                   <a:schemeClr val="tx2"/>
                 </a:solidFill>
               </a:rPr>
-              <a:t>Does CLICX cannibalize KTB customers?</a:t>
+              <a:t>Does CLICX take customers away from KTB?</a:t>
             </a:r>
             <a:endParaRPr lang="en-US" sz="2400" dirty="0"/>
           </a:p>
@@ -6594,7 +6594,7 @@
                   <a:schemeClr val="tx1"/>
                 </a:solidFill>
               </a:rPr>
-              <a:t>Limited. Only 13% of the 1.6M KTB x CLICX overlap are KTB-loyal customers; 61% are competitor-loyal or inactive with KTB, so CLICX mostly wins back or reactivates them</a:t>
+              <a:t>Very little. Of 1.6M customers we share with KTB, only 13% are loyal to KTB. 61% mainly used other banks or had stopped using KTB, so we are winning them back for the group</a:t>
             </a:r>
             <a:endParaRPr lang="en-US" sz="1600" dirty="0"/>
           </a:p>
@@ -6610,8 +6610,8 @@
         </p:nvSpPr>
         <p:spPr>
           <a:xfrm>
-            <a:off x="457200" y="6236208"/>
-            <a:ext cx="10241280" cy="411480"/>
+            <a:off x="457200" y="6327648"/>
+            <a:ext cx="10241280" cy="274320"/>
           </a:xfrm>
           <a:prstGeom prst="rect">
             <a:avLst/>
@@ -6632,21 +6632,7 @@
                   <a:srgbClr val="6E7C87"/>
                 </a:solidFill>
               </a:rPr>
-              <a:t>Note: KTB active = holds at least 1 of 4 core KTB products. KTB-inactive = no KTB transaction in 1 year (incl. Paotang-only without PaotangPay). Shared wallet = KTB swing, low engagement and PaotangPay users</a:t>
-            </a:r>
-            <a:endParaRPr lang="en-US" sz="1000" dirty="0"/>
-          </a:p>
-          <a:p>
-            <a:pPr indent="0" marL="0">
-              <a:buNone/>
-            </a:pPr>
-            <a:r>
-              <a:rPr lang="en-US" sz="1000" dirty="0">
-                <a:solidFill>
-                  <a:srgbClr val="6E7C87"/>
-                </a:solidFill>
-              </a:rPr>
-              <a:t>Source: KTB x CLICX engagement segmentation (Oct 2026)</a:t>
+              <a:t>Source: KTB and CLICX matched customer data (Oct 2026)</a:t>
             </a:r>
             <a:endParaRPr lang="en-US" sz="1000" dirty="0"/>
           </a:p>
@@ -6660,7 +6646,7 @@
         </p:nvGraphicFramePr>
         <p:xfrm>
           <a:off x="457200" y="2148840"/>
-          <a:ext cx="4480560" cy="3977640"/>
+          <a:ext cx="4572000" cy="3977640"/>
         </p:xfrm>
         <a:graphic xmlns:a="http://schemas.openxmlformats.org/drawingml/2006/main">
           <a:graphicData uri="http://schemas.openxmlformats.org/drawingml/2006/chart">
@@ -6675,8 +6661,8 @@
           <p:nvPr/>
         </p:nvGraphicFramePr>
         <p:xfrm>
-          <a:off x="5029200" y="2148840"/>
-          <a:ext cx="3108960" cy="3977640"/>
+          <a:off x="5120640" y="2148840"/>
+          <a:ext cx="3017520" cy="3977640"/>
         </p:xfrm>
         <a:graphic xmlns:a="http://schemas.openxmlformats.org/drawingml/2006/main">
           <a:graphicData uri="http://schemas.openxmlformats.org/drawingml/2006/chart">
@@ -6829,7 +6815,7 @@
                   <a:schemeClr val="tx2"/>
                 </a:solidFill>
               </a:rPr>
-              <a:t>Loyalists are hard to pull</a:t>
+              <a:t>KTB loyalists rarely switch</a:t>
             </a:r>
             <a:endParaRPr lang="en-US" sz="1400" dirty="0"/>
           </a:p>
@@ -6846,7 +6832,7 @@
                   <a:schemeClr val="tx1"/>
                 </a:solidFill>
               </a:rPr>
-              <a:t>KTB-loyal penetration is 3.3%, less than half that of competitor-loyal (7.9%) and shared-wallet (7.4%) customers</a:t>
+              <a:t>Only 3.3% of them joined, less than half the rate of people who bank elsewhere (7.9%)</a:t>
             </a:r>
             <a:endParaRPr lang="en-US" sz="1400" dirty="0"/>
           </a:p>
@@ -6941,7 +6927,7 @@
                   <a:schemeClr val="tx2"/>
                 </a:solidFill>
               </a:rPr>
-              <a:t>Defensive growth for KTB</a:t>
+              <a:t>We win back other banks' customers</a:t>
             </a:r>
             <a:endParaRPr lang="en-US" sz="1400" dirty="0"/>
           </a:p>
@@ -6958,7 +6944,7 @@
                   <a:schemeClr val="tx1"/>
                 </a:solidFill>
               </a:rPr>
-              <a:t>515K competitor-loyal customers, 79K of them quality users, now bank with the KTB ecosystem through CLICX</a:t>
+              <a:t>515K customers mainly banked elsewhere. Now they are back in the KTB group through CLICX</a:t>
             </a:r>
             <a:endParaRPr lang="en-US" sz="1400" dirty="0"/>
           </a:p>
@@ -7053,7 +7039,7 @@
                   <a:schemeClr val="tx2"/>
                 </a:solidFill>
               </a:rPr>
-              <a:t>Reactivation, not substitution</a:t>
+              <a:t>We wake up lapsed customers</a:t>
             </a:r>
             <a:endParaRPr lang="en-US" sz="1400" dirty="0"/>
           </a:p>
@@ -7070,7 +7056,7 @@
                   <a:schemeClr val="tx1"/>
                 </a:solidFill>
               </a:rPr>
-              <a:t>488K were inactive with KTB for a year or more but signed up for CLICX</a:t>
+              <a:t>488K had not used KTB for a year or more, then joined CLICX</a:t>
             </a:r>
             <a:endParaRPr lang="en-US" sz="1400" dirty="0"/>
           </a:p>
@@ -7178,7 +7164,7 @@
                   <a:schemeClr val="accent1"/>
                 </a:solidFill>
               </a:rPr>
-              <a:t>Q5  |  KTB CANNIBALIZATION  (2/2)</a:t>
+              <a:t>Q5  |  IMPACT ON KTB  (2/2)</a:t>
             </a:r>
             <a:endParaRPr lang="en-US" sz="1100" dirty="0"/>
           </a:p>
@@ -7216,7 +7202,7 @@
                   <a:schemeClr val="tx2"/>
                 </a:solidFill>
               </a:rPr>
-              <a:t>Does CLICX cannibalize KTB products?</a:t>
+              <a:t>Does CLICX take products away from KTB?</a:t>
             </a:r>
             <a:endParaRPr lang="en-US" sz="2400" dirty="0"/>
           </a:p>
@@ -7254,7 +7240,7 @@
                   <a:schemeClr val="tx1"/>
                 </a:solidFill>
               </a:rPr>
-              <a:t>Not on lending, where CLICX is additive. Its borrowers largely sit outside KTB's Jai-pump digital loan, and it catches customers Jai-pump rejects. Deposit cannibalization cannot yet be measured</a:t>
+              <a:t>Not for loans: we mostly lend to people KTB's own app loan (Jai-pump) does not serve or turns down. We cannot check savings yet</a:t>
             </a:r>
             <a:endParaRPr lang="en-US" sz="1600" dirty="0"/>
           </a:p>
@@ -7270,8 +7256,8 @@
         </p:nvSpPr>
         <p:spPr>
           <a:xfrm>
-            <a:off x="457200" y="6236208"/>
-            <a:ext cx="10241280" cy="411480"/>
+            <a:off x="457200" y="6327648"/>
+            <a:ext cx="10241280" cy="274320"/>
           </a:xfrm>
           <a:prstGeom prst="rect">
             <a:avLst/>
@@ -7292,21 +7278,7 @@
                   <a:srgbClr val="6E7C87"/>
                 </a:solidFill>
               </a:rPr>
-              <a:t>Note: Jai-pump = KTB's digital personal loan. Rejected = rejected by Jai-pump in the last 3 months. Quality = payment in last month, deposit &gt; THB 100 or a performing loan. CLICX balances are not yet in the data room</a:t>
-            </a:r>
-            <a:endParaRPr lang="en-US" sz="1000" dirty="0"/>
-          </a:p>
-          <a:p>
-            <a:pPr indent="0" marL="0">
-              <a:buNone/>
-            </a:pPr>
-            <a:r>
-              <a:rPr lang="en-US" sz="1000" dirty="0">
-                <a:solidFill>
-                  <a:srgbClr val="6E7C87"/>
-                </a:solidFill>
-              </a:rPr>
-              <a:t>Source: KTB x CLICX matched data (Oct 2026)</a:t>
+              <a:t>Source: KTB and CLICX matched customer data (Oct 2026)</a:t>
             </a:r>
             <a:endParaRPr lang="en-US" sz="1000" dirty="0"/>
           </a:p>
@@ -7383,7 +7355,7 @@
                   <a:schemeClr val="accent5"/>
                 </a:solidFill>
               </a:rPr>
-              <a:t>DEPOSITS: NOT YET MEASURABLE</a:t>
+              <a:t>SAVINGS: NOT KNOWN YET</a:t>
             </a:r>
             <a:endParaRPr lang="en-US" sz="1100" dirty="0"/>
           </a:p>
@@ -7411,7 +7383,7 @@
                   <a:schemeClr val="tx1"/>
                 </a:solidFill>
               </a:rPr>
-              <a:t>CLICX balances are not yet in the data room, so we cannot test whether KTB deposits move to CLICX.</a:t>
+              <a:t>We cannot yet see CLICX balances, so we cannot tell if money is moving out of KTB accounts.</a:t>
             </a:r>
             <a:endParaRPr lang="en-US" sz="1100" dirty="0"/>
           </a:p>
@@ -7439,7 +7411,7 @@
                   <a:schemeClr val="tx2"/>
                 </a:solidFill>
               </a:rPr>
-              <a:t>Next step: compare KTB balances of the 1.6M overlap before vs after CLICX sign-up once data lands</a:t>
+              <a:t>Next step: once the data is in, compare shared customers' KTB balances before and after they joined CLICX</a:t>
             </a:r>
             <a:endParaRPr lang="en-US" sz="1100" dirty="0"/>
           </a:p>
@@ -7590,7 +7562,7 @@
                   <a:schemeClr val="tx2"/>
                 </a:solidFill>
               </a:rPr>
-              <a:t>Additive loan book</a:t>
+              <a:t>New loans for the group</a:t>
             </a:r>
             <a:endParaRPr lang="en-US" sz="1400" dirty="0"/>
           </a:p>
@@ -7607,7 +7579,7 @@
                   <a:schemeClr val="tx1"/>
                 </a:solidFill>
               </a:rPr>
-              <a:t>116K CLICX borrowers hold no KTB Jai-pump loan, new credit for the ecosystem</a:t>
+              <a:t>116K of our borrowers have no KTB Jai-pump loan</a:t>
             </a:r>
             <a:endParaRPr lang="en-US" sz="1400" dirty="0"/>
           </a:p>
@@ -7702,7 +7674,7 @@
                   <a:schemeClr val="tx2"/>
                 </a:solidFill>
               </a:rPr>
-              <a:t>A safety net for KTB rejects</a:t>
+              <a:t>A safety net for KTB</a:t>
             </a:r>
             <a:endParaRPr lang="en-US" sz="1400" dirty="0"/>
           </a:p>
@@ -7719,7 +7691,7 @@
                   <a:schemeClr val="tx1"/>
                 </a:solidFill>
               </a:rPr>
-              <a:t>156K applicants and 23K borrowers were rejected by Jai-pump in the last 3 months, demand that would otherwise go to competitors</a:t>
+              <a:t>156K people KTB turned down in the last 3 months applied to us instead of going to another bank</a:t>
             </a:r>
             <a:endParaRPr lang="en-US" sz="1400" dirty="0"/>
           </a:p>
@@ -7814,7 +7786,7 @@
                   <a:schemeClr val="tx2"/>
                 </a:solidFill>
               </a:rPr>
-              <a:t>Value overlap is modest</a:t>
+              <a:t>Few loyal KTB users among our best customers</a:t>
             </a:r>
             <a:endParaRPr lang="en-US" sz="1400" dirty="0"/>
           </a:p>
@@ -7831,7 +7803,7 @@
                   <a:schemeClr val="tx1"/>
                 </a:solidFill>
               </a:rPr>
-              <a:t>Only 15% of the 251K quality CLICX customers in the overlap (38K) are KTB-loyal</a:t>
+              <a:t>Only 15% of our most engaged shared customers are loyal to KTB</a:t>
             </a:r>
             <a:endParaRPr lang="en-US" sz="1400" dirty="0"/>
           </a:p>
@@ -7939,7 +7911,7 @@
                   <a:schemeClr val="accent1"/>
                 </a:solidFill>
               </a:rPr>
-              <a:t>IMPLICATIONS</a:t>
+              <a:t>WHAT TO DO NEXT</a:t>
             </a:r>
             <a:endParaRPr lang="en-US" sz="1100" dirty="0"/>
           </a:p>
@@ -8015,7 +7987,7 @@
                   <a:schemeClr val="tx1"/>
                 </a:solidFill>
               </a:rPr>
-              <a:t>Keep the consortium as the acquisition engine, but move from sign-ups to active, credit-led customers in the personas that already work</a:t>
+              <a:t>Keep using partners to bring people in, and focus on turning sign-ups into regular users, starting with the customer types that already work</a:t>
             </a:r>
             <a:endParaRPr lang="en-US" sz="1600" dirty="0"/>
           </a:p>
@@ -8031,8 +8003,8 @@
         </p:nvSpPr>
         <p:spPr>
           <a:xfrm>
-            <a:off x="457200" y="6236208"/>
-            <a:ext cx="10241280" cy="411480"/>
+            <a:off x="457200" y="6327648"/>
+            <a:ext cx="10241280" cy="274320"/>
           </a:xfrm>
           <a:prstGeom prst="rect">
             <a:avLst/>
@@ -8053,7 +8025,7 @@
                   <a:srgbClr val="6E7C87"/>
                 </a:solidFill>
               </a:rPr>
-              <a:t>Source: synthesis of Q1–Q5; actions build on Data for Business Strategy (14 Oct 2026) and CLICX 5-Year Business Plan</a:t>
+              <a:t>Source: CLICX team analysis</a:t>
             </a:r>
             <a:endParaRPr lang="en-US" sz="1000" dirty="0"/>
           </a:p>
@@ -8165,7 +8137,7 @@
                   <a:schemeClr val="tx2"/>
                 </a:solidFill>
               </a:rPr>
-              <a:t>Mine the 47M base</a:t>
+              <a:t>Reach more partner customers</a:t>
             </a:r>
             <a:endParaRPr lang="en-US" sz="1500" dirty="0"/>
           </a:p>
@@ -8179,8 +8151,8 @@
         </p:nvSpPr>
         <p:spPr>
           <a:xfrm>
-            <a:off x="640080" y="3794760"/>
-            <a:ext cx="1764792" cy="2148840"/>
+            <a:off x="640080" y="3886200"/>
+            <a:ext cx="1764792" cy="2057400"/>
           </a:xfrm>
           <a:prstGeom prst="rect">
             <a:avLst/>
@@ -8201,7 +8173,7 @@
                   <a:schemeClr val="tx1"/>
                 </a:solidFill>
               </a:rPr>
-              <a:t>Go after AIS first (3.7% penetration on ~32M), through myAIS and Dipchip, starting with 1.1M active AIS customers</a:t>
+              <a:t>Start with AIS: only 3.7% of its ~32M customers have joined. Sign them up through the myAIS app and AIS shops</a:t>
             </a:r>
             <a:endParaRPr lang="en-US" sz="1200" dirty="0"/>
           </a:p>
@@ -8313,7 +8285,7 @@
                   <a:schemeClr val="tx2"/>
                 </a:solidFill>
               </a:rPr>
-              <a:t>Double down on what fits</a:t>
+              <a:t>Find more people like our best customers</a:t>
             </a:r>
             <a:endParaRPr lang="en-US" sz="1500" dirty="0"/>
           </a:p>
@@ -8327,8 +8299,8 @@
         </p:nvSpPr>
         <p:spPr>
           <a:xfrm>
-            <a:off x="2926080" y="3794760"/>
-            <a:ext cx="1764792" cy="2148840"/>
+            <a:off x="2926080" y="3886200"/>
+            <a:ext cx="1764792" cy="2057400"/>
           </a:xfrm>
           <a:prstGeom prst="rect">
             <a:avLst/>
@@ -8349,7 +8321,7 @@
                   <a:schemeClr val="tx1"/>
                 </a:solidFill>
               </a:rPr>
-              <a:t>Use Tech-Savvy aged 30–34 as the look-alike seed. Build a Multiple-Bank offer and a proxy-income journey for gig workers</a:t>
+              <a:t>Target tech-savvy 30–34s. Create a clear reason for multi-bank users to switch. Make it easy for gig workers to prove income</a:t>
             </a:r>
             <a:endParaRPr lang="en-US" sz="1200" dirty="0"/>
           </a:p>
@@ -8461,7 +8433,7 @@
                   <a:schemeClr val="tx2"/>
                 </a:solidFill>
               </a:rPr>
-              <a:t>Fix the credit funnel</a:t>
+              <a:t>Say 'yes' more safely</a:t>
             </a:r>
             <a:endParaRPr lang="en-US" sz="1500" dirty="0"/>
           </a:p>
@@ -8475,8 +8447,8 @@
         </p:nvSpPr>
         <p:spPr>
           <a:xfrm>
-            <a:off x="5212080" y="3794760"/>
-            <a:ext cx="1764792" cy="2148840"/>
+            <a:off x="5212080" y="3886200"/>
+            <a:ext cx="1764792" cy="2057400"/>
           </a:xfrm>
           <a:prstGeom prst="rect">
             <a:avLst/>
@@ -8497,7 +8469,7 @@
                   <a:schemeClr val="tx1"/>
                 </a:solidFill>
               </a:rPr>
-              <a:t>Over 90% of Blue-collar and gig workers apply but 5–7% are booked. Recalibrate underwriting and offer deposit-backed credit-builder loans</a:t>
+              <a:t>Over 90% of manual and gig workers apply but only 5–7% get a loan. Improve approval rules and offer small starter loans</a:t>
             </a:r>
             <a:endParaRPr lang="en-US" sz="1200" dirty="0"/>
           </a:p>
@@ -8609,7 +8581,7 @@
                   <a:schemeClr val="tx2"/>
                 </a:solidFill>
               </a:rPr>
-              <a:t>Activate after onboarding</a:t>
+              <a:t>Keep new customers using us</a:t>
             </a:r>
             <a:endParaRPr lang="en-US" sz="1500" dirty="0"/>
           </a:p>
@@ -8623,8 +8595,8 @@
         </p:nvSpPr>
         <p:spPr>
           <a:xfrm>
-            <a:off x="7498080" y="3794760"/>
-            <a:ext cx="1764792" cy="2148840"/>
+            <a:off x="7498080" y="3886200"/>
+            <a:ext cx="1764792" cy="2057400"/>
           </a:xfrm>
           <a:prstGeom prst="rect">
             <a:avLst/>
@@ -8645,7 +8617,7 @@
                   <a:schemeClr val="tx1"/>
                 </a:solidFill>
               </a:rPr>
-              <a:t>Get new customers onto 3+ use cases in 30 days. Give declined applicants a non-loan reason to stay; target prepaid and AIS-inactive customers</a:t>
+              <a:t>Get them using 3+ features in the first month. Give people we turn down another reason to stay</a:t>
             </a:r>
             <a:endParaRPr lang="en-US" sz="1200" dirty="0"/>
           </a:p>
@@ -8757,7 +8729,7 @@
                   <a:schemeClr val="tx2"/>
                 </a:solidFill>
               </a:rPr>
-              <a:t>Position CLICX as KTB's growth arm</a:t>
+              <a:t>Show KTB we grow the group</a:t>
             </a:r>
             <a:endParaRPr lang="en-US" sz="1500" dirty="0"/>
           </a:p>
@@ -8771,8 +8743,8 @@
         </p:nvSpPr>
         <p:spPr>
           <a:xfrm>
-            <a:off x="9784080" y="3794760"/>
-            <a:ext cx="1764792" cy="2148840"/>
+            <a:off x="9784080" y="3886200"/>
+            <a:ext cx="1764792" cy="2057400"/>
           </a:xfrm>
           <a:prstGeom prst="rect">
             <a:avLst/>
@@ -8793,7 +8765,7 @@
                   <a:schemeClr val="tx1"/>
                 </a:solidFill>
               </a:rPr>
-              <a:t>Report win-back (515K) and reactivation (488K) to KTB. Formalise Jai-pump reject referral; measure deposit overlap once data lands</a:t>
+              <a:t>Share the 515K won back and 488K brought back. Set up referrals for people KTB turns down. Check savings once data is in</a:t>
             </a:r>
             <a:endParaRPr lang="en-US" sz="1200" dirty="0"/>
           </a:p>
@@ -8939,7 +8911,7 @@
                   <a:schemeClr val="tx2"/>
                 </a:solidFill>
               </a:rPr>
-              <a:t>What have CLICX's first 1.8M customers told us?</a:t>
+              <a:t>What have our first 1.8 million customers told us?</a:t>
             </a:r>
             <a:endParaRPr lang="en-US" sz="2400" dirty="0"/>
           </a:p>
@@ -8977,7 +8949,7 @@
                   <a:schemeClr val="tx1"/>
                 </a:solidFill>
               </a:rPr>
-              <a:t>CLICX is an ecosystem bank: it wins consortium customers aged 25–39 who come for credit, and mostly grows the pie for KTB rather than taking from it</a:t>
+              <a:t>Our partners bring in almost everyone. Customers are mostly 25–39 and come to borrow. We mostly win people KTB had already lost, not KTB's loyal customers</a:t>
             </a:r>
             <a:endParaRPr lang="en-US" sz="1600" dirty="0"/>
           </a:p>
@@ -8993,8 +8965,8 @@
         </p:nvSpPr>
         <p:spPr>
           <a:xfrm>
-            <a:off x="457200" y="6236208"/>
-            <a:ext cx="10241280" cy="411480"/>
+            <a:off x="457200" y="6327648"/>
+            <a:ext cx="10241280" cy="274320"/>
           </a:xfrm>
           <a:prstGeom prst="rect">
             <a:avLst/>
@@ -9015,7 +8987,7 @@
                   <a:srgbClr val="6E7C87"/>
                 </a:solidFill>
               </a:rPr>
-              <a:t>Source: CLICX data room (Sep 2026); AIS, KTB, OR captive data (Apr 2026); Data for Business Strategy (14 Oct 2026)</a:t>
+              <a:t>Source: CLICX, AIS, KTB and OR customer data</a:t>
             </a:r>
             <a:endParaRPr lang="en-US" sz="1000" dirty="0"/>
           </a:p>
@@ -9203,7 +9175,7 @@
                           <a:ea typeface="Arial" pitchFamily="34" charset="-122"/>
                           <a:cs typeface="Arial" pitchFamily="34" charset="-120"/>
                         </a:rPr>
-                        <a:t>Answer</a:t>
+                        <a:t>Short answer</a:t>
                       </a:r>
                       <a:endParaRPr lang="en-US" sz="1200" dirty="0">
                         <a:latin typeface="Arial" charset="0"/>
@@ -9271,7 +9243,7 @@
                           <a:ea typeface="Arial" pitchFamily="34" charset="-122"/>
                           <a:cs typeface="Arial" pitchFamily="34" charset="-120"/>
                         </a:rPr>
-                        <a:t>Evidence</a:t>
+                        <a:t>Why we say so</a:t>
                       </a:r>
                       <a:endParaRPr lang="en-US" sz="1200" dirty="0">
                         <a:latin typeface="Arial" charset="0"/>
@@ -9406,7 +9378,7 @@
                           <a:ea typeface="Arial" pitchFamily="34" charset="-122"/>
                           <a:cs typeface="Arial" pitchFamily="34" charset="-120"/>
                         </a:rPr>
-                        <a:t>Do all CLICX customers come from captive consortium customers?</a:t>
+                        <a:t>Do all CLICX customers come from our partners' customers?</a:t>
                       </a:r>
                       <a:endParaRPr lang="en-US" sz="1200" dirty="0">
                         <a:latin typeface="Arial" charset="0"/>
@@ -9536,7 +9508,7 @@
                           <a:ea typeface="Arial" pitchFamily="34" charset="-122"/>
                           <a:cs typeface="Arial" pitchFamily="34" charset="-120"/>
                         </a:rPr>
-                        <a:t>96% come from the AIS x KTB x OR base; only 51K are outside it. Yet CLICX reaches just 3.7% of the 49M base</a:t>
+                        <a:t>96% were already KTB, AIS or OR customers. Only 51K came from outside. But just 3.7% of partner customers have joined so far</a:t>
                       </a:r>
                       <a:endParaRPr lang="en-US" sz="1200" dirty="0">
                         <a:latin typeface="Arial" charset="0"/>
@@ -9668,7 +9640,7 @@
                           <a:ea typeface="Arial" pitchFamily="34" charset="-122"/>
                           <a:cs typeface="Arial" pitchFamily="34" charset="-120"/>
                         </a:rPr>
-                        <a:t>Are the personas who come the ones we planned for?</a:t>
+                        <a:t>Are our customers the people we planned for?</a:t>
                       </a:r>
                       <a:endParaRPr lang="en-US" sz="1200" dirty="0">
                         <a:latin typeface="Arial" charset="0"/>
@@ -9733,7 +9705,7 @@
                           <a:ea typeface="Arial" pitchFamily="34" charset="-122"/>
                           <a:cs typeface="Arial" pitchFamily="34" charset="-120"/>
                         </a:rPr>
-                        <a:t>Mostly, with gaps</a:t>
+                        <a:t>Mostly</a:t>
                       </a:r>
                       <a:endParaRPr lang="en-US" sz="1300" dirty="0">
                         <a:latin typeface="Arial" charset="0"/>
@@ -9798,7 +9770,7 @@
                           <a:ea typeface="Arial" pitchFamily="34" charset="-122"/>
                           <a:cs typeface="Arial" pitchFamily="34" charset="-120"/>
                         </a:rPr>
-                        <a:t>Tech-Savvy over-index 2.2x and gig workers convert best (Freelancer 40%); Multiple-Bank and 40+ customers under-index</a:t>
+                        <a:t>Tech-savvy people and freelancers sign up far more than others, as planned. People who use several banks and over-40s are hard to win</a:t>
                       </a:r>
                       <a:endParaRPr lang="en-US" sz="1200" dirty="0">
                         <a:latin typeface="Arial" charset="0"/>
@@ -9930,7 +9902,7 @@
                           <a:ea typeface="Arial" pitchFamily="34" charset="-122"/>
                           <a:cs typeface="Arial" pitchFamily="34" charset="-120"/>
                         </a:rPr>
-                        <a:t>Do different personas come for the same or different products?</a:t>
+                        <a:t>Do different customers come for different products?</a:t>
                       </a:r>
                       <a:endParaRPr lang="en-US" sz="1200" dirty="0">
                         <a:latin typeface="Arial" charset="0"/>
@@ -9995,7 +9967,7 @@
                           <a:ea typeface="Arial" pitchFamily="34" charset="-122"/>
                           <a:cs typeface="Arial" pitchFamily="34" charset="-120"/>
                         </a:rPr>
-                        <a:t>Same entry, different use</a:t>
+                        <a:t>Same reason, different use</a:t>
                       </a:r>
                       <a:endParaRPr lang="en-US" sz="1300" dirty="0">
                         <a:latin typeface="Arial" charset="0"/>
@@ -10060,7 +10032,7 @@
                           <a:ea typeface="Arial" pitchFamily="34" charset="-122"/>
                           <a:cs typeface="Arial" pitchFamily="34" charset="-120"/>
                         </a:rPr>
-                        <a:t>84–92% of every occupation apply for a loan; White-collar books loans (11%), Merchants hold deposits (20%), gig workers rarely get booked (5–6%)</a:t>
+                        <a:t>Almost everyone (84–92%) applies for a loan. Office workers get loans, shop owners keep savings, gig workers are mostly turned down</a:t>
                       </a:r>
                       <a:endParaRPr lang="en-US" sz="1200" dirty="0">
                         <a:latin typeface="Arial" charset="0"/>
@@ -10192,7 +10164,7 @@
                           <a:ea typeface="Arial" pitchFamily="34" charset="-122"/>
                           <a:cs typeface="Arial" pitchFamily="34" charset="-120"/>
                         </a:rPr>
-                        <a:t>Is the persona different for active vs inactive customers?</a:t>
+                        <a:t>Are active customers different from inactive ones?</a:t>
                       </a:r>
                       <a:endParaRPr lang="en-US" sz="1200" dirty="0">
                         <a:latin typeface="Arial" charset="0"/>
@@ -10322,7 +10294,7 @@
                           <a:ea typeface="Arial" pitchFamily="34" charset="-122"/>
                           <a:cs typeface="Arial" pitchFamily="34" charset="-120"/>
                         </a:rPr>
-                        <a:t>Active base skews to White-collar and Merchant (65% vs 52%), post-paid and FBB users; inactive skews to Blue-collar, prepaid and unknown</a:t>
+                        <a:t>Active customers are mostly office workers and shop owners with monthly phone bills. Inactive ones are often manual workers or people turned down for a loan</a:t>
                       </a:r>
                       <a:endParaRPr lang="en-US" sz="1200" dirty="0">
                         <a:latin typeface="Arial" charset="0"/>
@@ -10454,7 +10426,7 @@
                           <a:ea typeface="Arial" pitchFamily="34" charset="-122"/>
                           <a:cs typeface="Arial" pitchFamily="34" charset="-120"/>
                         </a:rPr>
-                        <a:t>Does CLICX cannibalize KTB customers or products?</a:t>
+                        <a:t>Do we take customers or products away from KTB?</a:t>
                       </a:r>
                       <a:endParaRPr lang="en-US" sz="1200" dirty="0">
                         <a:latin typeface="Arial" charset="0"/>
@@ -10519,7 +10491,7 @@
                           <a:ea typeface="Arial" pitchFamily="34" charset="-122"/>
                           <a:cs typeface="Arial" pitchFamily="34" charset="-120"/>
                         </a:rPr>
-                        <a:t>Limited</a:t>
+                        <a:t>Very little</a:t>
                       </a:r>
                       <a:endParaRPr lang="en-US" sz="1300" dirty="0">
                         <a:latin typeface="Arial" charset="0"/>
@@ -10584,7 +10556,7 @@
                           <a:ea typeface="Arial" pitchFamily="34" charset="-122"/>
                           <a:cs typeface="Arial" pitchFamily="34" charset="-120"/>
                         </a:rPr>
-                        <a:t>Only 13% of overlap (212K) are KTB-loyal; 61% are competitor-loyal or KTB-inactive. 116K CLICX borrowers have no KTB Jai-pump loan</a:t>
+                        <a:t>Only 13% of shared customers are loyal to KTB. Most used other banks or had stopped using KTB. 116K of our borrowers have no KTB loan</a:t>
                       </a:r>
                       <a:endParaRPr lang="en-US" sz="1200" dirty="0">
                         <a:latin typeface="Arial" charset="0"/>
@@ -10739,7 +10711,7 @@
                   <a:schemeClr val="accent1"/>
                 </a:solidFill>
               </a:rPr>
-              <a:t>Q1  |  SOURCE OF CUSTOMERS</a:t>
+              <a:t>Q1  |  WHERE CUSTOMERS COME FROM</a:t>
             </a:r>
             <a:endParaRPr lang="en-US" sz="1100" dirty="0"/>
           </a:p>
@@ -10777,7 +10749,7 @@
                   <a:schemeClr val="tx2"/>
                 </a:solidFill>
               </a:rPr>
-              <a:t>Do all current CLICX customers come from captive consortium customers?</a:t>
+              <a:t>Do all current CLICX customers come from our partners' customers?</a:t>
             </a:r>
             <a:endParaRPr lang="en-US" sz="2400" dirty="0"/>
           </a:p>
@@ -10815,7 +10787,7 @@
                   <a:schemeClr val="tx1"/>
                 </a:solidFill>
               </a:rPr>
-              <a:t>Almost all: 96% of CLICX customers already bank, phone or fill up with KTB, AIS or OR; only 51K come from outside. But the consortium is far from tapped, with only 3.7% penetration</a:t>
+              <a:t>Almost all. 96% were already customers of KTB, AIS or OR, and only 51K came from outside. Yet only 3.7% of partner customers have joined, so there is plenty of room to grow</a:t>
             </a:r>
             <a:endParaRPr lang="en-US" sz="1600" dirty="0"/>
           </a:p>
@@ -10831,8 +10803,8 @@
         </p:nvSpPr>
         <p:spPr>
           <a:xfrm>
-            <a:off x="457200" y="6236208"/>
-            <a:ext cx="10241280" cy="411480"/>
+            <a:off x="457200" y="6327648"/>
+            <a:ext cx="10241280" cy="274320"/>
           </a:xfrm>
           <a:prstGeom prst="rect">
             <a:avLst/>
@@ -10853,21 +10825,7 @@
                   <a:srgbClr val="6E7C87"/>
                 </a:solidFill>
               </a:rPr>
-              <a:t>Note: one customer can belong to several partners, so partner shares add up to 195%. Penetration = CLICX customers ÷ partner customer base. 85% of CLICX customers gave consent for data matching</a:t>
-            </a:r>
-            <a:endParaRPr lang="en-US" sz="1000" dirty="0"/>
-          </a:p>
-          <a:p>
-            <a:pPr indent="0" marL="0">
-              <a:buNone/>
-            </a:pPr>
-            <a:r>
-              <a:rPr lang="en-US" sz="1000" dirty="0">
-                <a:solidFill>
-                  <a:srgbClr val="6E7C87"/>
-                </a:solidFill>
-              </a:rPr>
-              <a:t>Source: CLICX data (Sep 2026); AIS, KTB, OR data (Apr 2026)</a:t>
+              <a:t>Source: CLICX customer data (Sep 2026); AIS, KTB, OR customer data (Apr 2026)</a:t>
             </a:r>
             <a:endParaRPr lang="en-US" sz="1000" dirty="0"/>
           </a:p>
@@ -10939,7 +10897,7 @@
                   <a:schemeClr val="tx1"/>
                 </a:solidFill>
               </a:rPr>
-              <a:t>of 1.8M CLICX customers come from the consortium base</a:t>
+              <a:t>of our 1.8M customers were already partner customers</a:t>
             </a:r>
             <a:endParaRPr lang="en-US" sz="1200" dirty="0"/>
           </a:p>
@@ -11011,7 +10969,7 @@
                   <a:schemeClr val="tx1"/>
                 </a:solidFill>
               </a:rPr>
-              <a:t>CLICX customers who are not AIS, KTB or OR customers</a:t>
+              <a:t>customers came from outside our partners</a:t>
             </a:r>
             <a:endParaRPr lang="en-US" sz="1200" dirty="0"/>
           </a:p>
@@ -11083,7 +11041,7 @@
                   <a:schemeClr val="tx1"/>
                 </a:solidFill>
               </a:rPr>
-              <a:t>of the 49M consortium base is on CLICX so far</a:t>
+              <a:t>of 49M partner customers have joined CLICX</a:t>
             </a:r>
             <a:endParaRPr lang="en-US" sz="1200" dirty="0"/>
           </a:p>
@@ -11250,7 +11208,7 @@
                   <a:schemeClr val="tx2"/>
                 </a:solidFill>
               </a:rPr>
-              <a:t>KTB is the main gateway</a:t>
+              <a:t>KTB is the front door</a:t>
             </a:r>
             <a:endParaRPr lang="en-US" sz="1400" dirty="0"/>
           </a:p>
@@ -11267,7 +11225,7 @@
                   <a:schemeClr val="tx1"/>
                 </a:solidFill>
               </a:rPr>
-              <a:t>88% of CLICX customers are KTB customers (1.6M), helped by Paotang onboarding</a:t>
+              <a:t>9 in 10 of our customers bank with KTB, mostly joining through the Paotang app</a:t>
             </a:r>
             <a:endParaRPr lang="en-US" sz="1400" dirty="0"/>
           </a:p>
@@ -11362,7 +11320,7 @@
                   <a:schemeClr val="tx2"/>
                 </a:solidFill>
               </a:rPr>
-              <a:t>Customers sit in several partners</a:t>
+              <a:t>Most know us through 2+ partners</a:t>
             </a:r>
             <a:endParaRPr lang="en-US" sz="1400" dirty="0"/>
           </a:p>
@@ -11379,7 +11337,7 @@
                   <a:schemeClr val="tx1"/>
                 </a:solidFill>
               </a:rPr>
-              <a:t>Shares add up to 195%: most customers are known to 2+ partners, giving rich data for credit</a:t>
+              <a:t>That gives us more data to judge who to lend to and what else to offer</a:t>
             </a:r>
             <a:endParaRPr lang="en-US" sz="1400" dirty="0"/>
           </a:p>
@@ -11474,7 +11432,7 @@
                   <a:schemeClr val="tx2"/>
                 </a:solidFill>
               </a:rPr>
-              <a:t>AIS is the biggest headroom</a:t>
+              <a:t>AIS is the biggest opportunity</a:t>
             </a:r>
             <a:endParaRPr lang="en-US" sz="1400" dirty="0"/>
           </a:p>
@@ -11491,7 +11449,7 @@
                   <a:schemeClr val="tx1"/>
                 </a:solidFill>
               </a:rPr>
-              <a:t>Lowest penetration (3.7%) on the largest base (~32M). OR converts best at 7.4%, KTB 4.7%</a:t>
+              <a:t>Only 3.7% of AIS's ~32M customers have joined, against 7.4% for OR and 4.7% for KTB</a:t>
             </a:r>
             <a:endParaRPr lang="en-US" sz="1400" dirty="0"/>
           </a:p>
@@ -11599,7 +11557,7 @@
                   <a:schemeClr val="accent1"/>
                 </a:solidFill>
               </a:rPr>
-              <a:t>Q2  |  PERSONAS VS PLAN  (1/3)</a:t>
+              <a:t>Q2  |  WHO OUR CUSTOMERS ARE  (1/3)</a:t>
             </a:r>
             <a:endParaRPr lang="en-US" sz="1100" dirty="0"/>
           </a:p>
@@ -11637,7 +11595,7 @@
                   <a:schemeClr val="tx2"/>
                 </a:solidFill>
               </a:rPr>
-              <a:t>Are the personas of customers who come to CLICX the same as we planned?</a:t>
+              <a:t>Are the people who come to CLICX the ones we planned for?</a:t>
             </a:r>
             <a:endParaRPr lang="en-US" sz="2400" dirty="0"/>
           </a:p>
@@ -11675,7 +11633,7 @@
                   <a:schemeClr val="tx1"/>
                 </a:solidFill>
               </a:rPr>
-              <a:t>Mostly yes. The planned Tech-Savvy target over-indexes 2.2x and Single-Bank users bring the volume, but Multiple-Bank users, also a target, are under-won</a:t>
+              <a:t>Mostly yes. Tech-savvy people, our main target, join at twice the average rate, and one-bank users bring the most customers. People who use several banks are not yet won</a:t>
             </a:r>
             <a:endParaRPr lang="en-US" sz="1600" dirty="0"/>
           </a:p>
@@ -11691,8 +11649,8 @@
         </p:nvSpPr>
         <p:spPr>
           <a:xfrm>
-            <a:off x="457200" y="6236208"/>
-            <a:ext cx="10241280" cy="411480"/>
+            <a:off x="457200" y="6327648"/>
+            <a:ext cx="10241280" cy="274320"/>
           </a:xfrm>
           <a:prstGeom prst="rect">
             <a:avLst/>
@@ -11713,21 +11671,7 @@
                   <a:srgbClr val="6E7C87"/>
                 </a:solidFill>
               </a:rPr>
-              <a:t>Note: personas assigned by AIS and KTB. Single-Bank = uses one bank, or KTB customer holding Next but inactive. Penetration = CLICX customers ÷ consortium customers in that persona</a:t>
-            </a:r>
-            <a:endParaRPr lang="en-US" sz="1000" dirty="0"/>
-          </a:p>
-          <a:p>
-            <a:pPr indent="0" marL="0">
-              <a:buNone/>
-            </a:pPr>
-            <a:r>
-              <a:rPr lang="en-US" sz="1000" dirty="0">
-                <a:solidFill>
-                  <a:srgbClr val="6E7C87"/>
-                </a:solidFill>
-              </a:rPr>
-              <a:t>Source: CLICX data (Sep 2026); AIS, KTB, OR data (Apr 2026); initial target persona benchmark</a:t>
+              <a:t>Source: CLICX customer data (Sep 2026); AIS, KTB, OR customer data (Apr 2026)</a:t>
             </a:r>
             <a:endParaRPr lang="en-US" sz="1000" dirty="0"/>
           </a:p>
@@ -11894,7 +11838,7 @@
                   <a:schemeClr val="tx2"/>
                 </a:solidFill>
               </a:rPr>
-              <a:t>Tech-Savvy: target hit</a:t>
+              <a:t>Tech-savvy: target hit</a:t>
             </a:r>
             <a:endParaRPr lang="en-US" sz="1400" dirty="0"/>
           </a:p>
@@ -11911,7 +11855,7 @@
                   <a:schemeClr val="tx1"/>
                 </a:solidFill>
               </a:rPr>
-              <a:t>533K customers, 28% of CLICX from 13% of the base; penetration 8.5% (2.2x average), peaking at 13% for ages 30–34</a:t>
+              <a:t>28% of our customers vs 13% of partner customers. Best of all at ages 30–34, where 13% have joined</a:t>
             </a:r>
             <a:endParaRPr lang="en-US" sz="1400" dirty="0"/>
           </a:p>
@@ -12006,7 +11950,7 @@
                   <a:schemeClr val="tx2"/>
                 </a:solidFill>
               </a:rPr>
-              <a:t>Single-Bank: volume engine</a:t>
+              <a:t>One-bank users: the biggest group</a:t>
             </a:r>
             <a:endParaRPr lang="en-US" sz="1400" dirty="0"/>
           </a:p>
@@ -12023,7 +11967,7 @@
                   <a:schemeClr val="tx1"/>
                 </a:solidFill>
               </a:rPr>
-              <a:t>850K (45% of CLICX). 577K are KTB customers without AIS, a pool to cross-sell AIS</a:t>
+              <a:t>850K customers, almost half of CLICX. 577K are KTB customers who do not use AIS</a:t>
             </a:r>
             <a:endParaRPr lang="en-US" sz="1400" dirty="0"/>
           </a:p>
@@ -12118,7 +12062,7 @@
                   <a:schemeClr val="tx2"/>
                 </a:solidFill>
               </a:rPr>
-              <a:t>Multiple-Bank: the miss</a:t>
+              <a:t>Multi-bank users: not won yet</a:t>
             </a:r>
             <a:endParaRPr lang="en-US" sz="1400" dirty="0"/>
           </a:p>
@@ -12135,7 +12079,7 @@
                   <a:schemeClr val="tx1"/>
                 </a:solidFill>
               </a:rPr>
-              <a:t>8.2M base but only 2.4% penetration. CLICX is not yet winning customers who already shop around banks</a:t>
+              <a:t>8.2M people, but only 2.4% have joined. People who already shop around need a stronger reason</a:t>
             </a:r>
             <a:endParaRPr lang="en-US" sz="1400" dirty="0"/>
           </a:p>
@@ -12243,7 +12187,7 @@
                   <a:schemeClr val="accent1"/>
                 </a:solidFill>
               </a:rPr>
-              <a:t>Q2  |  PERSONAS VS PLAN  (2/3)</a:t>
+              <a:t>Q2  |  WHO OUR CUSTOMERS ARE  (2/3)</a:t>
             </a:r>
             <a:endParaRPr lang="en-US" sz="1100" dirty="0"/>
           </a:p>
@@ -12281,7 +12225,7 @@
                   <a:schemeClr val="tx2"/>
                 </a:solidFill>
               </a:rPr>
-              <a:t>Does the age profile of CLICX customers match the target pool?</a:t>
+              <a:t>Do our customers' ages match the people we can reach?</a:t>
             </a:r>
             <a:endParaRPr lang="en-US" sz="2400" dirty="0"/>
           </a:p>
@@ -12319,7 +12263,7 @@
                   <a:schemeClr val="tx1"/>
                 </a:solidFill>
               </a:rPr>
-              <a:t>No. The target pool skews older, but CLICX concentrates in ages 25–39: 56% of customers vs 29% of the base. Penetration falls off sharply after 45</a:t>
+              <a:t>No. Most partner customers are over 40, but most of ours are 25–39 (56% of CLICX vs 29% of partner customers). Few people over 45 join</a:t>
             </a:r>
             <a:endParaRPr lang="en-US" sz="1600" dirty="0"/>
           </a:p>
@@ -12335,8 +12279,8 @@
         </p:nvSpPr>
         <p:spPr>
           <a:xfrm>
-            <a:off x="457200" y="6236208"/>
-            <a:ext cx="10241280" cy="411480"/>
+            <a:off x="457200" y="6327648"/>
+            <a:ext cx="10241280" cy="274320"/>
           </a:xfrm>
           <a:prstGeom prst="rect">
             <a:avLst/>
@@ -12357,21 +12301,7 @@
                   <a:srgbClr val="6E7C87"/>
                 </a:solidFill>
               </a:rPr>
-              <a:t>Note: base share excludes 4.7M consortium customers of unknown age; penetration = CLICX customers ÷ captive customers in that age band</a:t>
-            </a:r>
-            <a:endParaRPr lang="en-US" sz="1000" dirty="0"/>
-          </a:p>
-          <a:p>
-            <a:pPr indent="0" marL="0">
-              <a:buNone/>
-            </a:pPr>
-            <a:r>
-              <a:rPr lang="en-US" sz="1000" dirty="0">
-                <a:solidFill>
-                  <a:srgbClr val="6E7C87"/>
-                </a:solidFill>
-              </a:rPr>
-              <a:t>Source: CLICX data (Sep 2026); AIS, KTB, OR data (Apr 2026)</a:t>
+              <a:t>Source: CLICX customer data (Sep 2026); AIS, KTB, OR customer data (Apr 2026)</a:t>
             </a:r>
             <a:endParaRPr lang="en-US" sz="1000" dirty="0"/>
           </a:p>
@@ -12538,7 +12468,7 @@
                   <a:schemeClr val="tx2"/>
                 </a:solidFill>
               </a:rPr>
-              <a:t>Sweet spot is 25–39</a:t>
+              <a:t>25–39 is our sweet spot</a:t>
             </a:r>
             <a:endParaRPr lang="en-US" sz="1400" dirty="0"/>
           </a:p>
@@ -12555,7 +12485,7 @@
                   <a:schemeClr val="tx1"/>
                 </a:solidFill>
               </a:rPr>
-              <a:t>1.05M customers (56% of CLICX); penetration of 8–9% vs 3.8% overall</a:t>
+              <a:t>1.05M customers. About 8–9% of people this age have joined, more than twice the average</a:t>
             </a:r>
             <a:endParaRPr lang="en-US" sz="1400" dirty="0"/>
           </a:p>
@@ -12650,7 +12580,7 @@
                   <a:schemeClr val="tx2"/>
                 </a:solidFill>
               </a:rPr>
-              <a:t>Older base is untouched</a:t>
+              <a:t>Older customers are untouched</a:t>
             </a:r>
             <a:endParaRPr lang="en-US" sz="1400" dirty="0"/>
           </a:p>
@@ -12667,7 +12597,7 @@
                   <a:schemeClr val="tx1"/>
                 </a:solidFill>
               </a:rPr>
-              <a:t>Customers aged 40+ make up 58% of the known-age base but only 34% of CLICX; 60+ penetration is 0.3% on 9.4M people</a:t>
+              <a:t>Over-40s are 58% of partner customers but 34% of ours. Only 0.3% of 9.4M over-60s have joined</a:t>
             </a:r>
             <a:endParaRPr lang="en-US" sz="1400" dirty="0"/>
           </a:p>
@@ -12762,7 +12692,7 @@
                   <a:schemeClr val="tx2"/>
                 </a:solidFill>
               </a:rPr>
-              <a:t>Room left in the core</a:t>
+              <a:t>Plenty left in our core group</a:t>
             </a:r>
             <a:endParaRPr lang="en-US" sz="1400" dirty="0"/>
           </a:p>
@@ -12779,7 +12709,7 @@
                   <a:schemeClr val="tx1"/>
                 </a:solidFill>
               </a:rPr>
-              <a:t>2.1M unconverted Tech-Savvy aged 25–39, 1.3M young tech users under 25 and 5.4M Single-Bank millennials</a:t>
+              <a:t>2.1M tech-savvy 25–39s and 5.4M one-bank 25–39s have not joined yet</a:t>
             </a:r>
             <a:endParaRPr lang="en-US" sz="1400" dirty="0"/>
           </a:p>
@@ -12887,7 +12817,7 @@
                   <a:schemeClr val="accent1"/>
                 </a:solidFill>
               </a:rPr>
-              <a:t>Q2  |  PERSONAS VS PLAN  (3/3)</a:t>
+              <a:t>Q2  |  WHO OUR CUSTOMERS ARE  (3/3)</a:t>
             </a:r>
             <a:endParaRPr lang="en-US" sz="1100" dirty="0"/>
           </a:p>
@@ -12925,7 +12855,7 @@
                   <a:schemeClr val="tx2"/>
                 </a:solidFill>
               </a:rPr>
-              <a:t>Are we reaching the thin-file, real-income customers our strategy targets?</a:t>
+              <a:t>Are we reaching people with real income but no payslip, as our strategy says?</a:t>
             </a:r>
             <a:endParaRPr lang="en-US" sz="2400" dirty="0"/>
           </a:p>
@@ -12963,7 +12893,7 @@
                   <a:schemeClr val="tx1"/>
                 </a:solidFill>
               </a:rPr>
-              <a:t>Yes. Gig workers convert 5–10x better than average (Freelancer 40%, Rider/Driver 22%), and unserved/underserved borrowers are 35% of loans vs a 30% target</a:t>
+              <a:t>Yes. Freelancers (40%) and riders/drivers (22%) join far more than anyone else, and 35% of our loans go to people banks usually turn away, above our 30% goal</a:t>
             </a:r>
             <a:endParaRPr lang="en-US" sz="1600" dirty="0"/>
           </a:p>
@@ -12979,8 +12909,8 @@
         </p:nvSpPr>
         <p:spPr>
           <a:xfrm>
-            <a:off x="457200" y="6236208"/>
-            <a:ext cx="10241280" cy="411480"/>
+            <a:off x="457200" y="6327648"/>
+            <a:ext cx="10241280" cy="274320"/>
           </a:xfrm>
           <a:prstGeom prst="rect">
             <a:avLst/>
@@ -13001,21 +12931,7 @@
                   <a:srgbClr val="6E7C87"/>
                 </a:solidFill>
               </a:rPr>
-              <a:t>Note: occupation from AIS x KTB x OR x CLICX matched data; penetration = CLICX customers ÷ captive customers in that occupation; Others = unknown occupation</a:t>
-            </a:r>
-            <a:endParaRPr lang="en-US" sz="1000" dirty="0"/>
-          </a:p>
-          <a:p>
-            <a:pPr indent="0" marL="0">
-              <a:buNone/>
-            </a:pPr>
-            <a:r>
-              <a:rPr lang="en-US" sz="1000" dirty="0">
-                <a:solidFill>
-                  <a:srgbClr val="6E7C87"/>
-                </a:solidFill>
-              </a:rPr>
-              <a:t>Source: Data team occupation analysis (Oct 2026); CLICX 5-Year Business Plan scorecard (Dec 2026 target)</a:t>
+              <a:t>Source: CLICX, AIS, KTB, OR matched occupation data (Oct 2026); CLICX 5-Year Business Plan</a:t>
             </a:r>
             <a:endParaRPr lang="en-US" sz="1000" dirty="0"/>
           </a:p>
@@ -13182,7 +13098,7 @@
                   <a:schemeClr val="tx2"/>
                 </a:solidFill>
               </a:rPr>
-              <a:t>Gig workers: best fit</a:t>
+              <a:t>Gig workers love CLICX</a:t>
             </a:r>
             <a:endParaRPr lang="en-US" sz="1400" dirty="0"/>
           </a:p>
@@ -13199,7 +13115,7 @@
                   <a:schemeClr val="tx1"/>
                 </a:solidFill>
               </a:rPr>
-              <a:t>Freelancers and riders convert at 40% and 22% of their small captive pools, which validates the alternative-data lending thesis</a:t>
+              <a:t>4 in 10 freelancers and 2 in 10 riders we can reach have joined. Proof that lending on phone and spending data works</a:t>
             </a:r>
             <a:endParaRPr lang="en-US" sz="1400" dirty="0"/>
           </a:p>
@@ -13294,7 +13210,7 @@
                   <a:schemeClr val="tx2"/>
                 </a:solidFill>
               </a:rPr>
-              <a:t>Collars: the volume</a:t>
+              <a:t>Workers are the bulk</a:t>
             </a:r>
             <a:endParaRPr lang="en-US" sz="1400" dirty="0"/>
           </a:p>
@@ -13311,7 +13227,7 @@
                   <a:schemeClr val="tx1"/>
                 </a:solidFill>
               </a:rPr>
-              <a:t>White- and Blue-collar make up 1.1M customers, over 60% of the portfolio</a:t>
+              <a:t>Office and manual workers are 1.1M customers, over 60% of CLICX</a:t>
             </a:r>
             <a:endParaRPr lang="en-US" sz="1400" dirty="0"/>
           </a:p>
@@ -13406,7 +13322,7 @@
                   <a:schemeClr val="tx2"/>
                 </a:solidFill>
               </a:rPr>
-              <a:t>Merchants: proven, not scaled</a:t>
+              <a:t>Shop owners: room to grow</a:t>
             </a:r>
             <a:endParaRPr lang="en-US" sz="1400" dirty="0"/>
           </a:p>
@@ -13423,7 +13339,7 @@
                   <a:schemeClr val="tx1"/>
                 </a:solidFill>
               </a:rPr>
-              <a:t>293K customers at 9% penetration from a 3.3M base, an entry point for SME supply-chain financing</a:t>
+              <a:t>293K have joined out of 3.3M. A route into small-business loans</a:t>
             </a:r>
             <a:endParaRPr lang="en-US" sz="1400" dirty="0"/>
           </a:p>
@@ -13531,7 +13447,7 @@
                   <a:schemeClr val="accent1"/>
                 </a:solidFill>
               </a:rPr>
-              <a:t>Q3  |  PERSONA x PRODUCT</a:t>
+              <a:t>Q3  |  WHAT THEY COME FOR</a:t>
             </a:r>
             <a:endParaRPr lang="en-US" sz="1100" dirty="0"/>
           </a:p>
@@ -13569,7 +13485,7 @@
                   <a:schemeClr val="tx2"/>
                 </a:solidFill>
               </a:rPr>
-              <a:t>For different customer personas, do they come for the same or different products?</a:t>
+              <a:t>Do different types of customer come for the same product or different ones?</a:t>
             </a:r>
             <a:endParaRPr lang="en-US" sz="2400" dirty="0"/>
           </a:p>
@@ -13607,7 +13523,7 @@
                   <a:schemeClr val="tx1"/>
                 </a:solidFill>
               </a:rPr>
-              <a:t>They come for the same thing, credit: 84–92% of every occupation applies for a loan. What they end up using differs: White-collar books loans, Merchants keep deposits, gig workers are mostly declined</a:t>
+              <a:t>The same: almost everyone comes to borrow. But what they end up using differs. Office workers get loans, shop owners keep savings, and gig workers are mostly turned down</a:t>
             </a:r>
             <a:endParaRPr lang="en-US" sz="1600" dirty="0"/>
           </a:p>
@@ -13623,8 +13539,8 @@
         </p:nvSpPr>
         <p:spPr>
           <a:xfrm>
-            <a:off x="457200" y="6236208"/>
-            <a:ext cx="10241280" cy="411480"/>
+            <a:off x="457200" y="6327648"/>
+            <a:ext cx="10241280" cy="274320"/>
           </a:xfrm>
           <a:prstGeom prst="rect">
             <a:avLst/>
@@ -13645,21 +13561,7 @@
                   <a:srgbClr val="6E7C87"/>
                 </a:solidFill>
               </a:rPr>
-              <a:t>Note: % of CLICX customers in each occupation. Deposit = balance &gt; 0; Payment = transacted in Sep 2026; Loan booked = loan disbursed</a:t>
-            </a:r>
-            <a:endParaRPr lang="en-US" sz="1000" dirty="0"/>
-          </a:p>
-          <a:p>
-            <a:pPr indent="0" marL="0">
-              <a:buNone/>
-            </a:pPr>
-            <a:r>
-              <a:rPr lang="en-US" sz="1000" dirty="0">
-                <a:solidFill>
-                  <a:srgbClr val="6E7C87"/>
-                </a:solidFill>
-              </a:rPr>
-              <a:t>Source: Data team occupation analysis, AIS x KTB x OR x CLICX (Oct 2026)</a:t>
+              <a:t>Source: CLICX, AIS, KTB, OR matched occupation data (Oct 2026)</a:t>
             </a:r>
             <a:endParaRPr lang="en-US" sz="1000" dirty="0"/>
           </a:p>
@@ -13731,7 +13633,7 @@
                   <a:schemeClr val="tx1"/>
                 </a:solidFill>
               </a:rPr>
-              <a:t>of every occupation applied for a CLICX loan: the same entry product</a:t>
+              <a:t>of every job type applied for a CLICX loan</a:t>
             </a:r>
             <a:endParaRPr lang="en-US" sz="1200" dirty="0"/>
           </a:p>
@@ -13803,7 +13705,7 @@
                   <a:schemeClr val="tx1"/>
                 </a:solidFill>
               </a:rPr>
-              <a:t>actually had a loan booked, so usage splits by persona</a:t>
+              <a:t>actually got a loan</a:t>
             </a:r>
             <a:endParaRPr lang="en-US" sz="1200" dirty="0"/>
           </a:p>
@@ -13970,7 +13872,7 @@
                   <a:schemeClr val="tx2"/>
                 </a:solidFill>
               </a:rPr>
-              <a:t>Credit is the hook for all</a:t>
+              <a:t>Loans bring everyone in</a:t>
             </a:r>
             <a:endParaRPr lang="en-US" sz="1400" dirty="0"/>
           </a:p>
@@ -13987,7 +13889,7 @@
                   <a:schemeClr val="tx1"/>
                 </a:solidFill>
               </a:rPr>
-              <a:t>1.52M customers (84%) have applied for a loan, whatever their occupation</a:t>
+              <a:t>1.52M customers (84%) have applied for a loan, whatever their job</a:t>
             </a:r>
             <a:endParaRPr lang="en-US" sz="1400" dirty="0"/>
           </a:p>
@@ -14082,7 +13984,7 @@
                   <a:schemeClr val="tx2"/>
                 </a:solidFill>
               </a:rPr>
-              <a:t>White-collar: borrow and pay</a:t>
+              <a:t>Office workers use the most</a:t>
             </a:r>
             <a:endParaRPr lang="en-US" sz="1400" dirty="0"/>
           </a:p>
@@ -14099,7 +14001,7 @@
                   <a:schemeClr val="tx1"/>
                 </a:solidFill>
               </a:rPr>
-              <a:t>Highest booking rate (11%, 79K loans) and 14% pay monthly. The most complete product user</a:t>
+              <a:t>Most likely to get a loan (11%) and to pay with CLICX (14%)</a:t>
             </a:r>
             <a:endParaRPr lang="en-US" sz="1400" dirty="0"/>
           </a:p>
@@ -14194,7 +14096,7 @@
                   <a:schemeClr val="tx2"/>
                 </a:solidFill>
               </a:rPr>
-              <a:t>Merchant: deposits</a:t>
+              <a:t>Shop owners save</a:t>
             </a:r>
             <a:endParaRPr lang="en-US" sz="1400" dirty="0"/>
           </a:p>
@@ -14211,7 +14113,7 @@
                   <a:schemeClr val="tx1"/>
                 </a:solidFill>
               </a:rPr>
-              <a:t>Highest deposit rate (20%) and payment use (14%), a natural fit for business accounts and SME credit</a:t>
+              <a:t>Most likely to keep money with us (20%), a natural fit for business accounts and loans</a:t>
             </a:r>
             <a:endParaRPr lang="en-US" sz="1400" dirty="0"/>
           </a:p>
@@ -14306,7 +14208,7 @@
                   <a:schemeClr val="tx2"/>
                 </a:solidFill>
               </a:rPr>
-              <a:t>Gig and Blue-collar: leakage</a:t>
+              <a:t>Gig workers get turned down</a:t>
             </a:r>
             <a:endParaRPr lang="en-US" sz="1400" dirty="0"/>
           </a:p>
@@ -14323,7 +14225,7 @@
                   <a:schemeClr val="tx1"/>
                 </a:solidFill>
               </a:rPr>
-              <a:t>Over 90% apply, but only 5–7% are booked. Underwriting, not demand, is the bottleneck</a:t>
+              <a:t>Over 90% apply but only 5–7% get a loan. The problem is our approval rules, not demand</a:t>
             </a:r>
             <a:endParaRPr lang="en-US" sz="1400" dirty="0"/>
           </a:p>
@@ -14431,7 +14333,7 @@
                   <a:schemeClr val="accent1"/>
                 </a:solidFill>
               </a:rPr>
-              <a:t>Q4  |  ACTIVE VS INACTIVE  (1/2)</a:t>
+              <a:t>Q4  |  WHO KEEPS USING US  (1/2)</a:t>
             </a:r>
             <a:endParaRPr lang="en-US" sz="1100" dirty="0"/>
           </a:p>
@@ -14469,7 +14371,7 @@
                   <a:schemeClr val="tx2"/>
                 </a:solidFill>
               </a:rPr>
-              <a:t>For active vs inactive CLICX customers, is the persona different?</a:t>
+              <a:t>Are active CLICX customers a different type of person from inactive ones?</a:t>
             </a:r>
             <a:endParaRPr lang="en-US" sz="2400" dirty="0"/>
           </a:p>
@@ -14507,7 +14409,7 @@
                   <a:schemeClr val="tx1"/>
                 </a:solidFill>
               </a:rPr>
-              <a:t>Yes. Only 1 in 5 customers is active, and the active base skews to salaried White-collar and Merchants, while inactive customers skew to Blue-collar and unknown occupations</a:t>
+              <a:t>Yes. Only 1 in 5 customers is active (has money in CLICX or a CLICX loan). Active customers are mostly office workers and shop owners; inactive ones are more often manual workers</a:t>
             </a:r>
             <a:endParaRPr lang="en-US" sz="1600" dirty="0"/>
           </a:p>
@@ -14523,8 +14425,8 @@
         </p:nvSpPr>
         <p:spPr>
           <a:xfrm>
-            <a:off x="457200" y="6236208"/>
-            <a:ext cx="10241280" cy="411480"/>
+            <a:off x="457200" y="6327648"/>
+            <a:ext cx="10241280" cy="274320"/>
           </a:xfrm>
           <a:prstGeom prst="rect">
             <a:avLst/>
@@ -14545,21 +14447,7 @@
                   <a:srgbClr val="6E7C87"/>
                 </a:solidFill>
               </a:rPr>
-              <a:t>Note: Active = CLICX deposit &gt; 0 or a booked CLICX loan. Inactive = all other CLICX customers. Totals: active 358K, inactive 1,462K. Labels show each occupation's active rate</a:t>
-            </a:r>
-            <a:endParaRPr lang="en-US" sz="1000" dirty="0"/>
-          </a:p>
-          <a:p>
-            <a:pPr indent="0" marL="0">
-              <a:buNone/>
-            </a:pPr>
-            <a:r>
-              <a:rPr lang="en-US" sz="1000" dirty="0">
-                <a:solidFill>
-                  <a:srgbClr val="6E7C87"/>
-                </a:solidFill>
-              </a:rPr>
-              <a:t>Source: Data team occupation analysis, AIS x KTB x OR x CLICX (Oct 2026)</a:t>
+              <a:t>Source: CLICX, AIS, KTB, OR matched occupation data (Oct 2026)</a:t>
             </a:r>
             <a:endParaRPr lang="en-US" sz="1000" dirty="0"/>
           </a:p>
@@ -14726,7 +14614,7 @@
                   <a:schemeClr val="tx2"/>
                 </a:solidFill>
               </a:rPr>
-              <a:t>Salaried and Merchants stay</a:t>
+              <a:t>Office workers and shop owners stay</a:t>
             </a:r>
             <a:endParaRPr lang="en-US" sz="1400" dirty="0"/>
           </a:p>
@@ -14743,7 +14631,7 @@
                   <a:schemeClr val="tx1"/>
                 </a:solidFill>
               </a:rPr>
-              <a:t>White-collar and Merchant make up 65% of active customers but 52% of inactive ones, with an active rate of 23% each</a:t>
+              <a:t>65% of active customers vs 52% of inactive ones. About 1 in 4 of them is active</a:t>
             </a:r>
             <a:endParaRPr lang="en-US" sz="1400" dirty="0"/>
           </a:p>
@@ -14838,7 +14726,7 @@
                   <a:schemeClr val="tx2"/>
                 </a:solidFill>
               </a:rPr>
-              <a:t>Blue-collar drops out</a:t>
+              <a:t>Manual workers drift away</a:t>
             </a:r>
             <a:endParaRPr lang="en-US" sz="1400" dirty="0"/>
           </a:p>
@@ -14855,7 +14743,7 @@
                   <a:schemeClr val="tx1"/>
                 </a:solidFill>
               </a:rPr>
-              <a:t>23% of inactive customers vs 18% of active ones. They apply for credit, get declined and leave</a:t>
+              <a:t>They apply for a loan, get turned down and stop using CLICX</a:t>
             </a:r>
             <a:endParaRPr lang="en-US" sz="1400" dirty="0"/>
           </a:p>
@@ -14950,7 +14838,7 @@
                   <a:schemeClr val="tx2"/>
                 </a:solidFill>
               </a:rPr>
-              <a:t>Unknown means inactive</a:t>
+              <a:t>Unknown job, unknown customer</a:t>
             </a:r>
             <a:endParaRPr lang="en-US" sz="1400" dirty="0"/>
           </a:p>
@@ -14967,7 +14855,7 @@
                   <a:schemeClr val="tx1"/>
                 </a:solidFill>
               </a:rPr>
-              <a:t>Customers with no occupation data are only 8% active, and 3 in 4 inactive customers never got a loan or funded an account</a:t>
+              <a:t>Only 8% are active. Most inactive customers never got a loan or put money in</a:t>
             </a:r>
             <a:endParaRPr lang="en-US" sz="1400" dirty="0"/>
           </a:p>
@@ -15075,7 +14963,7 @@
                   <a:schemeClr val="accent1"/>
                 </a:solidFill>
               </a:rPr>
-              <a:t>Q4  |  ACTIVE VS INACTIVE  (2/2)</a:t>
+              <a:t>Q4  |  WHO KEEPS USING US  (2/2)</a:t>
             </a:r>
             <a:endParaRPr lang="en-US" sz="1100" dirty="0"/>
           </a:p>
@@ -15113,7 +15001,7 @@
                   <a:schemeClr val="tx2"/>
                 </a:solidFill>
               </a:rPr>
-              <a:t>What else separates active from inactive customers?</a:t>
+              <a:t>What else separates active customers from inactive ones?</a:t>
             </a:r>
             <a:endParaRPr lang="en-US" sz="2400" dirty="0"/>
           </a:p>
@@ -15151,7 +15039,7 @@
                   <a:schemeClr val="tx1"/>
                 </a:solidFill>
               </a:rPr>
-              <a:t>Value-tier telco users and borrowers stay active. FBB and post-paid AIS customers are 2–4x more active than AIS-inactive ones, and borrowers pay 6x more often than declined depositors</a:t>
+              <a:t>Two things: how they pay for their phone and whether they got a loan. Monthly-bill AIS customers are 3x more active than lapsed ones, and borrowers pay with CLICX 6x more often</a:t>
             </a:r>
             <a:endParaRPr lang="en-US" sz="1600" dirty="0"/>
           </a:p>
@@ -15167,8 +15055,8 @@
         </p:nvSpPr>
         <p:spPr>
           <a:xfrm>
-            <a:off x="457200" y="6236208"/>
-            <a:ext cx="10241280" cy="411480"/>
+            <a:off x="457200" y="6327648"/>
+            <a:ext cx="10241280" cy="274320"/>
           </a:xfrm>
           <a:prstGeom prst="rect">
             <a:avLst/>
@@ -15189,21 +15077,7 @@
                   <a:srgbClr val="6E7C87"/>
                 </a:solidFill>
               </a:rPr>
-              <a:t>Note: Active = CLICX deposit &gt; 0 or a booked CLICX loan; AIS segment base = 1.2M CLICX customers with AIS. Paying = any payment transaction in CLICX; shares of customers in brackets</a:t>
-            </a:r>
-            <a:endParaRPr lang="en-US" sz="1000" dirty="0"/>
-          </a:p>
-          <a:p>
-            <a:pPr indent="0" marL="0">
-              <a:buNone/>
-            </a:pPr>
-            <a:r>
-              <a:rPr lang="en-US" sz="1000" dirty="0">
-                <a:solidFill>
-                  <a:srgbClr val="6E7C87"/>
-                </a:solidFill>
-              </a:rPr>
-              <a:t>Source: AIS x CLICX matched data; Data for Business Strategy (14 Oct 2026)</a:t>
+              <a:t>Source: AIS and CLICX matched customer data (Sep 2026)</a:t>
             </a:r>
             <a:endParaRPr lang="en-US" sz="1000" dirty="0"/>
           </a:p>
@@ -15217,7 +15091,7 @@
         </p:nvGraphicFramePr>
         <p:xfrm>
           <a:off x="457200" y="2148840"/>
-          <a:ext cx="4023360" cy="3977640"/>
+          <a:ext cx="4206240" cy="3977640"/>
         </p:xfrm>
         <a:graphic xmlns:a="http://schemas.openxmlformats.org/drawingml/2006/main">
           <a:graphicData uri="http://schemas.openxmlformats.org/drawingml/2006/chart">
@@ -15232,8 +15106,8 @@
           <p:nvPr/>
         </p:nvGraphicFramePr>
         <p:xfrm>
-          <a:off x="4572000" y="2148840"/>
-          <a:ext cx="3566160" cy="3977640"/>
+          <a:off x="4754880" y="2148840"/>
+          <a:ext cx="3383280" cy="3977640"/>
         </p:xfrm>
         <a:graphic xmlns:a="http://schemas.openxmlformats.org/drawingml/2006/main">
           <a:graphicData uri="http://schemas.openxmlformats.org/drawingml/2006/chart">
@@ -15386,7 +15260,7 @@
                   <a:schemeClr val="tx2"/>
                 </a:solidFill>
               </a:rPr>
-              <a:t>Telco tier predicts activity</a:t>
+              <a:t>Steady phone payers stay</a:t>
             </a:r>
             <a:endParaRPr lang="en-US" sz="1400" dirty="0"/>
           </a:p>
@@ -15403,7 +15277,7 @@
                   <a:schemeClr val="tx1"/>
                 </a:solidFill>
               </a:rPr>
-              <a:t>FBB (41%) and post-paid (28%) users are most active; post-paid is 44% of the active AIS base</a:t>
+              <a:t>Home internet (41%) and monthly-bill (28%) customers are the most active</a:t>
             </a:r>
             <a:endParaRPr lang="en-US" sz="1400" dirty="0"/>
           </a:p>
@@ -15498,7 +15372,7 @@
                   <a:schemeClr val="tx2"/>
                 </a:solidFill>
               </a:rPr>
-              <a:t>A loan creates the habit</a:t>
+              <a:t>A loan builds the habit</a:t>
             </a:r>
             <a:endParaRPr lang="en-US" sz="1400" dirty="0"/>
           </a:p>
@@ -15515,7 +15389,7 @@
                   <a:schemeClr val="tx1"/>
                 </a:solidFill>
               </a:rPr>
-              <a:t>51% of borrowers pay through CLICX vs 8% of customers whose loan was rejected</a:t>
+              <a:t>Half of borrowers pay with CLICX, against 8% of people we turned down</a:t>
             </a:r>
             <a:endParaRPr lang="en-US" sz="1400" dirty="0"/>
           </a:p>
@@ -15610,7 +15484,7 @@
                   <a:schemeClr val="tx2"/>
                 </a:solidFill>
               </a:rPr>
-              <a:t>Rejection drives inactivity</a:t>
+              <a:t>Saying 'no' loses customers</a:t>
             </a:r>
             <a:endParaRPr lang="en-US" sz="1400" dirty="0"/>
           </a:p>
@@ -15627,7 +15501,7 @@
                   <a:schemeClr val="tx1"/>
                 </a:solidFill>
               </a:rPr>
-              <a:t>67% of customers were rejected for credit at some point, and 83% of them never transact</a:t>
+              <a:t>2 in 3 customers have been turned down for a loan at some point, and most of them never use CLICX again</a:t>
             </a:r>
             <a:endParaRPr lang="en-US" sz="1400" dirty="0"/>
           </a:p>

</xml_diff>

<commit_message>
Split slide 7 into loan and saving/paying charts
Co-Authored-By: Claude Opus 5.5 <noreply@anthropic.com>
Claude-Session: https://claude.ai/code/session_01PMn7aLX79upLSj9P26uPyP
</commit_message>
<xml_diff>
--- a/clicx_insights/CLICX_Customer_Insights.pptx
+++ b/clicx_insights/CLICX_Customer_Insights.pptx
@@ -118,42 +118,42 @@
   <p:extLst>
     <p:ext uri="{521415D9-36F7-43E2-AB2F-B90AF26B5E84}">
       <p14:sectionLst xmlns:p14="http://schemas.microsoft.com/office/powerpoint/2010/main">
-        <p14:section name="Opening" id="{c5e80fb1-e75b-ec72-77c0-186d6ad0dd4c}">
+        <p14:section name="Opening" id="{d0464459-ac19-f042-cd71-3b769549949d}">
           <p14:sldIdLst>
             <p14:sldId id="256"/>
             <p14:sldId id="257"/>
           </p14:sldIdLst>
         </p14:section>
-        <p14:section name="Q1 Source of customers" id="{ec3e2830-c1a6-3cc9-bcc4-03b625baa6fa}">
+        <p14:section name="Q1 Source of customers" id="{69aeae12-3585-b17e-accc-f9fae2bc4ee3}">
           <p14:sldIdLst>
             <p14:sldId id="258"/>
           </p14:sldIdLst>
         </p14:section>
-        <p14:section name="Q2 Who our customers are" id="{7416bd3a-0ba0-5b83-65b5-b7d9dc67e7cc}">
+        <p14:section name="Q2 Who our customers are" id="{b16d88c3-ba00-7b1e-09a1-2a442ab1ee3e}">
           <p14:sldIdLst>
             <p14:sldId id="259"/>
             <p14:sldId id="260"/>
             <p14:sldId id="261"/>
           </p14:sldIdLst>
         </p14:section>
-        <p14:section name="Q3 What they come for" id="{3a31202b-5f9b-f73a-d1b3-0f3b5404401c}">
+        <p14:section name="Q3 What they come for" id="{700b0cf2-23ef-ae55-578c-3063c280966c}">
           <p14:sldIdLst>
             <p14:sldId id="262"/>
           </p14:sldIdLst>
         </p14:section>
-        <p14:section name="Q4 Active vs inactive" id="{8d40ba38-22c2-480d-f6c9-f54d72c0352a}">
+        <p14:section name="Q4 Active vs inactive" id="{ef702b70-7be6-b83c-df09-8a82e465a4a8}">
           <p14:sldIdLst>
             <p14:sldId id="263"/>
             <p14:sldId id="264"/>
           </p14:sldIdLst>
         </p14:section>
-        <p14:section name="Q5 Impact on KTB" id="{9caae850-46f5-33ff-d5e3-4ede0601b78e}">
+        <p14:section name="Q5 Impact on KTB" id="{638ade67-dfaf-9a31-82f5-10a50e8c485e}">
           <p14:sldIdLst>
             <p14:sldId id="265"/>
             <p14:sldId id="266"/>
           </p14:sldIdLst>
         </p14:section>
-        <p14:section name="What to do next" id="{002ce402-de67-71f0-5cee-93599700181e}">
+        <p14:section name="What to do next" id="{a0649def-3d37-e3f2-3305-fbaa963d1b41}">
           <p14:sldIdLst>
             <p14:sldId id="267"/>
           </p14:sldIdLst>
@@ -461,6 +461,315 @@
 </file>
 
 <file path=ppt/charts/chart10.xml><?xml version="1.0" encoding="utf-8"?>
+<c:chartSpace xmlns:c="http://schemas.openxmlformats.org/drawingml/2006/chart" xmlns:a="http://schemas.openxmlformats.org/drawingml/2006/main" xmlns:r="http://schemas.openxmlformats.org/officeDocument/2006/relationships">
+  <c:date1904 val="0"/>
+  <c:roundedCorners val="1"/>
+  <c:chart>
+    <c:title>
+      <c:tx>
+        <c:rich>
+          <a:bodyPr/>
+          <a:lstStyle/>
+          <a:p>
+            <a:pPr algn="l">
+              <a:defRPr sz="1300" b="1" i="0" u="none" strike="noStrike">
+                <a:solidFill>
+                  <a:srgbClr val="051C2C"/>
+                </a:solidFill>
+                <a:latin typeface="+mn-lt"/>
+              </a:defRPr>
+            </a:pPr>
+            <a:r>
+              <a:rPr sz="1300" b="1" i="0" u="none" strike="noStrike">
+                <a:solidFill>
+                  <a:srgbClr val="051C2C"/>
+                </a:solidFill>
+                <a:latin typeface="+mn-lt"/>
+              </a:rPr>
+              <a:t>Customers we share with KTB, by how they use KTB, %</a:t>
+            </a:r>
+          </a:p>
+        </c:rich>
+      </c:tx>
+      <c:layout/>
+      <c:overlay val="0"/>
+    </c:title>
+    <c:autoTitleDeleted val="0"/>
+    <c:plotArea>
+      <c:layout/>
+      <c:barChart>
+        <c:barDir val="bar"/>
+        <c:grouping val="clustered"/>
+        <c:varyColors val="0"/>
+        <c:ser>
+          <c:idx val="0"/>
+          <c:order val="0"/>
+          <c:tx>
+            <c:strRef>
+              <c:f>Sheet1!$B$1</c:f>
+              <c:strCache>
+                <c:ptCount val="1"/>
+                <c:pt idx="0">
+                  <c:v>Share of shared customers</c:v>
+                </c:pt>
+              </c:strCache>
+            </c:strRef>
+          </c:tx>
+          <c:spPr>
+            <a:solidFill>
+              <a:srgbClr val="D9475C"/>
+            </a:solidFill>
+            <a:effectLst/>
+          </c:spPr>
+          <c:invertIfNegative val="0"/>
+          <c:dLbls>
+            <c:numFmt formatCode="0%" sourceLinked="0"/>
+            <c:txPr>
+              <a:bodyPr/>
+              <a:lstStyle/>
+              <a:p>
+                <a:pPr>
+                  <a:defRPr b="0" i="0" strike="noStrike" sz="1200" u="none">
+                    <a:solidFill>
+                      <a:srgbClr val="1A1A1A"/>
+                    </a:solidFill>
+                    <a:latin typeface="+mn-lt"/>
+                  </a:defRPr>
+                </a:pPr>
+              </a:p>
+            </c:txPr>
+            <c:showLegendKey val="0"/>
+            <c:showVal val="1"/>
+            <c:showCatName val="0"/>
+            <c:showSerName val="0"/>
+            <c:showPercent val="0"/>
+            <c:showBubbleSize val="0"/>
+            <c:showLeaderLines val="0"/>
+          </c:dLbls>
+          <c:dPt>
+            <c:idx val="0"/>
+            <c:invertIfNegative val="0"/>
+            <c:bubble3D val="0"/>
+            <c:spPr>
+              <a:solidFill>
+                <a:srgbClr val="D9475C"/>
+              </a:solidFill>
+              <a:effectLst/>
+            </c:spPr>
+          </c:dPt>
+          <c:dPt>
+            <c:idx val="1"/>
+            <c:invertIfNegative val="0"/>
+            <c:bubble3D val="0"/>
+            <c:spPr>
+              <a:solidFill>
+                <a:srgbClr val="A2AAAD"/>
+              </a:solidFill>
+              <a:effectLst/>
+            </c:spPr>
+          </c:dPt>
+          <c:dPt>
+            <c:idx val="2"/>
+            <c:invertIfNegative val="0"/>
+            <c:bubble3D val="0"/>
+            <c:spPr>
+              <a:solidFill>
+                <a:srgbClr val="2251FF"/>
+              </a:solidFill>
+              <a:effectLst/>
+            </c:spPr>
+          </c:dPt>
+          <c:dPt>
+            <c:idx val="3"/>
+            <c:invertIfNegative val="0"/>
+            <c:bubble3D val="0"/>
+            <c:spPr>
+              <a:solidFill>
+                <a:srgbClr val="2251FF"/>
+              </a:solidFill>
+              <a:effectLst/>
+            </c:spPr>
+          </c:dPt>
+          <c:cat>
+            <c:multiLvlStrRef>
+              <c:f>Sheet1!$A$2:$A$5</c:f>
+              <c:multiLvlStrCache>
+                <c:ptCount val="4"/>
+                <c:lvl>
+                  <c:pt idx="0">
+                    <c:v>Loyal to KTB (at risk)</c:v>
+                  </c:pt>
+                  <c:pt idx="1">
+                    <c:v>Uses KTB and other banks</c:v>
+                  </c:pt>
+                  <c:pt idx="2">
+                    <c:v>Loyal to other banks (won back)</c:v>
+                  </c:pt>
+                  <c:pt idx="3">
+                    <c:v>Stopped using KTB (brought back)</c:v>
+                  </c:pt>
+                </c:lvl>
+              </c:multiLvlStrCache>
+            </c:multiLvlStrRef>
+          </c:cat>
+          <c:val>
+            <c:numRef>
+              <c:f>Sheet1!$B$2:$B$5</c:f>
+              <c:numCache>
+                <c:formatCode>General</c:formatCode>
+                <c:ptCount val="4"/>
+                <c:pt idx="0">
+                  <c:v>0.13</c:v>
+                </c:pt>
+                <c:pt idx="1">
+                  <c:v>0.26</c:v>
+                </c:pt>
+                <c:pt idx="2">
+                  <c:v>0.31</c:v>
+                </c:pt>
+                <c:pt idx="3">
+                  <c:v>0.3</c:v>
+                </c:pt>
+              </c:numCache>
+            </c:numRef>
+          </c:val>
+        </c:ser>
+        <c:dLbls>
+          <c:numFmt formatCode="0%" sourceLinked="0"/>
+          <c:txPr>
+            <a:bodyPr/>
+            <a:lstStyle/>
+            <a:p>
+              <a:pPr>
+                <a:defRPr b="0" i="0" strike="noStrike" sz="1200" u="none">
+                  <a:solidFill>
+                    <a:srgbClr val="1A1A1A"/>
+                  </a:solidFill>
+                  <a:latin typeface="+mn-lt"/>
+                </a:defRPr>
+              </a:pPr>
+            </a:p>
+          </c:txPr>
+          <c:showLegendKey val="0"/>
+          <c:showVal val="1"/>
+          <c:showCatName val="0"/>
+          <c:showSerName val="0"/>
+          <c:showPercent val="0"/>
+          <c:showBubbleSize val="0"/>
+          <c:showLeaderLines val="0"/>
+        </c:dLbls>
+        <c:gapWidth val="45"/>
+        <c:overlap val="0"/>
+        <c:axId val="2094734554"/>
+        <c:axId val="2094734552"/>
+        <c:axId val="2094734556"/>
+      </c:barChart>
+      <c:catAx>
+        <c:axId val="2094734554"/>
+        <c:scaling>
+          <c:orientation val="maxMin"/>
+        </c:scaling>
+        <c:delete val="0"/>
+        <c:axPos val="l"/>
+        <c:numFmt formatCode="General" sourceLinked="1"/>
+        <c:majorTickMark val="out"/>
+        <c:minorTickMark val="none"/>
+        <c:tickLblPos val="nextTo"/>
+        <c:spPr>
+          <a:ln w="12700" cap="flat">
+            <a:solidFill>
+              <a:srgbClr val="D5DADF"/>
+            </a:solidFill>
+            <a:prstDash val="solid"/>
+            <a:round/>
+          </a:ln>
+        </c:spPr>
+        <c:txPr>
+          <a:bodyPr/>
+          <a:lstStyle/>
+          <a:p>
+            <a:pPr>
+              <a:defRPr sz="1100" b="0" i="0" u="none" strike="noStrike">
+                <a:solidFill>
+                  <a:srgbClr val="5F6B76"/>
+                </a:solidFill>
+                <a:latin typeface="+mn-lt"/>
+              </a:defRPr>
+            </a:pPr>
+            <a:endParaRPr lang="en-US"/>
+          </a:p>
+        </c:txPr>
+        <c:crossAx val="2094734552"/>
+        <c:crosses val="autoZero"/>
+        <c:auto val="1"/>
+        <c:lblAlgn val="ctr"/>
+        <c:noMultiLvlLbl val="1"/>
+      </c:catAx>
+      <c:valAx>
+        <c:axId val="2094734552"/>
+        <c:scaling>
+          <c:orientation val="minMax"/>
+          <c:max val="0.4"/>
+        </c:scaling>
+        <c:delete val="1"/>
+        <c:axPos val="b"/>
+        <c:numFmt formatCode="General" sourceLinked="0"/>
+        <c:majorTickMark val="out"/>
+        <c:minorTickMark val="none"/>
+        <c:tickLblPos val="low"/>
+        <c:spPr>
+          <a:ln w="12700" cap="flat">
+            <a:solidFill>
+              <a:srgbClr val="888888"/>
+            </a:solidFill>
+            <a:prstDash val="solid"/>
+            <a:round/>
+          </a:ln>
+        </c:spPr>
+        <c:txPr>
+          <a:bodyPr/>
+          <a:lstStyle/>
+          <a:p>
+            <a:pPr>
+              <a:defRPr sz="1000" b="0" i="0" u="none" strike="noStrike">
+                <a:solidFill>
+                  <a:srgbClr val="5F6B76"/>
+                </a:solidFill>
+                <a:latin typeface="+mn-lt"/>
+              </a:defRPr>
+            </a:pPr>
+            <a:endParaRPr lang="en-US"/>
+          </a:p>
+        </c:txPr>
+        <c:crossAx val="2094734554"/>
+        <c:crosses val="autoZero"/>
+        <c:crossBetween val="between"/>
+      </c:valAx>
+      <c:spPr>
+        <a:noFill/>
+        <a:ln>
+          <a:noFill/>
+        </a:ln>
+        <a:effectLst/>
+      </c:spPr>
+    </c:plotArea>
+    <c:plotVisOnly val="1"/>
+    <c:dispBlanksAs val="span"/>
+  </c:chart>
+  <c:spPr>
+    <a:noFill/>
+    <a:ln>
+      <a:noFill/>
+    </a:ln>
+    <a:effectLst/>
+  </c:spPr>
+  <c:externalData r:id="rId1">
+    <c:autoUpdate val="0"/>
+  </c:externalData>
+</c:chartSpace>
+</file>
+
+<file path=ppt/charts/chart11.xml><?xml version="1.0" encoding="utf-8"?>
 <c:chartSpace xmlns:c="http://schemas.openxmlformats.org/drawingml/2006/chart" xmlns:a="http://schemas.openxmlformats.org/drawingml/2006/main" xmlns:r="http://schemas.openxmlformats.org/officeDocument/2006/relationships">
   <c:date1904 val="0"/>
   <c:roundedCorners val="1"/>
@@ -769,7 +1078,7 @@
 </c:chartSpace>
 </file>
 
-<file path=ppt/charts/chart11.xml><?xml version="1.0" encoding="utf-8"?>
+<file path=ppt/charts/chart12.xml><?xml version="1.0" encoding="utf-8"?>
 <c:chartSpace xmlns:c="http://schemas.openxmlformats.org/drawingml/2006/chart" xmlns:a="http://schemas.openxmlformats.org/drawingml/2006/main" xmlns:r="http://schemas.openxmlformats.org/officeDocument/2006/relationships">
   <c:date1904 val="0"/>
   <c:roundedCorners val="1"/>
@@ -2250,7 +2559,7 @@
                 </a:solidFill>
                 <a:latin typeface="+mn-lt"/>
               </a:rPr>
-              <a:t>What each job type actually uses, % of its CLICX customers</a:t>
+              <a:t>Loans: applied vs got one, % of each job type</a:t>
             </a:r>
           </a:p>
         </c:rich>
@@ -2271,6 +2580,101 @@
           <c:tx>
             <c:strRef>
               <c:f>Sheet1!$B$1</c:f>
+              <c:strCache>
+                <c:ptCount val="1"/>
+                <c:pt idx="0">
+                  <c:v>Applied for a loan</c:v>
+                </c:pt>
+              </c:strCache>
+            </c:strRef>
+          </c:tx>
+          <c:spPr>
+            <a:solidFill>
+              <a:srgbClr val="D5DADF"/>
+            </a:solidFill>
+            <a:effectLst/>
+          </c:spPr>
+          <c:invertIfNegative val="0"/>
+          <c:dLbls>
+            <c:numFmt formatCode="0%" sourceLinked="0"/>
+            <c:txPr>
+              <a:bodyPr/>
+              <a:lstStyle/>
+              <a:p>
+                <a:pPr>
+                  <a:defRPr b="0" i="0" strike="noStrike" sz="1000" u="none">
+                    <a:solidFill>
+                      <a:srgbClr val="1A1A1A"/>
+                    </a:solidFill>
+                    <a:latin typeface="+mn-lt"/>
+                  </a:defRPr>
+                </a:pPr>
+              </a:p>
+            </c:txPr>
+            <c:showLegendKey val="0"/>
+            <c:showVal val="1"/>
+            <c:showCatName val="0"/>
+            <c:showSerName val="0"/>
+            <c:showPercent val="0"/>
+            <c:showBubbleSize val="0"/>
+            <c:showLeaderLines val="0"/>
+          </c:dLbls>
+          <c:cat>
+            <c:multiLvlStrRef>
+              <c:f>Sheet1!$A$2:$A$6</c:f>
+              <c:multiLvlStrCache>
+                <c:ptCount val="5"/>
+                <c:lvl>
+                  <c:pt idx="0">
+                    <c:v>Office worker</c:v>
+                  </c:pt>
+                  <c:pt idx="1">
+                    <c:v>Shop owner</c:v>
+                  </c:pt>
+                  <c:pt idx="2">
+                    <c:v>Manual worker</c:v>
+                  </c:pt>
+                  <c:pt idx="3">
+                    <c:v>Freelancer</c:v>
+                  </c:pt>
+                  <c:pt idx="4">
+                    <c:v>Rider / driver</c:v>
+                  </c:pt>
+                </c:lvl>
+              </c:multiLvlStrCache>
+            </c:multiLvlStrRef>
+          </c:cat>
+          <c:val>
+            <c:numRef>
+              <c:f>Sheet1!$B$2:$B$6</c:f>
+              <c:numCache>
+                <c:formatCode>General</c:formatCode>
+                <c:ptCount val="5"/>
+                <c:pt idx="0">
+                  <c:v>0.85</c:v>
+                </c:pt>
+                <c:pt idx="1">
+                  <c:v>0.84</c:v>
+                </c:pt>
+                <c:pt idx="2">
+                  <c:v>0.92</c:v>
+                </c:pt>
+                <c:pt idx="3">
+                  <c:v>0.88</c:v>
+                </c:pt>
+                <c:pt idx="4">
+                  <c:v>0.91</c:v>
+                </c:pt>
+              </c:numCache>
+            </c:numRef>
+          </c:val>
+        </c:ser>
+        <c:ser>
+          <c:idx val="1"/>
+          <c:order val="1"/>
+          <c:tx>
+            <c:strRef>
+              <c:f>Sheet1!$C$1</c:f>
               <c:strCache>
                 <c:ptCount val="1"/>
                 <c:pt idx="0">
@@ -2337,7 +2741,7 @@
           </c:cat>
           <c:val>
             <c:numRef>
-              <c:f>Sheet1!$B$2:$B$6</c:f>
+              <c:f>Sheet1!$C$2:$C$6</c:f>
               <c:numCache>
                 <c:formatCode>General</c:formatCode>
                 <c:ptCount val="5"/>
@@ -2360,12 +2764,208 @@
             </c:numRef>
           </c:val>
         </c:ser>
+        <c:dLbls>
+          <c:numFmt formatCode="0%" sourceLinked="0"/>
+          <c:txPr>
+            <a:bodyPr/>
+            <a:lstStyle/>
+            <a:p>
+              <a:pPr>
+                <a:defRPr b="0" i="0" strike="noStrike" sz="1000" u="none">
+                  <a:solidFill>
+                    <a:srgbClr val="1A1A1A"/>
+                  </a:solidFill>
+                  <a:latin typeface="+mn-lt"/>
+                </a:defRPr>
+              </a:pPr>
+            </a:p>
+          </c:txPr>
+          <c:showLegendKey val="0"/>
+          <c:showVal val="1"/>
+          <c:showCatName val="0"/>
+          <c:showSerName val="0"/>
+          <c:showPercent val="0"/>
+          <c:showBubbleSize val="0"/>
+          <c:showLeaderLines val="0"/>
+        </c:dLbls>
+        <c:gapWidth val="40"/>
+        <c:overlap val="0"/>
+        <c:axId val="2094734554"/>
+        <c:axId val="2094734552"/>
+        <c:axId val="2094734556"/>
+      </c:barChart>
+      <c:catAx>
+        <c:axId val="2094734554"/>
+        <c:scaling>
+          <c:orientation val="maxMin"/>
+        </c:scaling>
+        <c:delete val="0"/>
+        <c:axPos val="l"/>
+        <c:numFmt formatCode="General" sourceLinked="1"/>
+        <c:majorTickMark val="out"/>
+        <c:minorTickMark val="none"/>
+        <c:tickLblPos val="nextTo"/>
+        <c:spPr>
+          <a:ln w="12700" cap="flat">
+            <a:solidFill>
+              <a:srgbClr val="D5DADF"/>
+            </a:solidFill>
+            <a:prstDash val="solid"/>
+            <a:round/>
+          </a:ln>
+        </c:spPr>
+        <c:txPr>
+          <a:bodyPr/>
+          <a:lstStyle/>
+          <a:p>
+            <a:pPr>
+              <a:defRPr sz="1100" b="0" i="0" u="none" strike="noStrike">
+                <a:solidFill>
+                  <a:srgbClr val="5F6B76"/>
+                </a:solidFill>
+                <a:latin typeface="+mn-lt"/>
+              </a:defRPr>
+            </a:pPr>
+            <a:endParaRPr lang="en-US"/>
+          </a:p>
+        </c:txPr>
+        <c:crossAx val="2094734552"/>
+        <c:crosses val="autoZero"/>
+        <c:auto val="1"/>
+        <c:lblAlgn val="ctr"/>
+        <c:noMultiLvlLbl val="1"/>
+      </c:catAx>
+      <c:valAx>
+        <c:axId val="2094734552"/>
+        <c:scaling>
+          <c:orientation val="minMax"/>
+          <c:max val="1.15"/>
+        </c:scaling>
+        <c:delete val="1"/>
+        <c:axPos val="b"/>
+        <c:numFmt formatCode="General" sourceLinked="0"/>
+        <c:majorTickMark val="out"/>
+        <c:minorTickMark val="none"/>
+        <c:tickLblPos val="low"/>
+        <c:spPr>
+          <a:ln w="12700" cap="flat">
+            <a:solidFill>
+              <a:srgbClr val="888888"/>
+            </a:solidFill>
+            <a:prstDash val="solid"/>
+            <a:round/>
+          </a:ln>
+        </c:spPr>
+        <c:txPr>
+          <a:bodyPr/>
+          <a:lstStyle/>
+          <a:p>
+            <a:pPr>
+              <a:defRPr sz="1000" b="0" i="0" u="none" strike="noStrike">
+                <a:solidFill>
+                  <a:srgbClr val="5F6B76"/>
+                </a:solidFill>
+                <a:latin typeface="+mn-lt"/>
+              </a:defRPr>
+            </a:pPr>
+            <a:endParaRPr lang="en-US"/>
+          </a:p>
+        </c:txPr>
+        <c:crossAx val="2094734554"/>
+        <c:crosses val="autoZero"/>
+        <c:crossBetween val="between"/>
+      </c:valAx>
+      <c:spPr>
+        <a:noFill/>
+        <a:ln>
+          <a:noFill/>
+        </a:ln>
+        <a:effectLst/>
+      </c:spPr>
+    </c:plotArea>
+    <c:legend>
+      <c:legendPos val="b"/>
+      <c:overlay val="0"/>
+      <c:txPr>
+        <a:bodyPr/>
+        <a:lstStyle/>
+        <a:p>
+          <a:pPr>
+            <a:defRPr sz="1000">
+              <a:solidFill>
+                <a:srgbClr val="5F6B76"/>
+              </a:solidFill>
+              <a:latin typeface="+mn-lt"/>
+              <a:cs typeface="+mn-lt"/>
+            </a:defRPr>
+          </a:pPr>
+          <a:endParaRPr lang="en-US"/>
+        </a:p>
+      </c:txPr>
+    </c:legend>
+    <c:plotVisOnly val="1"/>
+    <c:dispBlanksAs val="span"/>
+  </c:chart>
+  <c:spPr>
+    <a:noFill/>
+    <a:ln>
+      <a:noFill/>
+    </a:ln>
+    <a:effectLst/>
+  </c:spPr>
+  <c:externalData r:id="rId1">
+    <c:autoUpdate val="0"/>
+  </c:externalData>
+</c:chartSpace>
+</file>
+
+<file path=ppt/charts/chart6.xml><?xml version="1.0" encoding="utf-8"?>
+<c:chartSpace xmlns:c="http://schemas.openxmlformats.org/drawingml/2006/chart" xmlns:a="http://schemas.openxmlformats.org/drawingml/2006/main" xmlns:r="http://schemas.openxmlformats.org/officeDocument/2006/relationships">
+  <c:date1904 val="0"/>
+  <c:roundedCorners val="1"/>
+  <c:chart>
+    <c:title>
+      <c:tx>
+        <c:rich>
+          <a:bodyPr/>
+          <a:lstStyle/>
+          <a:p>
+            <a:pPr algn="l">
+              <a:defRPr sz="1300" b="1" i="0" u="none" strike="noStrike">
+                <a:solidFill>
+                  <a:srgbClr val="051C2C"/>
+                </a:solidFill>
+                <a:latin typeface="+mn-lt"/>
+              </a:defRPr>
+            </a:pPr>
+            <a:r>
+              <a:rPr sz="1300" b="1" i="0" u="none" strike="noStrike">
+                <a:solidFill>
+                  <a:srgbClr val="051C2C"/>
+                </a:solidFill>
+                <a:latin typeface="+mn-lt"/>
+              </a:rPr>
+              <a:t>Saving and paying, % of each job type</a:t>
+            </a:r>
+          </a:p>
+        </c:rich>
+      </c:tx>
+      <c:layout/>
+      <c:overlay val="0"/>
+    </c:title>
+    <c:autoTitleDeleted val="0"/>
+    <c:plotArea>
+      <c:layout/>
+      <c:barChart>
+        <c:barDir val="bar"/>
+        <c:grouping val="clustered"/>
+        <c:varyColors val="0"/>
         <c:ser>
-          <c:idx val="1"/>
-          <c:order val="1"/>
+          <c:idx val="0"/>
+          <c:order val="0"/>
           <c:tx>
             <c:strRef>
-              <c:f>Sheet1!$C$1</c:f>
+              <c:f>Sheet1!$B$1</c:f>
               <c:strCache>
                 <c:ptCount val="1"/>
                 <c:pt idx="0">
@@ -2432,7 +3032,7 @@
           </c:cat>
           <c:val>
             <c:numRef>
-              <c:f>Sheet1!$C$2:$C$6</c:f>
+              <c:f>Sheet1!$B$2:$B$6</c:f>
               <c:numCache>
                 <c:formatCode>General</c:formatCode>
                 <c:ptCount val="5"/>
@@ -2456,11 +3056,11 @@
           </c:val>
         </c:ser>
         <c:ser>
-          <c:idx val="2"/>
-          <c:order val="2"/>
+          <c:idx val="1"/>
+          <c:order val="1"/>
           <c:tx>
             <c:strRef>
-              <c:f>Sheet1!$D$1</c:f>
+              <c:f>Sheet1!$C$1</c:f>
               <c:strCache>
                 <c:ptCount val="1"/>
                 <c:pt idx="0">
@@ -2527,7 +3127,7 @@
           </c:cat>
           <c:val>
             <c:numRef>
-              <c:f>Sheet1!$D$2:$D$6</c:f>
+              <c:f>Sheet1!$C$2:$C$6</c:f>
               <c:numCache>
                 <c:formatCode>General</c:formatCode>
                 <c:ptCount val="5"/>
@@ -2574,7 +3174,7 @@
           <c:showBubbleSize val="0"/>
           <c:showLeaderLines val="0"/>
         </c:dLbls>
-        <c:gapWidth val="35"/>
+        <c:gapWidth val="40"/>
         <c:overlap val="0"/>
         <c:axId val="2094734554"/>
         <c:axId val="2094734552"/>
@@ -2625,7 +3225,7 @@
         <c:axId val="2094734552"/>
         <c:scaling>
           <c:orientation val="minMax"/>
-          <c:max val="0.25"/>
+          <c:max val="0.26"/>
         </c:scaling>
         <c:delete val="1"/>
         <c:axPos val="b"/>
@@ -2705,7 +3305,7 @@
 </c:chartSpace>
 </file>
 
-<file path=ppt/charts/chart6.xml><?xml version="1.0" encoding="utf-8"?>
+<file path=ppt/charts/chart7.xml><?xml version="1.0" encoding="utf-8"?>
 <c:chartSpace xmlns:c="http://schemas.openxmlformats.org/drawingml/2006/chart" xmlns:a="http://schemas.openxmlformats.org/drawingml/2006/main" xmlns:r="http://schemas.openxmlformats.org/officeDocument/2006/relationships">
   <c:date1904 val="0"/>
   <c:roundedCorners val="1"/>
@@ -3103,7 +3703,7 @@
 </c:chartSpace>
 </file>
 
-<file path=ppt/charts/chart7.xml><?xml version="1.0" encoding="utf-8"?>
+<file path=ppt/charts/chart8.xml><?xml version="1.0" encoding="utf-8"?>
 <c:chartSpace xmlns:c="http://schemas.openxmlformats.org/drawingml/2006/chart" xmlns:a="http://schemas.openxmlformats.org/drawingml/2006/main" xmlns:r="http://schemas.openxmlformats.org/officeDocument/2006/relationships">
   <c:date1904 val="0"/>
   <c:roundedCorners val="1"/>
@@ -3463,7 +4063,7 @@
 </c:chartSpace>
 </file>
 
-<file path=ppt/charts/chart8.xml><?xml version="1.0" encoding="utf-8"?>
+<file path=ppt/charts/chart9.xml><?xml version="1.0" encoding="utf-8"?>
 <c:chartSpace xmlns:c="http://schemas.openxmlformats.org/drawingml/2006/chart" xmlns:a="http://schemas.openxmlformats.org/drawingml/2006/main" xmlns:r="http://schemas.openxmlformats.org/officeDocument/2006/relationships">
   <c:date1904 val="0"/>
   <c:roundedCorners val="1"/>
@@ -3703,315 +4303,6 @@
         <c:majorTickMark val="out"/>
         <c:minorTickMark val="none"/>
         <c:tickLblPos val="nextTo"/>
-        <c:spPr>
-          <a:ln w="12700" cap="flat">
-            <a:solidFill>
-              <a:srgbClr val="888888"/>
-            </a:solidFill>
-            <a:prstDash val="solid"/>
-            <a:round/>
-          </a:ln>
-        </c:spPr>
-        <c:txPr>
-          <a:bodyPr/>
-          <a:lstStyle/>
-          <a:p>
-            <a:pPr>
-              <a:defRPr sz="1000" b="0" i="0" u="none" strike="noStrike">
-                <a:solidFill>
-                  <a:srgbClr val="5F6B76"/>
-                </a:solidFill>
-                <a:latin typeface="+mn-lt"/>
-              </a:defRPr>
-            </a:pPr>
-            <a:endParaRPr lang="en-US"/>
-          </a:p>
-        </c:txPr>
-        <c:crossAx val="2094734554"/>
-        <c:crosses val="autoZero"/>
-        <c:crossBetween val="between"/>
-      </c:valAx>
-      <c:spPr>
-        <a:noFill/>
-        <a:ln>
-          <a:noFill/>
-        </a:ln>
-        <a:effectLst/>
-      </c:spPr>
-    </c:plotArea>
-    <c:plotVisOnly val="1"/>
-    <c:dispBlanksAs val="span"/>
-  </c:chart>
-  <c:spPr>
-    <a:noFill/>
-    <a:ln>
-      <a:noFill/>
-    </a:ln>
-    <a:effectLst/>
-  </c:spPr>
-  <c:externalData r:id="rId1">
-    <c:autoUpdate val="0"/>
-  </c:externalData>
-</c:chartSpace>
-</file>
-
-<file path=ppt/charts/chart9.xml><?xml version="1.0" encoding="utf-8"?>
-<c:chartSpace xmlns:c="http://schemas.openxmlformats.org/drawingml/2006/chart" xmlns:a="http://schemas.openxmlformats.org/drawingml/2006/main" xmlns:r="http://schemas.openxmlformats.org/officeDocument/2006/relationships">
-  <c:date1904 val="0"/>
-  <c:roundedCorners val="1"/>
-  <c:chart>
-    <c:title>
-      <c:tx>
-        <c:rich>
-          <a:bodyPr/>
-          <a:lstStyle/>
-          <a:p>
-            <a:pPr algn="l">
-              <a:defRPr sz="1300" b="1" i="0" u="none" strike="noStrike">
-                <a:solidFill>
-                  <a:srgbClr val="051C2C"/>
-                </a:solidFill>
-                <a:latin typeface="+mn-lt"/>
-              </a:defRPr>
-            </a:pPr>
-            <a:r>
-              <a:rPr sz="1300" b="1" i="0" u="none" strike="noStrike">
-                <a:solidFill>
-                  <a:srgbClr val="051C2C"/>
-                </a:solidFill>
-                <a:latin typeface="+mn-lt"/>
-              </a:rPr>
-              <a:t>Customers we share with KTB, by how they use KTB, %</a:t>
-            </a:r>
-          </a:p>
-        </c:rich>
-      </c:tx>
-      <c:layout/>
-      <c:overlay val="0"/>
-    </c:title>
-    <c:autoTitleDeleted val="0"/>
-    <c:plotArea>
-      <c:layout/>
-      <c:barChart>
-        <c:barDir val="bar"/>
-        <c:grouping val="clustered"/>
-        <c:varyColors val="0"/>
-        <c:ser>
-          <c:idx val="0"/>
-          <c:order val="0"/>
-          <c:tx>
-            <c:strRef>
-              <c:f>Sheet1!$B$1</c:f>
-              <c:strCache>
-                <c:ptCount val="1"/>
-                <c:pt idx="0">
-                  <c:v>Share of shared customers</c:v>
-                </c:pt>
-              </c:strCache>
-            </c:strRef>
-          </c:tx>
-          <c:spPr>
-            <a:solidFill>
-              <a:srgbClr val="D9475C"/>
-            </a:solidFill>
-            <a:effectLst/>
-          </c:spPr>
-          <c:invertIfNegative val="0"/>
-          <c:dLbls>
-            <c:numFmt formatCode="0%" sourceLinked="0"/>
-            <c:txPr>
-              <a:bodyPr/>
-              <a:lstStyle/>
-              <a:p>
-                <a:pPr>
-                  <a:defRPr b="0" i="0" strike="noStrike" sz="1200" u="none">
-                    <a:solidFill>
-                      <a:srgbClr val="1A1A1A"/>
-                    </a:solidFill>
-                    <a:latin typeface="+mn-lt"/>
-                  </a:defRPr>
-                </a:pPr>
-              </a:p>
-            </c:txPr>
-            <c:showLegendKey val="0"/>
-            <c:showVal val="1"/>
-            <c:showCatName val="0"/>
-            <c:showSerName val="0"/>
-            <c:showPercent val="0"/>
-            <c:showBubbleSize val="0"/>
-            <c:showLeaderLines val="0"/>
-          </c:dLbls>
-          <c:dPt>
-            <c:idx val="0"/>
-            <c:invertIfNegative val="0"/>
-            <c:bubble3D val="0"/>
-            <c:spPr>
-              <a:solidFill>
-                <a:srgbClr val="D9475C"/>
-              </a:solidFill>
-              <a:effectLst/>
-            </c:spPr>
-          </c:dPt>
-          <c:dPt>
-            <c:idx val="1"/>
-            <c:invertIfNegative val="0"/>
-            <c:bubble3D val="0"/>
-            <c:spPr>
-              <a:solidFill>
-                <a:srgbClr val="A2AAAD"/>
-              </a:solidFill>
-              <a:effectLst/>
-            </c:spPr>
-          </c:dPt>
-          <c:dPt>
-            <c:idx val="2"/>
-            <c:invertIfNegative val="0"/>
-            <c:bubble3D val="0"/>
-            <c:spPr>
-              <a:solidFill>
-                <a:srgbClr val="2251FF"/>
-              </a:solidFill>
-              <a:effectLst/>
-            </c:spPr>
-          </c:dPt>
-          <c:dPt>
-            <c:idx val="3"/>
-            <c:invertIfNegative val="0"/>
-            <c:bubble3D val="0"/>
-            <c:spPr>
-              <a:solidFill>
-                <a:srgbClr val="2251FF"/>
-              </a:solidFill>
-              <a:effectLst/>
-            </c:spPr>
-          </c:dPt>
-          <c:cat>
-            <c:multiLvlStrRef>
-              <c:f>Sheet1!$A$2:$A$5</c:f>
-              <c:multiLvlStrCache>
-                <c:ptCount val="4"/>
-                <c:lvl>
-                  <c:pt idx="0">
-                    <c:v>Loyal to KTB (at risk)</c:v>
-                  </c:pt>
-                  <c:pt idx="1">
-                    <c:v>Uses KTB and other banks</c:v>
-                  </c:pt>
-                  <c:pt idx="2">
-                    <c:v>Loyal to other banks (won back)</c:v>
-                  </c:pt>
-                  <c:pt idx="3">
-                    <c:v>Stopped using KTB (brought back)</c:v>
-                  </c:pt>
-                </c:lvl>
-              </c:multiLvlStrCache>
-            </c:multiLvlStrRef>
-          </c:cat>
-          <c:val>
-            <c:numRef>
-              <c:f>Sheet1!$B$2:$B$5</c:f>
-              <c:numCache>
-                <c:formatCode>General</c:formatCode>
-                <c:ptCount val="4"/>
-                <c:pt idx="0">
-                  <c:v>0.13</c:v>
-                </c:pt>
-                <c:pt idx="1">
-                  <c:v>0.26</c:v>
-                </c:pt>
-                <c:pt idx="2">
-                  <c:v>0.31</c:v>
-                </c:pt>
-                <c:pt idx="3">
-                  <c:v>0.3</c:v>
-                </c:pt>
-              </c:numCache>
-            </c:numRef>
-          </c:val>
-        </c:ser>
-        <c:dLbls>
-          <c:numFmt formatCode="0%" sourceLinked="0"/>
-          <c:txPr>
-            <a:bodyPr/>
-            <a:lstStyle/>
-            <a:p>
-              <a:pPr>
-                <a:defRPr b="0" i="0" strike="noStrike" sz="1200" u="none">
-                  <a:solidFill>
-                    <a:srgbClr val="1A1A1A"/>
-                  </a:solidFill>
-                  <a:latin typeface="+mn-lt"/>
-                </a:defRPr>
-              </a:pPr>
-            </a:p>
-          </c:txPr>
-          <c:showLegendKey val="0"/>
-          <c:showVal val="1"/>
-          <c:showCatName val="0"/>
-          <c:showSerName val="0"/>
-          <c:showPercent val="0"/>
-          <c:showBubbleSize val="0"/>
-          <c:showLeaderLines val="0"/>
-        </c:dLbls>
-        <c:gapWidth val="45"/>
-        <c:overlap val="0"/>
-        <c:axId val="2094734554"/>
-        <c:axId val="2094734552"/>
-        <c:axId val="2094734556"/>
-      </c:barChart>
-      <c:catAx>
-        <c:axId val="2094734554"/>
-        <c:scaling>
-          <c:orientation val="maxMin"/>
-        </c:scaling>
-        <c:delete val="0"/>
-        <c:axPos val="l"/>
-        <c:numFmt formatCode="General" sourceLinked="1"/>
-        <c:majorTickMark val="out"/>
-        <c:minorTickMark val="none"/>
-        <c:tickLblPos val="nextTo"/>
-        <c:spPr>
-          <a:ln w="12700" cap="flat">
-            <a:solidFill>
-              <a:srgbClr val="D5DADF"/>
-            </a:solidFill>
-            <a:prstDash val="solid"/>
-            <a:round/>
-          </a:ln>
-        </c:spPr>
-        <c:txPr>
-          <a:bodyPr/>
-          <a:lstStyle/>
-          <a:p>
-            <a:pPr>
-              <a:defRPr sz="1100" b="0" i="0" u="none" strike="noStrike">
-                <a:solidFill>
-                  <a:srgbClr val="5F6B76"/>
-                </a:solidFill>
-                <a:latin typeface="+mn-lt"/>
-              </a:defRPr>
-            </a:pPr>
-            <a:endParaRPr lang="en-US"/>
-          </a:p>
-        </c:txPr>
-        <c:crossAx val="2094734552"/>
-        <c:crosses val="autoZero"/>
-        <c:auto val="1"/>
-        <c:lblAlgn val="ctr"/>
-        <c:noMultiLvlLbl val="1"/>
-      </c:catAx>
-      <c:valAx>
-        <c:axId val="2094734552"/>
-        <c:scaling>
-          <c:orientation val="minMax"/>
-          <c:max val="0.4"/>
-        </c:scaling>
-        <c:delete val="1"/>
-        <c:axPos val="b"/>
-        <c:numFmt formatCode="General" sourceLinked="0"/>
-        <c:majorTickMark val="out"/>
-        <c:minorTickMark val="none"/>
-        <c:tickLblPos val="low"/>
         <c:spPr>
           <a:ln w="12700" cap="flat">
             <a:solidFill>
@@ -13567,159 +13858,15 @@
           </a:p>
         </p:txBody>
       </p:sp>
-      <p:sp>
-        <p:nvSpPr>
-          <p:cNvPr id="6" name="Stat 84–92%"/>
-          <p:cNvSpPr txBox="1"/>
-          <p:nvPr/>
-        </p:nvSpPr>
-        <p:spPr>
-          <a:xfrm>
-            <a:off x="457200" y="2194560"/>
-            <a:ext cx="2194560" cy="640080"/>
-          </a:xfrm>
-          <a:prstGeom prst="rect">
-            <a:avLst/>
-          </a:prstGeom>
-          <a:noFill/>
-          <a:ln/>
-        </p:spPr>
-        <p:txBody>
-          <a:bodyPr wrap="square" lIns="0" tIns="0" rIns="0" bIns="0" rtlCol="0" anchor="ctr"/>
-          <a:lstStyle/>
-          <a:p>
-            <a:pPr indent="0" marL="0">
-              <a:buNone/>
-            </a:pPr>
-            <a:r>
-              <a:rPr lang="en-US" sz="4000" b="1" dirty="0">
-                <a:solidFill>
-                  <a:schemeClr val="accent1"/>
-                </a:solidFill>
-              </a:rPr>
-              <a:t>84–92%</a:t>
-            </a:r>
-            <a:endParaRPr lang="en-US" sz="4000" dirty="0"/>
-          </a:p>
-        </p:txBody>
-      </p:sp>
-      <p:sp>
-        <p:nvSpPr>
-          <p:cNvPr id="7" name="Stat label 84–92%"/>
-          <p:cNvSpPr txBox="1"/>
-          <p:nvPr/>
-        </p:nvSpPr>
-        <p:spPr>
-          <a:xfrm>
-            <a:off x="457200" y="2852928"/>
-            <a:ext cx="2194560" cy="502920"/>
-          </a:xfrm>
-          <a:prstGeom prst="rect">
-            <a:avLst/>
-          </a:prstGeom>
-          <a:noFill/>
-          <a:ln/>
-        </p:spPr>
-        <p:txBody>
-          <a:bodyPr wrap="square" lIns="0" tIns="0" rIns="0" bIns="0" rtlCol="0" anchor="t"/>
-          <a:lstStyle/>
-          <a:p>
-            <a:pPr indent="0" marL="0">
-              <a:buNone/>
-            </a:pPr>
-            <a:r>
-              <a:rPr lang="en-US" sz="1200" dirty="0">
-                <a:solidFill>
-                  <a:schemeClr val="tx1"/>
-                </a:solidFill>
-              </a:rPr>
-              <a:t>of every job type applied for a CLICX loan</a:t>
-            </a:r>
-            <a:endParaRPr lang="en-US" sz="1200" dirty="0"/>
-          </a:p>
-        </p:txBody>
-      </p:sp>
-      <p:sp>
-        <p:nvSpPr>
-          <p:cNvPr id="8" name="Stat 5–11%"/>
-          <p:cNvSpPr txBox="1"/>
-          <p:nvPr/>
-        </p:nvSpPr>
-        <p:spPr>
-          <a:xfrm>
-            <a:off x="457200" y="3611880"/>
-            <a:ext cx="2194560" cy="640080"/>
-          </a:xfrm>
-          <a:prstGeom prst="rect">
-            <a:avLst/>
-          </a:prstGeom>
-          <a:noFill/>
-          <a:ln/>
-        </p:spPr>
-        <p:txBody>
-          <a:bodyPr wrap="square" lIns="0" tIns="0" rIns="0" bIns="0" rtlCol="0" anchor="ctr"/>
-          <a:lstStyle/>
-          <a:p>
-            <a:pPr indent="0" marL="0">
-              <a:buNone/>
-            </a:pPr>
-            <a:r>
-              <a:rPr lang="en-US" sz="4000" b="1" dirty="0">
-                <a:solidFill>
-                  <a:schemeClr val="tx2"/>
-                </a:solidFill>
-              </a:rPr>
-              <a:t>5–11%</a:t>
-            </a:r>
-            <a:endParaRPr lang="en-US" sz="4000" dirty="0"/>
-          </a:p>
-        </p:txBody>
-      </p:sp>
-      <p:sp>
-        <p:nvSpPr>
-          <p:cNvPr id="9" name="Stat label 5–11%"/>
-          <p:cNvSpPr txBox="1"/>
-          <p:nvPr/>
-        </p:nvSpPr>
-        <p:spPr>
-          <a:xfrm>
-            <a:off x="457200" y="4270248"/>
-            <a:ext cx="2194560" cy="502920"/>
-          </a:xfrm>
-          <a:prstGeom prst="rect">
-            <a:avLst/>
-          </a:prstGeom>
-          <a:noFill/>
-          <a:ln/>
-        </p:spPr>
-        <p:txBody>
-          <a:bodyPr wrap="square" lIns="0" tIns="0" rIns="0" bIns="0" rtlCol="0" anchor="t"/>
-          <a:lstStyle/>
-          <a:p>
-            <a:pPr indent="0" marL="0">
-              <a:buNone/>
-            </a:pPr>
-            <a:r>
-              <a:rPr lang="en-US" sz="1200" dirty="0">
-                <a:solidFill>
-                  <a:schemeClr val="tx1"/>
-                </a:solidFill>
-              </a:rPr>
-              <a:t>actually got a loan</a:t>
-            </a:r>
-            <a:endParaRPr lang="en-US" sz="1200" dirty="0"/>
-          </a:p>
-        </p:txBody>
-      </p:sp>
       <p:graphicFrame>
         <p:nvGraphicFramePr>
-          <p:cNvPr id="10" name="Product use by occupation" descr=""/>
+          <p:cNvPr id="6" name="Loans applied vs got" descr=""/>
           <p:cNvGraphicFramePr/>
           <p:nvPr/>
         </p:nvGraphicFramePr>
         <p:xfrm>
-          <a:off x="2834640" y="2148840"/>
-          <a:ext cx="5303520" cy="3977640"/>
+          <a:off x="457200" y="2148840"/>
+          <a:ext cx="3840480" cy="3977640"/>
         </p:xfrm>
         <a:graphic xmlns:a="http://schemas.openxmlformats.org/drawingml/2006/main">
           <a:graphicData uri="http://schemas.openxmlformats.org/drawingml/2006/chart">
@@ -13727,9 +13874,25 @@
           </a:graphicData>
         </a:graphic>
       </p:graphicFrame>
-      <p:sp>
-        <p:nvSpPr>
-          <p:cNvPr id="11" name="Insight panel"/>
+      <p:graphicFrame>
+        <p:nvGraphicFramePr>
+          <p:cNvPr id="7" name="Saving and paying" descr=""/>
+          <p:cNvGraphicFramePr/>
+          <p:nvPr/>
+        </p:nvGraphicFramePr>
+        <p:xfrm>
+          <a:off x="4389120" y="2148840"/>
+          <a:ext cx="3749040" cy="3977640"/>
+        </p:xfrm>
+        <a:graphic xmlns:a="http://schemas.openxmlformats.org/drawingml/2006/main">
+          <a:graphicData uri="http://schemas.openxmlformats.org/drawingml/2006/chart">
+            <c:chart xmlns:c="http://schemas.openxmlformats.org/drawingml/2006/chart" r:id="rId2"/>
+          </a:graphicData>
+        </a:graphic>
+      </p:graphicFrame>
+      <p:sp>
+        <p:nvSpPr>
+          <p:cNvPr id="8" name="Insight panel"/>
           <p:cNvSpPr/>
           <p:nvPr/>
         </p:nvSpPr>
@@ -13749,7 +13912,7 @@
       </p:sp>
       <p:sp>
         <p:nvSpPr>
-          <p:cNvPr id="12" name="Insight header"/>
+          <p:cNvPr id="9" name="Insight header"/>
           <p:cNvSpPr txBox="1"/>
           <p:nvPr/>
         </p:nvSpPr>
@@ -13785,7 +13948,7 @@
       </p:sp>
       <p:sp>
         <p:nvSpPr>
-          <p:cNvPr id="13" name="Badge 1"/>
+          <p:cNvPr id="10" name="Badge 1"/>
           <p:cNvSpPr/>
           <p:nvPr/>
         </p:nvSpPr>
@@ -13805,7 +13968,7 @@
       </p:sp>
       <p:sp>
         <p:nvSpPr>
-          <p:cNvPr id="14" name="Badge num 1"/>
+          <p:cNvPr id="11" name="Badge num 1"/>
           <p:cNvSpPr txBox="1"/>
           <p:nvPr/>
         </p:nvSpPr>
@@ -13841,7 +14004,7 @@
       </p:sp>
       <p:sp>
         <p:nvSpPr>
-          <p:cNvPr id="15" name="Insight 1"/>
+          <p:cNvPr id="12" name="Insight 1"/>
           <p:cNvSpPr txBox="1"/>
           <p:nvPr/>
         </p:nvSpPr>
@@ -13897,7 +14060,7 @@
       </p:sp>
       <p:sp>
         <p:nvSpPr>
-          <p:cNvPr id="16" name="Badge 2"/>
+          <p:cNvPr id="13" name="Badge 2"/>
           <p:cNvSpPr/>
           <p:nvPr/>
         </p:nvSpPr>
@@ -13917,7 +14080,7 @@
       </p:sp>
       <p:sp>
         <p:nvSpPr>
-          <p:cNvPr id="17" name="Badge num 2"/>
+          <p:cNvPr id="14" name="Badge num 2"/>
           <p:cNvSpPr txBox="1"/>
           <p:nvPr/>
         </p:nvSpPr>
@@ -13953,7 +14116,7 @@
       </p:sp>
       <p:sp>
         <p:nvSpPr>
-          <p:cNvPr id="18" name="Insight 2"/>
+          <p:cNvPr id="15" name="Insight 2"/>
           <p:cNvSpPr txBox="1"/>
           <p:nvPr/>
         </p:nvSpPr>
@@ -14009,7 +14172,7 @@
       </p:sp>
       <p:sp>
         <p:nvSpPr>
-          <p:cNvPr id="19" name="Badge 3"/>
+          <p:cNvPr id="16" name="Badge 3"/>
           <p:cNvSpPr/>
           <p:nvPr/>
         </p:nvSpPr>
@@ -14029,7 +14192,7 @@
       </p:sp>
       <p:sp>
         <p:nvSpPr>
-          <p:cNvPr id="20" name="Badge num 3"/>
+          <p:cNvPr id="17" name="Badge num 3"/>
           <p:cNvSpPr txBox="1"/>
           <p:nvPr/>
         </p:nvSpPr>
@@ -14065,7 +14228,7 @@
       </p:sp>
       <p:sp>
         <p:nvSpPr>
-          <p:cNvPr id="21" name="Insight 3"/>
+          <p:cNvPr id="18" name="Insight 3"/>
           <p:cNvSpPr txBox="1"/>
           <p:nvPr/>
         </p:nvSpPr>
@@ -14121,7 +14284,7 @@
       </p:sp>
       <p:sp>
         <p:nvSpPr>
-          <p:cNvPr id="22" name="Badge 4"/>
+          <p:cNvPr id="19" name="Badge 4"/>
           <p:cNvSpPr/>
           <p:nvPr/>
         </p:nvSpPr>
@@ -14141,7 +14304,7 @@
       </p:sp>
       <p:sp>
         <p:nvSpPr>
-          <p:cNvPr id="23" name="Badge num 4"/>
+          <p:cNvPr id="20" name="Badge num 4"/>
           <p:cNvSpPr txBox="1"/>
           <p:nvPr/>
         </p:nvSpPr>
@@ -14177,7 +14340,7 @@
       </p:sp>
       <p:sp>
         <p:nvSpPr>
-          <p:cNvPr id="24" name="Insight 4"/>
+          <p:cNvPr id="21" name="Insight 4"/>
           <p:cNvSpPr txBox="1"/>
           <p:nvPr/>
         </p:nvSpPr>

</xml_diff>

<commit_message>
Rename manual worker to blue-collar worker
Co-Authored-By: Claude Opus 5.5 <noreply@anthropic.com>
Claude-Session: https://claude.ai/code/session_01PMn7aLX79upLSj9P26uPyP
</commit_message>
<xml_diff>
--- a/clicx_insights/CLICX_Customer_Insights.pptx
+++ b/clicx_insights/CLICX_Customer_Insights.pptx
@@ -118,42 +118,42 @@
   <p:extLst>
     <p:ext uri="{521415D9-36F7-43E2-AB2F-B90AF26B5E84}">
       <p14:sectionLst xmlns:p14="http://schemas.microsoft.com/office/powerpoint/2010/main">
-        <p14:section name="Opening" id="{d0464459-ac19-f042-cd71-3b769549949d}">
+        <p14:section name="Opening" id="{ff5e897e-bd3c-f5dd-a0a8-32adf933fa08}">
           <p14:sldIdLst>
             <p14:sldId id="256"/>
             <p14:sldId id="257"/>
           </p14:sldIdLst>
         </p14:section>
-        <p14:section name="Q1 Source of customers" id="{69aeae12-3585-b17e-accc-f9fae2bc4ee3}">
+        <p14:section name="Q1 Source of customers" id="{48b2feca-cf46-7d3f-f155-f72c0f1a617c}">
           <p14:sldIdLst>
             <p14:sldId id="258"/>
           </p14:sldIdLst>
         </p14:section>
-        <p14:section name="Q2 Who our customers are" id="{b16d88c3-ba00-7b1e-09a1-2a442ab1ee3e}">
+        <p14:section name="Q2 Who our customers are" id="{68b8e337-69d2-2daf-a67e-68e928c7d6e4}">
           <p14:sldIdLst>
             <p14:sldId id="259"/>
             <p14:sldId id="260"/>
             <p14:sldId id="261"/>
           </p14:sldIdLst>
         </p14:section>
-        <p14:section name="Q3 What they come for" id="{700b0cf2-23ef-ae55-578c-3063c280966c}">
+        <p14:section name="Q3 What they come for" id="{7916523b-7866-a267-12d8-7e8c23b6e466}">
           <p14:sldIdLst>
             <p14:sldId id="262"/>
           </p14:sldIdLst>
         </p14:section>
-        <p14:section name="Q4 Active vs inactive" id="{ef702b70-7be6-b83c-df09-8a82e465a4a8}">
+        <p14:section name="Q4 Active vs inactive" id="{0692a019-616f-1593-4c56-506451f1e71e}">
           <p14:sldIdLst>
             <p14:sldId id="263"/>
             <p14:sldId id="264"/>
           </p14:sldIdLst>
         </p14:section>
-        <p14:section name="Q5 Impact on KTB" id="{638ade67-dfaf-9a31-82f5-10a50e8c485e}">
+        <p14:section name="Q5 Impact on KTB" id="{eed4fe67-fda0-5033-2bda-f1c99c47a981}">
           <p14:sldIdLst>
             <p14:sldId id="265"/>
             <p14:sldId id="266"/>
           </p14:sldIdLst>
         </p14:section>
-        <p14:section name="What to do next" id="{a0649def-3d37-e3f2-3305-fbaa963d1b41}">
+        <p14:section name="What to do next" id="{a763d708-1752-375f-cc5a-3896a526970c}">
           <p14:sldIdLst>
             <p14:sldId id="267"/>
           </p14:sldIdLst>
@@ -2355,7 +2355,7 @@
                     <c:v>Rider / driver (66K)</c:v>
                   </c:pt>
                   <c:pt idx="2">
-                    <c:v>Manual worker (401K)</c:v>
+                    <c:v>Blue-collar worker (401K)</c:v>
                   </c:pt>
                   <c:pt idx="3">
                     <c:v>Office worker (700K)</c:v>
@@ -2632,7 +2632,7 @@
                     <c:v>Shop owner</c:v>
                   </c:pt>
                   <c:pt idx="2">
-                    <c:v>Manual worker</c:v>
+                    <c:v>Blue-collar worker</c:v>
                   </c:pt>
                   <c:pt idx="3">
                     <c:v>Freelancer</c:v>
@@ -2727,7 +2727,7 @@
                     <c:v>Shop owner</c:v>
                   </c:pt>
                   <c:pt idx="2">
-                    <c:v>Manual worker</c:v>
+                    <c:v>Blue-collar worker</c:v>
                   </c:pt>
                   <c:pt idx="3">
                     <c:v>Freelancer</c:v>
@@ -3018,7 +3018,7 @@
                     <c:v>Shop owner</c:v>
                   </c:pt>
                   <c:pt idx="2">
-                    <c:v>Manual worker</c:v>
+                    <c:v>Blue-collar worker</c:v>
                   </c:pt>
                   <c:pt idx="3">
                     <c:v>Freelancer</c:v>
@@ -3113,7 +3113,7 @@
                     <c:v>Shop owner</c:v>
                   </c:pt>
                   <c:pt idx="2">
-                    <c:v>Manual worker</c:v>
+                    <c:v>Blue-collar worker</c:v>
                   </c:pt>
                   <c:pt idx="3">
                     <c:v>Freelancer</c:v>
@@ -3404,7 +3404,7 @@
                     <c:v>Shop owner (23%)</c:v>
                   </c:pt>
                   <c:pt idx="2">
-                    <c:v>Manual worker (16%)</c:v>
+                    <c:v>Blue-collar worker (16%)</c:v>
                   </c:pt>
                   <c:pt idx="3">
                     <c:v>Freelancer (18%)</c:v>
@@ -3505,7 +3505,7 @@
                     <c:v>Shop owner (23%)</c:v>
                   </c:pt>
                   <c:pt idx="2">
-                    <c:v>Manual worker (16%)</c:v>
+                    <c:v>Blue-collar worker (16%)</c:v>
                   </c:pt>
                   <c:pt idx="3">
                     <c:v>Freelancer (18%)</c:v>
@@ -8760,7 +8760,7 @@
                   <a:schemeClr val="tx1"/>
                 </a:solidFill>
               </a:rPr>
-              <a:t>Over 90% of manual and gig workers apply but only 5–7% get a loan. Improve approval rules and offer small starter loans</a:t>
+              <a:t>Over 90% of blue-collar and gig workers apply but only 5–7% get a loan. Improve approval rules and offer small starter loans</a:t>
             </a:r>
             <a:endParaRPr lang="en-US" sz="1200" dirty="0"/>
           </a:p>
@@ -10585,7 +10585,7 @@
                           <a:ea typeface="Arial" pitchFamily="34" charset="-122"/>
                           <a:cs typeface="Arial" pitchFamily="34" charset="-120"/>
                         </a:rPr>
-                        <a:t>Active customers are mostly office workers and shop owners with monthly phone bills. Inactive ones are often manual workers or people turned down for a loan</a:t>
+                        <a:t>Active customers are mostly office workers and shop owners with monthly phone bills. Inactive ones are often blue-collar workers or people turned down for a loan</a:t>
                       </a:r>
                       <a:endParaRPr lang="en-US" sz="1200" dirty="0">
                         <a:latin typeface="Arial" charset="0"/>
@@ -13518,7 +13518,7 @@
                   <a:schemeClr val="tx1"/>
                 </a:solidFill>
               </a:rPr>
-              <a:t>Office and manual workers are 1.1M customers, over 60% of CLICX</a:t>
+              <a:t>Office and blue-collar workers are 1.1M customers, over 60% of CLICX</a:t>
             </a:r>
             <a:endParaRPr lang="en-US" sz="1400" dirty="0"/>
           </a:p>
@@ -14572,7 +14572,7 @@
                   <a:schemeClr val="tx1"/>
                 </a:solidFill>
               </a:rPr>
-              <a:t>Yes. Only 1 in 5 customers is active (has money in CLICX or a CLICX loan). Active customers are mostly office workers and shop owners; inactive ones are more often manual workers</a:t>
+              <a:t>Yes. Only 1 in 5 customers is active (has money in CLICX or a CLICX loan). Active customers are mostly office workers and shop owners; inactive ones are more often blue-collar workers</a:t>
             </a:r>
             <a:endParaRPr lang="en-US" sz="1600" dirty="0"/>
           </a:p>
@@ -14889,7 +14889,7 @@
                   <a:schemeClr val="tx2"/>
                 </a:solidFill>
               </a:rPr>
-              <a:t>Manual workers drift away</a:t>
+              <a:t>Blue-collar workers drift away</a:t>
             </a:r>
             <a:endParaRPr lang="en-US" sz="1400" dirty="0"/>
           </a:p>

</xml_diff>

<commit_message>
Add Q4 slide comparing payers vs non-payers
Co-Authored-By: Claude Opus 5.5 <noreply@anthropic.com>
Claude-Session: https://claude.ai/code/session_01PMn7aLX79upLSj9P26uPyP
</commit_message>
<xml_diff>
--- a/clicx_insights/CLICX_Customer_Insights.pptx
+++ b/clicx_insights/CLICX_Customer_Insights.pptx
@@ -17,9 +17,10 @@
     <p:sldId id="265" r:id="rId11"/>
     <p:sldId id="266" r:id="rId12"/>
     <p:sldId id="267" r:id="rId13"/>
+    <p:sldId id="268" r:id="rId14"/>
   </p:sldIdLst>
   <p:notesMasterIdLst>
-    <p:notesMasterId r:id="rId14"/>
+    <p:notesMasterId r:id="rId15"/>
   </p:notesMasterIdLst>
   <p:sldSz cx="12192000" cy="6858000"/>
   <p:notesSz cx="6858000" cy="12192000"/>
@@ -118,44 +119,45 @@
   <p:extLst>
     <p:ext uri="{521415D9-36F7-43E2-AB2F-B90AF26B5E84}">
       <p14:sectionLst xmlns:p14="http://schemas.microsoft.com/office/powerpoint/2010/main">
-        <p14:section name="Opening" id="{ff5e897e-bd3c-f5dd-a0a8-32adf933fa08}">
+        <p14:section name="Opening" id="{5177c535-ab6d-8083-8554-3868f96dfd32}">
           <p14:sldIdLst>
             <p14:sldId id="256"/>
             <p14:sldId id="257"/>
           </p14:sldIdLst>
         </p14:section>
-        <p14:section name="Q1 Source of customers" id="{48b2feca-cf46-7d3f-f155-f72c0f1a617c}">
+        <p14:section name="Q1 Source of customers" id="{b162ea8b-2c2b-3caf-9448-8cad1fcff7b7}">
           <p14:sldIdLst>
             <p14:sldId id="258"/>
           </p14:sldIdLst>
         </p14:section>
-        <p14:section name="Q2 Who our customers are" id="{68b8e337-69d2-2daf-a67e-68e928c7d6e4}">
+        <p14:section name="Q2 Who our customers are" id="{fd15ed15-bd8d-e3c3-f75a-ff4097882d82}">
           <p14:sldIdLst>
             <p14:sldId id="259"/>
             <p14:sldId id="260"/>
             <p14:sldId id="261"/>
           </p14:sldIdLst>
         </p14:section>
-        <p14:section name="Q3 What they come for" id="{7916523b-7866-a267-12d8-7e8c23b6e466}">
+        <p14:section name="Q3 What they come for" id="{78c775bc-0e07-062d-a208-182dcefb8fd4}">
           <p14:sldIdLst>
             <p14:sldId id="262"/>
           </p14:sldIdLst>
         </p14:section>
-        <p14:section name="Q4 Active vs inactive" id="{0692a019-616f-1593-4c56-506451f1e71e}">
+        <p14:section name="Q4 Active vs inactive" id="{57770db7-718a-3f16-bf06-e6b10bd0dd8d}">
           <p14:sldIdLst>
             <p14:sldId id="263"/>
             <p14:sldId id="264"/>
+            <p14:sldId id="265"/>
           </p14:sldIdLst>
         </p14:section>
-        <p14:section name="Q5 Impact on KTB" id="{eed4fe67-fda0-5033-2bda-f1c99c47a981}">
+        <p14:section name="Q5 Impact on KTB" id="{1b348ca3-ba02-d364-8023-bd117801684c}">
           <p14:sldIdLst>
-            <p14:sldId id="265"/>
             <p14:sldId id="266"/>
+            <p14:sldId id="267"/>
           </p14:sldIdLst>
         </p14:section>
-        <p14:section name="What to do next" id="{a763d708-1752-375f-cc5a-3896a526970c}">
+        <p14:section name="What to do next" id="{43b82ccf-aff4-7124-cfd3-28e65dbcf345}">
           <p14:sldIdLst>
-            <p14:sldId id="267"/>
+            <p14:sldId id="268"/>
           </p14:sldIdLst>
         </p14:section>
       </p14:sectionLst>
@@ -461,6 +463,428 @@
 </file>
 
 <file path=ppt/charts/chart10.xml><?xml version="1.0" encoding="utf-8"?>
+<c:chartSpace xmlns:c="http://schemas.openxmlformats.org/drawingml/2006/chart" xmlns:a="http://schemas.openxmlformats.org/drawingml/2006/main" xmlns:r="http://schemas.openxmlformats.org/officeDocument/2006/relationships">
+  <c:date1904 val="0"/>
+  <c:roundedCorners val="1"/>
+  <c:chart>
+    <c:title>
+      <c:tx>
+        <c:rich>
+          <a:bodyPr/>
+          <a:lstStyle/>
+          <a:p>
+            <a:pPr algn="l">
+              <a:defRPr sz="1300" b="1" i="0" u="none" strike="noStrike">
+                <a:solidFill>
+                  <a:srgbClr val="051C2C"/>
+                </a:solidFill>
+                <a:latin typeface="+mn-lt"/>
+              </a:defRPr>
+            </a:pPr>
+            <a:r>
+              <a:rPr sz="1300" b="1" i="0" u="none" strike="noStrike">
+                <a:solidFill>
+                  <a:srgbClr val="051C2C"/>
+                </a:solidFill>
+                <a:latin typeface="+mn-lt"/>
+              </a:rPr>
+              <a:t>Who they are: regular payers vs never paid, % of each group</a:t>
+            </a:r>
+          </a:p>
+        </c:rich>
+      </c:tx>
+      <c:layout/>
+      <c:overlay val="0"/>
+    </c:title>
+    <c:autoTitleDeleted val="0"/>
+    <c:plotArea>
+      <c:layout/>
+      <c:barChart>
+        <c:barDir val="bar"/>
+        <c:grouping val="clustered"/>
+        <c:varyColors val="0"/>
+        <c:ser>
+          <c:idx val="0"/>
+          <c:order val="0"/>
+          <c:tx>
+            <c:strRef>
+              <c:f>Sheet1!$B$1</c:f>
+              <c:strCache>
+                <c:ptCount val="1"/>
+                <c:pt idx="0">
+                  <c:v>Regular payers (paid Aug, Sep and Oct, 58K)</c:v>
+                </c:pt>
+              </c:strCache>
+            </c:strRef>
+          </c:tx>
+          <c:spPr>
+            <a:solidFill>
+              <a:srgbClr val="051C2C"/>
+            </a:solidFill>
+            <a:effectLst/>
+          </c:spPr>
+          <c:invertIfNegative val="0"/>
+          <c:dLbls>
+            <c:numFmt formatCode="0%" sourceLinked="0"/>
+            <c:txPr>
+              <a:bodyPr/>
+              <a:lstStyle/>
+              <a:p>
+                <a:pPr>
+                  <a:defRPr b="0" i="0" strike="noStrike" sz="900" u="none">
+                    <a:solidFill>
+                      <a:srgbClr val="1A1A1A"/>
+                    </a:solidFill>
+                    <a:latin typeface="+mn-lt"/>
+                  </a:defRPr>
+                </a:pPr>
+              </a:p>
+            </c:txPr>
+            <c:showLegendKey val="0"/>
+            <c:showVal val="1"/>
+            <c:showCatName val="0"/>
+            <c:showSerName val="0"/>
+            <c:showPercent val="0"/>
+            <c:showBubbleSize val="0"/>
+            <c:showLeaderLines val="0"/>
+          </c:dLbls>
+          <c:cat>
+            <c:multiLvlStrRef>
+              <c:f>Sheet1!$A$2:$A$9</c:f>
+              <c:multiLvlStrCache>
+                <c:ptCount val="8"/>
+                <c:lvl>
+                  <c:pt idx="0">
+                    <c:v>In their 30s</c:v>
+                  </c:pt>
+                  <c:pt idx="1">
+                    <c:v>In their 20s</c:v>
+                  </c:pt>
+                  <c:pt idx="2">
+                    <c:v>Salaried (company or government)</c:v>
+                  </c:pt>
+                  <c:pt idx="3">
+                    <c:v>Blue-collar or farm worker</c:v>
+                  </c:pt>
+                  <c:pt idx="4">
+                    <c:v>AIS monthly phone bill</c:v>
+                  </c:pt>
+                  <c:pt idx="5">
+                    <c:v>Not an AIS customer</c:v>
+                  </c:pt>
+                  <c:pt idx="6">
+                    <c:v>Has a CLICX loan</c:v>
+                  </c:pt>
+                  <c:pt idx="7">
+                    <c:v>Has put money into CLICX</c:v>
+                  </c:pt>
+                </c:lvl>
+              </c:multiLvlStrCache>
+            </c:multiLvlStrRef>
+          </c:cat>
+          <c:val>
+            <c:numRef>
+              <c:f>Sheet1!$B$2:$B$9</c:f>
+              <c:numCache>
+                <c:formatCode>General</c:formatCode>
+                <c:ptCount val="8"/>
+                <c:pt idx="0">
+                  <c:v>0.407</c:v>
+                </c:pt>
+                <c:pt idx="1">
+                  <c:v>0.212</c:v>
+                </c:pt>
+                <c:pt idx="2">
+                  <c:v>0.44</c:v>
+                </c:pt>
+                <c:pt idx="3">
+                  <c:v>0.14</c:v>
+                </c:pt>
+                <c:pt idx="4">
+                  <c:v>0.342</c:v>
+                </c:pt>
+                <c:pt idx="5">
+                  <c:v>0.306</c:v>
+                </c:pt>
+                <c:pt idx="6">
+                  <c:v>0.464</c:v>
+                </c:pt>
+                <c:pt idx="7">
+                  <c:v>0.999</c:v>
+                </c:pt>
+              </c:numCache>
+            </c:numRef>
+          </c:val>
+        </c:ser>
+        <c:ser>
+          <c:idx val="1"/>
+          <c:order val="1"/>
+          <c:tx>
+            <c:strRef>
+              <c:f>Sheet1!$C$1</c:f>
+              <c:strCache>
+                <c:ptCount val="1"/>
+                <c:pt idx="0">
+                  <c:v>Never paid (1.27M)</c:v>
+                </c:pt>
+              </c:strCache>
+            </c:strRef>
+          </c:tx>
+          <c:spPr>
+            <a:solidFill>
+              <a:srgbClr val="D5DADF"/>
+            </a:solidFill>
+            <a:effectLst/>
+          </c:spPr>
+          <c:invertIfNegative val="0"/>
+          <c:dLbls>
+            <c:numFmt formatCode="0%" sourceLinked="0"/>
+            <c:txPr>
+              <a:bodyPr/>
+              <a:lstStyle/>
+              <a:p>
+                <a:pPr>
+                  <a:defRPr b="0" i="0" strike="noStrike" sz="900" u="none">
+                    <a:solidFill>
+                      <a:srgbClr val="1A1A1A"/>
+                    </a:solidFill>
+                    <a:latin typeface="+mn-lt"/>
+                  </a:defRPr>
+                </a:pPr>
+              </a:p>
+            </c:txPr>
+            <c:showLegendKey val="0"/>
+            <c:showVal val="1"/>
+            <c:showCatName val="0"/>
+            <c:showSerName val="0"/>
+            <c:showPercent val="0"/>
+            <c:showBubbleSize val="0"/>
+            <c:showLeaderLines val="0"/>
+          </c:dLbls>
+          <c:cat>
+            <c:multiLvlStrRef>
+              <c:f>Sheet1!$A$2:$A$9</c:f>
+              <c:multiLvlStrCache>
+                <c:ptCount val="8"/>
+                <c:lvl>
+                  <c:pt idx="0">
+                    <c:v>In their 30s</c:v>
+                  </c:pt>
+                  <c:pt idx="1">
+                    <c:v>In their 20s</c:v>
+                  </c:pt>
+                  <c:pt idx="2">
+                    <c:v>Salaried (company or government)</c:v>
+                  </c:pt>
+                  <c:pt idx="3">
+                    <c:v>Blue-collar or farm worker</c:v>
+                  </c:pt>
+                  <c:pt idx="4">
+                    <c:v>AIS monthly phone bill</c:v>
+                  </c:pt>
+                  <c:pt idx="5">
+                    <c:v>Not an AIS customer</c:v>
+                  </c:pt>
+                  <c:pt idx="6">
+                    <c:v>Has a CLICX loan</c:v>
+                  </c:pt>
+                  <c:pt idx="7">
+                    <c:v>Has put money into CLICX</c:v>
+                  </c:pt>
+                </c:lvl>
+              </c:multiLvlStrCache>
+            </c:multiLvlStrRef>
+          </c:cat>
+          <c:val>
+            <c:numRef>
+              <c:f>Sheet1!$C$2:$C$9</c:f>
+              <c:numCache>
+                <c:formatCode>General</c:formatCode>
+                <c:ptCount val="8"/>
+                <c:pt idx="0">
+                  <c:v>0.382</c:v>
+                </c:pt>
+                <c:pt idx="1">
+                  <c:v>0.266</c:v>
+                </c:pt>
+                <c:pt idx="2">
+                  <c:v>0.37</c:v>
+                </c:pt>
+                <c:pt idx="3">
+                  <c:v>0.19</c:v>
+                </c:pt>
+                <c:pt idx="4">
+                  <c:v>0.188</c:v>
+                </c:pt>
+                <c:pt idx="5">
+                  <c:v>0.46</c:v>
+                </c:pt>
+                <c:pt idx="6">
+                  <c:v>0.059</c:v>
+                </c:pt>
+                <c:pt idx="7">
+                  <c:v>0.237</c:v>
+                </c:pt>
+              </c:numCache>
+            </c:numRef>
+          </c:val>
+        </c:ser>
+        <c:dLbls>
+          <c:numFmt formatCode="0%" sourceLinked="0"/>
+          <c:txPr>
+            <a:bodyPr/>
+            <a:lstStyle/>
+            <a:p>
+              <a:pPr>
+                <a:defRPr b="0" i="0" strike="noStrike" sz="900" u="none">
+                  <a:solidFill>
+                    <a:srgbClr val="1A1A1A"/>
+                  </a:solidFill>
+                  <a:latin typeface="+mn-lt"/>
+                </a:defRPr>
+              </a:pPr>
+            </a:p>
+          </c:txPr>
+          <c:showLegendKey val="0"/>
+          <c:showVal val="1"/>
+          <c:showCatName val="0"/>
+          <c:showSerName val="0"/>
+          <c:showPercent val="0"/>
+          <c:showBubbleSize val="0"/>
+          <c:showLeaderLines val="0"/>
+        </c:dLbls>
+        <c:gapWidth val="30"/>
+        <c:overlap val="0"/>
+        <c:axId val="2094734554"/>
+        <c:axId val="2094734552"/>
+        <c:axId val="2094734556"/>
+      </c:barChart>
+      <c:catAx>
+        <c:axId val="2094734554"/>
+        <c:scaling>
+          <c:orientation val="maxMin"/>
+        </c:scaling>
+        <c:delete val="0"/>
+        <c:axPos val="l"/>
+        <c:numFmt formatCode="General" sourceLinked="1"/>
+        <c:majorTickMark val="out"/>
+        <c:minorTickMark val="none"/>
+        <c:tickLblPos val="nextTo"/>
+        <c:spPr>
+          <a:ln w="12700" cap="flat">
+            <a:solidFill>
+              <a:srgbClr val="D5DADF"/>
+            </a:solidFill>
+            <a:prstDash val="solid"/>
+            <a:round/>
+          </a:ln>
+        </c:spPr>
+        <c:txPr>
+          <a:bodyPr/>
+          <a:lstStyle/>
+          <a:p>
+            <a:pPr>
+              <a:defRPr sz="1000" b="0" i="0" u="none" strike="noStrike">
+                <a:solidFill>
+                  <a:srgbClr val="5F6B76"/>
+                </a:solidFill>
+                <a:latin typeface="+mn-lt"/>
+              </a:defRPr>
+            </a:pPr>
+            <a:endParaRPr lang="en-US"/>
+          </a:p>
+        </c:txPr>
+        <c:crossAx val="2094734552"/>
+        <c:crosses val="autoZero"/>
+        <c:auto val="1"/>
+        <c:lblAlgn val="ctr"/>
+        <c:noMultiLvlLbl val="1"/>
+      </c:catAx>
+      <c:valAx>
+        <c:axId val="2094734552"/>
+        <c:scaling>
+          <c:orientation val="minMax"/>
+          <c:max val="1.2"/>
+        </c:scaling>
+        <c:delete val="1"/>
+        <c:axPos val="b"/>
+        <c:numFmt formatCode="General" sourceLinked="0"/>
+        <c:majorTickMark val="out"/>
+        <c:minorTickMark val="none"/>
+        <c:tickLblPos val="low"/>
+        <c:spPr>
+          <a:ln w="12700" cap="flat">
+            <a:solidFill>
+              <a:srgbClr val="888888"/>
+            </a:solidFill>
+            <a:prstDash val="solid"/>
+            <a:round/>
+          </a:ln>
+        </c:spPr>
+        <c:txPr>
+          <a:bodyPr/>
+          <a:lstStyle/>
+          <a:p>
+            <a:pPr>
+              <a:defRPr sz="1000" b="0" i="0" u="none" strike="noStrike">
+                <a:solidFill>
+                  <a:srgbClr val="5F6B76"/>
+                </a:solidFill>
+                <a:latin typeface="+mn-lt"/>
+              </a:defRPr>
+            </a:pPr>
+            <a:endParaRPr lang="en-US"/>
+          </a:p>
+        </c:txPr>
+        <c:crossAx val="2094734554"/>
+        <c:crosses val="autoZero"/>
+        <c:crossBetween val="between"/>
+      </c:valAx>
+      <c:spPr>
+        <a:noFill/>
+        <a:ln>
+          <a:noFill/>
+        </a:ln>
+        <a:effectLst/>
+      </c:spPr>
+    </c:plotArea>
+    <c:legend>
+      <c:legendPos val="b"/>
+      <c:overlay val="0"/>
+      <c:txPr>
+        <a:bodyPr/>
+        <a:lstStyle/>
+        <a:p>
+          <a:pPr>
+            <a:defRPr sz="1000">
+              <a:solidFill>
+                <a:srgbClr val="5F6B76"/>
+              </a:solidFill>
+              <a:latin typeface="+mn-lt"/>
+              <a:cs typeface="+mn-lt"/>
+            </a:defRPr>
+          </a:pPr>
+          <a:endParaRPr lang="en-US"/>
+        </a:p>
+      </c:txPr>
+    </c:legend>
+    <c:plotVisOnly val="1"/>
+    <c:dispBlanksAs val="span"/>
+  </c:chart>
+  <c:spPr>
+    <a:noFill/>
+    <a:ln>
+      <a:noFill/>
+    </a:ln>
+    <a:effectLst/>
+  </c:spPr>
+  <c:externalData r:id="rId1">
+    <c:autoUpdate val="0"/>
+  </c:externalData>
+</c:chartSpace>
+</file>
+
+<file path=ppt/charts/chart11.xml><?xml version="1.0" encoding="utf-8"?>
 <c:chartSpace xmlns:c="http://schemas.openxmlformats.org/drawingml/2006/chart" xmlns:a="http://schemas.openxmlformats.org/drawingml/2006/main" xmlns:r="http://schemas.openxmlformats.org/officeDocument/2006/relationships">
   <c:date1904 val="0"/>
   <c:roundedCorners val="1"/>
@@ -769,7 +1193,7 @@
 </c:chartSpace>
 </file>
 
-<file path=ppt/charts/chart11.xml><?xml version="1.0" encoding="utf-8"?>
+<file path=ppt/charts/chart12.xml><?xml version="1.0" encoding="utf-8"?>
 <c:chartSpace xmlns:c="http://schemas.openxmlformats.org/drawingml/2006/chart" xmlns:a="http://schemas.openxmlformats.org/drawingml/2006/main" xmlns:r="http://schemas.openxmlformats.org/officeDocument/2006/relationships">
   <c:date1904 val="0"/>
   <c:roundedCorners val="1"/>
@@ -1078,7 +1502,7 @@
 </c:chartSpace>
 </file>
 
-<file path=ppt/charts/chart12.xml><?xml version="1.0" encoding="utf-8"?>
+<file path=ppt/charts/chart13.xml><?xml version="1.0" encoding="utf-8"?>
 <c:chartSpace xmlns:c="http://schemas.openxmlformats.org/drawingml/2006/chart" xmlns:a="http://schemas.openxmlformats.org/drawingml/2006/main" xmlns:r="http://schemas.openxmlformats.org/officeDocument/2006/relationships">
   <c:date1904 val="0"/>
   <c:roundedCorners val="1"/>
@@ -5056,6 +5480,94 @@
 </p:notes>
 </file>
 
+<file path=ppt/notesSlides/notesSlide13.xml><?xml version="1.0" encoding="utf-8"?>
+<p:notes xmlns:a="http://schemas.openxmlformats.org/drawingml/2006/main" xmlns:r="http://schemas.openxmlformats.org/officeDocument/2006/relationships" xmlns:p="http://schemas.openxmlformats.org/presentationml/2006/main">
+  <p:cSld>
+    <p:spTree>
+      <p:nvGrpSpPr>
+        <p:cNvPr id="1" name=""/>
+        <p:cNvGrpSpPr/>
+        <p:nvPr/>
+      </p:nvGrpSpPr>
+      <p:grpSpPr>
+        <a:xfrm>
+          <a:off x="0" y="0"/>
+          <a:ext cx="0" cy="0"/>
+          <a:chOff x="0" y="0"/>
+          <a:chExt cx="0" cy="0"/>
+        </a:xfrm>
+      </p:grpSpPr>
+      <p:sp>
+        <p:nvSpPr>
+          <p:cNvPr id="2" name="Slide Image Placeholder 1"/>
+          <p:cNvSpPr>
+            <a:spLocks noGrp="1" noRot="1" noChangeAspect="1"/>
+          </p:cNvSpPr>
+          <p:nvPr>
+            <p:ph type="sldImg"/>
+          </p:nvPr>
+        </p:nvSpPr>
+        <p:spPr/>
+      </p:sp>
+      <p:sp>
+        <p:nvSpPr>
+          <p:cNvPr id="3" name="Notes Placeholder 2"/>
+          <p:cNvSpPr>
+            <a:spLocks noGrp="1"/>
+          </p:cNvSpPr>
+          <p:nvPr>
+            <p:ph type="body" idx="1"/>
+          </p:nvPr>
+        </p:nvSpPr>
+        <p:spPr/>
+        <p:txBody>
+          <a:bodyPr/>
+          <a:lstStyle/>
+          <a:p>
+            <a:r>
+              <a:rPr lang="en-US" dirty="0"/>
+              <a:t/>
+            </a:r>
+            <a:endParaRPr lang="en-US" dirty="0"/>
+          </a:p>
+        </p:txBody>
+      </p:sp>
+      <p:sp>
+        <p:nvSpPr>
+          <p:cNvPr id="4" name="Slide Number Placeholder 3"/>
+          <p:cNvSpPr>
+            <a:spLocks noGrp="1"/>
+          </p:cNvSpPr>
+          <p:nvPr>
+            <p:ph type="sldNum" sz="quarter" idx="10"/>
+          </p:nvPr>
+        </p:nvSpPr>
+        <p:spPr/>
+        <p:txBody>
+          <a:bodyPr/>
+          <a:lstStyle/>
+          <a:p>
+            <a:fld id="{F7021451-1387-4CA6-816F-3879F97B5CBC}" type="slidenum">
+              <a:rPr lang="en-US"/>
+              <a:t>13</a:t>
+            </a:fld>
+            <a:endParaRPr lang="en-US"/>
+          </a:p>
+        </p:txBody>
+      </p:sp>
+    </p:spTree>
+    <p:extLst>
+      <p:ext uri="{BB962C8B-B14F-4D97-AF65-F5344CB8AC3E}">
+        <p14:creationId xmlns:p14="http://schemas.microsoft.com/office/powerpoint/2010/main" val="1024086991"/>
+      </p:ext>
+    </p:extLst>
+  </p:cSld>
+  <p:clrMapOvr>
+    <a:masterClrMapping/>
+  </p:clrMapOvr>
+</p:notes>
+</file>
+
 <file path=ppt/notesSlides/notesSlide2.xml><?xml version="1.0" encoding="utf-8"?>
 <p:notes xmlns:a="http://schemas.openxmlformats.org/drawingml/2006/main" xmlns:r="http://schemas.openxmlformats.org/officeDocument/2006/relationships" xmlns:p="http://schemas.openxmlformats.org/presentationml/2006/main">
   <p:cSld>
@@ -6809,6 +7321,852 @@
                   <a:schemeClr val="accent1"/>
                 </a:solidFill>
               </a:rPr>
+              <a:t>Q4  |  WHO KEEPS USING US  (3/3)</a:t>
+            </a:r>
+            <a:endParaRPr lang="en-US" sz="1100" dirty="0"/>
+          </a:p>
+        </p:txBody>
+      </p:sp>
+      <p:sp>
+        <p:nvSpPr>
+          <p:cNvPr id="3" name="Text 0"/>
+          <p:cNvSpPr/>
+          <p:nvPr>
+            <p:ph idx="101" type="title" hasCustomPrompt="1"/>
+          </p:nvPr>
+        </p:nvSpPr>
+        <p:spPr>
+          <a:xfrm>
+            <a:off x="457200" y="566928"/>
+            <a:ext cx="11274552" cy="822960"/>
+          </a:xfrm>
+          <a:prstGeom prst="rect">
+            <a:avLst/>
+          </a:prstGeom>
+          <a:noFill/>
+          <a:ln/>
+        </p:spPr>
+        <p:txBody>
+          <a:bodyPr wrap="square" lIns="0" tIns="0" rIns="0" bIns="0" rtlCol="0" anchor="t"/>
+          <a:lstStyle/>
+          <a:p>
+            <a:pPr algn="l" indent="0" marL="0">
+              <a:buNone/>
+            </a:pPr>
+            <a:r>
+              <a:rPr lang="en-US" sz="2400" b="1" dirty="0">
+                <a:solidFill>
+                  <a:schemeClr val="tx2"/>
+                </a:solidFill>
+              </a:rPr>
+              <a:t>Who pays bills, tops up or scans to pay with CLICX, and are they different from those who don't?</a:t>
+            </a:r>
+            <a:endParaRPr lang="en-US" sz="2400" dirty="0"/>
+          </a:p>
+        </p:txBody>
+      </p:sp>
+      <p:sp>
+        <p:nvSpPr>
+          <p:cNvPr id="4" name="Text 0"/>
+          <p:cNvSpPr/>
+          <p:nvPr>
+            <p:ph idx="102" type="body" hasCustomPrompt="1"/>
+          </p:nvPr>
+        </p:nvSpPr>
+        <p:spPr>
+          <a:xfrm>
+            <a:off x="457200" y="1481328"/>
+            <a:ext cx="11274552" cy="594360"/>
+          </a:xfrm>
+          <a:prstGeom prst="rect">
+            <a:avLst/>
+          </a:prstGeom>
+          <a:noFill/>
+          <a:ln/>
+        </p:spPr>
+        <p:txBody>
+          <a:bodyPr wrap="square" lIns="0" tIns="0" rIns="0" bIns="0" rtlCol="0" anchor="t"/>
+          <a:lstStyle/>
+          <a:p>
+            <a:pPr indent="0" marL="0">
+              <a:buNone/>
+            </a:pPr>
+            <a:r>
+              <a:rPr lang="en-US" sz="1600" dirty="0">
+                <a:solidFill>
+                  <a:schemeClr val="tx1"/>
+                </a:solidFill>
+              </a:rPr>
+              <a:t>Payers are not a different type of person: their age and job look almost the same as non-payers. What sets them apart is that they have put money in and got a loan</a:t>
+            </a:r>
+            <a:endParaRPr lang="en-US" sz="1600" dirty="0"/>
+          </a:p>
+        </p:txBody>
+      </p:sp>
+      <p:sp>
+        <p:nvSpPr>
+          <p:cNvPr id="5" name="Text 0"/>
+          <p:cNvSpPr/>
+          <p:nvPr>
+            <p:ph idx="103" type="body" hasCustomPrompt="1"/>
+          </p:nvPr>
+        </p:nvSpPr>
+        <p:spPr>
+          <a:xfrm>
+            <a:off x="457200" y="6327648"/>
+            <a:ext cx="10241280" cy="274320"/>
+          </a:xfrm>
+          <a:prstGeom prst="rect">
+            <a:avLst/>
+          </a:prstGeom>
+          <a:noFill/>
+          <a:ln/>
+        </p:spPr>
+        <p:txBody>
+          <a:bodyPr wrap="square" lIns="0" tIns="0" rIns="0" bIns="0" rtlCol="0" anchor="t"/>
+          <a:lstStyle/>
+          <a:p>
+            <a:pPr indent="0" marL="0">
+              <a:buNone/>
+            </a:pPr>
+            <a:r>
+              <a:rPr lang="en-US" sz="1000" dirty="0">
+                <a:solidFill>
+                  <a:srgbClr val="6E7C87"/>
+                </a:solidFill>
+              </a:rPr>
+              <a:t>Source: CLICX payment segments, Aug–Oct 2026 (1.50M customers with an account)</a:t>
+            </a:r>
+            <a:endParaRPr lang="en-US" sz="1000" dirty="0"/>
+          </a:p>
+        </p:txBody>
+      </p:sp>
+      <p:sp>
+        <p:nvSpPr>
+          <p:cNvPr id="6" name="Stat 8%"/>
+          <p:cNvSpPr txBox="1"/>
+          <p:nvPr/>
+        </p:nvSpPr>
+        <p:spPr>
+          <a:xfrm>
+            <a:off x="457200" y="2194560"/>
+            <a:ext cx="2194560" cy="640080"/>
+          </a:xfrm>
+          <a:prstGeom prst="rect">
+            <a:avLst/>
+          </a:prstGeom>
+          <a:noFill/>
+          <a:ln/>
+        </p:spPr>
+        <p:txBody>
+          <a:bodyPr wrap="square" lIns="0" tIns="0" rIns="0" bIns="0" rtlCol="0" anchor="ctr"/>
+          <a:lstStyle/>
+          <a:p>
+            <a:pPr indent="0" marL="0">
+              <a:buNone/>
+            </a:pPr>
+            <a:r>
+              <a:rPr lang="en-US" sz="4000" b="1" dirty="0">
+                <a:solidFill>
+                  <a:schemeClr val="accent1"/>
+                </a:solidFill>
+              </a:rPr>
+              <a:t>8%</a:t>
+            </a:r>
+            <a:endParaRPr lang="en-US" sz="4000" dirty="0"/>
+          </a:p>
+        </p:txBody>
+      </p:sp>
+      <p:sp>
+        <p:nvSpPr>
+          <p:cNvPr id="7" name="Stat label 8%"/>
+          <p:cNvSpPr txBox="1"/>
+          <p:nvPr/>
+        </p:nvSpPr>
+        <p:spPr>
+          <a:xfrm>
+            <a:off x="457200" y="2852928"/>
+            <a:ext cx="2194560" cy="502920"/>
+          </a:xfrm>
+          <a:prstGeom prst="rect">
+            <a:avLst/>
+          </a:prstGeom>
+          <a:noFill/>
+          <a:ln/>
+        </p:spPr>
+        <p:txBody>
+          <a:bodyPr wrap="square" lIns="0" tIns="0" rIns="0" bIns="0" rtlCol="0" anchor="t"/>
+          <a:lstStyle/>
+          <a:p>
+            <a:pPr indent="0" marL="0">
+              <a:buNone/>
+            </a:pPr>
+            <a:r>
+              <a:rPr lang="en-US" sz="1200" dirty="0">
+                <a:solidFill>
+                  <a:schemeClr val="tx1"/>
+                </a:solidFill>
+              </a:rPr>
+              <a:t>paid with CLICX in October (117K of 1.5M)</a:t>
+            </a:r>
+            <a:endParaRPr lang="en-US" sz="1200" dirty="0"/>
+          </a:p>
+        </p:txBody>
+      </p:sp>
+      <p:sp>
+        <p:nvSpPr>
+          <p:cNvPr id="8" name="Stat 85%"/>
+          <p:cNvSpPr txBox="1"/>
+          <p:nvPr/>
+        </p:nvSpPr>
+        <p:spPr>
+          <a:xfrm>
+            <a:off x="457200" y="3611880"/>
+            <a:ext cx="2194560" cy="640080"/>
+          </a:xfrm>
+          <a:prstGeom prst="rect">
+            <a:avLst/>
+          </a:prstGeom>
+          <a:noFill/>
+          <a:ln/>
+        </p:spPr>
+        <p:txBody>
+          <a:bodyPr wrap="square" lIns="0" tIns="0" rIns="0" bIns="0" rtlCol="0" anchor="ctr"/>
+          <a:lstStyle/>
+          <a:p>
+            <a:pPr indent="0" marL="0">
+              <a:buNone/>
+            </a:pPr>
+            <a:r>
+              <a:rPr lang="en-US" sz="4000" b="1" dirty="0">
+                <a:solidFill>
+                  <a:schemeClr val="tx2"/>
+                </a:solidFill>
+              </a:rPr>
+              <a:t>85%</a:t>
+            </a:r>
+            <a:endParaRPr lang="en-US" sz="4000" dirty="0"/>
+          </a:p>
+        </p:txBody>
+      </p:sp>
+      <p:sp>
+        <p:nvSpPr>
+          <p:cNvPr id="9" name="Stat label 85%"/>
+          <p:cNvSpPr txBox="1"/>
+          <p:nvPr/>
+        </p:nvSpPr>
+        <p:spPr>
+          <a:xfrm>
+            <a:off x="457200" y="4270248"/>
+            <a:ext cx="2194560" cy="502920"/>
+          </a:xfrm>
+          <a:prstGeom prst="rect">
+            <a:avLst/>
+          </a:prstGeom>
+          <a:noFill/>
+          <a:ln/>
+        </p:spPr>
+        <p:txBody>
+          <a:bodyPr wrap="square" lIns="0" tIns="0" rIns="0" bIns="0" rtlCol="0" anchor="t"/>
+          <a:lstStyle/>
+          <a:p>
+            <a:pPr indent="0" marL="0">
+              <a:buNone/>
+            </a:pPr>
+            <a:r>
+              <a:rPr lang="en-US" sz="1200" dirty="0">
+                <a:solidFill>
+                  <a:schemeClr val="tx1"/>
+                </a:solidFill>
+              </a:rPr>
+              <a:t>have never paid with CLICX in the last 3 months (1.27M)</a:t>
+            </a:r>
+            <a:endParaRPr lang="en-US" sz="1200" dirty="0"/>
+          </a:p>
+        </p:txBody>
+      </p:sp>
+      <p:sp>
+        <p:nvSpPr>
+          <p:cNvPr id="10" name="Stat −29%"/>
+          <p:cNvSpPr txBox="1"/>
+          <p:nvPr/>
+        </p:nvSpPr>
+        <p:spPr>
+          <a:xfrm>
+            <a:off x="457200" y="5029200"/>
+            <a:ext cx="2194560" cy="640080"/>
+          </a:xfrm>
+          <a:prstGeom prst="rect">
+            <a:avLst/>
+          </a:prstGeom>
+          <a:noFill/>
+          <a:ln/>
+        </p:spPr>
+        <p:txBody>
+          <a:bodyPr wrap="square" lIns="0" tIns="0" rIns="0" bIns="0" rtlCol="0" anchor="ctr"/>
+          <a:lstStyle/>
+          <a:p>
+            <a:pPr indent="0" marL="0">
+              <a:buNone/>
+            </a:pPr>
+            <a:r>
+              <a:rPr lang="en-US" sz="4000" b="1" dirty="0">
+                <a:solidFill>
+                  <a:schemeClr val="accent5"/>
+                </a:solidFill>
+              </a:rPr>
+              <a:t>−29%</a:t>
+            </a:r>
+            <a:endParaRPr lang="en-US" sz="4000" dirty="0"/>
+          </a:p>
+        </p:txBody>
+      </p:sp>
+      <p:sp>
+        <p:nvSpPr>
+          <p:cNvPr id="11" name="Stat label −29%"/>
+          <p:cNvSpPr txBox="1"/>
+          <p:nvPr/>
+        </p:nvSpPr>
+        <p:spPr>
+          <a:xfrm>
+            <a:off x="457200" y="5687568"/>
+            <a:ext cx="2194560" cy="502920"/>
+          </a:xfrm>
+          <a:prstGeom prst="rect">
+            <a:avLst/>
+          </a:prstGeom>
+          <a:noFill/>
+          <a:ln/>
+        </p:spPr>
+        <p:txBody>
+          <a:bodyPr wrap="square" lIns="0" tIns="0" rIns="0" bIns="0" rtlCol="0" anchor="t"/>
+          <a:lstStyle/>
+          <a:p>
+            <a:pPr indent="0" marL="0">
+              <a:buNone/>
+            </a:pPr>
+            <a:r>
+              <a:rPr lang="en-US" sz="1200" dirty="0">
+                <a:solidFill>
+                  <a:schemeClr val="tx1"/>
+                </a:solidFill>
+              </a:rPr>
+              <a:t>fewer payers in Oct than in Aug</a:t>
+            </a:r>
+            <a:endParaRPr lang="en-US" sz="1200" dirty="0"/>
+          </a:p>
+        </p:txBody>
+      </p:sp>
+      <p:graphicFrame>
+        <p:nvGraphicFramePr>
+          <p:cNvPr id="12" name="Payers vs non-payers profile" descr=""/>
+          <p:cNvGraphicFramePr/>
+          <p:nvPr/>
+        </p:nvGraphicFramePr>
+        <p:xfrm>
+          <a:off x="2834640" y="2148840"/>
+          <a:ext cx="5303520" cy="3977640"/>
+        </p:xfrm>
+        <a:graphic xmlns:a="http://schemas.openxmlformats.org/drawingml/2006/main">
+          <a:graphicData uri="http://schemas.openxmlformats.org/drawingml/2006/chart">
+            <c:chart xmlns:c="http://schemas.openxmlformats.org/drawingml/2006/chart" r:id="rId1"/>
+          </a:graphicData>
+        </a:graphic>
+      </p:graphicFrame>
+      <p:sp>
+        <p:nvSpPr>
+          <p:cNvPr id="13" name="Insight panel"/>
+          <p:cNvSpPr/>
+          <p:nvPr/>
+        </p:nvSpPr>
+        <p:spPr>
+          <a:xfrm>
+            <a:off x="8275320" y="2148840"/>
+            <a:ext cx="3456432" cy="3977640"/>
+          </a:xfrm>
+          <a:prstGeom prst="rect">
+            <a:avLst/>
+          </a:prstGeom>
+          <a:solidFill>
+            <a:schemeClr val="bg2"/>
+          </a:solidFill>
+          <a:ln/>
+        </p:spPr>
+      </p:sp>
+      <p:sp>
+        <p:nvSpPr>
+          <p:cNvPr id="14" name="Insight header"/>
+          <p:cNvSpPr txBox="1"/>
+          <p:nvPr/>
+        </p:nvSpPr>
+        <p:spPr>
+          <a:xfrm>
+            <a:off x="8503920" y="2313432"/>
+            <a:ext cx="2999232" cy="274320"/>
+          </a:xfrm>
+          <a:prstGeom prst="rect">
+            <a:avLst/>
+          </a:prstGeom>
+          <a:noFill/>
+          <a:ln/>
+        </p:spPr>
+        <p:txBody>
+          <a:bodyPr wrap="square" lIns="0" tIns="0" rIns="0" bIns="0" rtlCol="0" anchor="ctr"/>
+          <a:lstStyle/>
+          <a:p>
+            <a:pPr indent="0" marL="0">
+              <a:buNone/>
+            </a:pPr>
+            <a:r>
+              <a:rPr lang="en-US" sz="1100" b="1" spc="100" kern="0" dirty="0">
+                <a:solidFill>
+                  <a:schemeClr val="accent1"/>
+                </a:solidFill>
+              </a:rPr>
+              <a:t>SO WHAT</a:t>
+            </a:r>
+            <a:endParaRPr lang="en-US" sz="1100" dirty="0"/>
+          </a:p>
+        </p:txBody>
+      </p:sp>
+      <p:sp>
+        <p:nvSpPr>
+          <p:cNvPr id="15" name="Badge 1"/>
+          <p:cNvSpPr/>
+          <p:nvPr/>
+        </p:nvSpPr>
+        <p:spPr>
+          <a:xfrm>
+            <a:off x="8503920" y="2715768"/>
+            <a:ext cx="292608" cy="292608"/>
+          </a:xfrm>
+          <a:prstGeom prst="ellipse">
+            <a:avLst/>
+          </a:prstGeom>
+          <a:solidFill>
+            <a:schemeClr val="tx2"/>
+          </a:solidFill>
+          <a:ln/>
+        </p:spPr>
+      </p:sp>
+      <p:sp>
+        <p:nvSpPr>
+          <p:cNvPr id="16" name="Badge num 1"/>
+          <p:cNvSpPr txBox="1"/>
+          <p:nvPr/>
+        </p:nvSpPr>
+        <p:spPr>
+          <a:xfrm>
+            <a:off x="8503920" y="2715768"/>
+            <a:ext cx="292608" cy="292608"/>
+          </a:xfrm>
+          <a:prstGeom prst="rect">
+            <a:avLst/>
+          </a:prstGeom>
+          <a:noFill/>
+          <a:ln/>
+        </p:spPr>
+        <p:txBody>
+          <a:bodyPr wrap="square" lIns="0" tIns="0" rIns="0" bIns="0" rtlCol="0" anchor="ctr"/>
+          <a:lstStyle/>
+          <a:p>
+            <a:pPr algn="ctr" indent="0" marL="0">
+              <a:buNone/>
+            </a:pPr>
+            <a:r>
+              <a:rPr lang="en-US" sz="1100" b="1" dirty="0">
+                <a:solidFill>
+                  <a:schemeClr val="bg1"/>
+                </a:solidFill>
+              </a:rPr>
+              <a:t>1</a:t>
+            </a:r>
+            <a:endParaRPr lang="en-US" sz="1100" dirty="0"/>
+          </a:p>
+        </p:txBody>
+      </p:sp>
+      <p:sp>
+        <p:nvSpPr>
+          <p:cNvPr id="17" name="Insight 1"/>
+          <p:cNvSpPr txBox="1"/>
+          <p:nvPr/>
+        </p:nvSpPr>
+        <p:spPr>
+          <a:xfrm>
+            <a:off x="8915400" y="2670048"/>
+            <a:ext cx="2633472" cy="1054608"/>
+          </a:xfrm>
+          <a:prstGeom prst="rect">
+            <a:avLst/>
+          </a:prstGeom>
+          <a:noFill/>
+          <a:ln/>
+        </p:spPr>
+        <p:txBody>
+          <a:bodyPr wrap="square" lIns="0" tIns="0" rIns="0" bIns="0" rtlCol="0" anchor="t"/>
+          <a:lstStyle/>
+          <a:p>
+            <a:pPr indent="0" marL="0">
+              <a:spcAft>
+                <a:spcPts val="300"/>
+              </a:spcAft>
+              <a:buNone/>
+            </a:pPr>
+            <a:r>
+              <a:rPr lang="en-US" sz="1400" b="1" dirty="0">
+                <a:solidFill>
+                  <a:schemeClr val="tx2"/>
+                </a:solidFill>
+              </a:rPr>
+              <a:t>Age and job barely matter</a:t>
+            </a:r>
+            <a:endParaRPr lang="en-US" sz="1400" dirty="0"/>
+          </a:p>
+          <a:p>
+            <a:pPr indent="0" marL="0">
+              <a:spcAft>
+                <a:spcPts val="300"/>
+              </a:spcAft>
+              <a:buNone/>
+            </a:pPr>
+            <a:r>
+              <a:rPr lang="en-US" sz="1200" dirty="0">
+                <a:solidFill>
+                  <a:schemeClr val="tx1"/>
+                </a:solidFill>
+              </a:rPr>
+              <a:t>Gaps are small: 41% vs 38% in their 30s, 44% vs 37% salaried, 14% vs 19% blue-collar</a:t>
+            </a:r>
+            <a:endParaRPr lang="en-US" sz="1400" dirty="0"/>
+          </a:p>
+        </p:txBody>
+      </p:sp>
+      <p:sp>
+        <p:nvSpPr>
+          <p:cNvPr id="18" name="Badge 2"/>
+          <p:cNvSpPr/>
+          <p:nvPr/>
+        </p:nvSpPr>
+        <p:spPr>
+          <a:xfrm>
+            <a:off x="8503920" y="3843528"/>
+            <a:ext cx="292608" cy="292608"/>
+          </a:xfrm>
+          <a:prstGeom prst="ellipse">
+            <a:avLst/>
+          </a:prstGeom>
+          <a:solidFill>
+            <a:schemeClr val="tx2"/>
+          </a:solidFill>
+          <a:ln/>
+        </p:spPr>
+      </p:sp>
+      <p:sp>
+        <p:nvSpPr>
+          <p:cNvPr id="19" name="Badge num 2"/>
+          <p:cNvSpPr txBox="1"/>
+          <p:nvPr/>
+        </p:nvSpPr>
+        <p:spPr>
+          <a:xfrm>
+            <a:off x="8503920" y="3843528"/>
+            <a:ext cx="292608" cy="292608"/>
+          </a:xfrm>
+          <a:prstGeom prst="rect">
+            <a:avLst/>
+          </a:prstGeom>
+          <a:noFill/>
+          <a:ln/>
+        </p:spPr>
+        <p:txBody>
+          <a:bodyPr wrap="square" lIns="0" tIns="0" rIns="0" bIns="0" rtlCol="0" anchor="ctr"/>
+          <a:lstStyle/>
+          <a:p>
+            <a:pPr algn="ctr" indent="0" marL="0">
+              <a:buNone/>
+            </a:pPr>
+            <a:r>
+              <a:rPr lang="en-US" sz="1100" b="1" dirty="0">
+                <a:solidFill>
+                  <a:schemeClr val="bg1"/>
+                </a:solidFill>
+              </a:rPr>
+              <a:t>2</a:t>
+            </a:r>
+            <a:endParaRPr lang="en-US" sz="1100" dirty="0"/>
+          </a:p>
+        </p:txBody>
+      </p:sp>
+      <p:sp>
+        <p:nvSpPr>
+          <p:cNvPr id="20" name="Insight 2"/>
+          <p:cNvSpPr txBox="1"/>
+          <p:nvPr/>
+        </p:nvSpPr>
+        <p:spPr>
+          <a:xfrm>
+            <a:off x="8915400" y="3797808"/>
+            <a:ext cx="2633472" cy="1054608"/>
+          </a:xfrm>
+          <a:prstGeom prst="rect">
+            <a:avLst/>
+          </a:prstGeom>
+          <a:noFill/>
+          <a:ln/>
+        </p:spPr>
+        <p:txBody>
+          <a:bodyPr wrap="square" lIns="0" tIns="0" rIns="0" bIns="0" rtlCol="0" anchor="t"/>
+          <a:lstStyle/>
+          <a:p>
+            <a:pPr indent="0" marL="0">
+              <a:spcAft>
+                <a:spcPts val="300"/>
+              </a:spcAft>
+              <a:buNone/>
+            </a:pPr>
+            <a:r>
+              <a:rPr lang="en-US" sz="1400" b="1" dirty="0">
+                <a:solidFill>
+                  <a:schemeClr val="tx2"/>
+                </a:solidFill>
+              </a:rPr>
+              <a:t>Money in is the dividing line</a:t>
+            </a:r>
+            <a:endParaRPr lang="en-US" sz="1400" dirty="0"/>
+          </a:p>
+          <a:p>
+            <a:pPr indent="0" marL="0">
+              <a:spcAft>
+                <a:spcPts val="300"/>
+              </a:spcAft>
+              <a:buNone/>
+            </a:pPr>
+            <a:r>
+              <a:rPr lang="en-US" sz="1200" dirty="0">
+                <a:solidFill>
+                  <a:schemeClr val="tx1"/>
+                </a:solidFill>
+              </a:rPr>
+              <a:t>Nearly all regular payers have put money in, vs 24% of non-payers. Without money in, almost no one pays (0.1%)</a:t>
+            </a:r>
+            <a:endParaRPr lang="en-US" sz="1400" dirty="0"/>
+          </a:p>
+        </p:txBody>
+      </p:sp>
+      <p:sp>
+        <p:nvSpPr>
+          <p:cNvPr id="21" name="Badge 3"/>
+          <p:cNvSpPr/>
+          <p:nvPr/>
+        </p:nvSpPr>
+        <p:spPr>
+          <a:xfrm>
+            <a:off x="8503920" y="4971288"/>
+            <a:ext cx="292608" cy="292608"/>
+          </a:xfrm>
+          <a:prstGeom prst="ellipse">
+            <a:avLst/>
+          </a:prstGeom>
+          <a:solidFill>
+            <a:schemeClr val="tx2"/>
+          </a:solidFill>
+          <a:ln/>
+        </p:spPr>
+      </p:sp>
+      <p:sp>
+        <p:nvSpPr>
+          <p:cNvPr id="22" name="Badge num 3"/>
+          <p:cNvSpPr txBox="1"/>
+          <p:nvPr/>
+        </p:nvSpPr>
+        <p:spPr>
+          <a:xfrm>
+            <a:off x="8503920" y="4971288"/>
+            <a:ext cx="292608" cy="292608"/>
+          </a:xfrm>
+          <a:prstGeom prst="rect">
+            <a:avLst/>
+          </a:prstGeom>
+          <a:noFill/>
+          <a:ln/>
+        </p:spPr>
+        <p:txBody>
+          <a:bodyPr wrap="square" lIns="0" tIns="0" rIns="0" bIns="0" rtlCol="0" anchor="ctr"/>
+          <a:lstStyle/>
+          <a:p>
+            <a:pPr algn="ctr" indent="0" marL="0">
+              <a:buNone/>
+            </a:pPr>
+            <a:r>
+              <a:rPr lang="en-US" sz="1100" b="1" dirty="0">
+                <a:solidFill>
+                  <a:schemeClr val="bg1"/>
+                </a:solidFill>
+              </a:rPr>
+              <a:t>3</a:t>
+            </a:r>
+            <a:endParaRPr lang="en-US" sz="1100" dirty="0"/>
+          </a:p>
+        </p:txBody>
+      </p:sp>
+      <p:sp>
+        <p:nvSpPr>
+          <p:cNvPr id="23" name="Insight 3"/>
+          <p:cNvSpPr txBox="1"/>
+          <p:nvPr/>
+        </p:nvSpPr>
+        <p:spPr>
+          <a:xfrm>
+            <a:off x="8915400" y="4925568"/>
+            <a:ext cx="2633472" cy="1054608"/>
+          </a:xfrm>
+          <a:prstGeom prst="rect">
+            <a:avLst/>
+          </a:prstGeom>
+          <a:noFill/>
+          <a:ln/>
+        </p:spPr>
+        <p:txBody>
+          <a:bodyPr wrap="square" lIns="0" tIns="0" rIns="0" bIns="0" rtlCol="0" anchor="t"/>
+          <a:lstStyle/>
+          <a:p>
+            <a:pPr indent="0" marL="0">
+              <a:spcAft>
+                <a:spcPts val="300"/>
+              </a:spcAft>
+              <a:buNone/>
+            </a:pPr>
+            <a:r>
+              <a:rPr lang="en-US" sz="1400" b="1" dirty="0">
+                <a:solidFill>
+                  <a:schemeClr val="tx2"/>
+                </a:solidFill>
+              </a:rPr>
+              <a:t>Loans and phone bills help</a:t>
+            </a:r>
+            <a:endParaRPr lang="en-US" sz="1400" dirty="0"/>
+          </a:p>
+          <a:p>
+            <a:pPr indent="0" marL="0">
+              <a:spcAft>
+                <a:spcPts val="300"/>
+              </a:spcAft>
+              <a:buNone/>
+            </a:pPr>
+            <a:r>
+              <a:rPr lang="en-US" sz="1200" dirty="0">
+                <a:solidFill>
+                  <a:schemeClr val="tx1"/>
+                </a:solidFill>
+              </a:rPr>
+              <a:t>46% of regular payers have a loan vs 6% of non-payers. AIS monthly-bill customers are 34% of regular payers vs 19% of non-payers</a:t>
+            </a:r>
+            <a:endParaRPr lang="en-US" sz="1400" dirty="0"/>
+          </a:p>
+        </p:txBody>
+      </p:sp>
+      <p:sp>
+        <p:nvSpPr>
+          <p:cNvPr id="25" name="Slide Number Placeholder 0"/>
+          <p:cNvSpPr>
+            <a:spLocks noGrp="1"/>
+          </p:cNvSpPr>
+          <p:nvPr>
+            <p:ph type="sldNum" sz="quarter" idx="4294967295"/>
+          </p:nvPr>
+        </p:nvSpPr>
+        <p:spPr>
+          <a:xfrm>
+            <a:off x="11274552" y="6355080"/>
+            <a:ext cx="457200" cy="274320"/>
+          </a:xfrm>
+          <a:prstGeom prst="rect">
+            <a:avLst/>
+          </a:prstGeom>
+          <a:extLst>
+            <a:ext uri="{C572A759-6A51-4108-AA02-DFA0A04FC94B}">
+              <ma14:wrappingTextBoxFlag xmlns:ma14="http://schemas.microsoft.com/office/mac/drawingml/2011/main" val="0"/>
+            </a:ext>
+          </a:extLst>
+        </p:spPr>
+        <p:txBody>
+          <a:bodyPr/>
+          <a:lstStyle>
+            <a:lvl1pPr>
+              <a:defRPr sz="1000">
+                <a:solidFill>
+                  <a:srgbClr val="6E7C87"/>
+                </a:solidFill>
+              </a:defRPr>
+            </a:lvl1pPr>
+          </a:lstStyle>
+          <a:p>
+            <a:pPr algn="r"/>
+            <a:fld id="{F7021451-1387-4CA6-816F-3879F97B5CBC}" type="slidenum">
+              <a:rPr b="0" lang="en-US"/>
+              <a:t>10</a:t>
+            </a:fld>
+            <a:endParaRPr lang="en-US"/>
+          </a:p>
+        </p:txBody>
+      </p:sp>
+    </p:spTree>
+  </p:cSld>
+  <p:clrMapOvr>
+    <a:masterClrMapping/>
+  </p:clrMapOvr>
+</p:sld>
+</file>
+
+<file path=ppt/slides/slide11.xml><?xml version="1.0" encoding="utf-8"?>
+<p:sld xmlns:a="http://schemas.openxmlformats.org/drawingml/2006/main" xmlns:r="http://schemas.openxmlformats.org/officeDocument/2006/relationships" xmlns:p="http://schemas.openxmlformats.org/presentationml/2006/main">
+  <p:cSld name="Slide 11">
+    <p:spTree>
+      <p:nvGrpSpPr>
+        <p:cNvPr id="1" name=""/>
+        <p:cNvGrpSpPr/>
+        <p:nvPr/>
+      </p:nvGrpSpPr>
+      <p:grpSpPr>
+        <a:xfrm>
+          <a:off x="0" y="0"/>
+          <a:ext cx="0" cy="0"/>
+          <a:chOff x="0" y="0"/>
+          <a:chExt cx="0" cy="0"/>
+        </a:xfrm>
+      </p:grpSpPr>
+      <p:sp>
+        <p:nvSpPr>
+          <p:cNvPr id="2" name="Text 0"/>
+          <p:cNvSpPr/>
+          <p:nvPr>
+            <p:ph idx="100" type="body" hasCustomPrompt="1"/>
+          </p:nvPr>
+        </p:nvSpPr>
+        <p:spPr>
+          <a:xfrm>
+            <a:off x="457200" y="274320"/>
+            <a:ext cx="8229600" cy="274320"/>
+          </a:xfrm>
+          <a:prstGeom prst="rect">
+            <a:avLst/>
+          </a:prstGeom>
+          <a:noFill/>
+          <a:ln/>
+        </p:spPr>
+        <p:txBody>
+          <a:bodyPr wrap="square" lIns="0" tIns="0" rIns="0" bIns="0" rtlCol="0"/>
+          <a:lstStyle/>
+          <a:p>
+            <a:pPr indent="0" marL="0">
+              <a:buNone/>
+            </a:pPr>
+            <a:r>
+              <a:rPr lang="en-US" sz="1100" b="1" spc="100" kern="0" dirty="0">
+                <a:solidFill>
+                  <a:schemeClr val="accent1"/>
+                </a:solidFill>
+              </a:rPr>
               <a:t>Q5  |  IMPACT ON KTB  (1/2)</a:t>
             </a:r>
             <a:endParaRPr lang="en-US" sz="1100" dirty="0"/>
@@ -7392,753 +8750,6 @@
             <a:pPr algn="r"/>
             <a:fld id="{F7021451-1387-4CA6-816F-3879F97B5CBC}" type="slidenum">
               <a:rPr b="0" lang="en-US"/>
-              <a:t>10</a:t>
-            </a:fld>
-            <a:endParaRPr lang="en-US"/>
-          </a:p>
-        </p:txBody>
-      </p:sp>
-    </p:spTree>
-  </p:cSld>
-  <p:clrMapOvr>
-    <a:masterClrMapping/>
-  </p:clrMapOvr>
-</p:sld>
-</file>
-
-<file path=ppt/slides/slide11.xml><?xml version="1.0" encoding="utf-8"?>
-<p:sld xmlns:a="http://schemas.openxmlformats.org/drawingml/2006/main" xmlns:r="http://schemas.openxmlformats.org/officeDocument/2006/relationships" xmlns:p="http://schemas.openxmlformats.org/presentationml/2006/main">
-  <p:cSld name="Slide 11">
-    <p:spTree>
-      <p:nvGrpSpPr>
-        <p:cNvPr id="1" name=""/>
-        <p:cNvGrpSpPr/>
-        <p:nvPr/>
-      </p:nvGrpSpPr>
-      <p:grpSpPr>
-        <a:xfrm>
-          <a:off x="0" y="0"/>
-          <a:ext cx="0" cy="0"/>
-          <a:chOff x="0" y="0"/>
-          <a:chExt cx="0" cy="0"/>
-        </a:xfrm>
-      </p:grpSpPr>
-      <p:sp>
-        <p:nvSpPr>
-          <p:cNvPr id="2" name="Text 0"/>
-          <p:cNvSpPr/>
-          <p:nvPr>
-            <p:ph idx="100" type="body" hasCustomPrompt="1"/>
-          </p:nvPr>
-        </p:nvSpPr>
-        <p:spPr>
-          <a:xfrm>
-            <a:off x="457200" y="274320"/>
-            <a:ext cx="8229600" cy="274320"/>
-          </a:xfrm>
-          <a:prstGeom prst="rect">
-            <a:avLst/>
-          </a:prstGeom>
-          <a:noFill/>
-          <a:ln/>
-        </p:spPr>
-        <p:txBody>
-          <a:bodyPr wrap="square" lIns="0" tIns="0" rIns="0" bIns="0" rtlCol="0"/>
-          <a:lstStyle/>
-          <a:p>
-            <a:pPr indent="0" marL="0">
-              <a:buNone/>
-            </a:pPr>
-            <a:r>
-              <a:rPr lang="en-US" sz="1100" b="1" spc="100" kern="0" dirty="0">
-                <a:solidFill>
-                  <a:schemeClr val="accent1"/>
-                </a:solidFill>
-              </a:rPr>
-              <a:t>Q5  |  IMPACT ON KTB  (2/2)</a:t>
-            </a:r>
-            <a:endParaRPr lang="en-US" sz="1100" dirty="0"/>
-          </a:p>
-        </p:txBody>
-      </p:sp>
-      <p:sp>
-        <p:nvSpPr>
-          <p:cNvPr id="3" name="Text 0"/>
-          <p:cNvSpPr/>
-          <p:nvPr>
-            <p:ph idx="101" type="title" hasCustomPrompt="1"/>
-          </p:nvPr>
-        </p:nvSpPr>
-        <p:spPr>
-          <a:xfrm>
-            <a:off x="457200" y="566928"/>
-            <a:ext cx="11274552" cy="822960"/>
-          </a:xfrm>
-          <a:prstGeom prst="rect">
-            <a:avLst/>
-          </a:prstGeom>
-          <a:noFill/>
-          <a:ln/>
-        </p:spPr>
-        <p:txBody>
-          <a:bodyPr wrap="square" lIns="0" tIns="0" rIns="0" bIns="0" rtlCol="0" anchor="t"/>
-          <a:lstStyle/>
-          <a:p>
-            <a:pPr algn="l" indent="0" marL="0">
-              <a:buNone/>
-            </a:pPr>
-            <a:r>
-              <a:rPr lang="en-US" sz="2400" b="1" dirty="0">
-                <a:solidFill>
-                  <a:schemeClr val="tx2"/>
-                </a:solidFill>
-              </a:rPr>
-              <a:t>Does CLICX take products away from KTB?</a:t>
-            </a:r>
-            <a:endParaRPr lang="en-US" sz="2400" dirty="0"/>
-          </a:p>
-        </p:txBody>
-      </p:sp>
-      <p:sp>
-        <p:nvSpPr>
-          <p:cNvPr id="4" name="Text 0"/>
-          <p:cNvSpPr/>
-          <p:nvPr>
-            <p:ph idx="102" type="body" hasCustomPrompt="1"/>
-          </p:nvPr>
-        </p:nvSpPr>
-        <p:spPr>
-          <a:xfrm>
-            <a:off x="457200" y="1481328"/>
-            <a:ext cx="11274552" cy="594360"/>
-          </a:xfrm>
-          <a:prstGeom prst="rect">
-            <a:avLst/>
-          </a:prstGeom>
-          <a:noFill/>
-          <a:ln/>
-        </p:spPr>
-        <p:txBody>
-          <a:bodyPr wrap="square" lIns="0" tIns="0" rIns="0" bIns="0" rtlCol="0" anchor="t"/>
-          <a:lstStyle/>
-          <a:p>
-            <a:pPr indent="0" marL="0">
-              <a:buNone/>
-            </a:pPr>
-            <a:r>
-              <a:rPr lang="en-US" sz="1600" dirty="0">
-                <a:solidFill>
-                  <a:schemeClr val="tx1"/>
-                </a:solidFill>
-              </a:rPr>
-              <a:t>Not for loans: we mostly lend to people KTB's own app loan (Jai-pump) does not serve or turns down. We cannot check savings yet</a:t>
-            </a:r>
-            <a:endParaRPr lang="en-US" sz="1600" dirty="0"/>
-          </a:p>
-        </p:txBody>
-      </p:sp>
-      <p:sp>
-        <p:nvSpPr>
-          <p:cNvPr id="5" name="Text 0"/>
-          <p:cNvSpPr/>
-          <p:nvPr>
-            <p:ph idx="103" type="body" hasCustomPrompt="1"/>
-          </p:nvPr>
-        </p:nvSpPr>
-        <p:spPr>
-          <a:xfrm>
-            <a:off x="457200" y="6327648"/>
-            <a:ext cx="10241280" cy="274320"/>
-          </a:xfrm>
-          <a:prstGeom prst="rect">
-            <a:avLst/>
-          </a:prstGeom>
-          <a:noFill/>
-          <a:ln/>
-        </p:spPr>
-        <p:txBody>
-          <a:bodyPr wrap="square" lIns="0" tIns="0" rIns="0" bIns="0" rtlCol="0" anchor="t"/>
-          <a:lstStyle/>
-          <a:p>
-            <a:pPr indent="0" marL="0">
-              <a:buNone/>
-            </a:pPr>
-            <a:r>
-              <a:rPr lang="en-US" sz="1000" dirty="0">
-                <a:solidFill>
-                  <a:srgbClr val="6E7C87"/>
-                </a:solidFill>
-              </a:rPr>
-              <a:t>Source: KTB and CLICX matched customer data (Oct 2026)</a:t>
-            </a:r>
-            <a:endParaRPr lang="en-US" sz="1000" dirty="0"/>
-          </a:p>
-        </p:txBody>
-      </p:sp>
-      <p:graphicFrame>
-        <p:nvGraphicFramePr>
-          <p:cNvPr id="6" name="Lending outside KTB" descr=""/>
-          <p:cNvGraphicFramePr/>
-          <p:nvPr/>
-        </p:nvGraphicFramePr>
-        <p:xfrm>
-          <a:off x="457200" y="2148840"/>
-          <a:ext cx="4937760" cy="3977640"/>
-        </p:xfrm>
-        <a:graphic xmlns:a="http://schemas.openxmlformats.org/drawingml/2006/main">
-          <a:graphicData uri="http://schemas.openxmlformats.org/drawingml/2006/chart">
-            <c:chart xmlns:c="http://schemas.openxmlformats.org/drawingml/2006/chart" r:id="rId1"/>
-          </a:graphicData>
-        </a:graphic>
-      </p:graphicFrame>
-      <p:sp>
-        <p:nvSpPr>
-          <p:cNvPr id="7" name="Deposit gap box"/>
-          <p:cNvSpPr/>
-          <p:nvPr/>
-        </p:nvSpPr>
-        <p:spPr>
-          <a:xfrm>
-            <a:off x="5577840" y="2240280"/>
-            <a:ext cx="2560320" cy="3794760"/>
-          </a:xfrm>
-          <a:prstGeom prst="rect">
-            <a:avLst/>
-          </a:prstGeom>
-          <a:solidFill>
-            <a:schemeClr val="bg2"/>
-          </a:solidFill>
-          <a:ln w="12700">
-            <a:solidFill>
-              <a:srgbClr val="A2AAAD"/>
-            </a:solidFill>
-            <a:prstDash val="dash"/>
-          </a:ln>
-        </p:spPr>
-      </p:sp>
-      <p:sp>
-        <p:nvSpPr>
-          <p:cNvPr id="8" name="Deposit gap text"/>
-          <p:cNvSpPr txBox="1"/>
-          <p:nvPr/>
-        </p:nvSpPr>
-        <p:spPr>
-          <a:xfrm>
-            <a:off x="5760720" y="2423160"/>
-            <a:ext cx="2194560" cy="3474720"/>
-          </a:xfrm>
-          <a:prstGeom prst="rect">
-            <a:avLst/>
-          </a:prstGeom>
-          <a:noFill/>
-          <a:ln/>
-        </p:spPr>
-        <p:txBody>
-          <a:bodyPr wrap="square" lIns="0" tIns="0" rIns="0" bIns="0" rtlCol="0" anchor="t"/>
-          <a:lstStyle/>
-          <a:p>
-            <a:pPr indent="0" marL="0">
-              <a:buNone/>
-            </a:pPr>
-            <a:r>
-              <a:rPr lang="en-US" sz="1100" b="1" spc="100" kern="0" dirty="0">
-                <a:solidFill>
-                  <a:schemeClr val="accent5"/>
-                </a:solidFill>
-              </a:rPr>
-              <a:t>SAVINGS: NOT KNOWN YET</a:t>
-            </a:r>
-            <a:endParaRPr lang="en-US" sz="1100" dirty="0"/>
-          </a:p>
-          <a:p>
-            <a:pPr indent="0" marL="0">
-              <a:buNone/>
-            </a:pPr>
-            <a:r>
-              <a:rPr lang="en-US" sz="800" dirty="0">
-                <a:solidFill>
-                  <a:srgbClr val="000000"/>
-                </a:solidFill>
-              </a:rPr>
-              <a:t> </a:t>
-            </a:r>
-            <a:endParaRPr lang="en-US" sz="1100" dirty="0"/>
-          </a:p>
-          <a:p>
-            <a:pPr indent="0" marL="0">
-              <a:buNone/>
-            </a:pPr>
-            <a:r>
-              <a:rPr lang="en-US" sz="1200" dirty="0">
-                <a:solidFill>
-                  <a:schemeClr val="tx1"/>
-                </a:solidFill>
-              </a:rPr>
-              <a:t>We cannot yet see CLICX balances, so we cannot tell if money is moving out of KTB accounts.</a:t>
-            </a:r>
-            <a:endParaRPr lang="en-US" sz="1100" dirty="0"/>
-          </a:p>
-          <a:p>
-            <a:pPr indent="0" marL="0">
-              <a:buNone/>
-            </a:pPr>
-            <a:r>
-              <a:rPr lang="en-US" sz="800" dirty="0">
-                <a:solidFill>
-                  <a:srgbClr val="000000"/>
-                </a:solidFill>
-              </a:rPr>
-              <a:t> </a:t>
-            </a:r>
-            <a:endParaRPr lang="en-US" sz="1100" dirty="0"/>
-          </a:p>
-          <a:p>
-            <a:pPr indent="0" marL="0">
-              <a:buNone/>
-            </a:pPr>
-            <a:r>
-              <a:rPr lang="en-US" sz="1200" b="1" dirty="0">
-                <a:solidFill>
-                  <a:schemeClr val="tx2"/>
-                </a:solidFill>
-              </a:rPr>
-              <a:t>Next step: once the data is in, compare shared customers' KTB balances before and after they joined CLICX</a:t>
-            </a:r>
-            <a:endParaRPr lang="en-US" sz="1100" dirty="0"/>
-          </a:p>
-        </p:txBody>
-      </p:sp>
-      <p:sp>
-        <p:nvSpPr>
-          <p:cNvPr id="9" name="Insight panel"/>
-          <p:cNvSpPr/>
-          <p:nvPr/>
-        </p:nvSpPr>
-        <p:spPr>
-          <a:xfrm>
-            <a:off x="8275320" y="2148840"/>
-            <a:ext cx="3456432" cy="3977640"/>
-          </a:xfrm>
-          <a:prstGeom prst="rect">
-            <a:avLst/>
-          </a:prstGeom>
-          <a:solidFill>
-            <a:schemeClr val="bg2"/>
-          </a:solidFill>
-          <a:ln/>
-        </p:spPr>
-      </p:sp>
-      <p:sp>
-        <p:nvSpPr>
-          <p:cNvPr id="10" name="Insight header"/>
-          <p:cNvSpPr txBox="1"/>
-          <p:nvPr/>
-        </p:nvSpPr>
-        <p:spPr>
-          <a:xfrm>
-            <a:off x="8503920" y="2313432"/>
-            <a:ext cx="2999232" cy="274320"/>
-          </a:xfrm>
-          <a:prstGeom prst="rect">
-            <a:avLst/>
-          </a:prstGeom>
-          <a:noFill/>
-          <a:ln/>
-        </p:spPr>
-        <p:txBody>
-          <a:bodyPr wrap="square" lIns="0" tIns="0" rIns="0" bIns="0" rtlCol="0" anchor="ctr"/>
-          <a:lstStyle/>
-          <a:p>
-            <a:pPr indent="0" marL="0">
-              <a:buNone/>
-            </a:pPr>
-            <a:r>
-              <a:rPr lang="en-US" sz="1100" b="1" spc="100" kern="0" dirty="0">
-                <a:solidFill>
-                  <a:schemeClr val="accent1"/>
-                </a:solidFill>
-              </a:rPr>
-              <a:t>SO WHAT</a:t>
-            </a:r>
-            <a:endParaRPr lang="en-US" sz="1100" dirty="0"/>
-          </a:p>
-        </p:txBody>
-      </p:sp>
-      <p:sp>
-        <p:nvSpPr>
-          <p:cNvPr id="11" name="Badge 1"/>
-          <p:cNvSpPr/>
-          <p:nvPr/>
-        </p:nvSpPr>
-        <p:spPr>
-          <a:xfrm>
-            <a:off x="8503920" y="2715768"/>
-            <a:ext cx="292608" cy="292608"/>
-          </a:xfrm>
-          <a:prstGeom prst="ellipse">
-            <a:avLst/>
-          </a:prstGeom>
-          <a:solidFill>
-            <a:schemeClr val="tx2"/>
-          </a:solidFill>
-          <a:ln/>
-        </p:spPr>
-      </p:sp>
-      <p:sp>
-        <p:nvSpPr>
-          <p:cNvPr id="12" name="Badge num 1"/>
-          <p:cNvSpPr txBox="1"/>
-          <p:nvPr/>
-        </p:nvSpPr>
-        <p:spPr>
-          <a:xfrm>
-            <a:off x="8503920" y="2715768"/>
-            <a:ext cx="292608" cy="292608"/>
-          </a:xfrm>
-          <a:prstGeom prst="rect">
-            <a:avLst/>
-          </a:prstGeom>
-          <a:noFill/>
-          <a:ln/>
-        </p:spPr>
-        <p:txBody>
-          <a:bodyPr wrap="square" lIns="0" tIns="0" rIns="0" bIns="0" rtlCol="0" anchor="ctr"/>
-          <a:lstStyle/>
-          <a:p>
-            <a:pPr algn="ctr" indent="0" marL="0">
-              <a:buNone/>
-            </a:pPr>
-            <a:r>
-              <a:rPr lang="en-US" sz="1100" b="1" dirty="0">
-                <a:solidFill>
-                  <a:schemeClr val="bg1"/>
-                </a:solidFill>
-              </a:rPr>
-              <a:t>1</a:t>
-            </a:r>
-            <a:endParaRPr lang="en-US" sz="1100" dirty="0"/>
-          </a:p>
-        </p:txBody>
-      </p:sp>
-      <p:sp>
-        <p:nvSpPr>
-          <p:cNvPr id="13" name="Insight 1"/>
-          <p:cNvSpPr txBox="1"/>
-          <p:nvPr/>
-        </p:nvSpPr>
-        <p:spPr>
-          <a:xfrm>
-            <a:off x="8915400" y="2670048"/>
-            <a:ext cx="2633472" cy="1054608"/>
-          </a:xfrm>
-          <a:prstGeom prst="rect">
-            <a:avLst/>
-          </a:prstGeom>
-          <a:noFill/>
-          <a:ln/>
-        </p:spPr>
-        <p:txBody>
-          <a:bodyPr wrap="square" lIns="0" tIns="0" rIns="0" bIns="0" rtlCol="0" anchor="t"/>
-          <a:lstStyle/>
-          <a:p>
-            <a:pPr indent="0" marL="0">
-              <a:spcAft>
-                <a:spcPts val="300"/>
-              </a:spcAft>
-              <a:buNone/>
-            </a:pPr>
-            <a:r>
-              <a:rPr lang="en-US" sz="1400" b="1" dirty="0">
-                <a:solidFill>
-                  <a:schemeClr val="tx2"/>
-                </a:solidFill>
-              </a:rPr>
-              <a:t>New loans for the group</a:t>
-            </a:r>
-            <a:endParaRPr lang="en-US" sz="1400" dirty="0"/>
-          </a:p>
-          <a:p>
-            <a:pPr indent="0" marL="0">
-              <a:spcAft>
-                <a:spcPts val="300"/>
-              </a:spcAft>
-              <a:buNone/>
-            </a:pPr>
-            <a:r>
-              <a:rPr lang="en-US" sz="1200" dirty="0">
-                <a:solidFill>
-                  <a:schemeClr val="tx1"/>
-                </a:solidFill>
-              </a:rPr>
-              <a:t>116K of our borrowers have no KTB Jai-pump loan</a:t>
-            </a:r>
-            <a:endParaRPr lang="en-US" sz="1400" dirty="0"/>
-          </a:p>
-        </p:txBody>
-      </p:sp>
-      <p:sp>
-        <p:nvSpPr>
-          <p:cNvPr id="14" name="Badge 2"/>
-          <p:cNvSpPr/>
-          <p:nvPr/>
-        </p:nvSpPr>
-        <p:spPr>
-          <a:xfrm>
-            <a:off x="8503920" y="3843528"/>
-            <a:ext cx="292608" cy="292608"/>
-          </a:xfrm>
-          <a:prstGeom prst="ellipse">
-            <a:avLst/>
-          </a:prstGeom>
-          <a:solidFill>
-            <a:schemeClr val="tx2"/>
-          </a:solidFill>
-          <a:ln/>
-        </p:spPr>
-      </p:sp>
-      <p:sp>
-        <p:nvSpPr>
-          <p:cNvPr id="15" name="Badge num 2"/>
-          <p:cNvSpPr txBox="1"/>
-          <p:nvPr/>
-        </p:nvSpPr>
-        <p:spPr>
-          <a:xfrm>
-            <a:off x="8503920" y="3843528"/>
-            <a:ext cx="292608" cy="292608"/>
-          </a:xfrm>
-          <a:prstGeom prst="rect">
-            <a:avLst/>
-          </a:prstGeom>
-          <a:noFill/>
-          <a:ln/>
-        </p:spPr>
-        <p:txBody>
-          <a:bodyPr wrap="square" lIns="0" tIns="0" rIns="0" bIns="0" rtlCol="0" anchor="ctr"/>
-          <a:lstStyle/>
-          <a:p>
-            <a:pPr algn="ctr" indent="0" marL="0">
-              <a:buNone/>
-            </a:pPr>
-            <a:r>
-              <a:rPr lang="en-US" sz="1100" b="1" dirty="0">
-                <a:solidFill>
-                  <a:schemeClr val="bg1"/>
-                </a:solidFill>
-              </a:rPr>
-              <a:t>2</a:t>
-            </a:r>
-            <a:endParaRPr lang="en-US" sz="1100" dirty="0"/>
-          </a:p>
-        </p:txBody>
-      </p:sp>
-      <p:sp>
-        <p:nvSpPr>
-          <p:cNvPr id="16" name="Insight 2"/>
-          <p:cNvSpPr txBox="1"/>
-          <p:nvPr/>
-        </p:nvSpPr>
-        <p:spPr>
-          <a:xfrm>
-            <a:off x="8915400" y="3797808"/>
-            <a:ext cx="2633472" cy="1054608"/>
-          </a:xfrm>
-          <a:prstGeom prst="rect">
-            <a:avLst/>
-          </a:prstGeom>
-          <a:noFill/>
-          <a:ln/>
-        </p:spPr>
-        <p:txBody>
-          <a:bodyPr wrap="square" lIns="0" tIns="0" rIns="0" bIns="0" rtlCol="0" anchor="t"/>
-          <a:lstStyle/>
-          <a:p>
-            <a:pPr indent="0" marL="0">
-              <a:spcAft>
-                <a:spcPts val="300"/>
-              </a:spcAft>
-              <a:buNone/>
-            </a:pPr>
-            <a:r>
-              <a:rPr lang="en-US" sz="1400" b="1" dirty="0">
-                <a:solidFill>
-                  <a:schemeClr val="tx2"/>
-                </a:solidFill>
-              </a:rPr>
-              <a:t>A safety net for KTB</a:t>
-            </a:r>
-            <a:endParaRPr lang="en-US" sz="1400" dirty="0"/>
-          </a:p>
-          <a:p>
-            <a:pPr indent="0" marL="0">
-              <a:spcAft>
-                <a:spcPts val="300"/>
-              </a:spcAft>
-              <a:buNone/>
-            </a:pPr>
-            <a:r>
-              <a:rPr lang="en-US" sz="1200" dirty="0">
-                <a:solidFill>
-                  <a:schemeClr val="tx1"/>
-                </a:solidFill>
-              </a:rPr>
-              <a:t>156K people KTB turned down in the last 3 months applied to us instead of going to another bank</a:t>
-            </a:r>
-            <a:endParaRPr lang="en-US" sz="1400" dirty="0"/>
-          </a:p>
-        </p:txBody>
-      </p:sp>
-      <p:sp>
-        <p:nvSpPr>
-          <p:cNvPr id="17" name="Badge 3"/>
-          <p:cNvSpPr/>
-          <p:nvPr/>
-        </p:nvSpPr>
-        <p:spPr>
-          <a:xfrm>
-            <a:off x="8503920" y="4971288"/>
-            <a:ext cx="292608" cy="292608"/>
-          </a:xfrm>
-          <a:prstGeom prst="ellipse">
-            <a:avLst/>
-          </a:prstGeom>
-          <a:solidFill>
-            <a:schemeClr val="tx2"/>
-          </a:solidFill>
-          <a:ln/>
-        </p:spPr>
-      </p:sp>
-      <p:sp>
-        <p:nvSpPr>
-          <p:cNvPr id="18" name="Badge num 3"/>
-          <p:cNvSpPr txBox="1"/>
-          <p:nvPr/>
-        </p:nvSpPr>
-        <p:spPr>
-          <a:xfrm>
-            <a:off x="8503920" y="4971288"/>
-            <a:ext cx="292608" cy="292608"/>
-          </a:xfrm>
-          <a:prstGeom prst="rect">
-            <a:avLst/>
-          </a:prstGeom>
-          <a:noFill/>
-          <a:ln/>
-        </p:spPr>
-        <p:txBody>
-          <a:bodyPr wrap="square" lIns="0" tIns="0" rIns="0" bIns="0" rtlCol="0" anchor="ctr"/>
-          <a:lstStyle/>
-          <a:p>
-            <a:pPr algn="ctr" indent="0" marL="0">
-              <a:buNone/>
-            </a:pPr>
-            <a:r>
-              <a:rPr lang="en-US" sz="1100" b="1" dirty="0">
-                <a:solidFill>
-                  <a:schemeClr val="bg1"/>
-                </a:solidFill>
-              </a:rPr>
-              <a:t>3</a:t>
-            </a:r>
-            <a:endParaRPr lang="en-US" sz="1100" dirty="0"/>
-          </a:p>
-        </p:txBody>
-      </p:sp>
-      <p:sp>
-        <p:nvSpPr>
-          <p:cNvPr id="19" name="Insight 3"/>
-          <p:cNvSpPr txBox="1"/>
-          <p:nvPr/>
-        </p:nvSpPr>
-        <p:spPr>
-          <a:xfrm>
-            <a:off x="8915400" y="4925568"/>
-            <a:ext cx="2633472" cy="1054608"/>
-          </a:xfrm>
-          <a:prstGeom prst="rect">
-            <a:avLst/>
-          </a:prstGeom>
-          <a:noFill/>
-          <a:ln/>
-        </p:spPr>
-        <p:txBody>
-          <a:bodyPr wrap="square" lIns="0" tIns="0" rIns="0" bIns="0" rtlCol="0" anchor="t"/>
-          <a:lstStyle/>
-          <a:p>
-            <a:pPr indent="0" marL="0">
-              <a:spcAft>
-                <a:spcPts val="300"/>
-              </a:spcAft>
-              <a:buNone/>
-            </a:pPr>
-            <a:r>
-              <a:rPr lang="en-US" sz="1400" b="1" dirty="0">
-                <a:solidFill>
-                  <a:schemeClr val="tx2"/>
-                </a:solidFill>
-              </a:rPr>
-              <a:t>Few loyal KTB users among our best customers</a:t>
-            </a:r>
-            <a:endParaRPr lang="en-US" sz="1400" dirty="0"/>
-          </a:p>
-          <a:p>
-            <a:pPr indent="0" marL="0">
-              <a:spcAft>
-                <a:spcPts val="300"/>
-              </a:spcAft>
-              <a:buNone/>
-            </a:pPr>
-            <a:r>
-              <a:rPr lang="en-US" sz="1200" dirty="0">
-                <a:solidFill>
-                  <a:schemeClr val="tx1"/>
-                </a:solidFill>
-              </a:rPr>
-              <a:t>Only 15% of our most engaged shared customers are loyal to KTB</a:t>
-            </a:r>
-            <a:endParaRPr lang="en-US" sz="1400" dirty="0"/>
-          </a:p>
-        </p:txBody>
-      </p:sp>
-      <p:sp>
-        <p:nvSpPr>
-          <p:cNvPr id="25" name="Slide Number Placeholder 0"/>
-          <p:cNvSpPr>
-            <a:spLocks noGrp="1"/>
-          </p:cNvSpPr>
-          <p:nvPr>
-            <p:ph type="sldNum" sz="quarter" idx="4294967295"/>
-          </p:nvPr>
-        </p:nvSpPr>
-        <p:spPr>
-          <a:xfrm>
-            <a:off x="11274552" y="6355080"/>
-            <a:ext cx="457200" cy="274320"/>
-          </a:xfrm>
-          <a:prstGeom prst="rect">
-            <a:avLst/>
-          </a:prstGeom>
-          <a:extLst>
-            <a:ext uri="{C572A759-6A51-4108-AA02-DFA0A04FC94B}">
-              <ma14:wrappingTextBoxFlag xmlns:ma14="http://schemas.microsoft.com/office/mac/drawingml/2011/main" val="0"/>
-            </a:ext>
-          </a:extLst>
-        </p:spPr>
-        <p:txBody>
-          <a:bodyPr/>
-          <a:lstStyle>
-            <a:lvl1pPr>
-              <a:defRPr sz="1000">
-                <a:solidFill>
-                  <a:srgbClr val="6E7C87"/>
-                </a:solidFill>
-              </a:defRPr>
-            </a:lvl1pPr>
-          </a:lstStyle>
-          <a:p>
-            <a:pPr algn="r"/>
-            <a:fld id="{F7021451-1387-4CA6-816F-3879F97B5CBC}" type="slidenum">
-              <a:rPr b="0" lang="en-US"/>
               <a:t>11</a:t>
             </a:fld>
             <a:endParaRPr lang="en-US"/>
@@ -8202,7 +8813,7 @@
                   <a:schemeClr val="accent1"/>
                 </a:solidFill>
               </a:rPr>
-              <a:t>WHAT TO DO NEXT</a:t>
+              <a:t>Q5  |  IMPACT ON KTB  (2/2)</a:t>
             </a:r>
             <a:endParaRPr lang="en-US" sz="1100" dirty="0"/>
           </a:p>
@@ -8240,7 +8851,7 @@
                   <a:schemeClr val="tx2"/>
                 </a:solidFill>
               </a:rPr>
-              <a:t>What should we do with these answers?</a:t>
+              <a:t>Does CLICX take products away from KTB?</a:t>
             </a:r>
             <a:endParaRPr lang="en-US" sz="2400" dirty="0"/>
           </a:p>
@@ -8278,7 +8889,7 @@
                   <a:schemeClr val="tx1"/>
                 </a:solidFill>
               </a:rPr>
-              <a:t>Keep using partners to bring people in, and focus on turning sign-ups into regular users, starting with the customer types that already work</a:t>
+              <a:t>Not for loans: we mostly lend to people KTB's own app loan (Jai-pump) does not serve or turns down. We cannot check savings yet</a:t>
             </a:r>
             <a:endParaRPr lang="en-US" sz="1600" dirty="0"/>
           </a:p>
@@ -8316,22 +8927,38 @@
                   <a:srgbClr val="6E7C87"/>
                 </a:solidFill>
               </a:rPr>
-              <a:t>Source: CLICX team analysis</a:t>
+              <a:t>Source: KTB and CLICX matched customer data (Oct 2026)</a:t>
             </a:r>
             <a:endParaRPr lang="en-US" sz="1000" dirty="0"/>
           </a:p>
         </p:txBody>
       </p:sp>
-      <p:sp>
-        <p:nvSpPr>
-          <p:cNvPr id="6" name="Card Q1"/>
+      <p:graphicFrame>
+        <p:nvGraphicFramePr>
+          <p:cNvPr id="6" name="Lending outside KTB" descr=""/>
+          <p:cNvGraphicFramePr/>
+          <p:nvPr/>
+        </p:nvGraphicFramePr>
+        <p:xfrm>
+          <a:off x="457200" y="2148840"/>
+          <a:ext cx="4937760" cy="3977640"/>
+        </p:xfrm>
+        <a:graphic xmlns:a="http://schemas.openxmlformats.org/drawingml/2006/main">
+          <a:graphicData uri="http://schemas.openxmlformats.org/drawingml/2006/chart">
+            <c:chart xmlns:c="http://schemas.openxmlformats.org/drawingml/2006/chart" r:id="rId1"/>
+          </a:graphicData>
+        </a:graphic>
+      </p:graphicFrame>
+      <p:sp>
+        <p:nvSpPr>
+          <p:cNvPr id="7" name="Deposit gap box"/>
           <p:cNvSpPr/>
           <p:nvPr/>
         </p:nvSpPr>
         <p:spPr>
           <a:xfrm>
-            <a:off x="457200" y="2194560"/>
-            <a:ext cx="2130552" cy="3886200"/>
+            <a:off x="5577840" y="2240280"/>
+            <a:ext cx="2560320" cy="3794760"/>
           </a:xfrm>
           <a:prstGeom prst="rect">
             <a:avLst/>
@@ -8339,19 +8966,172 @@
           <a:solidFill>
             <a:schemeClr val="bg2"/>
           </a:solidFill>
-          <a:ln/>
-        </p:spPr>
-      </p:sp>
-      <p:sp>
-        <p:nvSpPr>
-          <p:cNvPr id="7" name="Card badge Q1"/>
+          <a:ln w="12700">
+            <a:solidFill>
+              <a:srgbClr val="A2AAAD"/>
+            </a:solidFill>
+            <a:prstDash val="dash"/>
+          </a:ln>
+        </p:spPr>
+      </p:sp>
+      <p:sp>
+        <p:nvSpPr>
+          <p:cNvPr id="8" name="Deposit gap text"/>
+          <p:cNvSpPr txBox="1"/>
+          <p:nvPr/>
+        </p:nvSpPr>
+        <p:spPr>
+          <a:xfrm>
+            <a:off x="5760720" y="2423160"/>
+            <a:ext cx="2194560" cy="3474720"/>
+          </a:xfrm>
+          <a:prstGeom prst="rect">
+            <a:avLst/>
+          </a:prstGeom>
+          <a:noFill/>
+          <a:ln/>
+        </p:spPr>
+        <p:txBody>
+          <a:bodyPr wrap="square" lIns="0" tIns="0" rIns="0" bIns="0" rtlCol="0" anchor="t"/>
+          <a:lstStyle/>
+          <a:p>
+            <a:pPr indent="0" marL="0">
+              <a:buNone/>
+            </a:pPr>
+            <a:r>
+              <a:rPr lang="en-US" sz="1100" b="1" spc="100" kern="0" dirty="0">
+                <a:solidFill>
+                  <a:schemeClr val="accent5"/>
+                </a:solidFill>
+              </a:rPr>
+              <a:t>SAVINGS: NOT KNOWN YET</a:t>
+            </a:r>
+            <a:endParaRPr lang="en-US" sz="1100" dirty="0"/>
+          </a:p>
+          <a:p>
+            <a:pPr indent="0" marL="0">
+              <a:buNone/>
+            </a:pPr>
+            <a:r>
+              <a:rPr lang="en-US" sz="800" dirty="0">
+                <a:solidFill>
+                  <a:srgbClr val="000000"/>
+                </a:solidFill>
+              </a:rPr>
+              <a:t> </a:t>
+            </a:r>
+            <a:endParaRPr lang="en-US" sz="1100" dirty="0"/>
+          </a:p>
+          <a:p>
+            <a:pPr indent="0" marL="0">
+              <a:buNone/>
+            </a:pPr>
+            <a:r>
+              <a:rPr lang="en-US" sz="1200" dirty="0">
+                <a:solidFill>
+                  <a:schemeClr val="tx1"/>
+                </a:solidFill>
+              </a:rPr>
+              <a:t>We cannot yet see CLICX balances, so we cannot tell if money is moving out of KTB accounts.</a:t>
+            </a:r>
+            <a:endParaRPr lang="en-US" sz="1100" dirty="0"/>
+          </a:p>
+          <a:p>
+            <a:pPr indent="0" marL="0">
+              <a:buNone/>
+            </a:pPr>
+            <a:r>
+              <a:rPr lang="en-US" sz="800" dirty="0">
+                <a:solidFill>
+                  <a:srgbClr val="000000"/>
+                </a:solidFill>
+              </a:rPr>
+              <a:t> </a:t>
+            </a:r>
+            <a:endParaRPr lang="en-US" sz="1100" dirty="0"/>
+          </a:p>
+          <a:p>
+            <a:pPr indent="0" marL="0">
+              <a:buNone/>
+            </a:pPr>
+            <a:r>
+              <a:rPr lang="en-US" sz="1200" b="1" dirty="0">
+                <a:solidFill>
+                  <a:schemeClr val="tx2"/>
+                </a:solidFill>
+              </a:rPr>
+              <a:t>Next step: once the data is in, compare shared customers' KTB balances before and after they joined CLICX</a:t>
+            </a:r>
+            <a:endParaRPr lang="en-US" sz="1100" dirty="0"/>
+          </a:p>
+        </p:txBody>
+      </p:sp>
+      <p:sp>
+        <p:nvSpPr>
+          <p:cNvPr id="9" name="Insight panel"/>
           <p:cNvSpPr/>
           <p:nvPr/>
         </p:nvSpPr>
         <p:spPr>
           <a:xfrm>
-            <a:off x="640080" y="2395728"/>
-            <a:ext cx="502920" cy="502920"/>
+            <a:off x="8275320" y="2148840"/>
+            <a:ext cx="3456432" cy="3977640"/>
+          </a:xfrm>
+          <a:prstGeom prst="rect">
+            <a:avLst/>
+          </a:prstGeom>
+          <a:solidFill>
+            <a:schemeClr val="bg2"/>
+          </a:solidFill>
+          <a:ln/>
+        </p:spPr>
+      </p:sp>
+      <p:sp>
+        <p:nvSpPr>
+          <p:cNvPr id="10" name="Insight header"/>
+          <p:cNvSpPr txBox="1"/>
+          <p:nvPr/>
+        </p:nvSpPr>
+        <p:spPr>
+          <a:xfrm>
+            <a:off x="8503920" y="2313432"/>
+            <a:ext cx="2999232" cy="274320"/>
+          </a:xfrm>
+          <a:prstGeom prst="rect">
+            <a:avLst/>
+          </a:prstGeom>
+          <a:noFill/>
+          <a:ln/>
+        </p:spPr>
+        <p:txBody>
+          <a:bodyPr wrap="square" lIns="0" tIns="0" rIns="0" bIns="0" rtlCol="0" anchor="ctr"/>
+          <a:lstStyle/>
+          <a:p>
+            <a:pPr indent="0" marL="0">
+              <a:buNone/>
+            </a:pPr>
+            <a:r>
+              <a:rPr lang="en-US" sz="1100" b="1" spc="100" kern="0" dirty="0">
+                <a:solidFill>
+                  <a:schemeClr val="accent1"/>
+                </a:solidFill>
+              </a:rPr>
+              <a:t>SO WHAT</a:t>
+            </a:r>
+            <a:endParaRPr lang="en-US" sz="1100" dirty="0"/>
+          </a:p>
+        </p:txBody>
+      </p:sp>
+      <p:sp>
+        <p:nvSpPr>
+          <p:cNvPr id="11" name="Badge 1"/>
+          <p:cNvSpPr/>
+          <p:nvPr/>
+        </p:nvSpPr>
+        <p:spPr>
+          <a:xfrm>
+            <a:off x="8503920" y="2715768"/>
+            <a:ext cx="292608" cy="292608"/>
           </a:xfrm>
           <a:prstGeom prst="ellipse">
             <a:avLst/>
@@ -8364,14 +9144,14 @@
       </p:sp>
       <p:sp>
         <p:nvSpPr>
-          <p:cNvPr id="8" name="Card badge text Q1"/>
+          <p:cNvPr id="12" name="Badge num 1"/>
           <p:cNvSpPr txBox="1"/>
           <p:nvPr/>
         </p:nvSpPr>
         <p:spPr>
           <a:xfrm>
-            <a:off x="640080" y="2395728"/>
-            <a:ext cx="502920" cy="502920"/>
+            <a:off x="8503920" y="2715768"/>
+            <a:ext cx="292608" cy="292608"/>
           </a:xfrm>
           <a:prstGeom prst="rect">
             <a:avLst/>
@@ -8387,27 +9167,27 @@
               <a:buNone/>
             </a:pPr>
             <a:r>
-              <a:rPr lang="en-US" sz="1300" b="1" dirty="0">
+              <a:rPr lang="en-US" sz="1100" b="1" dirty="0">
                 <a:solidFill>
                   <a:schemeClr val="bg1"/>
                 </a:solidFill>
               </a:rPr>
-              <a:t>Q1</a:t>
-            </a:r>
-            <a:endParaRPr lang="en-US" sz="1300" dirty="0"/>
-          </a:p>
-        </p:txBody>
-      </p:sp>
-      <p:sp>
-        <p:nvSpPr>
-          <p:cNvPr id="9" name="Card title Q1"/>
+              <a:t>1</a:t>
+            </a:r>
+            <a:endParaRPr lang="en-US" sz="1100" dirty="0"/>
+          </a:p>
+        </p:txBody>
+      </p:sp>
+      <p:sp>
+        <p:nvSpPr>
+          <p:cNvPr id="13" name="Insight 1"/>
           <p:cNvSpPr txBox="1"/>
           <p:nvPr/>
         </p:nvSpPr>
         <p:spPr>
           <a:xfrm>
-            <a:off x="640080" y="3063240"/>
-            <a:ext cx="1764792" cy="777240"/>
+            <a:off x="8915400" y="2670048"/>
+            <a:ext cx="2633472" cy="1054608"/>
           </a:xfrm>
           <a:prstGeom prst="rect">
             <a:avLst/>
@@ -8420,42 +9200,26 @@
           <a:lstStyle/>
           <a:p>
             <a:pPr indent="0" marL="0">
-              <a:buNone/>
-            </a:pPr>
-            <a:r>
-              <a:rPr lang="en-US" sz="1500" b="1" dirty="0">
+              <a:spcAft>
+                <a:spcPts val="300"/>
+              </a:spcAft>
+              <a:buNone/>
+            </a:pPr>
+            <a:r>
+              <a:rPr lang="en-US" sz="1400" b="1" dirty="0">
                 <a:solidFill>
                   <a:schemeClr val="tx2"/>
                 </a:solidFill>
               </a:rPr>
-              <a:t>Reach more partner customers</a:t>
-            </a:r>
-            <a:endParaRPr lang="en-US" sz="1500" dirty="0"/>
-          </a:p>
-        </p:txBody>
-      </p:sp>
-      <p:sp>
-        <p:nvSpPr>
-          <p:cNvPr id="10" name="Card body Q1"/>
-          <p:cNvSpPr txBox="1"/>
-          <p:nvPr/>
-        </p:nvSpPr>
-        <p:spPr>
-          <a:xfrm>
-            <a:off x="640080" y="3886200"/>
-            <a:ext cx="1764792" cy="2057400"/>
-          </a:xfrm>
-          <a:prstGeom prst="rect">
-            <a:avLst/>
-          </a:prstGeom>
-          <a:noFill/>
-          <a:ln/>
-        </p:spPr>
-        <p:txBody>
-          <a:bodyPr wrap="square" lIns="0" tIns="0" rIns="0" bIns="0" rtlCol="0" anchor="t"/>
-          <a:lstStyle/>
+              <a:t>New loans for the group</a:t>
+            </a:r>
+            <a:endParaRPr lang="en-US" sz="1400" dirty="0"/>
+          </a:p>
           <a:p>
             <a:pPr indent="0" marL="0">
+              <a:spcAft>
+                <a:spcPts val="300"/>
+              </a:spcAft>
               <a:buNone/>
             </a:pPr>
             <a:r>
@@ -8464,42 +9228,22 @@
                   <a:schemeClr val="tx1"/>
                 </a:solidFill>
               </a:rPr>
-              <a:t>Start with AIS: only 3.7% of its ~32M customers have joined. Sign them up through the myAIS app and AIS shops</a:t>
-            </a:r>
-            <a:endParaRPr lang="en-US" sz="1200" dirty="0"/>
-          </a:p>
-        </p:txBody>
-      </p:sp>
-      <p:sp>
-        <p:nvSpPr>
-          <p:cNvPr id="11" name="Card Q2"/>
+              <a:t>116K of our borrowers have no KTB Jai-pump loan</a:t>
+            </a:r>
+            <a:endParaRPr lang="en-US" sz="1400" dirty="0"/>
+          </a:p>
+        </p:txBody>
+      </p:sp>
+      <p:sp>
+        <p:nvSpPr>
+          <p:cNvPr id="14" name="Badge 2"/>
           <p:cNvSpPr/>
           <p:nvPr/>
         </p:nvSpPr>
         <p:spPr>
           <a:xfrm>
-            <a:off x="2743200" y="2194560"/>
-            <a:ext cx="2130552" cy="3886200"/>
-          </a:xfrm>
-          <a:prstGeom prst="rect">
-            <a:avLst/>
-          </a:prstGeom>
-          <a:solidFill>
-            <a:schemeClr val="bg2"/>
-          </a:solidFill>
-          <a:ln/>
-        </p:spPr>
-      </p:sp>
-      <p:sp>
-        <p:nvSpPr>
-          <p:cNvPr id="12" name="Card badge Q2"/>
-          <p:cNvSpPr/>
-          <p:nvPr/>
-        </p:nvSpPr>
-        <p:spPr>
-          <a:xfrm>
-            <a:off x="2926080" y="2395728"/>
-            <a:ext cx="502920" cy="502920"/>
+            <a:off x="8503920" y="3843528"/>
+            <a:ext cx="292608" cy="292608"/>
           </a:xfrm>
           <a:prstGeom prst="ellipse">
             <a:avLst/>
@@ -8512,14 +9256,14 @@
       </p:sp>
       <p:sp>
         <p:nvSpPr>
-          <p:cNvPr id="13" name="Card badge text Q2"/>
+          <p:cNvPr id="15" name="Badge num 2"/>
           <p:cNvSpPr txBox="1"/>
           <p:nvPr/>
         </p:nvSpPr>
         <p:spPr>
           <a:xfrm>
-            <a:off x="2926080" y="2395728"/>
-            <a:ext cx="502920" cy="502920"/>
+            <a:off x="8503920" y="3843528"/>
+            <a:ext cx="292608" cy="292608"/>
           </a:xfrm>
           <a:prstGeom prst="rect">
             <a:avLst/>
@@ -8535,27 +9279,27 @@
               <a:buNone/>
             </a:pPr>
             <a:r>
-              <a:rPr lang="en-US" sz="1300" b="1" dirty="0">
+              <a:rPr lang="en-US" sz="1100" b="1" dirty="0">
                 <a:solidFill>
                   <a:schemeClr val="bg1"/>
                 </a:solidFill>
               </a:rPr>
-              <a:t>Q2</a:t>
-            </a:r>
-            <a:endParaRPr lang="en-US" sz="1300" dirty="0"/>
-          </a:p>
-        </p:txBody>
-      </p:sp>
-      <p:sp>
-        <p:nvSpPr>
-          <p:cNvPr id="14" name="Card title Q2"/>
+              <a:t>2</a:t>
+            </a:r>
+            <a:endParaRPr lang="en-US" sz="1100" dirty="0"/>
+          </a:p>
+        </p:txBody>
+      </p:sp>
+      <p:sp>
+        <p:nvSpPr>
+          <p:cNvPr id="16" name="Insight 2"/>
           <p:cNvSpPr txBox="1"/>
           <p:nvPr/>
         </p:nvSpPr>
         <p:spPr>
           <a:xfrm>
-            <a:off x="2926080" y="3063240"/>
-            <a:ext cx="1764792" cy="777240"/>
+            <a:off x="8915400" y="3797808"/>
+            <a:ext cx="2633472" cy="1054608"/>
           </a:xfrm>
           <a:prstGeom prst="rect">
             <a:avLst/>
@@ -8568,42 +9312,26 @@
           <a:lstStyle/>
           <a:p>
             <a:pPr indent="0" marL="0">
-              <a:buNone/>
-            </a:pPr>
-            <a:r>
-              <a:rPr lang="en-US" sz="1500" b="1" dirty="0">
+              <a:spcAft>
+                <a:spcPts val="300"/>
+              </a:spcAft>
+              <a:buNone/>
+            </a:pPr>
+            <a:r>
+              <a:rPr lang="en-US" sz="1400" b="1" dirty="0">
                 <a:solidFill>
                   <a:schemeClr val="tx2"/>
                 </a:solidFill>
               </a:rPr>
-              <a:t>Find more people like our best customers</a:t>
-            </a:r>
-            <a:endParaRPr lang="en-US" sz="1500" dirty="0"/>
-          </a:p>
-        </p:txBody>
-      </p:sp>
-      <p:sp>
-        <p:nvSpPr>
-          <p:cNvPr id="15" name="Card body Q2"/>
-          <p:cNvSpPr txBox="1"/>
-          <p:nvPr/>
-        </p:nvSpPr>
-        <p:spPr>
-          <a:xfrm>
-            <a:off x="2926080" y="3886200"/>
-            <a:ext cx="1764792" cy="2057400"/>
-          </a:xfrm>
-          <a:prstGeom prst="rect">
-            <a:avLst/>
-          </a:prstGeom>
-          <a:noFill/>
-          <a:ln/>
-        </p:spPr>
-        <p:txBody>
-          <a:bodyPr wrap="square" lIns="0" tIns="0" rIns="0" bIns="0" rtlCol="0" anchor="t"/>
-          <a:lstStyle/>
+              <a:t>A safety net for KTB</a:t>
+            </a:r>
+            <a:endParaRPr lang="en-US" sz="1400" dirty="0"/>
+          </a:p>
           <a:p>
             <a:pPr indent="0" marL="0">
+              <a:spcAft>
+                <a:spcPts val="300"/>
+              </a:spcAft>
               <a:buNone/>
             </a:pPr>
             <a:r>
@@ -8612,42 +9340,22 @@
                   <a:schemeClr val="tx1"/>
                 </a:solidFill>
               </a:rPr>
-              <a:t>Target tech-savvy 30–34s. Create a clear reason for multi-bank users to switch. Make it easy for gig workers to prove income</a:t>
-            </a:r>
-            <a:endParaRPr lang="en-US" sz="1200" dirty="0"/>
-          </a:p>
-        </p:txBody>
-      </p:sp>
-      <p:sp>
-        <p:nvSpPr>
-          <p:cNvPr id="16" name="Card Q3"/>
+              <a:t>156K people KTB turned down in the last 3 months applied to us instead of going to another bank</a:t>
+            </a:r>
+            <a:endParaRPr lang="en-US" sz="1400" dirty="0"/>
+          </a:p>
+        </p:txBody>
+      </p:sp>
+      <p:sp>
+        <p:nvSpPr>
+          <p:cNvPr id="17" name="Badge 3"/>
           <p:cNvSpPr/>
           <p:nvPr/>
         </p:nvSpPr>
         <p:spPr>
           <a:xfrm>
-            <a:off x="5029200" y="2194560"/>
-            <a:ext cx="2130552" cy="3886200"/>
-          </a:xfrm>
-          <a:prstGeom prst="rect">
-            <a:avLst/>
-          </a:prstGeom>
-          <a:solidFill>
-            <a:schemeClr val="bg2"/>
-          </a:solidFill>
-          <a:ln/>
-        </p:spPr>
-      </p:sp>
-      <p:sp>
-        <p:nvSpPr>
-          <p:cNvPr id="17" name="Card badge Q3"/>
-          <p:cNvSpPr/>
-          <p:nvPr/>
-        </p:nvSpPr>
-        <p:spPr>
-          <a:xfrm>
-            <a:off x="5212080" y="2395728"/>
-            <a:ext cx="502920" cy="502920"/>
+            <a:off x="8503920" y="4971288"/>
+            <a:ext cx="292608" cy="292608"/>
           </a:xfrm>
           <a:prstGeom prst="ellipse">
             <a:avLst/>
@@ -8660,14 +9368,14 @@
       </p:sp>
       <p:sp>
         <p:nvSpPr>
-          <p:cNvPr id="18" name="Card badge text Q3"/>
+          <p:cNvPr id="18" name="Badge num 3"/>
           <p:cNvSpPr txBox="1"/>
           <p:nvPr/>
         </p:nvSpPr>
         <p:spPr>
           <a:xfrm>
-            <a:off x="5212080" y="2395728"/>
-            <a:ext cx="502920" cy="502920"/>
+            <a:off x="8503920" y="4971288"/>
+            <a:ext cx="292608" cy="292608"/>
           </a:xfrm>
           <a:prstGeom prst="rect">
             <a:avLst/>
@@ -8683,27 +9391,27 @@
               <a:buNone/>
             </a:pPr>
             <a:r>
-              <a:rPr lang="en-US" sz="1300" b="1" dirty="0">
+              <a:rPr lang="en-US" sz="1100" b="1" dirty="0">
                 <a:solidFill>
                   <a:schemeClr val="bg1"/>
                 </a:solidFill>
               </a:rPr>
-              <a:t>Q3</a:t>
-            </a:r>
-            <a:endParaRPr lang="en-US" sz="1300" dirty="0"/>
-          </a:p>
-        </p:txBody>
-      </p:sp>
-      <p:sp>
-        <p:nvSpPr>
-          <p:cNvPr id="19" name="Card title Q3"/>
+              <a:t>3</a:t>
+            </a:r>
+            <a:endParaRPr lang="en-US" sz="1100" dirty="0"/>
+          </a:p>
+        </p:txBody>
+      </p:sp>
+      <p:sp>
+        <p:nvSpPr>
+          <p:cNvPr id="19" name="Insight 3"/>
           <p:cNvSpPr txBox="1"/>
           <p:nvPr/>
         </p:nvSpPr>
         <p:spPr>
           <a:xfrm>
-            <a:off x="5212080" y="3063240"/>
-            <a:ext cx="1764792" cy="777240"/>
+            <a:off x="8915400" y="4925568"/>
+            <a:ext cx="2633472" cy="1054608"/>
           </a:xfrm>
           <a:prstGeom prst="rect">
             <a:avLst/>
@@ -8716,42 +9424,26 @@
           <a:lstStyle/>
           <a:p>
             <a:pPr indent="0" marL="0">
-              <a:buNone/>
-            </a:pPr>
-            <a:r>
-              <a:rPr lang="en-US" sz="1500" b="1" dirty="0">
+              <a:spcAft>
+                <a:spcPts val="300"/>
+              </a:spcAft>
+              <a:buNone/>
+            </a:pPr>
+            <a:r>
+              <a:rPr lang="en-US" sz="1400" b="1" dirty="0">
                 <a:solidFill>
                   <a:schemeClr val="tx2"/>
                 </a:solidFill>
               </a:rPr>
-              <a:t>Say 'yes' more safely</a:t>
-            </a:r>
-            <a:endParaRPr lang="en-US" sz="1500" dirty="0"/>
-          </a:p>
-        </p:txBody>
-      </p:sp>
-      <p:sp>
-        <p:nvSpPr>
-          <p:cNvPr id="20" name="Card body Q3"/>
-          <p:cNvSpPr txBox="1"/>
-          <p:nvPr/>
-        </p:nvSpPr>
-        <p:spPr>
-          <a:xfrm>
-            <a:off x="5212080" y="3886200"/>
-            <a:ext cx="1764792" cy="2057400"/>
-          </a:xfrm>
-          <a:prstGeom prst="rect">
-            <a:avLst/>
-          </a:prstGeom>
-          <a:noFill/>
-          <a:ln/>
-        </p:spPr>
-        <p:txBody>
-          <a:bodyPr wrap="square" lIns="0" tIns="0" rIns="0" bIns="0" rtlCol="0" anchor="t"/>
-          <a:lstStyle/>
+              <a:t>Few loyal KTB users among our best customers</a:t>
+            </a:r>
+            <a:endParaRPr lang="en-US" sz="1400" dirty="0"/>
+          </a:p>
           <a:p>
             <a:pPr indent="0" marL="0">
+              <a:spcAft>
+                <a:spcPts val="300"/>
+              </a:spcAft>
               <a:buNone/>
             </a:pPr>
             <a:r>
@@ -8760,305 +9452,9 @@
                   <a:schemeClr val="tx1"/>
                 </a:solidFill>
               </a:rPr>
-              <a:t>Over 90% of blue-collar and gig workers apply but only 5–7% get a loan. Improve approval rules and offer small starter loans</a:t>
-            </a:r>
-            <a:endParaRPr lang="en-US" sz="1200" dirty="0"/>
-          </a:p>
-        </p:txBody>
-      </p:sp>
-      <p:sp>
-        <p:nvSpPr>
-          <p:cNvPr id="21" name="Card Q4"/>
-          <p:cNvSpPr/>
-          <p:nvPr/>
-        </p:nvSpPr>
-        <p:spPr>
-          <a:xfrm>
-            <a:off x="7315200" y="2194560"/>
-            <a:ext cx="2130552" cy="3886200"/>
-          </a:xfrm>
-          <a:prstGeom prst="rect">
-            <a:avLst/>
-          </a:prstGeom>
-          <a:solidFill>
-            <a:schemeClr val="bg2"/>
-          </a:solidFill>
-          <a:ln/>
-        </p:spPr>
-      </p:sp>
-      <p:sp>
-        <p:nvSpPr>
-          <p:cNvPr id="22" name="Card badge Q4"/>
-          <p:cNvSpPr/>
-          <p:nvPr/>
-        </p:nvSpPr>
-        <p:spPr>
-          <a:xfrm>
-            <a:off x="7498080" y="2395728"/>
-            <a:ext cx="502920" cy="502920"/>
-          </a:xfrm>
-          <a:prstGeom prst="ellipse">
-            <a:avLst/>
-          </a:prstGeom>
-          <a:solidFill>
-            <a:schemeClr val="tx2"/>
-          </a:solidFill>
-          <a:ln/>
-        </p:spPr>
-      </p:sp>
-      <p:sp>
-        <p:nvSpPr>
-          <p:cNvPr id="23" name="Card badge text Q4"/>
-          <p:cNvSpPr txBox="1"/>
-          <p:nvPr/>
-        </p:nvSpPr>
-        <p:spPr>
-          <a:xfrm>
-            <a:off x="7498080" y="2395728"/>
-            <a:ext cx="502920" cy="502920"/>
-          </a:xfrm>
-          <a:prstGeom prst="rect">
-            <a:avLst/>
-          </a:prstGeom>
-          <a:noFill/>
-          <a:ln/>
-        </p:spPr>
-        <p:txBody>
-          <a:bodyPr wrap="square" lIns="0" tIns="0" rIns="0" bIns="0" rtlCol="0" anchor="ctr"/>
-          <a:lstStyle/>
-          <a:p>
-            <a:pPr algn="ctr" indent="0" marL="0">
-              <a:buNone/>
-            </a:pPr>
-            <a:r>
-              <a:rPr lang="en-US" sz="1300" b="1" dirty="0">
-                <a:solidFill>
-                  <a:schemeClr val="bg1"/>
-                </a:solidFill>
-              </a:rPr>
-              <a:t>Q4</a:t>
-            </a:r>
-            <a:endParaRPr lang="en-US" sz="1300" dirty="0"/>
-          </a:p>
-        </p:txBody>
-      </p:sp>
-      <p:sp>
-        <p:nvSpPr>
-          <p:cNvPr id="24" name="Card title Q4"/>
-          <p:cNvSpPr txBox="1"/>
-          <p:nvPr/>
-        </p:nvSpPr>
-        <p:spPr>
-          <a:xfrm>
-            <a:off x="7498080" y="3063240"/>
-            <a:ext cx="1764792" cy="777240"/>
-          </a:xfrm>
-          <a:prstGeom prst="rect">
-            <a:avLst/>
-          </a:prstGeom>
-          <a:noFill/>
-          <a:ln/>
-        </p:spPr>
-        <p:txBody>
-          <a:bodyPr wrap="square" lIns="0" tIns="0" rIns="0" bIns="0" rtlCol="0" anchor="t"/>
-          <a:lstStyle/>
-          <a:p>
-            <a:pPr indent="0" marL="0">
-              <a:buNone/>
-            </a:pPr>
-            <a:r>
-              <a:rPr lang="en-US" sz="1500" b="1" dirty="0">
-                <a:solidFill>
-                  <a:schemeClr val="tx2"/>
-                </a:solidFill>
-              </a:rPr>
-              <a:t>Keep new customers using us</a:t>
-            </a:r>
-            <a:endParaRPr lang="en-US" sz="1500" dirty="0"/>
-          </a:p>
-        </p:txBody>
-      </p:sp>
-      <p:sp>
-        <p:nvSpPr>
-          <p:cNvPr id="25" name="Card body Q4"/>
-          <p:cNvSpPr txBox="1"/>
-          <p:nvPr/>
-        </p:nvSpPr>
-        <p:spPr>
-          <a:xfrm>
-            <a:off x="7498080" y="3886200"/>
-            <a:ext cx="1764792" cy="2057400"/>
-          </a:xfrm>
-          <a:prstGeom prst="rect">
-            <a:avLst/>
-          </a:prstGeom>
-          <a:noFill/>
-          <a:ln/>
-        </p:spPr>
-        <p:txBody>
-          <a:bodyPr wrap="square" lIns="0" tIns="0" rIns="0" bIns="0" rtlCol="0" anchor="t"/>
-          <a:lstStyle/>
-          <a:p>
-            <a:pPr indent="0" marL="0">
-              <a:buNone/>
-            </a:pPr>
-            <a:r>
-              <a:rPr lang="en-US" sz="1200" dirty="0">
-                <a:solidFill>
-                  <a:schemeClr val="tx1"/>
-                </a:solidFill>
-              </a:rPr>
-              <a:t>Get them using 3+ features in the first month. Give people we turn down another reason to stay</a:t>
-            </a:r>
-            <a:endParaRPr lang="en-US" sz="1200" dirty="0"/>
-          </a:p>
-        </p:txBody>
-      </p:sp>
-      <p:sp>
-        <p:nvSpPr>
-          <p:cNvPr id="26" name="Card Q5"/>
-          <p:cNvSpPr/>
-          <p:nvPr/>
-        </p:nvSpPr>
-        <p:spPr>
-          <a:xfrm>
-            <a:off x="9601200" y="2194560"/>
-            <a:ext cx="2130552" cy="3886200"/>
-          </a:xfrm>
-          <a:prstGeom prst="rect">
-            <a:avLst/>
-          </a:prstGeom>
-          <a:solidFill>
-            <a:schemeClr val="bg2"/>
-          </a:solidFill>
-          <a:ln/>
-        </p:spPr>
-      </p:sp>
-      <p:sp>
-        <p:nvSpPr>
-          <p:cNvPr id="27" name="Card badge Q5"/>
-          <p:cNvSpPr/>
-          <p:nvPr/>
-        </p:nvSpPr>
-        <p:spPr>
-          <a:xfrm>
-            <a:off x="9784080" y="2395728"/>
-            <a:ext cx="502920" cy="502920"/>
-          </a:xfrm>
-          <a:prstGeom prst="ellipse">
-            <a:avLst/>
-          </a:prstGeom>
-          <a:solidFill>
-            <a:schemeClr val="tx2"/>
-          </a:solidFill>
-          <a:ln/>
-        </p:spPr>
-      </p:sp>
-      <p:sp>
-        <p:nvSpPr>
-          <p:cNvPr id="28" name="Card badge text Q5"/>
-          <p:cNvSpPr txBox="1"/>
-          <p:nvPr/>
-        </p:nvSpPr>
-        <p:spPr>
-          <a:xfrm>
-            <a:off x="9784080" y="2395728"/>
-            <a:ext cx="502920" cy="502920"/>
-          </a:xfrm>
-          <a:prstGeom prst="rect">
-            <a:avLst/>
-          </a:prstGeom>
-          <a:noFill/>
-          <a:ln/>
-        </p:spPr>
-        <p:txBody>
-          <a:bodyPr wrap="square" lIns="0" tIns="0" rIns="0" bIns="0" rtlCol="0" anchor="ctr"/>
-          <a:lstStyle/>
-          <a:p>
-            <a:pPr algn="ctr" indent="0" marL="0">
-              <a:buNone/>
-            </a:pPr>
-            <a:r>
-              <a:rPr lang="en-US" sz="1300" b="1" dirty="0">
-                <a:solidFill>
-                  <a:schemeClr val="bg1"/>
-                </a:solidFill>
-              </a:rPr>
-              <a:t>Q5</a:t>
-            </a:r>
-            <a:endParaRPr lang="en-US" sz="1300" dirty="0"/>
-          </a:p>
-        </p:txBody>
-      </p:sp>
-      <p:sp>
-        <p:nvSpPr>
-          <p:cNvPr id="29" name="Card title Q5"/>
-          <p:cNvSpPr txBox="1"/>
-          <p:nvPr/>
-        </p:nvSpPr>
-        <p:spPr>
-          <a:xfrm>
-            <a:off x="9784080" y="3063240"/>
-            <a:ext cx="1764792" cy="777240"/>
-          </a:xfrm>
-          <a:prstGeom prst="rect">
-            <a:avLst/>
-          </a:prstGeom>
-          <a:noFill/>
-          <a:ln/>
-        </p:spPr>
-        <p:txBody>
-          <a:bodyPr wrap="square" lIns="0" tIns="0" rIns="0" bIns="0" rtlCol="0" anchor="t"/>
-          <a:lstStyle/>
-          <a:p>
-            <a:pPr indent="0" marL="0">
-              <a:buNone/>
-            </a:pPr>
-            <a:r>
-              <a:rPr lang="en-US" sz="1500" b="1" dirty="0">
-                <a:solidFill>
-                  <a:schemeClr val="tx2"/>
-                </a:solidFill>
-              </a:rPr>
-              <a:t>Show KTB we grow the group</a:t>
-            </a:r>
-            <a:endParaRPr lang="en-US" sz="1500" dirty="0"/>
-          </a:p>
-        </p:txBody>
-      </p:sp>
-      <p:sp>
-        <p:nvSpPr>
-          <p:cNvPr id="30" name="Card body Q5"/>
-          <p:cNvSpPr txBox="1"/>
-          <p:nvPr/>
-        </p:nvSpPr>
-        <p:spPr>
-          <a:xfrm>
-            <a:off x="9784080" y="3886200"/>
-            <a:ext cx="1764792" cy="2057400"/>
-          </a:xfrm>
-          <a:prstGeom prst="rect">
-            <a:avLst/>
-          </a:prstGeom>
-          <a:noFill/>
-          <a:ln/>
-        </p:spPr>
-        <p:txBody>
-          <a:bodyPr wrap="square" lIns="0" tIns="0" rIns="0" bIns="0" rtlCol="0" anchor="t"/>
-          <a:lstStyle/>
-          <a:p>
-            <a:pPr indent="0" marL="0">
-              <a:buNone/>
-            </a:pPr>
-            <a:r>
-              <a:rPr lang="en-US" sz="1200" dirty="0">
-                <a:solidFill>
-                  <a:schemeClr val="tx1"/>
-                </a:solidFill>
-              </a:rPr>
-              <a:t>Share the 515K won back and 488K brought back. Set up referrals for people KTB turns down. Check savings once data is in</a:t>
-            </a:r>
-            <a:endParaRPr lang="en-US" sz="1200" dirty="0"/>
+              <a:t>Only 15% of our most engaged shared customers are loyal to KTB</a:t>
+            </a:r>
+            <a:endParaRPr lang="en-US" sz="1400" dirty="0"/>
           </a:p>
         </p:txBody>
       </p:sp>
@@ -9102,6 +9498,968 @@
             <a:fld id="{F7021451-1387-4CA6-816F-3879F97B5CBC}" type="slidenum">
               <a:rPr b="0" lang="en-US"/>
               <a:t>12</a:t>
+            </a:fld>
+            <a:endParaRPr lang="en-US"/>
+          </a:p>
+        </p:txBody>
+      </p:sp>
+    </p:spTree>
+  </p:cSld>
+  <p:clrMapOvr>
+    <a:masterClrMapping/>
+  </p:clrMapOvr>
+</p:sld>
+</file>
+
+<file path=ppt/slides/slide13.xml><?xml version="1.0" encoding="utf-8"?>
+<p:sld xmlns:a="http://schemas.openxmlformats.org/drawingml/2006/main" xmlns:r="http://schemas.openxmlformats.org/officeDocument/2006/relationships" xmlns:p="http://schemas.openxmlformats.org/presentationml/2006/main">
+  <p:cSld name="Slide 13">
+    <p:spTree>
+      <p:nvGrpSpPr>
+        <p:cNvPr id="1" name=""/>
+        <p:cNvGrpSpPr/>
+        <p:nvPr/>
+      </p:nvGrpSpPr>
+      <p:grpSpPr>
+        <a:xfrm>
+          <a:off x="0" y="0"/>
+          <a:ext cx="0" cy="0"/>
+          <a:chOff x="0" y="0"/>
+          <a:chExt cx="0" cy="0"/>
+        </a:xfrm>
+      </p:grpSpPr>
+      <p:sp>
+        <p:nvSpPr>
+          <p:cNvPr id="2" name="Text 0"/>
+          <p:cNvSpPr/>
+          <p:nvPr>
+            <p:ph idx="100" type="body" hasCustomPrompt="1"/>
+          </p:nvPr>
+        </p:nvSpPr>
+        <p:spPr>
+          <a:xfrm>
+            <a:off x="457200" y="274320"/>
+            <a:ext cx="8229600" cy="274320"/>
+          </a:xfrm>
+          <a:prstGeom prst="rect">
+            <a:avLst/>
+          </a:prstGeom>
+          <a:noFill/>
+          <a:ln/>
+        </p:spPr>
+        <p:txBody>
+          <a:bodyPr wrap="square" lIns="0" tIns="0" rIns="0" bIns="0" rtlCol="0"/>
+          <a:lstStyle/>
+          <a:p>
+            <a:pPr indent="0" marL="0">
+              <a:buNone/>
+            </a:pPr>
+            <a:r>
+              <a:rPr lang="en-US" sz="1100" b="1" spc="100" kern="0" dirty="0">
+                <a:solidFill>
+                  <a:schemeClr val="accent1"/>
+                </a:solidFill>
+              </a:rPr>
+              <a:t>WHAT TO DO NEXT</a:t>
+            </a:r>
+            <a:endParaRPr lang="en-US" sz="1100" dirty="0"/>
+          </a:p>
+        </p:txBody>
+      </p:sp>
+      <p:sp>
+        <p:nvSpPr>
+          <p:cNvPr id="3" name="Text 0"/>
+          <p:cNvSpPr/>
+          <p:nvPr>
+            <p:ph idx="101" type="title" hasCustomPrompt="1"/>
+          </p:nvPr>
+        </p:nvSpPr>
+        <p:spPr>
+          <a:xfrm>
+            <a:off x="457200" y="566928"/>
+            <a:ext cx="11274552" cy="822960"/>
+          </a:xfrm>
+          <a:prstGeom prst="rect">
+            <a:avLst/>
+          </a:prstGeom>
+          <a:noFill/>
+          <a:ln/>
+        </p:spPr>
+        <p:txBody>
+          <a:bodyPr wrap="square" lIns="0" tIns="0" rIns="0" bIns="0" rtlCol="0" anchor="t"/>
+          <a:lstStyle/>
+          <a:p>
+            <a:pPr algn="l" indent="0" marL="0">
+              <a:buNone/>
+            </a:pPr>
+            <a:r>
+              <a:rPr lang="en-US" sz="2400" b="1" dirty="0">
+                <a:solidFill>
+                  <a:schemeClr val="tx2"/>
+                </a:solidFill>
+              </a:rPr>
+              <a:t>What should we do with these answers?</a:t>
+            </a:r>
+            <a:endParaRPr lang="en-US" sz="2400" dirty="0"/>
+          </a:p>
+        </p:txBody>
+      </p:sp>
+      <p:sp>
+        <p:nvSpPr>
+          <p:cNvPr id="4" name="Text 0"/>
+          <p:cNvSpPr/>
+          <p:nvPr>
+            <p:ph idx="102" type="body" hasCustomPrompt="1"/>
+          </p:nvPr>
+        </p:nvSpPr>
+        <p:spPr>
+          <a:xfrm>
+            <a:off x="457200" y="1481328"/>
+            <a:ext cx="11274552" cy="594360"/>
+          </a:xfrm>
+          <a:prstGeom prst="rect">
+            <a:avLst/>
+          </a:prstGeom>
+          <a:noFill/>
+          <a:ln/>
+        </p:spPr>
+        <p:txBody>
+          <a:bodyPr wrap="square" lIns="0" tIns="0" rIns="0" bIns="0" rtlCol="0" anchor="t"/>
+          <a:lstStyle/>
+          <a:p>
+            <a:pPr indent="0" marL="0">
+              <a:buNone/>
+            </a:pPr>
+            <a:r>
+              <a:rPr lang="en-US" sz="1600" dirty="0">
+                <a:solidFill>
+                  <a:schemeClr val="tx1"/>
+                </a:solidFill>
+              </a:rPr>
+              <a:t>Keep using partners to bring people in, and focus on turning sign-ups into regular users, starting with the customer types that already work</a:t>
+            </a:r>
+            <a:endParaRPr lang="en-US" sz="1600" dirty="0"/>
+          </a:p>
+        </p:txBody>
+      </p:sp>
+      <p:sp>
+        <p:nvSpPr>
+          <p:cNvPr id="5" name="Text 0"/>
+          <p:cNvSpPr/>
+          <p:nvPr>
+            <p:ph idx="103" type="body" hasCustomPrompt="1"/>
+          </p:nvPr>
+        </p:nvSpPr>
+        <p:spPr>
+          <a:xfrm>
+            <a:off x="457200" y="6327648"/>
+            <a:ext cx="10241280" cy="274320"/>
+          </a:xfrm>
+          <a:prstGeom prst="rect">
+            <a:avLst/>
+          </a:prstGeom>
+          <a:noFill/>
+          <a:ln/>
+        </p:spPr>
+        <p:txBody>
+          <a:bodyPr wrap="square" lIns="0" tIns="0" rIns="0" bIns="0" rtlCol="0" anchor="t"/>
+          <a:lstStyle/>
+          <a:p>
+            <a:pPr indent="0" marL="0">
+              <a:buNone/>
+            </a:pPr>
+            <a:r>
+              <a:rPr lang="en-US" sz="1000" dirty="0">
+                <a:solidFill>
+                  <a:srgbClr val="6E7C87"/>
+                </a:solidFill>
+              </a:rPr>
+              <a:t>Source: CLICX team analysis</a:t>
+            </a:r>
+            <a:endParaRPr lang="en-US" sz="1000" dirty="0"/>
+          </a:p>
+        </p:txBody>
+      </p:sp>
+      <p:sp>
+        <p:nvSpPr>
+          <p:cNvPr id="6" name="Card Q1"/>
+          <p:cNvSpPr/>
+          <p:nvPr/>
+        </p:nvSpPr>
+        <p:spPr>
+          <a:xfrm>
+            <a:off x="457200" y="2194560"/>
+            <a:ext cx="2130552" cy="3886200"/>
+          </a:xfrm>
+          <a:prstGeom prst="rect">
+            <a:avLst/>
+          </a:prstGeom>
+          <a:solidFill>
+            <a:schemeClr val="bg2"/>
+          </a:solidFill>
+          <a:ln/>
+        </p:spPr>
+      </p:sp>
+      <p:sp>
+        <p:nvSpPr>
+          <p:cNvPr id="7" name="Card badge Q1"/>
+          <p:cNvSpPr/>
+          <p:nvPr/>
+        </p:nvSpPr>
+        <p:spPr>
+          <a:xfrm>
+            <a:off x="640080" y="2395728"/>
+            <a:ext cx="502920" cy="502920"/>
+          </a:xfrm>
+          <a:prstGeom prst="ellipse">
+            <a:avLst/>
+          </a:prstGeom>
+          <a:solidFill>
+            <a:schemeClr val="tx2"/>
+          </a:solidFill>
+          <a:ln/>
+        </p:spPr>
+      </p:sp>
+      <p:sp>
+        <p:nvSpPr>
+          <p:cNvPr id="8" name="Card badge text Q1"/>
+          <p:cNvSpPr txBox="1"/>
+          <p:nvPr/>
+        </p:nvSpPr>
+        <p:spPr>
+          <a:xfrm>
+            <a:off x="640080" y="2395728"/>
+            <a:ext cx="502920" cy="502920"/>
+          </a:xfrm>
+          <a:prstGeom prst="rect">
+            <a:avLst/>
+          </a:prstGeom>
+          <a:noFill/>
+          <a:ln/>
+        </p:spPr>
+        <p:txBody>
+          <a:bodyPr wrap="square" lIns="0" tIns="0" rIns="0" bIns="0" rtlCol="0" anchor="ctr"/>
+          <a:lstStyle/>
+          <a:p>
+            <a:pPr algn="ctr" indent="0" marL="0">
+              <a:buNone/>
+            </a:pPr>
+            <a:r>
+              <a:rPr lang="en-US" sz="1300" b="1" dirty="0">
+                <a:solidFill>
+                  <a:schemeClr val="bg1"/>
+                </a:solidFill>
+              </a:rPr>
+              <a:t>Q1</a:t>
+            </a:r>
+            <a:endParaRPr lang="en-US" sz="1300" dirty="0"/>
+          </a:p>
+        </p:txBody>
+      </p:sp>
+      <p:sp>
+        <p:nvSpPr>
+          <p:cNvPr id="9" name="Card title Q1"/>
+          <p:cNvSpPr txBox="1"/>
+          <p:nvPr/>
+        </p:nvSpPr>
+        <p:spPr>
+          <a:xfrm>
+            <a:off x="640080" y="3063240"/>
+            <a:ext cx="1764792" cy="777240"/>
+          </a:xfrm>
+          <a:prstGeom prst="rect">
+            <a:avLst/>
+          </a:prstGeom>
+          <a:noFill/>
+          <a:ln/>
+        </p:spPr>
+        <p:txBody>
+          <a:bodyPr wrap="square" lIns="0" tIns="0" rIns="0" bIns="0" rtlCol="0" anchor="t"/>
+          <a:lstStyle/>
+          <a:p>
+            <a:pPr indent="0" marL="0">
+              <a:buNone/>
+            </a:pPr>
+            <a:r>
+              <a:rPr lang="en-US" sz="1500" b="1" dirty="0">
+                <a:solidFill>
+                  <a:schemeClr val="tx2"/>
+                </a:solidFill>
+              </a:rPr>
+              <a:t>Reach more partner customers</a:t>
+            </a:r>
+            <a:endParaRPr lang="en-US" sz="1500" dirty="0"/>
+          </a:p>
+        </p:txBody>
+      </p:sp>
+      <p:sp>
+        <p:nvSpPr>
+          <p:cNvPr id="10" name="Card body Q1"/>
+          <p:cNvSpPr txBox="1"/>
+          <p:nvPr/>
+        </p:nvSpPr>
+        <p:spPr>
+          <a:xfrm>
+            <a:off x="640080" y="3886200"/>
+            <a:ext cx="1764792" cy="2057400"/>
+          </a:xfrm>
+          <a:prstGeom prst="rect">
+            <a:avLst/>
+          </a:prstGeom>
+          <a:noFill/>
+          <a:ln/>
+        </p:spPr>
+        <p:txBody>
+          <a:bodyPr wrap="square" lIns="0" tIns="0" rIns="0" bIns="0" rtlCol="0" anchor="t"/>
+          <a:lstStyle/>
+          <a:p>
+            <a:pPr indent="0" marL="0">
+              <a:buNone/>
+            </a:pPr>
+            <a:r>
+              <a:rPr lang="en-US" sz="1200" dirty="0">
+                <a:solidFill>
+                  <a:schemeClr val="tx1"/>
+                </a:solidFill>
+              </a:rPr>
+              <a:t>Start with AIS: only 3.7% of its ~32M customers have joined. Sign them up through the myAIS app and AIS shops</a:t>
+            </a:r>
+            <a:endParaRPr lang="en-US" sz="1200" dirty="0"/>
+          </a:p>
+        </p:txBody>
+      </p:sp>
+      <p:sp>
+        <p:nvSpPr>
+          <p:cNvPr id="11" name="Card Q2"/>
+          <p:cNvSpPr/>
+          <p:nvPr/>
+        </p:nvSpPr>
+        <p:spPr>
+          <a:xfrm>
+            <a:off x="2743200" y="2194560"/>
+            <a:ext cx="2130552" cy="3886200"/>
+          </a:xfrm>
+          <a:prstGeom prst="rect">
+            <a:avLst/>
+          </a:prstGeom>
+          <a:solidFill>
+            <a:schemeClr val="bg2"/>
+          </a:solidFill>
+          <a:ln/>
+        </p:spPr>
+      </p:sp>
+      <p:sp>
+        <p:nvSpPr>
+          <p:cNvPr id="12" name="Card badge Q2"/>
+          <p:cNvSpPr/>
+          <p:nvPr/>
+        </p:nvSpPr>
+        <p:spPr>
+          <a:xfrm>
+            <a:off x="2926080" y="2395728"/>
+            <a:ext cx="502920" cy="502920"/>
+          </a:xfrm>
+          <a:prstGeom prst="ellipse">
+            <a:avLst/>
+          </a:prstGeom>
+          <a:solidFill>
+            <a:schemeClr val="tx2"/>
+          </a:solidFill>
+          <a:ln/>
+        </p:spPr>
+      </p:sp>
+      <p:sp>
+        <p:nvSpPr>
+          <p:cNvPr id="13" name="Card badge text Q2"/>
+          <p:cNvSpPr txBox="1"/>
+          <p:nvPr/>
+        </p:nvSpPr>
+        <p:spPr>
+          <a:xfrm>
+            <a:off x="2926080" y="2395728"/>
+            <a:ext cx="502920" cy="502920"/>
+          </a:xfrm>
+          <a:prstGeom prst="rect">
+            <a:avLst/>
+          </a:prstGeom>
+          <a:noFill/>
+          <a:ln/>
+        </p:spPr>
+        <p:txBody>
+          <a:bodyPr wrap="square" lIns="0" tIns="0" rIns="0" bIns="0" rtlCol="0" anchor="ctr"/>
+          <a:lstStyle/>
+          <a:p>
+            <a:pPr algn="ctr" indent="0" marL="0">
+              <a:buNone/>
+            </a:pPr>
+            <a:r>
+              <a:rPr lang="en-US" sz="1300" b="1" dirty="0">
+                <a:solidFill>
+                  <a:schemeClr val="bg1"/>
+                </a:solidFill>
+              </a:rPr>
+              <a:t>Q2</a:t>
+            </a:r>
+            <a:endParaRPr lang="en-US" sz="1300" dirty="0"/>
+          </a:p>
+        </p:txBody>
+      </p:sp>
+      <p:sp>
+        <p:nvSpPr>
+          <p:cNvPr id="14" name="Card title Q2"/>
+          <p:cNvSpPr txBox="1"/>
+          <p:nvPr/>
+        </p:nvSpPr>
+        <p:spPr>
+          <a:xfrm>
+            <a:off x="2926080" y="3063240"/>
+            <a:ext cx="1764792" cy="777240"/>
+          </a:xfrm>
+          <a:prstGeom prst="rect">
+            <a:avLst/>
+          </a:prstGeom>
+          <a:noFill/>
+          <a:ln/>
+        </p:spPr>
+        <p:txBody>
+          <a:bodyPr wrap="square" lIns="0" tIns="0" rIns="0" bIns="0" rtlCol="0" anchor="t"/>
+          <a:lstStyle/>
+          <a:p>
+            <a:pPr indent="0" marL="0">
+              <a:buNone/>
+            </a:pPr>
+            <a:r>
+              <a:rPr lang="en-US" sz="1500" b="1" dirty="0">
+                <a:solidFill>
+                  <a:schemeClr val="tx2"/>
+                </a:solidFill>
+              </a:rPr>
+              <a:t>Find more people like our best customers</a:t>
+            </a:r>
+            <a:endParaRPr lang="en-US" sz="1500" dirty="0"/>
+          </a:p>
+        </p:txBody>
+      </p:sp>
+      <p:sp>
+        <p:nvSpPr>
+          <p:cNvPr id="15" name="Card body Q2"/>
+          <p:cNvSpPr txBox="1"/>
+          <p:nvPr/>
+        </p:nvSpPr>
+        <p:spPr>
+          <a:xfrm>
+            <a:off x="2926080" y="3886200"/>
+            <a:ext cx="1764792" cy="2057400"/>
+          </a:xfrm>
+          <a:prstGeom prst="rect">
+            <a:avLst/>
+          </a:prstGeom>
+          <a:noFill/>
+          <a:ln/>
+        </p:spPr>
+        <p:txBody>
+          <a:bodyPr wrap="square" lIns="0" tIns="0" rIns="0" bIns="0" rtlCol="0" anchor="t"/>
+          <a:lstStyle/>
+          <a:p>
+            <a:pPr indent="0" marL="0">
+              <a:buNone/>
+            </a:pPr>
+            <a:r>
+              <a:rPr lang="en-US" sz="1200" dirty="0">
+                <a:solidFill>
+                  <a:schemeClr val="tx1"/>
+                </a:solidFill>
+              </a:rPr>
+              <a:t>Target tech-savvy 30–34s. Create a clear reason for multi-bank users to switch. Make it easy for gig workers to prove income</a:t>
+            </a:r>
+            <a:endParaRPr lang="en-US" sz="1200" dirty="0"/>
+          </a:p>
+        </p:txBody>
+      </p:sp>
+      <p:sp>
+        <p:nvSpPr>
+          <p:cNvPr id="16" name="Card Q3"/>
+          <p:cNvSpPr/>
+          <p:nvPr/>
+        </p:nvSpPr>
+        <p:spPr>
+          <a:xfrm>
+            <a:off x="5029200" y="2194560"/>
+            <a:ext cx="2130552" cy="3886200"/>
+          </a:xfrm>
+          <a:prstGeom prst="rect">
+            <a:avLst/>
+          </a:prstGeom>
+          <a:solidFill>
+            <a:schemeClr val="bg2"/>
+          </a:solidFill>
+          <a:ln/>
+        </p:spPr>
+      </p:sp>
+      <p:sp>
+        <p:nvSpPr>
+          <p:cNvPr id="17" name="Card badge Q3"/>
+          <p:cNvSpPr/>
+          <p:nvPr/>
+        </p:nvSpPr>
+        <p:spPr>
+          <a:xfrm>
+            <a:off x="5212080" y="2395728"/>
+            <a:ext cx="502920" cy="502920"/>
+          </a:xfrm>
+          <a:prstGeom prst="ellipse">
+            <a:avLst/>
+          </a:prstGeom>
+          <a:solidFill>
+            <a:schemeClr val="tx2"/>
+          </a:solidFill>
+          <a:ln/>
+        </p:spPr>
+      </p:sp>
+      <p:sp>
+        <p:nvSpPr>
+          <p:cNvPr id="18" name="Card badge text Q3"/>
+          <p:cNvSpPr txBox="1"/>
+          <p:nvPr/>
+        </p:nvSpPr>
+        <p:spPr>
+          <a:xfrm>
+            <a:off x="5212080" y="2395728"/>
+            <a:ext cx="502920" cy="502920"/>
+          </a:xfrm>
+          <a:prstGeom prst="rect">
+            <a:avLst/>
+          </a:prstGeom>
+          <a:noFill/>
+          <a:ln/>
+        </p:spPr>
+        <p:txBody>
+          <a:bodyPr wrap="square" lIns="0" tIns="0" rIns="0" bIns="0" rtlCol="0" anchor="ctr"/>
+          <a:lstStyle/>
+          <a:p>
+            <a:pPr algn="ctr" indent="0" marL="0">
+              <a:buNone/>
+            </a:pPr>
+            <a:r>
+              <a:rPr lang="en-US" sz="1300" b="1" dirty="0">
+                <a:solidFill>
+                  <a:schemeClr val="bg1"/>
+                </a:solidFill>
+              </a:rPr>
+              <a:t>Q3</a:t>
+            </a:r>
+            <a:endParaRPr lang="en-US" sz="1300" dirty="0"/>
+          </a:p>
+        </p:txBody>
+      </p:sp>
+      <p:sp>
+        <p:nvSpPr>
+          <p:cNvPr id="19" name="Card title Q3"/>
+          <p:cNvSpPr txBox="1"/>
+          <p:nvPr/>
+        </p:nvSpPr>
+        <p:spPr>
+          <a:xfrm>
+            <a:off x="5212080" y="3063240"/>
+            <a:ext cx="1764792" cy="777240"/>
+          </a:xfrm>
+          <a:prstGeom prst="rect">
+            <a:avLst/>
+          </a:prstGeom>
+          <a:noFill/>
+          <a:ln/>
+        </p:spPr>
+        <p:txBody>
+          <a:bodyPr wrap="square" lIns="0" tIns="0" rIns="0" bIns="0" rtlCol="0" anchor="t"/>
+          <a:lstStyle/>
+          <a:p>
+            <a:pPr indent="0" marL="0">
+              <a:buNone/>
+            </a:pPr>
+            <a:r>
+              <a:rPr lang="en-US" sz="1500" b="1" dirty="0">
+                <a:solidFill>
+                  <a:schemeClr val="tx2"/>
+                </a:solidFill>
+              </a:rPr>
+              <a:t>Say 'yes' more safely</a:t>
+            </a:r>
+            <a:endParaRPr lang="en-US" sz="1500" dirty="0"/>
+          </a:p>
+        </p:txBody>
+      </p:sp>
+      <p:sp>
+        <p:nvSpPr>
+          <p:cNvPr id="20" name="Card body Q3"/>
+          <p:cNvSpPr txBox="1"/>
+          <p:nvPr/>
+        </p:nvSpPr>
+        <p:spPr>
+          <a:xfrm>
+            <a:off x="5212080" y="3886200"/>
+            <a:ext cx="1764792" cy="2057400"/>
+          </a:xfrm>
+          <a:prstGeom prst="rect">
+            <a:avLst/>
+          </a:prstGeom>
+          <a:noFill/>
+          <a:ln/>
+        </p:spPr>
+        <p:txBody>
+          <a:bodyPr wrap="square" lIns="0" tIns="0" rIns="0" bIns="0" rtlCol="0" anchor="t"/>
+          <a:lstStyle/>
+          <a:p>
+            <a:pPr indent="0" marL="0">
+              <a:buNone/>
+            </a:pPr>
+            <a:r>
+              <a:rPr lang="en-US" sz="1200" dirty="0">
+                <a:solidFill>
+                  <a:schemeClr val="tx1"/>
+                </a:solidFill>
+              </a:rPr>
+              <a:t>Over 90% of blue-collar and gig workers apply but only 5–7% get a loan. Improve approval rules and offer small starter loans</a:t>
+            </a:r>
+            <a:endParaRPr lang="en-US" sz="1200" dirty="0"/>
+          </a:p>
+        </p:txBody>
+      </p:sp>
+      <p:sp>
+        <p:nvSpPr>
+          <p:cNvPr id="21" name="Card Q4"/>
+          <p:cNvSpPr/>
+          <p:nvPr/>
+        </p:nvSpPr>
+        <p:spPr>
+          <a:xfrm>
+            <a:off x="7315200" y="2194560"/>
+            <a:ext cx="2130552" cy="3886200"/>
+          </a:xfrm>
+          <a:prstGeom prst="rect">
+            <a:avLst/>
+          </a:prstGeom>
+          <a:solidFill>
+            <a:schemeClr val="bg2"/>
+          </a:solidFill>
+          <a:ln/>
+        </p:spPr>
+      </p:sp>
+      <p:sp>
+        <p:nvSpPr>
+          <p:cNvPr id="22" name="Card badge Q4"/>
+          <p:cNvSpPr/>
+          <p:nvPr/>
+        </p:nvSpPr>
+        <p:spPr>
+          <a:xfrm>
+            <a:off x="7498080" y="2395728"/>
+            <a:ext cx="502920" cy="502920"/>
+          </a:xfrm>
+          <a:prstGeom prst="ellipse">
+            <a:avLst/>
+          </a:prstGeom>
+          <a:solidFill>
+            <a:schemeClr val="tx2"/>
+          </a:solidFill>
+          <a:ln/>
+        </p:spPr>
+      </p:sp>
+      <p:sp>
+        <p:nvSpPr>
+          <p:cNvPr id="23" name="Card badge text Q4"/>
+          <p:cNvSpPr txBox="1"/>
+          <p:nvPr/>
+        </p:nvSpPr>
+        <p:spPr>
+          <a:xfrm>
+            <a:off x="7498080" y="2395728"/>
+            <a:ext cx="502920" cy="502920"/>
+          </a:xfrm>
+          <a:prstGeom prst="rect">
+            <a:avLst/>
+          </a:prstGeom>
+          <a:noFill/>
+          <a:ln/>
+        </p:spPr>
+        <p:txBody>
+          <a:bodyPr wrap="square" lIns="0" tIns="0" rIns="0" bIns="0" rtlCol="0" anchor="ctr"/>
+          <a:lstStyle/>
+          <a:p>
+            <a:pPr algn="ctr" indent="0" marL="0">
+              <a:buNone/>
+            </a:pPr>
+            <a:r>
+              <a:rPr lang="en-US" sz="1300" b="1" dirty="0">
+                <a:solidFill>
+                  <a:schemeClr val="bg1"/>
+                </a:solidFill>
+              </a:rPr>
+              <a:t>Q4</a:t>
+            </a:r>
+            <a:endParaRPr lang="en-US" sz="1300" dirty="0"/>
+          </a:p>
+        </p:txBody>
+      </p:sp>
+      <p:sp>
+        <p:nvSpPr>
+          <p:cNvPr id="24" name="Card title Q4"/>
+          <p:cNvSpPr txBox="1"/>
+          <p:nvPr/>
+        </p:nvSpPr>
+        <p:spPr>
+          <a:xfrm>
+            <a:off x="7498080" y="3063240"/>
+            <a:ext cx="1764792" cy="777240"/>
+          </a:xfrm>
+          <a:prstGeom prst="rect">
+            <a:avLst/>
+          </a:prstGeom>
+          <a:noFill/>
+          <a:ln/>
+        </p:spPr>
+        <p:txBody>
+          <a:bodyPr wrap="square" lIns="0" tIns="0" rIns="0" bIns="0" rtlCol="0" anchor="t"/>
+          <a:lstStyle/>
+          <a:p>
+            <a:pPr indent="0" marL="0">
+              <a:buNone/>
+            </a:pPr>
+            <a:r>
+              <a:rPr lang="en-US" sz="1500" b="1" dirty="0">
+                <a:solidFill>
+                  <a:schemeClr val="tx2"/>
+                </a:solidFill>
+              </a:rPr>
+              <a:t>Keep new customers using us</a:t>
+            </a:r>
+            <a:endParaRPr lang="en-US" sz="1500" dirty="0"/>
+          </a:p>
+        </p:txBody>
+      </p:sp>
+      <p:sp>
+        <p:nvSpPr>
+          <p:cNvPr id="25" name="Card body Q4"/>
+          <p:cNvSpPr txBox="1"/>
+          <p:nvPr/>
+        </p:nvSpPr>
+        <p:spPr>
+          <a:xfrm>
+            <a:off x="7498080" y="3886200"/>
+            <a:ext cx="1764792" cy="2057400"/>
+          </a:xfrm>
+          <a:prstGeom prst="rect">
+            <a:avLst/>
+          </a:prstGeom>
+          <a:noFill/>
+          <a:ln/>
+        </p:spPr>
+        <p:txBody>
+          <a:bodyPr wrap="square" lIns="0" tIns="0" rIns="0" bIns="0" rtlCol="0" anchor="t"/>
+          <a:lstStyle/>
+          <a:p>
+            <a:pPr indent="0" marL="0">
+              <a:buNone/>
+            </a:pPr>
+            <a:r>
+              <a:rPr lang="en-US" sz="1200" dirty="0">
+                <a:solidFill>
+                  <a:schemeClr val="tx1"/>
+                </a:solidFill>
+              </a:rPr>
+              <a:t>Get them using 3+ features in the first month. Give people we turn down another reason to stay</a:t>
+            </a:r>
+            <a:endParaRPr lang="en-US" sz="1200" dirty="0"/>
+          </a:p>
+        </p:txBody>
+      </p:sp>
+      <p:sp>
+        <p:nvSpPr>
+          <p:cNvPr id="26" name="Card Q5"/>
+          <p:cNvSpPr/>
+          <p:nvPr/>
+        </p:nvSpPr>
+        <p:spPr>
+          <a:xfrm>
+            <a:off x="9601200" y="2194560"/>
+            <a:ext cx="2130552" cy="3886200"/>
+          </a:xfrm>
+          <a:prstGeom prst="rect">
+            <a:avLst/>
+          </a:prstGeom>
+          <a:solidFill>
+            <a:schemeClr val="bg2"/>
+          </a:solidFill>
+          <a:ln/>
+        </p:spPr>
+      </p:sp>
+      <p:sp>
+        <p:nvSpPr>
+          <p:cNvPr id="27" name="Card badge Q5"/>
+          <p:cNvSpPr/>
+          <p:nvPr/>
+        </p:nvSpPr>
+        <p:spPr>
+          <a:xfrm>
+            <a:off x="9784080" y="2395728"/>
+            <a:ext cx="502920" cy="502920"/>
+          </a:xfrm>
+          <a:prstGeom prst="ellipse">
+            <a:avLst/>
+          </a:prstGeom>
+          <a:solidFill>
+            <a:schemeClr val="tx2"/>
+          </a:solidFill>
+          <a:ln/>
+        </p:spPr>
+      </p:sp>
+      <p:sp>
+        <p:nvSpPr>
+          <p:cNvPr id="28" name="Card badge text Q5"/>
+          <p:cNvSpPr txBox="1"/>
+          <p:nvPr/>
+        </p:nvSpPr>
+        <p:spPr>
+          <a:xfrm>
+            <a:off x="9784080" y="2395728"/>
+            <a:ext cx="502920" cy="502920"/>
+          </a:xfrm>
+          <a:prstGeom prst="rect">
+            <a:avLst/>
+          </a:prstGeom>
+          <a:noFill/>
+          <a:ln/>
+        </p:spPr>
+        <p:txBody>
+          <a:bodyPr wrap="square" lIns="0" tIns="0" rIns="0" bIns="0" rtlCol="0" anchor="ctr"/>
+          <a:lstStyle/>
+          <a:p>
+            <a:pPr algn="ctr" indent="0" marL="0">
+              <a:buNone/>
+            </a:pPr>
+            <a:r>
+              <a:rPr lang="en-US" sz="1300" b="1" dirty="0">
+                <a:solidFill>
+                  <a:schemeClr val="bg1"/>
+                </a:solidFill>
+              </a:rPr>
+              <a:t>Q5</a:t>
+            </a:r>
+            <a:endParaRPr lang="en-US" sz="1300" dirty="0"/>
+          </a:p>
+        </p:txBody>
+      </p:sp>
+      <p:sp>
+        <p:nvSpPr>
+          <p:cNvPr id="29" name="Card title Q5"/>
+          <p:cNvSpPr txBox="1"/>
+          <p:nvPr/>
+        </p:nvSpPr>
+        <p:spPr>
+          <a:xfrm>
+            <a:off x="9784080" y="3063240"/>
+            <a:ext cx="1764792" cy="777240"/>
+          </a:xfrm>
+          <a:prstGeom prst="rect">
+            <a:avLst/>
+          </a:prstGeom>
+          <a:noFill/>
+          <a:ln/>
+        </p:spPr>
+        <p:txBody>
+          <a:bodyPr wrap="square" lIns="0" tIns="0" rIns="0" bIns="0" rtlCol="0" anchor="t"/>
+          <a:lstStyle/>
+          <a:p>
+            <a:pPr indent="0" marL="0">
+              <a:buNone/>
+            </a:pPr>
+            <a:r>
+              <a:rPr lang="en-US" sz="1500" b="1" dirty="0">
+                <a:solidFill>
+                  <a:schemeClr val="tx2"/>
+                </a:solidFill>
+              </a:rPr>
+              <a:t>Show KTB we grow the group</a:t>
+            </a:r>
+            <a:endParaRPr lang="en-US" sz="1500" dirty="0"/>
+          </a:p>
+        </p:txBody>
+      </p:sp>
+      <p:sp>
+        <p:nvSpPr>
+          <p:cNvPr id="30" name="Card body Q5"/>
+          <p:cNvSpPr txBox="1"/>
+          <p:nvPr/>
+        </p:nvSpPr>
+        <p:spPr>
+          <a:xfrm>
+            <a:off x="9784080" y="3886200"/>
+            <a:ext cx="1764792" cy="2057400"/>
+          </a:xfrm>
+          <a:prstGeom prst="rect">
+            <a:avLst/>
+          </a:prstGeom>
+          <a:noFill/>
+          <a:ln/>
+        </p:spPr>
+        <p:txBody>
+          <a:bodyPr wrap="square" lIns="0" tIns="0" rIns="0" bIns="0" rtlCol="0" anchor="t"/>
+          <a:lstStyle/>
+          <a:p>
+            <a:pPr indent="0" marL="0">
+              <a:buNone/>
+            </a:pPr>
+            <a:r>
+              <a:rPr lang="en-US" sz="1200" dirty="0">
+                <a:solidFill>
+                  <a:schemeClr val="tx1"/>
+                </a:solidFill>
+              </a:rPr>
+              <a:t>Share the 515K won back and 488K brought back. Set up referrals for people KTB turns down. Check savings once data is in</a:t>
+            </a:r>
+            <a:endParaRPr lang="en-US" sz="1200" dirty="0"/>
+          </a:p>
+        </p:txBody>
+      </p:sp>
+      <p:sp>
+        <p:nvSpPr>
+          <p:cNvPr id="25" name="Slide Number Placeholder 0"/>
+          <p:cNvSpPr>
+            <a:spLocks noGrp="1"/>
+          </p:cNvSpPr>
+          <p:nvPr>
+            <p:ph type="sldNum" sz="quarter" idx="4294967295"/>
+          </p:nvPr>
+        </p:nvSpPr>
+        <p:spPr>
+          <a:xfrm>
+            <a:off x="11274552" y="6355080"/>
+            <a:ext cx="457200" cy="274320"/>
+          </a:xfrm>
+          <a:prstGeom prst="rect">
+            <a:avLst/>
+          </a:prstGeom>
+          <a:extLst>
+            <a:ext uri="{C572A759-6A51-4108-AA02-DFA0A04FC94B}">
+              <ma14:wrappingTextBoxFlag xmlns:ma14="http://schemas.microsoft.com/office/mac/drawingml/2011/main" val="0"/>
+            </a:ext>
+          </a:extLst>
+        </p:spPr>
+        <p:txBody>
+          <a:bodyPr/>
+          <a:lstStyle>
+            <a:lvl1pPr>
+              <a:defRPr sz="1000">
+                <a:solidFill>
+                  <a:srgbClr val="6E7C87"/>
+                </a:solidFill>
+              </a:defRPr>
+            </a:lvl1pPr>
+          </a:lstStyle>
+          <a:p>
+            <a:pPr algn="r"/>
+            <a:fld id="{F7021451-1387-4CA6-816F-3879F97B5CBC}" type="slidenum">
+              <a:rPr b="0" lang="en-US"/>
+              <a:t>13</a:t>
             </a:fld>
             <a:endParaRPr lang="en-US"/>
           </a:p>
@@ -14496,7 +15854,7 @@
                   <a:schemeClr val="accent1"/>
                 </a:solidFill>
               </a:rPr>
-              <a:t>Q4  |  WHO KEEPS USING US  (1/2)</a:t>
+              <a:t>Q4  |  WHO KEEPS USING US  (1/3)</a:t>
             </a:r>
             <a:endParaRPr lang="en-US" sz="1100" dirty="0"/>
           </a:p>
@@ -15126,7 +16484,7 @@
                   <a:schemeClr val="accent1"/>
                 </a:solidFill>
               </a:rPr>
-              <a:t>Q4  |  WHO KEEPS USING US  (2/2)</a:t>
+              <a:t>Q4  |  WHO KEEPS USING US  (2/3)</a:t>
             </a:r>
             <a:endParaRPr lang="en-US" sz="1100" dirty="0"/>
           </a:p>

</xml_diff>

<commit_message>
Slide 10: payment rate by loan, job and region
Co-Authored-By: Claude Opus 5.5 <noreply@anthropic.com>
Claude-Session: https://claude.ai/code/session_01PMn7aLX79upLSj9P26uPyP
</commit_message>
<xml_diff>
--- a/clicx_insights/CLICX_Customer_Insights.pptx
+++ b/clicx_insights/CLICX_Customer_Insights.pptx
@@ -119,43 +119,43 @@
   <p:extLst>
     <p:ext uri="{521415D9-36F7-43E2-AB2F-B90AF26B5E84}">
       <p14:sectionLst xmlns:p14="http://schemas.microsoft.com/office/powerpoint/2010/main">
-        <p14:section name="Opening" id="{5177c535-ab6d-8083-8554-3868f96dfd32}">
+        <p14:section name="Opening" id="{9f3e2b13-90a4-fa18-8455-2fca6705af5b}">
           <p14:sldIdLst>
             <p14:sldId id="256"/>
             <p14:sldId id="257"/>
           </p14:sldIdLst>
         </p14:section>
-        <p14:section name="Q1 Source of customers" id="{b162ea8b-2c2b-3caf-9448-8cad1fcff7b7}">
+        <p14:section name="Q1 Source of customers" id="{0d6fd1ec-a3c6-0342-1772-6c5a4b1eb112}">
           <p14:sldIdLst>
             <p14:sldId id="258"/>
           </p14:sldIdLst>
         </p14:section>
-        <p14:section name="Q2 Who our customers are" id="{fd15ed15-bd8d-e3c3-f75a-ff4097882d82}">
+        <p14:section name="Q2 Who our customers are" id="{51991864-8d98-0fe9-eb92-5402d1527c59}">
           <p14:sldIdLst>
             <p14:sldId id="259"/>
             <p14:sldId id="260"/>
             <p14:sldId id="261"/>
           </p14:sldIdLst>
         </p14:section>
-        <p14:section name="Q3 What they come for" id="{78c775bc-0e07-062d-a208-182dcefb8fd4}">
+        <p14:section name="Q3 What they come for" id="{9c3ff3db-97ae-88d2-6dd2-715fc1c09b56}">
           <p14:sldIdLst>
             <p14:sldId id="262"/>
           </p14:sldIdLst>
         </p14:section>
-        <p14:section name="Q4 Active vs inactive" id="{57770db7-718a-3f16-bf06-e6b10bd0dd8d}">
+        <p14:section name="Q4 Active vs inactive" id="{2218d6d5-f89f-d8c5-966d-5ab1dd73b620}">
           <p14:sldIdLst>
             <p14:sldId id="263"/>
             <p14:sldId id="264"/>
             <p14:sldId id="265"/>
           </p14:sldIdLst>
         </p14:section>
-        <p14:section name="Q5 Impact on KTB" id="{1b348ca3-ba02-d364-8023-bd117801684c}">
+        <p14:section name="Q5 Impact on KTB" id="{6d827b68-42b7-ccfa-e470-b7ddc41c0eaf}">
           <p14:sldIdLst>
             <p14:sldId id="266"/>
             <p14:sldId id="267"/>
           </p14:sldIdLst>
         </p14:section>
-        <p14:section name="What to do next" id="{43b82ccf-aff4-7124-cfd3-28e65dbcf345}">
+        <p14:section name="What to do next" id="{2983b876-17e4-2cea-c6ac-d226ded2e5c6}">
           <p14:sldIdLst>
             <p14:sldId id="268"/>
           </p14:sldIdLst>
@@ -488,7 +488,282 @@
                 </a:solidFill>
                 <a:latin typeface="+mn-lt"/>
               </a:rPr>
-              <a:t>Who they are: regular payers vs never paid, % of each group</a:t>
+              <a:t>% paid, by loan</a:t>
+            </a:r>
+          </a:p>
+        </c:rich>
+      </c:tx>
+      <c:layout/>
+      <c:overlay val="0"/>
+    </c:title>
+    <c:autoTitleDeleted val="0"/>
+    <c:plotArea>
+      <c:layout/>
+      <c:barChart>
+        <c:barDir val="col"/>
+        <c:grouping val="clustered"/>
+        <c:varyColors val="0"/>
+        <c:ser>
+          <c:idx val="0"/>
+          <c:order val="0"/>
+          <c:tx>
+            <c:strRef>
+              <c:f>Sheet1!$B$1</c:f>
+              <c:strCache>
+                <c:ptCount val="1"/>
+                <c:pt idx="0">
+                  <c:v>Paid Aug–Oct</c:v>
+                </c:pt>
+              </c:strCache>
+            </c:strRef>
+          </c:tx>
+          <c:spPr>
+            <a:solidFill>
+              <a:srgbClr val="051C2C"/>
+            </a:solidFill>
+            <a:effectLst/>
+          </c:spPr>
+          <c:invertIfNegative val="0"/>
+          <c:dLbls>
+            <c:numFmt formatCode="0%" sourceLinked="0"/>
+            <c:txPr>
+              <a:bodyPr/>
+              <a:lstStyle/>
+              <a:p>
+                <a:pPr>
+                  <a:defRPr b="0" i="0" strike="noStrike" sz="1000" u="none">
+                    <a:solidFill>
+                      <a:srgbClr val="1A1A1A"/>
+                    </a:solidFill>
+                    <a:latin typeface="+mn-lt"/>
+                  </a:defRPr>
+                </a:pPr>
+              </a:p>
+            </c:txPr>
+            <c:showLegendKey val="0"/>
+            <c:showVal val="1"/>
+            <c:showCatName val="0"/>
+            <c:showSerName val="0"/>
+            <c:showPercent val="0"/>
+            <c:showBubbleSize val="0"/>
+            <c:showLeaderLines val="0"/>
+          </c:dLbls>
+          <c:dPt>
+            <c:idx val="0"/>
+            <c:invertIfNegative val="0"/>
+            <c:bubble3D val="0"/>
+            <c:spPr>
+              <a:solidFill>
+                <a:srgbClr val="051C2C"/>
+              </a:solidFill>
+              <a:effectLst/>
+            </c:spPr>
+          </c:dPt>
+          <c:dPt>
+            <c:idx val="1"/>
+            <c:invertIfNegative val="0"/>
+            <c:bubble3D val="0"/>
+            <c:spPr>
+              <a:solidFill>
+                <a:srgbClr val="A2AAAD"/>
+              </a:solidFill>
+              <a:effectLst/>
+            </c:spPr>
+          </c:dPt>
+          <c:cat>
+            <c:multiLvlStrRef>
+              <c:f>Sheet1!$A$2:$A$3</c:f>
+              <c:multiLvlStrCache>
+                <c:ptCount val="2"/>
+                <c:lvl>
+                  <c:pt idx="0">
+                    <c:v>Has a CLICX loan</c:v>
+                  </c:pt>
+                  <c:pt idx="1">
+                    <c:v>No CLICX loan</c:v>
+                  </c:pt>
+                </c:lvl>
+              </c:multiLvlStrCache>
+            </c:multiLvlStrRef>
+          </c:cat>
+          <c:val>
+            <c:numRef>
+              <c:f>Sheet1!$B$2:$B$3</c:f>
+              <c:numCache>
+                <c:formatCode>General</c:formatCode>
+                <c:ptCount val="2"/>
+                <c:pt idx="0">
+                  <c:v>0.543</c:v>
+                </c:pt>
+                <c:pt idx="1">
+                  <c:v>0.106</c:v>
+                </c:pt>
+              </c:numCache>
+            </c:numRef>
+          </c:val>
+        </c:ser>
+        <c:dLbls>
+          <c:numFmt formatCode="0%" sourceLinked="0"/>
+          <c:txPr>
+            <a:bodyPr/>
+            <a:lstStyle/>
+            <a:p>
+              <a:pPr>
+                <a:defRPr b="0" i="0" strike="noStrike" sz="1000" u="none">
+                  <a:solidFill>
+                    <a:srgbClr val="1A1A1A"/>
+                  </a:solidFill>
+                  <a:latin typeface="+mn-lt"/>
+                </a:defRPr>
+              </a:pPr>
+            </a:p>
+          </c:txPr>
+          <c:showLegendKey val="0"/>
+          <c:showVal val="1"/>
+          <c:showCatName val="0"/>
+          <c:showSerName val="0"/>
+          <c:showPercent val="0"/>
+          <c:showBubbleSize val="0"/>
+          <c:showLeaderLines val="0"/>
+        </c:dLbls>
+        <c:gapWidth val="50"/>
+        <c:overlap val="0"/>
+        <c:axId val="2094734554"/>
+        <c:axId val="2094734552"/>
+        <c:axId val="2094734556"/>
+      </c:barChart>
+      <c:catAx>
+        <c:axId val="2094734554"/>
+        <c:scaling>
+          <c:orientation val="minMax"/>
+        </c:scaling>
+        <c:delete val="0"/>
+        <c:axPos val="b"/>
+        <c:numFmt formatCode="General" sourceLinked="1"/>
+        <c:majorTickMark val="out"/>
+        <c:minorTickMark val="none"/>
+        <c:tickLblPos val="low"/>
+        <c:spPr>
+          <a:ln w="12700" cap="flat">
+            <a:solidFill>
+              <a:srgbClr val="D5DADF"/>
+            </a:solidFill>
+            <a:prstDash val="solid"/>
+            <a:round/>
+          </a:ln>
+        </c:spPr>
+        <c:txPr>
+          <a:bodyPr/>
+          <a:lstStyle/>
+          <a:p>
+            <a:pPr>
+              <a:defRPr sz="1000" b="0" i="0" u="none" strike="noStrike">
+                <a:solidFill>
+                  <a:srgbClr val="5F6B76"/>
+                </a:solidFill>
+                <a:latin typeface="+mn-lt"/>
+              </a:defRPr>
+            </a:pPr>
+            <a:endParaRPr lang="en-US"/>
+          </a:p>
+        </c:txPr>
+        <c:crossAx val="2094734552"/>
+        <c:crosses val="autoZero"/>
+        <c:auto val="1"/>
+        <c:lblAlgn val="ctr"/>
+        <c:noMultiLvlLbl val="1"/>
+      </c:catAx>
+      <c:valAx>
+        <c:axId val="2094734552"/>
+        <c:scaling>
+          <c:orientation val="minMax"/>
+          <c:max val="0.65"/>
+        </c:scaling>
+        <c:delete val="1"/>
+        <c:axPos val="l"/>
+        <c:numFmt formatCode="General" sourceLinked="0"/>
+        <c:majorTickMark val="out"/>
+        <c:minorTickMark val="none"/>
+        <c:tickLblPos val="nextTo"/>
+        <c:spPr>
+          <a:ln w="12700" cap="flat">
+            <a:solidFill>
+              <a:srgbClr val="888888"/>
+            </a:solidFill>
+            <a:prstDash val="solid"/>
+            <a:round/>
+          </a:ln>
+        </c:spPr>
+        <c:txPr>
+          <a:bodyPr/>
+          <a:lstStyle/>
+          <a:p>
+            <a:pPr>
+              <a:defRPr sz="1000" b="0" i="0" u="none" strike="noStrike">
+                <a:solidFill>
+                  <a:srgbClr val="5F6B76"/>
+                </a:solidFill>
+                <a:latin typeface="+mn-lt"/>
+              </a:defRPr>
+            </a:pPr>
+            <a:endParaRPr lang="en-US"/>
+          </a:p>
+        </c:txPr>
+        <c:crossAx val="2094734554"/>
+        <c:crosses val="autoZero"/>
+        <c:crossBetween val="between"/>
+      </c:valAx>
+      <c:spPr>
+        <a:noFill/>
+        <a:ln>
+          <a:noFill/>
+        </a:ln>
+        <a:effectLst/>
+      </c:spPr>
+    </c:plotArea>
+    <c:plotVisOnly val="1"/>
+    <c:dispBlanksAs val="span"/>
+  </c:chart>
+  <c:spPr>
+    <a:noFill/>
+    <a:ln>
+      <a:noFill/>
+    </a:ln>
+    <a:effectLst/>
+  </c:spPr>
+  <c:externalData r:id="rId1">
+    <c:autoUpdate val="0"/>
+  </c:externalData>
+</c:chartSpace>
+</file>
+
+<file path=ppt/charts/chart11.xml><?xml version="1.0" encoding="utf-8"?>
+<c:chartSpace xmlns:c="http://schemas.openxmlformats.org/drawingml/2006/chart" xmlns:a="http://schemas.openxmlformats.org/drawingml/2006/main" xmlns:r="http://schemas.openxmlformats.org/officeDocument/2006/relationships">
+  <c:date1904 val="0"/>
+  <c:roundedCorners val="1"/>
+  <c:chart>
+    <c:title>
+      <c:tx>
+        <c:rich>
+          <a:bodyPr/>
+          <a:lstStyle/>
+          <a:p>
+            <a:pPr algn="l">
+              <a:defRPr sz="1300" b="1" i="0" u="none" strike="noStrike">
+                <a:solidFill>
+                  <a:srgbClr val="051C2C"/>
+                </a:solidFill>
+                <a:latin typeface="+mn-lt"/>
+              </a:defRPr>
+            </a:pPr>
+            <a:r>
+              <a:rPr sz="1300" b="1" i="0" u="none" strike="noStrike">
+                <a:solidFill>
+                  <a:srgbClr val="051C2C"/>
+                </a:solidFill>
+                <a:latin typeface="+mn-lt"/>
+              </a:rPr>
+              <a:t>% paid, by job</a:t>
             </a:r>
           </a:p>
         </c:rich>
@@ -512,7 +787,7 @@
               <c:strCache>
                 <c:ptCount val="1"/>
                 <c:pt idx="0">
-                  <c:v>Regular payers (paid Aug, Sep and Oct, 58K)</c:v>
+                  <c:v>Paid Aug–Oct</c:v>
                 </c:pt>
               </c:strCache>
             </c:strRef>
@@ -525,13 +800,13 @@
           </c:spPr>
           <c:invertIfNegative val="0"/>
           <c:dLbls>
-            <c:numFmt formatCode="0%" sourceLinked="0"/>
+            <c:numFmt formatCode="0.0%" sourceLinked="0"/>
             <c:txPr>
               <a:bodyPr/>
               <a:lstStyle/>
               <a:p>
                 <a:pPr>
-                  <a:defRPr b="0" i="0" strike="noStrike" sz="900" u="none">
+                  <a:defRPr b="0" i="0" strike="noStrike" sz="1000" u="none">
                     <a:solidFill>
                       <a:srgbClr val="1A1A1A"/>
                     </a:solidFill>
@@ -548,35 +823,137 @@
             <c:showBubbleSize val="0"/>
             <c:showLeaderLines val="0"/>
           </c:dLbls>
+          <c:dPt>
+            <c:idx val="0"/>
+            <c:invertIfNegative val="0"/>
+            <c:bubble3D val="0"/>
+            <c:spPr>
+              <a:solidFill>
+                <a:srgbClr val="051C2C"/>
+              </a:solidFill>
+              <a:effectLst/>
+            </c:spPr>
+          </c:dPt>
+          <c:dPt>
+            <c:idx val="1"/>
+            <c:invertIfNegative val="0"/>
+            <c:bubble3D val="0"/>
+            <c:spPr>
+              <a:solidFill>
+                <a:srgbClr val="051C2C"/>
+              </a:solidFill>
+              <a:effectLst/>
+            </c:spPr>
+          </c:dPt>
+          <c:dPt>
+            <c:idx val="2"/>
+            <c:invertIfNegative val="0"/>
+            <c:bubble3D val="0"/>
+            <c:spPr>
+              <a:solidFill>
+                <a:srgbClr val="051C2C"/>
+              </a:solidFill>
+              <a:effectLst/>
+            </c:spPr>
+          </c:dPt>
+          <c:dPt>
+            <c:idx val="3"/>
+            <c:invertIfNegative val="0"/>
+            <c:bubble3D val="0"/>
+            <c:spPr>
+              <a:solidFill>
+                <a:srgbClr val="051C2C"/>
+              </a:solidFill>
+              <a:effectLst/>
+            </c:spPr>
+          </c:dPt>
+          <c:dPt>
+            <c:idx val="4"/>
+            <c:invertIfNegative val="0"/>
+            <c:bubble3D val="0"/>
+            <c:spPr>
+              <a:solidFill>
+                <a:srgbClr val="A2AAAD"/>
+              </a:solidFill>
+              <a:effectLst/>
+            </c:spPr>
+          </c:dPt>
+          <c:dPt>
+            <c:idx val="5"/>
+            <c:invertIfNegative val="0"/>
+            <c:bubble3D val="0"/>
+            <c:spPr>
+              <a:solidFill>
+                <a:srgbClr val="A2AAAD"/>
+              </a:solidFill>
+              <a:effectLst/>
+            </c:spPr>
+          </c:dPt>
+          <c:dPt>
+            <c:idx val="6"/>
+            <c:invertIfNegative val="0"/>
+            <c:bubble3D val="0"/>
+            <c:spPr>
+              <a:solidFill>
+                <a:srgbClr val="A2AAAD"/>
+              </a:solidFill>
+              <a:effectLst/>
+            </c:spPr>
+          </c:dPt>
+          <c:dPt>
+            <c:idx val="7"/>
+            <c:invertIfNegative val="0"/>
+            <c:bubble3D val="0"/>
+            <c:spPr>
+              <a:solidFill>
+                <a:srgbClr val="A2AAAD"/>
+              </a:solidFill>
+              <a:effectLst/>
+            </c:spPr>
+          </c:dPt>
+          <c:dPt>
+            <c:idx val="8"/>
+            <c:invertIfNegative val="0"/>
+            <c:bubble3D val="0"/>
+            <c:spPr>
+              <a:solidFill>
+                <a:srgbClr val="D9475C"/>
+              </a:solidFill>
+              <a:effectLst/>
+            </c:spPr>
+          </c:dPt>
           <c:cat>
             <c:multiLvlStrRef>
-              <c:f>Sheet1!$A$2:$A$9</c:f>
+              <c:f>Sheet1!$A$2:$A$10</c:f>
               <c:multiLvlStrCache>
-                <c:ptCount val="8"/>
+                <c:ptCount val="9"/>
                 <c:lvl>
                   <c:pt idx="0">
-                    <c:v>In their 30s</c:v>
+                    <c:v>Government staff</c:v>
                   </c:pt>
                   <c:pt idx="1">
-                    <c:v>In their 20s</c:v>
+                    <c:v>Online seller</c:v>
                   </c:pt>
                   <c:pt idx="2">
-                    <c:v>Salaried (company or government)</c:v>
+                    <c:v>Shop owner</c:v>
                   </c:pt>
                   <c:pt idx="3">
-                    <c:v>Blue-collar or farm worker</c:v>
+                    <c:v>Company employee</c:v>
                   </c:pt>
                   <c:pt idx="4">
-                    <c:v>AIS monthly phone bill</c:v>
+                    <c:v>Freelancer</c:v>
                   </c:pt>
                   <c:pt idx="5">
-                    <c:v>Not an AIS customer</c:v>
+                    <c:v>Rider / driver</c:v>
                   </c:pt>
                   <c:pt idx="6">
-                    <c:v>Has a CLICX loan</c:v>
+                    <c:v>Daily wage earner</c:v>
                   </c:pt>
                   <c:pt idx="7">
-                    <c:v>Has put money into CLICX</c:v>
+                    <c:v>Farmer</c:v>
+                  </c:pt>
+                  <c:pt idx="8">
+                    <c:v>Blue-collar worker</c:v>
                   </c:pt>
                 </c:lvl>
               </c:multiLvlStrCache>
@@ -584,159 +961,49 @@
           </c:cat>
           <c:val>
             <c:numRef>
-              <c:f>Sheet1!$B$2:$B$9</c:f>
+              <c:f>Sheet1!$B$2:$B$10</c:f>
               <c:numCache>
                 <c:formatCode>General</c:formatCode>
-                <c:ptCount val="8"/>
+                <c:ptCount val="9"/>
                 <c:pt idx="0">
-                  <c:v>0.407</c:v>
+                  <c:v>0.183</c:v>
                 </c:pt>
                 <c:pt idx="1">
-                  <c:v>0.212</c:v>
+                  <c:v>0.181</c:v>
                 </c:pt>
                 <c:pt idx="2">
-                  <c:v>0.44</c:v>
+                  <c:v>0.177</c:v>
                 </c:pt>
                 <c:pt idx="3">
-                  <c:v>0.14</c:v>
+                  <c:v>0.169</c:v>
                 </c:pt>
                 <c:pt idx="4">
-                  <c:v>0.342</c:v>
+                  <c:v>0.132</c:v>
                 </c:pt>
                 <c:pt idx="5">
-                  <c:v>0.306</c:v>
+                  <c:v>0.13</c:v>
                 </c:pt>
                 <c:pt idx="6">
-                  <c:v>0.464</c:v>
+                  <c:v>0.125</c:v>
                 </c:pt>
                 <c:pt idx="7">
-                  <c:v>0.999</c:v>
+                  <c:v>0.124</c:v>
                 </c:pt>
-              </c:numCache>
-            </c:numRef>
-          </c:val>
-        </c:ser>
-        <c:ser>
-          <c:idx val="1"/>
-          <c:order val="1"/>
-          <c:tx>
-            <c:strRef>
-              <c:f>Sheet1!$C$1</c:f>
-              <c:strCache>
-                <c:ptCount val="1"/>
-                <c:pt idx="0">
-                  <c:v>Never paid (1.27M)</c:v>
-                </c:pt>
-              </c:strCache>
-            </c:strRef>
-          </c:tx>
-          <c:spPr>
-            <a:solidFill>
-              <a:srgbClr val="D5DADF"/>
-            </a:solidFill>
-            <a:effectLst/>
-          </c:spPr>
-          <c:invertIfNegative val="0"/>
-          <c:dLbls>
-            <c:numFmt formatCode="0%" sourceLinked="0"/>
-            <c:txPr>
-              <a:bodyPr/>
-              <a:lstStyle/>
-              <a:p>
-                <a:pPr>
-                  <a:defRPr b="0" i="0" strike="noStrike" sz="900" u="none">
-                    <a:solidFill>
-                      <a:srgbClr val="1A1A1A"/>
-                    </a:solidFill>
-                    <a:latin typeface="+mn-lt"/>
-                  </a:defRPr>
-                </a:pPr>
-              </a:p>
-            </c:txPr>
-            <c:showLegendKey val="0"/>
-            <c:showVal val="1"/>
-            <c:showCatName val="0"/>
-            <c:showSerName val="0"/>
-            <c:showPercent val="0"/>
-            <c:showBubbleSize val="0"/>
-            <c:showLeaderLines val="0"/>
-          </c:dLbls>
-          <c:cat>
-            <c:multiLvlStrRef>
-              <c:f>Sheet1!$A$2:$A$9</c:f>
-              <c:multiLvlStrCache>
-                <c:ptCount val="8"/>
-                <c:lvl>
-                  <c:pt idx="0">
-                    <c:v>In their 30s</c:v>
-                  </c:pt>
-                  <c:pt idx="1">
-                    <c:v>In their 20s</c:v>
-                  </c:pt>
-                  <c:pt idx="2">
-                    <c:v>Salaried (company or government)</c:v>
-                  </c:pt>
-                  <c:pt idx="3">
-                    <c:v>Blue-collar or farm worker</c:v>
-                  </c:pt>
-                  <c:pt idx="4">
-                    <c:v>AIS monthly phone bill</c:v>
-                  </c:pt>
-                  <c:pt idx="5">
-                    <c:v>Not an AIS customer</c:v>
-                  </c:pt>
-                  <c:pt idx="6">
-                    <c:v>Has a CLICX loan</c:v>
-                  </c:pt>
-                  <c:pt idx="7">
-                    <c:v>Has put money into CLICX</c:v>
-                  </c:pt>
-                </c:lvl>
-              </c:multiLvlStrCache>
-            </c:multiLvlStrRef>
-          </c:cat>
-          <c:val>
-            <c:numRef>
-              <c:f>Sheet1!$C$2:$C$9</c:f>
-              <c:numCache>
-                <c:formatCode>General</c:formatCode>
-                <c:ptCount val="8"/>
-                <c:pt idx="0">
-                  <c:v>0.382</c:v>
-                </c:pt>
-                <c:pt idx="1">
-                  <c:v>0.266</c:v>
-                </c:pt>
-                <c:pt idx="2">
-                  <c:v>0.37</c:v>
-                </c:pt>
-                <c:pt idx="3">
-                  <c:v>0.19</c:v>
-                </c:pt>
-                <c:pt idx="4">
-                  <c:v>0.188</c:v>
-                </c:pt>
-                <c:pt idx="5">
-                  <c:v>0.46</c:v>
-                </c:pt>
-                <c:pt idx="6">
-                  <c:v>0.059</c:v>
-                </c:pt>
-                <c:pt idx="7">
-                  <c:v>0.237</c:v>
+                <c:pt idx="8">
+                  <c:v>0.118</c:v>
                 </c:pt>
               </c:numCache>
             </c:numRef>
           </c:val>
         </c:ser>
         <c:dLbls>
-          <c:numFmt formatCode="0%" sourceLinked="0"/>
+          <c:numFmt formatCode="0.0%" sourceLinked="0"/>
           <c:txPr>
             <a:bodyPr/>
             <a:lstStyle/>
             <a:p>
               <a:pPr>
-                <a:defRPr b="0" i="0" strike="noStrike" sz="900" u="none">
+                <a:defRPr b="0" i="0" strike="noStrike" sz="1000" u="none">
                   <a:solidFill>
                     <a:srgbClr val="1A1A1A"/>
                   </a:solidFill>
@@ -753,7 +1020,7 @@
           <c:showBubbleSize val="0"/>
           <c:showLeaderLines val="0"/>
         </c:dLbls>
-        <c:gapWidth val="30"/>
+        <c:gapWidth val="35"/>
         <c:overlap val="0"/>
         <c:axId val="2094734554"/>
         <c:axId val="2094734552"/>
@@ -804,7 +1071,7 @@
         <c:axId val="2094734552"/>
         <c:scaling>
           <c:orientation val="minMax"/>
-          <c:max val="1.2"/>
+          <c:max val="0.24"/>
         </c:scaling>
         <c:delete val="1"/>
         <c:axPos val="b"/>
@@ -848,26 +1115,6 @@
         <a:effectLst/>
       </c:spPr>
     </c:plotArea>
-    <c:legend>
-      <c:legendPos val="b"/>
-      <c:overlay val="0"/>
-      <c:txPr>
-        <a:bodyPr/>
-        <a:lstStyle/>
-        <a:p>
-          <a:pPr>
-            <a:defRPr sz="1000">
-              <a:solidFill>
-                <a:srgbClr val="5F6B76"/>
-              </a:solidFill>
-              <a:latin typeface="+mn-lt"/>
-              <a:cs typeface="+mn-lt"/>
-            </a:defRPr>
-          </a:pPr>
-          <a:endParaRPr lang="en-US"/>
-        </a:p>
-      </c:txPr>
-    </c:legend>
     <c:plotVisOnly val="1"/>
     <c:dispBlanksAs val="span"/>
   </c:chart>
@@ -884,7 +1131,401 @@
 </c:chartSpace>
 </file>
 
-<file path=ppt/charts/chart11.xml><?xml version="1.0" encoding="utf-8"?>
+<file path=ppt/charts/chart12.xml><?xml version="1.0" encoding="utf-8"?>
+<c:chartSpace xmlns:c="http://schemas.openxmlformats.org/drawingml/2006/chart" xmlns:a="http://schemas.openxmlformats.org/drawingml/2006/main" xmlns:r="http://schemas.openxmlformats.org/officeDocument/2006/relationships">
+  <c:date1904 val="0"/>
+  <c:roundedCorners val="1"/>
+  <c:chart>
+    <c:title>
+      <c:tx>
+        <c:rich>
+          <a:bodyPr/>
+          <a:lstStyle/>
+          <a:p>
+            <a:pPr algn="l">
+              <a:defRPr sz="1300" b="1" i="0" u="none" strike="noStrike">
+                <a:solidFill>
+                  <a:srgbClr val="051C2C"/>
+                </a:solidFill>
+                <a:latin typeface="+mn-lt"/>
+              </a:defRPr>
+            </a:pPr>
+            <a:r>
+              <a:rPr sz="1300" b="1" i="0" u="none" strike="noStrike">
+                <a:solidFill>
+                  <a:srgbClr val="051C2C"/>
+                </a:solidFill>
+                <a:latin typeface="+mn-lt"/>
+              </a:rPr>
+              <a:t>% paid, by region</a:t>
+            </a:r>
+          </a:p>
+        </c:rich>
+      </c:tx>
+      <c:layout/>
+      <c:overlay val="0"/>
+    </c:title>
+    <c:autoTitleDeleted val="0"/>
+    <c:plotArea>
+      <c:layout/>
+      <c:barChart>
+        <c:barDir val="bar"/>
+        <c:grouping val="clustered"/>
+        <c:varyColors val="0"/>
+        <c:ser>
+          <c:idx val="0"/>
+          <c:order val="0"/>
+          <c:tx>
+            <c:strRef>
+              <c:f>Sheet1!$B$1</c:f>
+              <c:strCache>
+                <c:ptCount val="1"/>
+                <c:pt idx="0">
+                  <c:v>Paid Aug–Oct</c:v>
+                </c:pt>
+              </c:strCache>
+            </c:strRef>
+          </c:tx>
+          <c:spPr>
+            <a:solidFill>
+              <a:srgbClr val="051C2C"/>
+            </a:solidFill>
+            <a:effectLst/>
+          </c:spPr>
+          <c:invertIfNegative val="0"/>
+          <c:dLbls>
+            <c:numFmt formatCode="0.0%" sourceLinked="0"/>
+            <c:txPr>
+              <a:bodyPr/>
+              <a:lstStyle/>
+              <a:p>
+                <a:pPr>
+                  <a:defRPr b="0" i="0" strike="noStrike" sz="1000" u="none">
+                    <a:solidFill>
+                      <a:srgbClr val="1A1A1A"/>
+                    </a:solidFill>
+                    <a:latin typeface="+mn-lt"/>
+                  </a:defRPr>
+                </a:pPr>
+              </a:p>
+            </c:txPr>
+            <c:showLegendKey val="0"/>
+            <c:showVal val="1"/>
+            <c:showCatName val="0"/>
+            <c:showSerName val="0"/>
+            <c:showPercent val="0"/>
+            <c:showBubbleSize val="0"/>
+            <c:showLeaderLines val="0"/>
+          </c:dLbls>
+          <c:dPt>
+            <c:idx val="0"/>
+            <c:invertIfNegative val="0"/>
+            <c:bubble3D val="0"/>
+            <c:spPr>
+              <a:solidFill>
+                <a:srgbClr val="051C2C"/>
+              </a:solidFill>
+              <a:effectLst/>
+            </c:spPr>
+          </c:dPt>
+          <c:dPt>
+            <c:idx val="1"/>
+            <c:invertIfNegative val="0"/>
+            <c:bubble3D val="0"/>
+            <c:spPr>
+              <a:solidFill>
+                <a:srgbClr val="051C2C"/>
+              </a:solidFill>
+              <a:effectLst/>
+            </c:spPr>
+          </c:dPt>
+          <c:dPt>
+            <c:idx val="2"/>
+            <c:invertIfNegative val="0"/>
+            <c:bubble3D val="0"/>
+            <c:spPr>
+              <a:solidFill>
+                <a:srgbClr val="051C2C"/>
+              </a:solidFill>
+              <a:effectLst/>
+            </c:spPr>
+          </c:dPt>
+          <c:dPt>
+            <c:idx val="3"/>
+            <c:invertIfNegative val="0"/>
+            <c:bubble3D val="0"/>
+            <c:spPr>
+              <a:solidFill>
+                <a:srgbClr val="A2AAAD"/>
+              </a:solidFill>
+              <a:effectLst/>
+            </c:spPr>
+          </c:dPt>
+          <c:dPt>
+            <c:idx val="4"/>
+            <c:invertIfNegative val="0"/>
+            <c:bubble3D val="0"/>
+            <c:spPr>
+              <a:solidFill>
+                <a:srgbClr val="A2AAAD"/>
+              </a:solidFill>
+              <a:effectLst/>
+            </c:spPr>
+          </c:dPt>
+          <c:dPt>
+            <c:idx val="5"/>
+            <c:invertIfNegative val="0"/>
+            <c:bubble3D val="0"/>
+            <c:spPr>
+              <a:solidFill>
+                <a:srgbClr val="A2AAAD"/>
+              </a:solidFill>
+              <a:effectLst/>
+            </c:spPr>
+          </c:dPt>
+          <c:dPt>
+            <c:idx val="6"/>
+            <c:invertIfNegative val="0"/>
+            <c:bubble3D val="0"/>
+            <c:spPr>
+              <a:solidFill>
+                <a:srgbClr val="A2AAAD"/>
+              </a:solidFill>
+              <a:effectLst/>
+            </c:spPr>
+          </c:dPt>
+          <c:dPt>
+            <c:idx val="7"/>
+            <c:invertIfNegative val="0"/>
+            <c:bubble3D val="0"/>
+            <c:spPr>
+              <a:solidFill>
+                <a:srgbClr val="A2AAAD"/>
+              </a:solidFill>
+              <a:effectLst/>
+            </c:spPr>
+          </c:dPt>
+          <c:dPt>
+            <c:idx val="8"/>
+            <c:invertIfNegative val="0"/>
+            <c:bubble3D val="0"/>
+            <c:spPr>
+              <a:solidFill>
+                <a:srgbClr val="A2AAAD"/>
+              </a:solidFill>
+              <a:effectLst/>
+            </c:spPr>
+          </c:dPt>
+          <c:cat>
+            <c:multiLvlStrRef>
+              <c:f>Sheet1!$A$2:$A$10</c:f>
+              <c:multiLvlStrCache>
+                <c:ptCount val="9"/>
+                <c:lvl>
+                  <c:pt idx="0">
+                    <c:v>Chiang Mai</c:v>
+                  </c:pt>
+                  <c:pt idx="1">
+                    <c:v>Nonthaburi</c:v>
+                  </c:pt>
+                  <c:pt idx="2">
+                    <c:v>Bangkok</c:v>
+                  </c:pt>
+                  <c:pt idx="3">
+                    <c:v>Pathum Thani</c:v>
+                  </c:pt>
+                  <c:pt idx="4">
+                    <c:v>Chon Buri</c:v>
+                  </c:pt>
+                  <c:pt idx="5">
+                    <c:v>Rayong</c:v>
+                  </c:pt>
+                  <c:pt idx="6">
+                    <c:v>Nakhon Ratchasima</c:v>
+                  </c:pt>
+                  <c:pt idx="7">
+                    <c:v>Other provinces</c:v>
+                  </c:pt>
+                  <c:pt idx="8">
+                    <c:v>Samut Prakan</c:v>
+                  </c:pt>
+                </c:lvl>
+              </c:multiLvlStrCache>
+            </c:multiLvlStrRef>
+          </c:cat>
+          <c:val>
+            <c:numRef>
+              <c:f>Sheet1!$B$2:$B$10</c:f>
+              <c:numCache>
+                <c:formatCode>General</c:formatCode>
+                <c:ptCount val="9"/>
+                <c:pt idx="0">
+                  <c:v>0.185</c:v>
+                </c:pt>
+                <c:pt idx="1">
+                  <c:v>0.175</c:v>
+                </c:pt>
+                <c:pt idx="2">
+                  <c:v>0.169</c:v>
+                </c:pt>
+                <c:pt idx="3">
+                  <c:v>0.155</c:v>
+                </c:pt>
+                <c:pt idx="4">
+                  <c:v>0.151</c:v>
+                </c:pt>
+                <c:pt idx="5">
+                  <c:v>0.151</c:v>
+                </c:pt>
+                <c:pt idx="6">
+                  <c:v>0.151</c:v>
+                </c:pt>
+                <c:pt idx="7">
+                  <c:v>0.147</c:v>
+                </c:pt>
+                <c:pt idx="8">
+                  <c:v>0.144</c:v>
+                </c:pt>
+              </c:numCache>
+            </c:numRef>
+          </c:val>
+        </c:ser>
+        <c:dLbls>
+          <c:numFmt formatCode="0.0%" sourceLinked="0"/>
+          <c:txPr>
+            <a:bodyPr/>
+            <a:lstStyle/>
+            <a:p>
+              <a:pPr>
+                <a:defRPr b="0" i="0" strike="noStrike" sz="1000" u="none">
+                  <a:solidFill>
+                    <a:srgbClr val="1A1A1A"/>
+                  </a:solidFill>
+                  <a:latin typeface="+mn-lt"/>
+                </a:defRPr>
+              </a:pPr>
+            </a:p>
+          </c:txPr>
+          <c:showLegendKey val="0"/>
+          <c:showVal val="1"/>
+          <c:showCatName val="0"/>
+          <c:showSerName val="0"/>
+          <c:showPercent val="0"/>
+          <c:showBubbleSize val="0"/>
+          <c:showLeaderLines val="0"/>
+        </c:dLbls>
+        <c:gapWidth val="35"/>
+        <c:overlap val="0"/>
+        <c:axId val="2094734554"/>
+        <c:axId val="2094734552"/>
+        <c:axId val="2094734556"/>
+      </c:barChart>
+      <c:catAx>
+        <c:axId val="2094734554"/>
+        <c:scaling>
+          <c:orientation val="maxMin"/>
+        </c:scaling>
+        <c:delete val="0"/>
+        <c:axPos val="l"/>
+        <c:numFmt formatCode="General" sourceLinked="1"/>
+        <c:majorTickMark val="out"/>
+        <c:minorTickMark val="none"/>
+        <c:tickLblPos val="nextTo"/>
+        <c:spPr>
+          <a:ln w="12700" cap="flat">
+            <a:solidFill>
+              <a:srgbClr val="D5DADF"/>
+            </a:solidFill>
+            <a:prstDash val="solid"/>
+            <a:round/>
+          </a:ln>
+        </c:spPr>
+        <c:txPr>
+          <a:bodyPr/>
+          <a:lstStyle/>
+          <a:p>
+            <a:pPr>
+              <a:defRPr sz="1000" b="0" i="0" u="none" strike="noStrike">
+                <a:solidFill>
+                  <a:srgbClr val="5F6B76"/>
+                </a:solidFill>
+                <a:latin typeface="+mn-lt"/>
+              </a:defRPr>
+            </a:pPr>
+            <a:endParaRPr lang="en-US"/>
+          </a:p>
+        </c:txPr>
+        <c:crossAx val="2094734552"/>
+        <c:crosses val="autoZero"/>
+        <c:auto val="1"/>
+        <c:lblAlgn val="ctr"/>
+        <c:noMultiLvlLbl val="1"/>
+      </c:catAx>
+      <c:valAx>
+        <c:axId val="2094734552"/>
+        <c:scaling>
+          <c:orientation val="minMax"/>
+          <c:max val="0.24"/>
+        </c:scaling>
+        <c:delete val="1"/>
+        <c:axPos val="b"/>
+        <c:numFmt formatCode="General" sourceLinked="0"/>
+        <c:majorTickMark val="out"/>
+        <c:minorTickMark val="none"/>
+        <c:tickLblPos val="low"/>
+        <c:spPr>
+          <a:ln w="12700" cap="flat">
+            <a:solidFill>
+              <a:srgbClr val="888888"/>
+            </a:solidFill>
+            <a:prstDash val="solid"/>
+            <a:round/>
+          </a:ln>
+        </c:spPr>
+        <c:txPr>
+          <a:bodyPr/>
+          <a:lstStyle/>
+          <a:p>
+            <a:pPr>
+              <a:defRPr sz="1000" b="0" i="0" u="none" strike="noStrike">
+                <a:solidFill>
+                  <a:srgbClr val="5F6B76"/>
+                </a:solidFill>
+                <a:latin typeface="+mn-lt"/>
+              </a:defRPr>
+            </a:pPr>
+            <a:endParaRPr lang="en-US"/>
+          </a:p>
+        </c:txPr>
+        <c:crossAx val="2094734554"/>
+        <c:crosses val="autoZero"/>
+        <c:crossBetween val="between"/>
+      </c:valAx>
+      <c:spPr>
+        <a:noFill/>
+        <a:ln>
+          <a:noFill/>
+        </a:ln>
+        <a:effectLst/>
+      </c:spPr>
+    </c:plotArea>
+    <c:plotVisOnly val="1"/>
+    <c:dispBlanksAs val="span"/>
+  </c:chart>
+  <c:spPr>
+    <a:noFill/>
+    <a:ln>
+      <a:noFill/>
+    </a:ln>
+    <a:effectLst/>
+  </c:spPr>
+  <c:externalData r:id="rId1">
+    <c:autoUpdate val="0"/>
+  </c:externalData>
+</c:chartSpace>
+</file>
+
+<file path=ppt/charts/chart13.xml><?xml version="1.0" encoding="utf-8"?>
 <c:chartSpace xmlns:c="http://schemas.openxmlformats.org/drawingml/2006/chart" xmlns:a="http://schemas.openxmlformats.org/drawingml/2006/main" xmlns:r="http://schemas.openxmlformats.org/officeDocument/2006/relationships">
   <c:date1904 val="0"/>
   <c:roundedCorners val="1"/>
@@ -1193,7 +1834,7 @@
 </c:chartSpace>
 </file>
 
-<file path=ppt/charts/chart12.xml><?xml version="1.0" encoding="utf-8"?>
+<file path=ppt/charts/chart14.xml><?xml version="1.0" encoding="utf-8"?>
 <c:chartSpace xmlns:c="http://schemas.openxmlformats.org/drawingml/2006/chart" xmlns:a="http://schemas.openxmlformats.org/drawingml/2006/main" xmlns:r="http://schemas.openxmlformats.org/officeDocument/2006/relationships">
   <c:date1904 val="0"/>
   <c:roundedCorners val="1"/>
@@ -1502,7 +2143,7 @@
 </c:chartSpace>
 </file>
 
-<file path=ppt/charts/chart13.xml><?xml version="1.0" encoding="utf-8"?>
+<file path=ppt/charts/chart15.xml><?xml version="1.0" encoding="utf-8"?>
 <c:chartSpace xmlns:c="http://schemas.openxmlformats.org/drawingml/2006/chart" xmlns:a="http://schemas.openxmlformats.org/drawingml/2006/main" xmlns:r="http://schemas.openxmlformats.org/officeDocument/2006/relationships">
   <c:date1904 val="0"/>
   <c:roundedCorners val="1"/>
@@ -7397,7 +8038,7 @@
                   <a:schemeClr val="tx1"/>
                 </a:solidFill>
               </a:rPr>
-              <a:t>Payers are not a different type of person: their age and job look almost the same as non-payers. What sets them apart is that they have put money in and got a loan</a:t>
+              <a:t>Having a CLICX loan matters most: 54% of borrowers paid with CLICX in Aug–Oct vs 11% of everyone else. Job and region matter less, but government staff, merchants and Chiang Mai lead</a:t>
             </a:r>
             <a:endParaRPr lang="en-US" sz="1600" dirty="0"/>
           </a:p>
@@ -7435,237 +8076,21 @@
                   <a:srgbClr val="6E7C87"/>
                 </a:solidFill>
               </a:rPr>
-              <a:t>Source: CLICX payment segments, Aug–Oct 2026 (1.50M customers with an account)</a:t>
+              <a:t>% paid = share who paid a bill, topped up or scanned to pay with CLICX at least once in Aug–Oct 2026 (average 15.4%). Source: CLICX payment segments (1.50M customers)</a:t>
             </a:r>
             <a:endParaRPr lang="en-US" sz="1000" dirty="0"/>
-          </a:p>
-        </p:txBody>
-      </p:sp>
-      <p:sp>
-        <p:nvSpPr>
-          <p:cNvPr id="6" name="Stat 8%"/>
-          <p:cNvSpPr txBox="1"/>
-          <p:nvPr/>
-        </p:nvSpPr>
-        <p:spPr>
-          <a:xfrm>
-            <a:off x="457200" y="2194560"/>
-            <a:ext cx="2194560" cy="640080"/>
-          </a:xfrm>
-          <a:prstGeom prst="rect">
-            <a:avLst/>
-          </a:prstGeom>
-          <a:noFill/>
-          <a:ln/>
-        </p:spPr>
-        <p:txBody>
-          <a:bodyPr wrap="square" lIns="0" tIns="0" rIns="0" bIns="0" rtlCol="0" anchor="ctr"/>
-          <a:lstStyle/>
-          <a:p>
-            <a:pPr indent="0" marL="0">
-              <a:buNone/>
-            </a:pPr>
-            <a:r>
-              <a:rPr lang="en-US" sz="4000" b="1" dirty="0">
-                <a:solidFill>
-                  <a:schemeClr val="accent1"/>
-                </a:solidFill>
-              </a:rPr>
-              <a:t>8%</a:t>
-            </a:r>
-            <a:endParaRPr lang="en-US" sz="4000" dirty="0"/>
-          </a:p>
-        </p:txBody>
-      </p:sp>
-      <p:sp>
-        <p:nvSpPr>
-          <p:cNvPr id="7" name="Stat label 8%"/>
-          <p:cNvSpPr txBox="1"/>
-          <p:nvPr/>
-        </p:nvSpPr>
-        <p:spPr>
-          <a:xfrm>
-            <a:off x="457200" y="2852928"/>
-            <a:ext cx="2194560" cy="502920"/>
-          </a:xfrm>
-          <a:prstGeom prst="rect">
-            <a:avLst/>
-          </a:prstGeom>
-          <a:noFill/>
-          <a:ln/>
-        </p:spPr>
-        <p:txBody>
-          <a:bodyPr wrap="square" lIns="0" tIns="0" rIns="0" bIns="0" rtlCol="0" anchor="t"/>
-          <a:lstStyle/>
-          <a:p>
-            <a:pPr indent="0" marL="0">
-              <a:buNone/>
-            </a:pPr>
-            <a:r>
-              <a:rPr lang="en-US" sz="1200" dirty="0">
-                <a:solidFill>
-                  <a:schemeClr val="tx1"/>
-                </a:solidFill>
-              </a:rPr>
-              <a:t>paid with CLICX in October (117K of 1.5M)</a:t>
-            </a:r>
-            <a:endParaRPr lang="en-US" sz="1200" dirty="0"/>
-          </a:p>
-        </p:txBody>
-      </p:sp>
-      <p:sp>
-        <p:nvSpPr>
-          <p:cNvPr id="8" name="Stat 85%"/>
-          <p:cNvSpPr txBox="1"/>
-          <p:nvPr/>
-        </p:nvSpPr>
-        <p:spPr>
-          <a:xfrm>
-            <a:off x="457200" y="3611880"/>
-            <a:ext cx="2194560" cy="640080"/>
-          </a:xfrm>
-          <a:prstGeom prst="rect">
-            <a:avLst/>
-          </a:prstGeom>
-          <a:noFill/>
-          <a:ln/>
-        </p:spPr>
-        <p:txBody>
-          <a:bodyPr wrap="square" lIns="0" tIns="0" rIns="0" bIns="0" rtlCol="0" anchor="ctr"/>
-          <a:lstStyle/>
-          <a:p>
-            <a:pPr indent="0" marL="0">
-              <a:buNone/>
-            </a:pPr>
-            <a:r>
-              <a:rPr lang="en-US" sz="4000" b="1" dirty="0">
-                <a:solidFill>
-                  <a:schemeClr val="tx2"/>
-                </a:solidFill>
-              </a:rPr>
-              <a:t>85%</a:t>
-            </a:r>
-            <a:endParaRPr lang="en-US" sz="4000" dirty="0"/>
-          </a:p>
-        </p:txBody>
-      </p:sp>
-      <p:sp>
-        <p:nvSpPr>
-          <p:cNvPr id="9" name="Stat label 85%"/>
-          <p:cNvSpPr txBox="1"/>
-          <p:nvPr/>
-        </p:nvSpPr>
-        <p:spPr>
-          <a:xfrm>
-            <a:off x="457200" y="4270248"/>
-            <a:ext cx="2194560" cy="502920"/>
-          </a:xfrm>
-          <a:prstGeom prst="rect">
-            <a:avLst/>
-          </a:prstGeom>
-          <a:noFill/>
-          <a:ln/>
-        </p:spPr>
-        <p:txBody>
-          <a:bodyPr wrap="square" lIns="0" tIns="0" rIns="0" bIns="0" rtlCol="0" anchor="t"/>
-          <a:lstStyle/>
-          <a:p>
-            <a:pPr indent="0" marL="0">
-              <a:buNone/>
-            </a:pPr>
-            <a:r>
-              <a:rPr lang="en-US" sz="1200" dirty="0">
-                <a:solidFill>
-                  <a:schemeClr val="tx1"/>
-                </a:solidFill>
-              </a:rPr>
-              <a:t>have never paid with CLICX in the last 3 months (1.27M)</a:t>
-            </a:r>
-            <a:endParaRPr lang="en-US" sz="1200" dirty="0"/>
-          </a:p>
-        </p:txBody>
-      </p:sp>
-      <p:sp>
-        <p:nvSpPr>
-          <p:cNvPr id="10" name="Stat −29%"/>
-          <p:cNvSpPr txBox="1"/>
-          <p:nvPr/>
-        </p:nvSpPr>
-        <p:spPr>
-          <a:xfrm>
-            <a:off x="457200" y="5029200"/>
-            <a:ext cx="2194560" cy="640080"/>
-          </a:xfrm>
-          <a:prstGeom prst="rect">
-            <a:avLst/>
-          </a:prstGeom>
-          <a:noFill/>
-          <a:ln/>
-        </p:spPr>
-        <p:txBody>
-          <a:bodyPr wrap="square" lIns="0" tIns="0" rIns="0" bIns="0" rtlCol="0" anchor="ctr"/>
-          <a:lstStyle/>
-          <a:p>
-            <a:pPr indent="0" marL="0">
-              <a:buNone/>
-            </a:pPr>
-            <a:r>
-              <a:rPr lang="en-US" sz="4000" b="1" dirty="0">
-                <a:solidFill>
-                  <a:schemeClr val="accent5"/>
-                </a:solidFill>
-              </a:rPr>
-              <a:t>−29%</a:t>
-            </a:r>
-            <a:endParaRPr lang="en-US" sz="4000" dirty="0"/>
-          </a:p>
-        </p:txBody>
-      </p:sp>
-      <p:sp>
-        <p:nvSpPr>
-          <p:cNvPr id="11" name="Stat label −29%"/>
-          <p:cNvSpPr txBox="1"/>
-          <p:nvPr/>
-        </p:nvSpPr>
-        <p:spPr>
-          <a:xfrm>
-            <a:off x="457200" y="5687568"/>
-            <a:ext cx="2194560" cy="502920"/>
-          </a:xfrm>
-          <a:prstGeom prst="rect">
-            <a:avLst/>
-          </a:prstGeom>
-          <a:noFill/>
-          <a:ln/>
-        </p:spPr>
-        <p:txBody>
-          <a:bodyPr wrap="square" lIns="0" tIns="0" rIns="0" bIns="0" rtlCol="0" anchor="t"/>
-          <a:lstStyle/>
-          <a:p>
-            <a:pPr indent="0" marL="0">
-              <a:buNone/>
-            </a:pPr>
-            <a:r>
-              <a:rPr lang="en-US" sz="1200" dirty="0">
-                <a:solidFill>
-                  <a:schemeClr val="tx1"/>
-                </a:solidFill>
-              </a:rPr>
-              <a:t>fewer payers in Oct than in Aug</a:t>
-            </a:r>
-            <a:endParaRPr lang="en-US" sz="1200" dirty="0"/>
           </a:p>
         </p:txBody>
       </p:sp>
       <p:graphicFrame>
         <p:nvGraphicFramePr>
-          <p:cNvPr id="12" name="Payers vs non-payers profile" descr=""/>
+          <p:cNvPr id="6" name="Paid by loan status" descr=""/>
           <p:cNvGraphicFramePr/>
           <p:nvPr/>
         </p:nvGraphicFramePr>
         <p:xfrm>
-          <a:off x="2834640" y="2148840"/>
-          <a:ext cx="5303520" cy="3977640"/>
+          <a:off x="457200" y="2148840"/>
+          <a:ext cx="1828800" cy="3977640"/>
         </p:xfrm>
         <a:graphic xmlns:a="http://schemas.openxmlformats.org/drawingml/2006/main">
           <a:graphicData uri="http://schemas.openxmlformats.org/drawingml/2006/chart">
@@ -7673,9 +8098,41 @@
           </a:graphicData>
         </a:graphic>
       </p:graphicFrame>
-      <p:sp>
-        <p:nvSpPr>
-          <p:cNvPr id="13" name="Insight panel"/>
+      <p:graphicFrame>
+        <p:nvGraphicFramePr>
+          <p:cNvPr id="7" name="Paid by occupation" descr=""/>
+          <p:cNvGraphicFramePr/>
+          <p:nvPr/>
+        </p:nvGraphicFramePr>
+        <p:xfrm>
+          <a:off x="2377440" y="2148840"/>
+          <a:ext cx="2926080" cy="3977640"/>
+        </p:xfrm>
+        <a:graphic xmlns:a="http://schemas.openxmlformats.org/drawingml/2006/main">
+          <a:graphicData uri="http://schemas.openxmlformats.org/drawingml/2006/chart">
+            <c:chart xmlns:c="http://schemas.openxmlformats.org/drawingml/2006/chart" r:id="rId2"/>
+          </a:graphicData>
+        </a:graphic>
+      </p:graphicFrame>
+      <p:graphicFrame>
+        <p:nvGraphicFramePr>
+          <p:cNvPr id="8" name="Paid by region" descr=""/>
+          <p:cNvGraphicFramePr/>
+          <p:nvPr/>
+        </p:nvGraphicFramePr>
+        <p:xfrm>
+          <a:off x="5394960" y="2148840"/>
+          <a:ext cx="2743200" cy="3977640"/>
+        </p:xfrm>
+        <a:graphic xmlns:a="http://schemas.openxmlformats.org/drawingml/2006/main">
+          <a:graphicData uri="http://schemas.openxmlformats.org/drawingml/2006/chart">
+            <c:chart xmlns:c="http://schemas.openxmlformats.org/drawingml/2006/chart" r:id="rId3"/>
+          </a:graphicData>
+        </a:graphic>
+      </p:graphicFrame>
+      <p:sp>
+        <p:nvSpPr>
+          <p:cNvPr id="9" name="Insight panel"/>
           <p:cNvSpPr/>
           <p:nvPr/>
         </p:nvSpPr>
@@ -7695,7 +8152,7 @@
       </p:sp>
       <p:sp>
         <p:nvSpPr>
-          <p:cNvPr id="14" name="Insight header"/>
+          <p:cNvPr id="10" name="Insight header"/>
           <p:cNvSpPr txBox="1"/>
           <p:nvPr/>
         </p:nvSpPr>
@@ -7731,7 +8188,7 @@
       </p:sp>
       <p:sp>
         <p:nvSpPr>
-          <p:cNvPr id="15" name="Badge 1"/>
+          <p:cNvPr id="11" name="Badge 1"/>
           <p:cNvSpPr/>
           <p:nvPr/>
         </p:nvSpPr>
@@ -7751,7 +8208,7 @@
       </p:sp>
       <p:sp>
         <p:nvSpPr>
-          <p:cNvPr id="16" name="Badge num 1"/>
+          <p:cNvPr id="12" name="Badge num 1"/>
           <p:cNvSpPr txBox="1"/>
           <p:nvPr/>
         </p:nvSpPr>
@@ -7787,7 +8244,7 @@
       </p:sp>
       <p:sp>
         <p:nvSpPr>
-          <p:cNvPr id="17" name="Insight 1"/>
+          <p:cNvPr id="13" name="Insight 1"/>
           <p:cNvSpPr txBox="1"/>
           <p:nvPr/>
         </p:nvSpPr>
@@ -7818,7 +8275,7 @@
                   <a:schemeClr val="tx2"/>
                 </a:solidFill>
               </a:rPr>
-              <a:t>Age and job barely matter</a:t>
+              <a:t>A loan is the strongest signal</a:t>
             </a:r>
             <a:endParaRPr lang="en-US" sz="1400" dirty="0"/>
           </a:p>
@@ -7835,7 +8292,7 @@
                   <a:schemeClr val="tx1"/>
                 </a:solidFill>
               </a:rPr>
-              <a:t>Gaps are small: 41% vs 38% in their 30s, 44% vs 37% salaried, 14% vs 19% blue-collar</a:t>
+              <a:t>Borrowers are 5x more likely to pay with CLICX (54% vs 11%)</a:t>
             </a:r>
             <a:endParaRPr lang="en-US" sz="1400" dirty="0"/>
           </a:p>
@@ -7843,7 +8300,7 @@
       </p:sp>
       <p:sp>
         <p:nvSpPr>
-          <p:cNvPr id="18" name="Badge 2"/>
+          <p:cNvPr id="14" name="Badge 2"/>
           <p:cNvSpPr/>
           <p:nvPr/>
         </p:nvSpPr>
@@ -7863,7 +8320,7 @@
       </p:sp>
       <p:sp>
         <p:nvSpPr>
-          <p:cNvPr id="19" name="Badge num 2"/>
+          <p:cNvPr id="15" name="Badge num 2"/>
           <p:cNvSpPr txBox="1"/>
           <p:nvPr/>
         </p:nvSpPr>
@@ -7899,7 +8356,7 @@
       </p:sp>
       <p:sp>
         <p:nvSpPr>
-          <p:cNvPr id="20" name="Insight 2"/>
+          <p:cNvPr id="16" name="Insight 2"/>
           <p:cNvSpPr txBox="1"/>
           <p:nvPr/>
         </p:nvSpPr>
@@ -7930,7 +8387,7 @@
                   <a:schemeClr val="tx2"/>
                 </a:solidFill>
               </a:rPr>
-              <a:t>Money in is the dividing line</a:t>
+              <a:t>Steady earners pay more</a:t>
             </a:r>
             <a:endParaRPr lang="en-US" sz="1400" dirty="0"/>
           </a:p>
@@ -7947,7 +8404,7 @@
                   <a:schemeClr val="tx1"/>
                 </a:solidFill>
               </a:rPr>
-              <a:t>Nearly all regular payers have put money in, vs 24% of non-payers. Without money in, almost no one pays (0.1%)</a:t>
+              <a:t>Government staff, sellers and company employees: 17–18%. Blue-collar workers and farmers: about 12%</a:t>
             </a:r>
             <a:endParaRPr lang="en-US" sz="1400" dirty="0"/>
           </a:p>
@@ -7955,7 +8412,7 @@
       </p:sp>
       <p:sp>
         <p:nvSpPr>
-          <p:cNvPr id="21" name="Badge 3"/>
+          <p:cNvPr id="17" name="Badge 3"/>
           <p:cNvSpPr/>
           <p:nvPr/>
         </p:nvSpPr>
@@ -7975,7 +8432,7 @@
       </p:sp>
       <p:sp>
         <p:nvSpPr>
-          <p:cNvPr id="22" name="Badge num 3"/>
+          <p:cNvPr id="18" name="Badge num 3"/>
           <p:cNvSpPr txBox="1"/>
           <p:nvPr/>
         </p:nvSpPr>
@@ -8011,7 +8468,7 @@
       </p:sp>
       <p:sp>
         <p:nvSpPr>
-          <p:cNvPr id="23" name="Insight 3"/>
+          <p:cNvPr id="19" name="Insight 3"/>
           <p:cNvSpPr txBox="1"/>
           <p:nvPr/>
         </p:nvSpPr>
@@ -8042,7 +8499,7 @@
                   <a:schemeClr val="tx2"/>
                 </a:solidFill>
               </a:rPr>
-              <a:t>Loans and phone bills help</a:t>
+              <a:t>Chiang Mai and Nonthaburi lead</a:t>
             </a:r>
             <a:endParaRPr lang="en-US" sz="1400" dirty="0"/>
           </a:p>
@@ -8059,7 +8516,7 @@
                   <a:schemeClr val="tx1"/>
                 </a:solidFill>
               </a:rPr>
-              <a:t>46% of regular payers have a loan vs 6% of non-payers. AIS monthly-bill customers are 34% of regular payers vs 19% of non-payers</a:t>
+              <a:t>18.5% and 17.5%, vs 14–15% in most provinces. Region matters less than job</a:t>
             </a:r>
             <a:endParaRPr lang="en-US" sz="1400" dirty="0"/>
           </a:p>

</xml_diff>

<commit_message>
Slide 11: illustrative placeholder for product use by KTB group
Co-Authored-By: Claude Opus 5.5 <noreply@anthropic.com>
Claude-Session: https://claude.ai/code/session_01PMn7aLX79upLSj9P26uPyP
</commit_message>
<xml_diff>
--- a/clicx_insights/CLICX_Customer_Insights.pptx
+++ b/clicx_insights/CLICX_Customer_Insights.pptx
@@ -119,43 +119,43 @@
   <p:extLst>
     <p:ext uri="{521415D9-36F7-43E2-AB2F-B90AF26B5E84}">
       <p14:sectionLst xmlns:p14="http://schemas.microsoft.com/office/powerpoint/2010/main">
-        <p14:section name="Opening" id="{9f3e2b13-90a4-fa18-8455-2fca6705af5b}">
+        <p14:section name="Opening" id="{1d46391c-f9b9-7fa9-de93-d94dd260ab9f}">
           <p14:sldIdLst>
             <p14:sldId id="256"/>
             <p14:sldId id="257"/>
           </p14:sldIdLst>
         </p14:section>
-        <p14:section name="Q1 Source of customers" id="{0d6fd1ec-a3c6-0342-1772-6c5a4b1eb112}">
+        <p14:section name="Q1 Source of customers" id="{a5e7ee5a-473b-ffa3-a818-a20b88b21f74}">
           <p14:sldIdLst>
             <p14:sldId id="258"/>
           </p14:sldIdLst>
         </p14:section>
-        <p14:section name="Q2 Who our customers are" id="{51991864-8d98-0fe9-eb92-5402d1527c59}">
+        <p14:section name="Q2 Who our customers are" id="{16442675-1c7b-47d6-3b97-b79a691df49e}">
           <p14:sldIdLst>
             <p14:sldId id="259"/>
             <p14:sldId id="260"/>
             <p14:sldId id="261"/>
           </p14:sldIdLst>
         </p14:section>
-        <p14:section name="Q3 What they come for" id="{9c3ff3db-97ae-88d2-6dd2-715fc1c09b56}">
+        <p14:section name="Q3 What they come for" id="{f77316ff-6b69-239d-319a-8ac199c86d0c}">
           <p14:sldIdLst>
             <p14:sldId id="262"/>
           </p14:sldIdLst>
         </p14:section>
-        <p14:section name="Q4 Active vs inactive" id="{2218d6d5-f89f-d8c5-966d-5ab1dd73b620}">
+        <p14:section name="Q4 Active vs inactive" id="{a837e638-b500-0aa7-463b-47f068293f98}">
           <p14:sldIdLst>
             <p14:sldId id="263"/>
             <p14:sldId id="264"/>
             <p14:sldId id="265"/>
           </p14:sldIdLst>
         </p14:section>
-        <p14:section name="Q5 Impact on KTB" id="{6d827b68-42b7-ccfa-e470-b7ddc41c0eaf}">
+        <p14:section name="Q5 Impact on KTB" id="{4eb8bd09-da15-06de-c860-6f1a78e63012}">
           <p14:sldIdLst>
             <p14:sldId id="266"/>
             <p14:sldId id="267"/>
           </p14:sldIdLst>
         </p14:section>
-        <p14:section name="What to do next" id="{2983b876-17e4-2cea-c6ac-d226ded2e5c6}">
+        <p14:section name="What to do next" id="{40b6aabc-fed8-d842-cfb5-2653c5dfe04e}">
           <p14:sldIdLst>
             <p14:sldId id="268"/>
           </p14:sldIdLst>
@@ -1860,7 +1860,7 @@
                 </a:solidFill>
                 <a:latin typeface="+mn-lt"/>
               </a:rPr>
-              <a:t>% of each KTB group who joined CLICX</a:t>
+              <a:t>What each KTB group uses in CLICX, %</a:t>
             </a:r>
           </a:p>
         </c:rich>
@@ -1884,20 +1884,20 @@
               <c:strCache>
                 <c:ptCount val="1"/>
                 <c:pt idx="0">
-                  <c:v>Joined CLICX</c:v>
+                  <c:v>Applied for loan</c:v>
                 </c:pt>
               </c:strCache>
             </c:strRef>
           </c:tx>
           <c:spPr>
             <a:solidFill>
-              <a:srgbClr val="D9475C"/>
+              <a:srgbClr val="C9CED3"/>
             </a:solidFill>
             <a:effectLst/>
           </c:spPr>
           <c:invertIfNegative val="0"/>
           <c:dLbls>
-            <c:numFmt formatCode="0.0%" sourceLinked="0"/>
+            <c:numFmt formatCode="#,##0" sourceLinked="0"/>
             <c:txPr>
               <a:bodyPr/>
               <a:lstStyle/>
@@ -1905,7 +1905,7 @@
                 <a:pPr>
                   <a:defRPr b="0" i="0" strike="noStrike" sz="1200" u="none">
                     <a:solidFill>
-                      <a:srgbClr val="1A1A1A"/>
+                      <a:srgbClr val="000000"/>
                     </a:solidFill>
                     <a:latin typeface="+mn-lt"/>
                   </a:defRPr>
@@ -1913,57 +1913,13 @@
               </a:p>
             </c:txPr>
             <c:showLegendKey val="0"/>
-            <c:showVal val="1"/>
+            <c:showVal val="0"/>
             <c:showCatName val="0"/>
             <c:showSerName val="0"/>
             <c:showPercent val="0"/>
             <c:showBubbleSize val="0"/>
             <c:showLeaderLines val="0"/>
           </c:dLbls>
-          <c:dPt>
-            <c:idx val="0"/>
-            <c:invertIfNegative val="0"/>
-            <c:bubble3D val="0"/>
-            <c:spPr>
-              <a:solidFill>
-                <a:srgbClr val="D9475C"/>
-              </a:solidFill>
-              <a:effectLst/>
-            </c:spPr>
-          </c:dPt>
-          <c:dPt>
-            <c:idx val="1"/>
-            <c:invertIfNegative val="0"/>
-            <c:bubble3D val="0"/>
-            <c:spPr>
-              <a:solidFill>
-                <a:srgbClr val="A2AAAD"/>
-              </a:solidFill>
-              <a:effectLst/>
-            </c:spPr>
-          </c:dPt>
-          <c:dPt>
-            <c:idx val="2"/>
-            <c:invertIfNegative val="0"/>
-            <c:bubble3D val="0"/>
-            <c:spPr>
-              <a:solidFill>
-                <a:srgbClr val="2251FF"/>
-              </a:solidFill>
-              <a:effectLst/>
-            </c:spPr>
-          </c:dPt>
-          <c:dPt>
-            <c:idx val="3"/>
-            <c:invertIfNegative val="0"/>
-            <c:bubble3D val="0"/>
-            <c:spPr>
-              <a:solidFill>
-                <a:srgbClr val="2251FF"/>
-              </a:solidFill>
-              <a:effectLst/>
-            </c:spPr>
-          </c:dPt>
           <c:cat>
             <c:multiLvlStrRef>
               <c:f>Sheet1!$A$2:$A$5</c:f>
@@ -1993,23 +1949,290 @@
                 <c:formatCode>General</c:formatCode>
                 <c:ptCount val="4"/>
                 <c:pt idx="0">
-                  <c:v>0.033</c:v>
+                  <c:v>0.6</c:v>
                 </c:pt>
                 <c:pt idx="1">
-                  <c:v>0.074</c:v>
+                  <c:v>0.8</c:v>
                 </c:pt>
                 <c:pt idx="2">
-                  <c:v>0.079</c:v>
+                  <c:v>0.85</c:v>
                 </c:pt>
                 <c:pt idx="3">
-                  <c:v>0.03</c:v>
+                  <c:v>0.7</c:v>
+                </c:pt>
+              </c:numCache>
+            </c:numRef>
+          </c:val>
+        </c:ser>
+        <c:ser>
+          <c:idx val="1"/>
+          <c:order val="1"/>
+          <c:tx>
+            <c:strRef>
+              <c:f>Sheet1!$C$1</c:f>
+              <c:strCache>
+                <c:ptCount val="1"/>
+                <c:pt idx="0">
+                  <c:v>Got a loan</c:v>
+                </c:pt>
+              </c:strCache>
+            </c:strRef>
+          </c:tx>
+          <c:spPr>
+            <a:solidFill>
+              <a:srgbClr val="B3BAC1"/>
+            </a:solidFill>
+            <a:effectLst/>
+          </c:spPr>
+          <c:invertIfNegative val="0"/>
+          <c:dLbls>
+            <c:numFmt formatCode="#,##0" sourceLinked="0"/>
+            <c:txPr>
+              <a:bodyPr/>
+              <a:lstStyle/>
+              <a:p>
+                <a:pPr>
+                  <a:defRPr b="0" i="0" strike="noStrike" sz="1200" u="none">
+                    <a:solidFill>
+                      <a:srgbClr val="000000"/>
+                    </a:solidFill>
+                    <a:latin typeface="+mn-lt"/>
+                  </a:defRPr>
+                </a:pPr>
+              </a:p>
+            </c:txPr>
+            <c:showLegendKey val="0"/>
+            <c:showVal val="0"/>
+            <c:showCatName val="0"/>
+            <c:showSerName val="0"/>
+            <c:showPercent val="0"/>
+            <c:showBubbleSize val="0"/>
+            <c:showLeaderLines val="0"/>
+          </c:dLbls>
+          <c:cat>
+            <c:multiLvlStrRef>
+              <c:f>Sheet1!$A$2:$A$5</c:f>
+              <c:multiLvlStrCache>
+                <c:ptCount val="4"/>
+                <c:lvl>
+                  <c:pt idx="0">
+                    <c:v>Loyal to KTB</c:v>
+                  </c:pt>
+                  <c:pt idx="1">
+                    <c:v>KTB and others</c:v>
+                  </c:pt>
+                  <c:pt idx="2">
+                    <c:v>Other banks</c:v>
+                  </c:pt>
+                  <c:pt idx="3">
+                    <c:v>Stopped KTB</c:v>
+                  </c:pt>
+                </c:lvl>
+              </c:multiLvlStrCache>
+            </c:multiLvlStrRef>
+          </c:cat>
+          <c:val>
+            <c:numRef>
+              <c:f>Sheet1!$C$2:$C$5</c:f>
+              <c:numCache>
+                <c:formatCode>General</c:formatCode>
+                <c:ptCount val="4"/>
+                <c:pt idx="0">
+                  <c:v>0.12</c:v>
+                </c:pt>
+                <c:pt idx="1">
+                  <c:v>0.08</c:v>
+                </c:pt>
+                <c:pt idx="2">
+                  <c:v>0.1</c:v>
+                </c:pt>
+                <c:pt idx="3">
+                  <c:v>0.06</c:v>
+                </c:pt>
+              </c:numCache>
+            </c:numRef>
+          </c:val>
+        </c:ser>
+        <c:ser>
+          <c:idx val="2"/>
+          <c:order val="2"/>
+          <c:tx>
+            <c:strRef>
+              <c:f>Sheet1!$D$1</c:f>
+              <c:strCache>
+                <c:ptCount val="1"/>
+                <c:pt idx="0">
+                  <c:v>Save pocket</c:v>
+                </c:pt>
+              </c:strCache>
+            </c:strRef>
+          </c:tx>
+          <c:spPr>
+            <a:solidFill>
+              <a:srgbClr val="DDE1E5"/>
+            </a:solidFill>
+            <a:effectLst/>
+          </c:spPr>
+          <c:invertIfNegative val="0"/>
+          <c:dLbls>
+            <c:numFmt formatCode="#,##0" sourceLinked="0"/>
+            <c:txPr>
+              <a:bodyPr/>
+              <a:lstStyle/>
+              <a:p>
+                <a:pPr>
+                  <a:defRPr b="0" i="0" strike="noStrike" sz="1200" u="none">
+                    <a:solidFill>
+                      <a:srgbClr val="000000"/>
+                    </a:solidFill>
+                    <a:latin typeface="+mn-lt"/>
+                  </a:defRPr>
+                </a:pPr>
+              </a:p>
+            </c:txPr>
+            <c:showLegendKey val="0"/>
+            <c:showVal val="0"/>
+            <c:showCatName val="0"/>
+            <c:showSerName val="0"/>
+            <c:showPercent val="0"/>
+            <c:showBubbleSize val="0"/>
+            <c:showLeaderLines val="0"/>
+          </c:dLbls>
+          <c:cat>
+            <c:multiLvlStrRef>
+              <c:f>Sheet1!$A$2:$A$5</c:f>
+              <c:multiLvlStrCache>
+                <c:ptCount val="4"/>
+                <c:lvl>
+                  <c:pt idx="0">
+                    <c:v>Loyal to KTB</c:v>
+                  </c:pt>
+                  <c:pt idx="1">
+                    <c:v>KTB and others</c:v>
+                  </c:pt>
+                  <c:pt idx="2">
+                    <c:v>Other banks</c:v>
+                  </c:pt>
+                  <c:pt idx="3">
+                    <c:v>Stopped KTB</c:v>
+                  </c:pt>
+                </c:lvl>
+              </c:multiLvlStrCache>
+            </c:multiLvlStrRef>
+          </c:cat>
+          <c:val>
+            <c:numRef>
+              <c:f>Sheet1!$D$2:$D$5</c:f>
+              <c:numCache>
+                <c:formatCode>General</c:formatCode>
+                <c:ptCount val="4"/>
+                <c:pt idx="0">
+                  <c:v>0.3</c:v>
+                </c:pt>
+                <c:pt idx="1">
+                  <c:v>0.2</c:v>
+                </c:pt>
+                <c:pt idx="2">
+                  <c:v>0.25</c:v>
+                </c:pt>
+                <c:pt idx="3">
+                  <c:v>0.15</c:v>
+                </c:pt>
+              </c:numCache>
+            </c:numRef>
+          </c:val>
+        </c:ser>
+        <c:ser>
+          <c:idx val="3"/>
+          <c:order val="3"/>
+          <c:tx>
+            <c:strRef>
+              <c:f>Sheet1!$E$1</c:f>
+              <c:strCache>
+                <c:ptCount val="1"/>
+                <c:pt idx="0">
+                  <c:v>Paid with CLICX</c:v>
+                </c:pt>
+              </c:strCache>
+            </c:strRef>
+          </c:tx>
+          <c:spPr>
+            <a:solidFill>
+              <a:srgbClr val="A2AAAD"/>
+            </a:solidFill>
+            <a:effectLst/>
+          </c:spPr>
+          <c:invertIfNegative val="0"/>
+          <c:dLbls>
+            <c:numFmt formatCode="#,##0" sourceLinked="0"/>
+            <c:txPr>
+              <a:bodyPr/>
+              <a:lstStyle/>
+              <a:p>
+                <a:pPr>
+                  <a:defRPr b="0" i="0" strike="noStrike" sz="1200" u="none">
+                    <a:solidFill>
+                      <a:srgbClr val="000000"/>
+                    </a:solidFill>
+                    <a:latin typeface="+mn-lt"/>
+                  </a:defRPr>
+                </a:pPr>
+              </a:p>
+            </c:txPr>
+            <c:showLegendKey val="0"/>
+            <c:showVal val="0"/>
+            <c:showCatName val="0"/>
+            <c:showSerName val="0"/>
+            <c:showPercent val="0"/>
+            <c:showBubbleSize val="0"/>
+            <c:showLeaderLines val="0"/>
+          </c:dLbls>
+          <c:cat>
+            <c:multiLvlStrRef>
+              <c:f>Sheet1!$A$2:$A$5</c:f>
+              <c:multiLvlStrCache>
+                <c:ptCount val="4"/>
+                <c:lvl>
+                  <c:pt idx="0">
+                    <c:v>Loyal to KTB</c:v>
+                  </c:pt>
+                  <c:pt idx="1">
+                    <c:v>KTB and others</c:v>
+                  </c:pt>
+                  <c:pt idx="2">
+                    <c:v>Other banks</c:v>
+                  </c:pt>
+                  <c:pt idx="3">
+                    <c:v>Stopped KTB</c:v>
+                  </c:pt>
+                </c:lvl>
+              </c:multiLvlStrCache>
+            </c:multiLvlStrRef>
+          </c:cat>
+          <c:val>
+            <c:numRef>
+              <c:f>Sheet1!$E$2:$E$5</c:f>
+              <c:numCache>
+                <c:formatCode>General</c:formatCode>
+                <c:ptCount val="4"/>
+                <c:pt idx="0">
+                  <c:v>0.25</c:v>
+                </c:pt>
+                <c:pt idx="1">
+                  <c:v>0.18</c:v>
+                </c:pt>
+                <c:pt idx="2">
+                  <c:v>0.2</c:v>
+                </c:pt>
+                <c:pt idx="3">
+                  <c:v>0.1</c:v>
                 </c:pt>
               </c:numCache>
             </c:numRef>
           </c:val>
         </c:ser>
         <c:dLbls>
-          <c:numFmt formatCode="0.0%" sourceLinked="0"/>
+          <c:numFmt formatCode="#,##0" sourceLinked="0"/>
           <c:txPr>
             <a:bodyPr/>
             <a:lstStyle/>
@@ -2017,7 +2240,7 @@
               <a:pPr>
                 <a:defRPr b="0" i="0" strike="noStrike" sz="1200" u="none">
                   <a:solidFill>
-                    <a:srgbClr val="1A1A1A"/>
+                    <a:srgbClr val="000000"/>
                   </a:solidFill>
                   <a:latin typeface="+mn-lt"/>
                 </a:defRPr>
@@ -2025,14 +2248,14 @@
             </a:p>
           </c:txPr>
           <c:showLegendKey val="0"/>
-          <c:showVal val="1"/>
+          <c:showVal val="0"/>
           <c:showCatName val="0"/>
           <c:showSerName val="0"/>
           <c:showPercent val="0"/>
           <c:showBubbleSize val="0"/>
           <c:showLeaderLines val="0"/>
         </c:dLbls>
-        <c:gapWidth val="45"/>
+        <c:gapWidth val="35"/>
         <c:overlap val="0"/>
         <c:axId val="2094734554"/>
         <c:axId val="2094734552"/>
@@ -2083,7 +2306,7 @@
         <c:axId val="2094734552"/>
         <c:scaling>
           <c:orientation val="minMax"/>
-          <c:max val="0.1"/>
+          <c:max val="1"/>
         </c:scaling>
         <c:delete val="1"/>
         <c:axPos val="b"/>
@@ -2127,6 +2350,26 @@
         <a:effectLst/>
       </c:spPr>
     </c:plotArea>
+    <c:legend>
+      <c:legendPos val="b"/>
+      <c:overlay val="0"/>
+      <c:txPr>
+        <a:bodyPr/>
+        <a:lstStyle/>
+        <a:p>
+          <a:pPr>
+            <a:defRPr sz="1000">
+              <a:solidFill>
+                <a:srgbClr val="5F6B76"/>
+              </a:solidFill>
+              <a:latin typeface="+mn-lt"/>
+              <a:cs typeface="+mn-lt"/>
+            </a:defRPr>
+          </a:pPr>
+          <a:endParaRPr lang="en-US"/>
+        </a:p>
+      </c:txPr>
+    </c:legend>
     <c:plotVisOnly val="1"/>
     <c:dispBlanksAs val="span"/>
   </c:chart>
@@ -8752,7 +8995,7 @@
         </p:nvGraphicFramePr>
         <p:xfrm>
           <a:off x="457200" y="2148840"/>
-          <a:ext cx="4572000" cy="3977640"/>
+          <a:ext cx="3840480" cy="3977640"/>
         </p:xfrm>
         <a:graphic xmlns:a="http://schemas.openxmlformats.org/drawingml/2006/main">
           <a:graphicData uri="http://schemas.openxmlformats.org/drawingml/2006/chart">
@@ -8760,15 +9003,40 @@
           </a:graphicData>
         </a:graphic>
       </p:graphicFrame>
+      <p:sp>
+        <p:nvSpPr>
+          <p:cNvPr id="7" name="Placeholder frame"/>
+          <p:cNvSpPr/>
+          <p:nvPr/>
+        </p:nvSpPr>
+        <p:spPr>
+          <a:xfrm>
+            <a:off x="4389120" y="2194560"/>
+            <a:ext cx="3749040" cy="3886200"/>
+          </a:xfrm>
+          <a:prstGeom prst="rect">
+            <a:avLst/>
+          </a:prstGeom>
+          <a:solidFill>
+            <a:srgbClr val="FFFFFF"/>
+          </a:solidFill>
+          <a:ln w="12700">
+            <a:solidFill>
+              <a:srgbClr val="A2AAAD"/>
+            </a:solidFill>
+            <a:prstDash val="dash"/>
+          </a:ln>
+        </p:spPr>
+      </p:sp>
       <p:graphicFrame>
         <p:nvGraphicFramePr>
-          <p:cNvPr id="7" name="Penetration by KTB group" descr=""/>
+          <p:cNvPr id="8" name="Placeholder product use by KTB group" descr=""/>
           <p:cNvGraphicFramePr/>
           <p:nvPr/>
         </p:nvGraphicFramePr>
         <p:xfrm>
-          <a:off x="5120640" y="2148840"/>
-          <a:ext cx="3017520" cy="3977640"/>
+          <a:off x="4480560" y="2240280"/>
+          <a:ext cx="3566160" cy="3794760"/>
         </p:xfrm>
         <a:graphic xmlns:a="http://schemas.openxmlformats.org/drawingml/2006/main">
           <a:graphicData uri="http://schemas.openxmlformats.org/drawingml/2006/chart">
@@ -8778,7 +9046,84 @@
       </p:graphicFrame>
       <p:sp>
         <p:nvSpPr>
-          <p:cNvPr id="8" name="Insight panel"/>
+          <p:cNvPr id="9" name="Illustrative tag"/>
+          <p:cNvSpPr/>
+          <p:nvPr/>
+        </p:nvSpPr>
+        <p:spPr>
+          <a:xfrm>
+            <a:off x="5806440" y="3794760"/>
+            <a:ext cx="2103120" cy="685800"/>
+          </a:xfrm>
+          <a:prstGeom prst="roundRect">
+            <a:avLst>
+              <a:gd name="adj" fmla="val 10667"/>
+            </a:avLst>
+          </a:prstGeom>
+          <a:solidFill>
+            <a:srgbClr val="FFFFFF"/>
+          </a:solidFill>
+          <a:ln w="15875">
+            <a:solidFill>
+              <a:schemeClr val="accent5"/>
+            </a:solidFill>
+            <a:prstDash val="solid"/>
+          </a:ln>
+        </p:spPr>
+      </p:sp>
+      <p:sp>
+        <p:nvSpPr>
+          <p:cNvPr id="10" name="Illustrative tag text"/>
+          <p:cNvSpPr txBox="1"/>
+          <p:nvPr/>
+        </p:nvSpPr>
+        <p:spPr>
+          <a:xfrm>
+            <a:off x="5806440" y="3794760"/>
+            <a:ext cx="2103120" cy="685800"/>
+          </a:xfrm>
+          <a:prstGeom prst="rect">
+            <a:avLst/>
+          </a:prstGeom>
+          <a:noFill/>
+          <a:ln/>
+        </p:spPr>
+        <p:txBody>
+          <a:bodyPr wrap="square" lIns="0" tIns="0" rIns="0" bIns="0" rtlCol="0" anchor="ctr"/>
+          <a:lstStyle/>
+          <a:p>
+            <a:pPr algn="ctr" indent="0" marL="0">
+              <a:buNone/>
+            </a:pPr>
+            <a:r>
+              <a:rPr lang="en-US" sz="1200" b="1" spc="100" kern="0" dirty="0">
+                <a:solidFill>
+                  <a:schemeClr val="accent5"/>
+                </a:solidFill>
+              </a:rPr>
+              <a:t>ILLUSTRATIVE</a:t>
+            </a:r>
+            <a:endParaRPr lang="en-US" sz="1200" dirty="0"/>
+          </a:p>
+          <a:p>
+            <a:pPr algn="ctr" indent="0" marL="0">
+              <a:buNone/>
+            </a:pPr>
+            <a:r>
+              <a:rPr lang="en-US" sz="1100" dirty="0">
+                <a:solidFill>
+                  <a:schemeClr val="tx1"/>
+                </a:solidFill>
+              </a:rPr>
+              <a:t>Data not yet available</a:t>
+            </a:r>
+            <a:endParaRPr lang="en-US" sz="1200" dirty="0"/>
+          </a:p>
+        </p:txBody>
+      </p:sp>
+      <p:sp>
+        <p:nvSpPr>
+          <p:cNvPr id="11" name="Insight panel"/>
           <p:cNvSpPr/>
           <p:nvPr/>
         </p:nvSpPr>
@@ -8798,7 +9143,7 @@
       </p:sp>
       <p:sp>
         <p:nvSpPr>
-          <p:cNvPr id="9" name="Insight header"/>
+          <p:cNvPr id="12" name="Insight header"/>
           <p:cNvSpPr txBox="1"/>
           <p:nvPr/>
         </p:nvSpPr>
@@ -8834,7 +9179,7 @@
       </p:sp>
       <p:sp>
         <p:nvSpPr>
-          <p:cNvPr id="10" name="Badge 1"/>
+          <p:cNvPr id="13" name="Badge 1"/>
           <p:cNvSpPr/>
           <p:nvPr/>
         </p:nvSpPr>
@@ -8854,7 +9199,7 @@
       </p:sp>
       <p:sp>
         <p:nvSpPr>
-          <p:cNvPr id="11" name="Badge num 1"/>
+          <p:cNvPr id="14" name="Badge num 1"/>
           <p:cNvSpPr txBox="1"/>
           <p:nvPr/>
         </p:nvSpPr>
@@ -8890,7 +9235,7 @@
       </p:sp>
       <p:sp>
         <p:nvSpPr>
-          <p:cNvPr id="12" name="Insight 1"/>
+          <p:cNvPr id="15" name="Insight 1"/>
           <p:cNvSpPr txBox="1"/>
           <p:nvPr/>
         </p:nvSpPr>
@@ -8946,7 +9291,7 @@
       </p:sp>
       <p:sp>
         <p:nvSpPr>
-          <p:cNvPr id="13" name="Badge 2"/>
+          <p:cNvPr id="16" name="Badge 2"/>
           <p:cNvSpPr/>
           <p:nvPr/>
         </p:nvSpPr>
@@ -8966,7 +9311,7 @@
       </p:sp>
       <p:sp>
         <p:nvSpPr>
-          <p:cNvPr id="14" name="Badge num 2"/>
+          <p:cNvPr id="17" name="Badge num 2"/>
           <p:cNvSpPr txBox="1"/>
           <p:nvPr/>
         </p:nvSpPr>
@@ -9002,7 +9347,7 @@
       </p:sp>
       <p:sp>
         <p:nvSpPr>
-          <p:cNvPr id="15" name="Insight 2"/>
+          <p:cNvPr id="18" name="Insight 2"/>
           <p:cNvSpPr txBox="1"/>
           <p:nvPr/>
         </p:nvSpPr>
@@ -9058,7 +9403,7 @@
       </p:sp>
       <p:sp>
         <p:nvSpPr>
-          <p:cNvPr id="16" name="Badge 3"/>
+          <p:cNvPr id="19" name="Badge 3"/>
           <p:cNvSpPr/>
           <p:nvPr/>
         </p:nvSpPr>
@@ -9078,7 +9423,7 @@
       </p:sp>
       <p:sp>
         <p:nvSpPr>
-          <p:cNvPr id="17" name="Badge num 3"/>
+          <p:cNvPr id="20" name="Badge num 3"/>
           <p:cNvSpPr txBox="1"/>
           <p:nvPr/>
         </p:nvSpPr>
@@ -9114,7 +9459,7 @@
       </p:sp>
       <p:sp>
         <p:nvSpPr>
-          <p:cNvPr id="18" name="Insight 3"/>
+          <p:cNvPr id="21" name="Insight 3"/>
           <p:cNvSpPr txBox="1"/>
           <p:nvPr/>
         </p:nvSpPr>

</xml_diff>

<commit_message>
Slide 12: borrower split doughnut and KTB rejection funnel
Co-Authored-By: Claude Opus 5.5 <noreply@anthropic.com>
Claude-Session: https://claude.ai/code/session_01PMn7aLX79upLSj9P26uPyP
</commit_message>
<xml_diff>
--- a/clicx_insights/CLICX_Customer_Insights.pptx
+++ b/clicx_insights/CLICX_Customer_Insights.pptx
@@ -119,43 +119,43 @@
   <p:extLst>
     <p:ext uri="{521415D9-36F7-43E2-AB2F-B90AF26B5E84}">
       <p14:sectionLst xmlns:p14="http://schemas.microsoft.com/office/powerpoint/2010/main">
-        <p14:section name="Opening" id="{1d46391c-f9b9-7fa9-de93-d94dd260ab9f}">
+        <p14:section name="Opening" id="{2a775e19-3dae-8e1a-3b97-bfb8847c4e36}">
           <p14:sldIdLst>
             <p14:sldId id="256"/>
             <p14:sldId id="257"/>
           </p14:sldIdLst>
         </p14:section>
-        <p14:section name="Q1 Source of customers" id="{a5e7ee5a-473b-ffa3-a818-a20b88b21f74}">
+        <p14:section name="Q1 Source of customers" id="{23fd0c29-54d0-7093-2dbd-6716a4764594}">
           <p14:sldIdLst>
             <p14:sldId id="258"/>
           </p14:sldIdLst>
         </p14:section>
-        <p14:section name="Q2 Who our customers are" id="{16442675-1c7b-47d6-3b97-b79a691df49e}">
+        <p14:section name="Q2 Who our customers are" id="{782a03b8-6e49-8a07-89f2-cdd0a8d7883e}">
           <p14:sldIdLst>
             <p14:sldId id="259"/>
             <p14:sldId id="260"/>
             <p14:sldId id="261"/>
           </p14:sldIdLst>
         </p14:section>
-        <p14:section name="Q3 What they come for" id="{f77316ff-6b69-239d-319a-8ac199c86d0c}">
+        <p14:section name="Q3 What they come for" id="{f31735d5-1798-ca0e-ae65-18156a1cd8c1}">
           <p14:sldIdLst>
             <p14:sldId id="262"/>
           </p14:sldIdLst>
         </p14:section>
-        <p14:section name="Q4 Active vs inactive" id="{a837e638-b500-0aa7-463b-47f068293f98}">
+        <p14:section name="Q4 Active vs inactive" id="{754f9e7b-daf8-3e91-ec68-4b01f06655b9}">
           <p14:sldIdLst>
             <p14:sldId id="263"/>
             <p14:sldId id="264"/>
             <p14:sldId id="265"/>
           </p14:sldIdLst>
         </p14:section>
-        <p14:section name="Q5 Impact on KTB" id="{4eb8bd09-da15-06de-c860-6f1a78e63012}">
+        <p14:section name="Q5 Impact on KTB" id="{f7be1211-1fb0-eb15-ed21-e025a6c6a437}">
           <p14:sldIdLst>
             <p14:sldId id="266"/>
             <p14:sldId id="267"/>
           </p14:sldIdLst>
         </p14:section>
-        <p14:section name="What to do next" id="{40b6aabc-fed8-d842-cfb5-2653c5dfe04e}">
+        <p14:section name="What to do next" id="{25adbf70-5839-f331-6094-fc99639442f0}">
           <p14:sldIdLst>
             <p14:sldId id="268"/>
           </p14:sldIdLst>
@@ -2412,7 +2412,7 @@
                 </a:solidFill>
                 <a:latin typeface="+mn-lt"/>
               </a:rPr>
-              <a:t>CLICX lending that KTB's Jai-pump loan does not cover, thousand customers</a:t>
+              <a:t>Our borrowers: do they also have a KTB loan?</a:t>
             </a:r>
           </a:p>
         </c:rich>
@@ -2423,10 +2423,8 @@
     <c:autoTitleDeleted val="0"/>
     <c:plotArea>
       <c:layout/>
-      <c:barChart>
-        <c:barDir val="bar"/>
-        <c:grouping val="clustered"/>
-        <c:varyColors val="0"/>
+      <c:doughnutChart>
+        <c:varyColors val="1"/>
         <c:ser>
           <c:idx val="0"/>
           <c:order val="0"/>
@@ -2436,45 +2434,26 @@
               <c:strCache>
                 <c:ptCount val="1"/>
                 <c:pt idx="0">
-                  <c:v>CLICX customers, K</c:v>
+                  <c:v>CLICX borrowers</c:v>
                 </c:pt>
               </c:strCache>
             </c:strRef>
           </c:tx>
           <c:spPr>
             <a:solidFill>
-              <a:srgbClr val="2251FF"/>
+              <a:schemeClr val="accent1"/>
             </a:solidFill>
+            <a:ln w="9525" cap="flat">
+              <a:solidFill>
+                <a:srgbClr val="F9F9F9"/>
+              </a:solidFill>
+              <a:prstDash val="solid"/>
+              <a:round/>
+            </a:ln>
             <a:effectLst/>
           </c:spPr>
-          <c:invertIfNegative val="0"/>
-          <c:dLbls>
-            <c:numFmt formatCode="#,##0" sourceLinked="0"/>
-            <c:txPr>
-              <a:bodyPr/>
-              <a:lstStyle/>
-              <a:p>
-                <a:pPr>
-                  <a:defRPr b="0" i="0" strike="noStrike" sz="1200" u="none">
-                    <a:solidFill>
-                      <a:srgbClr val="1A1A1A"/>
-                    </a:solidFill>
-                    <a:latin typeface="+mn-lt"/>
-                  </a:defRPr>
-                </a:pPr>
-              </a:p>
-            </c:txPr>
-            <c:showLegendKey val="0"/>
-            <c:showVal val="1"/>
-            <c:showCatName val="0"/>
-            <c:showSerName val="0"/>
-            <c:showPercent val="0"/>
-            <c:showBubbleSize val="0"/>
-            <c:showLeaderLines val="0"/>
-          </c:dLbls>
           <c:dPt>
             <c:idx val="0"/>
-            <c:invertIfNegative val="0"/>
             <c:bubble3D val="0"/>
             <c:spPr>
               <a:solidFill>
@@ -2485,175 +2464,120 @@
           </c:dPt>
           <c:dPt>
             <c:idx val="1"/>
-            <c:invertIfNegative val="0"/>
             <c:bubble3D val="0"/>
             <c:spPr>
               <a:solidFill>
-                <a:srgbClr val="051C2C"/>
+                <a:srgbClr val="A2AAAD"/>
               </a:solidFill>
               <a:effectLst/>
             </c:spPr>
           </c:dPt>
-          <c:dPt>
-            <c:idx val="2"/>
-            <c:invertIfNegative val="0"/>
-            <c:bubble3D val="0"/>
-            <c:spPr>
-              <a:solidFill>
-                <a:srgbClr val="051C2C"/>
-              </a:solidFill>
-              <a:effectLst/>
-            </c:spPr>
-          </c:dPt>
+          <c:dLbls>
+            <c:dLbl>
+              <c:idx val="0"/>
+              <c:numFmt formatCode="0%" sourceLinked="0"/>
+              <c:spPr/>
+              <c:txPr>
+                <a:bodyPr/>
+                <a:lstStyle/>
+                <a:p>
+                  <a:pPr>
+                    <a:defRPr sz="1200" b="0" i="0" u="none" strike="noStrike">
+                      <a:solidFill>
+                        <a:srgbClr val="FFFFFF"/>
+                      </a:solidFill>
+                      <a:latin typeface="+mn-lt"/>
+                    </a:defRPr>
+                  </a:pPr>
+                </a:p>
+              </c:txPr>
+              <c:showLegendKey val="0"/>
+              <c:showVal val="0"/>
+              <c:showCatName val="0"/>
+              <c:showSerName val="0"/>
+              <c:showPercent val="1"/>
+              <c:showBubbleSize val="0"/>
+            </c:dLbl>
+            <c:dLbl>
+              <c:idx val="1"/>
+              <c:numFmt formatCode="0%" sourceLinked="0"/>
+              <c:spPr/>
+              <c:txPr>
+                <a:bodyPr/>
+                <a:lstStyle/>
+                <a:p>
+                  <a:pPr>
+                    <a:defRPr sz="1200" b="0" i="0" u="none" strike="noStrike">
+                      <a:solidFill>
+                        <a:srgbClr val="FFFFFF"/>
+                      </a:solidFill>
+                      <a:latin typeface="+mn-lt"/>
+                    </a:defRPr>
+                  </a:pPr>
+                </a:p>
+              </c:txPr>
+              <c:showLegendKey val="0"/>
+              <c:showVal val="0"/>
+              <c:showCatName val="0"/>
+              <c:showSerName val="0"/>
+              <c:showPercent val="1"/>
+              <c:showBubbleSize val="0"/>
+            </c:dLbl>
+            <c:numFmt formatCode="0%" sourceLinked="0"/>
+            <c:txPr>
+              <a:bodyPr/>
+              <a:lstStyle/>
+              <a:p>
+                <a:pPr>
+                  <a:defRPr sz="1800" b="0" i="0" u="none" strike="noStrike">
+                    <a:solidFill>
+                      <a:srgbClr val="000000"/>
+                    </a:solidFill>
+                    <a:latin typeface="Arial"/>
+                  </a:defRPr>
+                </a:pPr>
+              </a:p>
+            </c:txPr>
+            <c:showLegendKey val="0"/>
+            <c:showVal val="0"/>
+            <c:showCatName val="1"/>
+            <c:showSerName val="0"/>
+            <c:showPercent val="1"/>
+            <c:showBubbleSize val="0"/>
+            <c:showLeaderLines val="0"/>
+          </c:dLbls>
           <c:cat>
-            <c:multiLvlStrRef>
-              <c:f>Sheet1!$A$2:$A$4</c:f>
-              <c:multiLvlStrCache>
-                <c:ptCount val="3"/>
-                <c:lvl>
-                  <c:pt idx="0">
-                    <c:v>Our borrowers with no KTB loan</c:v>
-                  </c:pt>
-                  <c:pt idx="1">
-                    <c:v>Turned down by KTB, applied to us</c:v>
-                  </c:pt>
-                  <c:pt idx="2">
-                    <c:v>Turned down by KTB, got our loan</c:v>
-                  </c:pt>
-                </c:lvl>
-              </c:multiLvlStrCache>
-            </c:multiLvlStrRef>
+            <c:strRef>
+              <c:f>Sheet1!$A$2:$A$3</c:f>
+              <c:strCache>
+                <c:ptCount val="2"/>
+                <c:pt idx="0">
+                  <c:v>No KTB Jai-pump loan (116K)</c:v>
+                </c:pt>
+                <c:pt idx="1">
+                  <c:v>Also has a Jai-pump loan (32K)</c:v>
+                </c:pt>
+              </c:strCache>
+            </c:strRef>
           </c:cat>
           <c:val>
             <c:numRef>
-              <c:f>Sheet1!$B$2:$B$4</c:f>
+              <c:f>Sheet1!$B$2:$B$3</c:f>
               <c:numCache>
-                <c:formatCode>General</c:formatCode>
-                <c:ptCount val="3"/>
+                <c:ptCount val="2"/>
                 <c:pt idx="0">
                   <c:v>116</c:v>
                 </c:pt>
                 <c:pt idx="1">
-                  <c:v>156</c:v>
-                </c:pt>
-                <c:pt idx="2">
-                  <c:v>23</c:v>
+                  <c:v>32</c:v>
                 </c:pt>
               </c:numCache>
             </c:numRef>
           </c:val>
         </c:ser>
-        <c:dLbls>
-          <c:numFmt formatCode="#,##0" sourceLinked="0"/>
-          <c:txPr>
-            <a:bodyPr/>
-            <a:lstStyle/>
-            <a:p>
-              <a:pPr>
-                <a:defRPr b="0" i="0" strike="noStrike" sz="1200" u="none">
-                  <a:solidFill>
-                    <a:srgbClr val="1A1A1A"/>
-                  </a:solidFill>
-                  <a:latin typeface="+mn-lt"/>
-                </a:defRPr>
-              </a:pPr>
-            </a:p>
-          </c:txPr>
-          <c:showLegendKey val="0"/>
-          <c:showVal val="1"/>
-          <c:showCatName val="0"/>
-          <c:showSerName val="0"/>
-          <c:showPercent val="0"/>
-          <c:showBubbleSize val="0"/>
-          <c:showLeaderLines val="0"/>
-        </c:dLbls>
-        <c:gapWidth val="50"/>
-        <c:overlap val="0"/>
-        <c:axId val="2094734554"/>
-        <c:axId val="2094734552"/>
-        <c:axId val="2094734556"/>
-      </c:barChart>
-      <c:catAx>
-        <c:axId val="2094734554"/>
-        <c:scaling>
-          <c:orientation val="maxMin"/>
-        </c:scaling>
-        <c:delete val="0"/>
-        <c:axPos val="l"/>
-        <c:numFmt formatCode="General" sourceLinked="1"/>
-        <c:majorTickMark val="out"/>
-        <c:minorTickMark val="none"/>
-        <c:tickLblPos val="nextTo"/>
-        <c:spPr>
-          <a:ln w="12700" cap="flat">
-            <a:solidFill>
-              <a:srgbClr val="D5DADF"/>
-            </a:solidFill>
-            <a:prstDash val="solid"/>
-            <a:round/>
-          </a:ln>
-        </c:spPr>
-        <c:txPr>
-          <a:bodyPr/>
-          <a:lstStyle/>
-          <a:p>
-            <a:pPr>
-              <a:defRPr sz="1100" b="0" i="0" u="none" strike="noStrike">
-                <a:solidFill>
-                  <a:srgbClr val="5F6B76"/>
-                </a:solidFill>
-                <a:latin typeface="+mn-lt"/>
-              </a:defRPr>
-            </a:pPr>
-            <a:endParaRPr lang="en-US"/>
-          </a:p>
-        </c:txPr>
-        <c:crossAx val="2094734552"/>
-        <c:crosses val="autoZero"/>
-        <c:auto val="1"/>
-        <c:lblAlgn val="ctr"/>
-        <c:noMultiLvlLbl val="1"/>
-      </c:catAx>
-      <c:valAx>
-        <c:axId val="2094734552"/>
-        <c:scaling>
-          <c:orientation val="minMax"/>
-          <c:max val="190"/>
-        </c:scaling>
-        <c:delete val="1"/>
-        <c:axPos val="b"/>
-        <c:numFmt formatCode="General" sourceLinked="0"/>
-        <c:majorTickMark val="out"/>
-        <c:minorTickMark val="none"/>
-        <c:tickLblPos val="low"/>
-        <c:spPr>
-          <a:ln w="12700" cap="flat">
-            <a:solidFill>
-              <a:srgbClr val="888888"/>
-            </a:solidFill>
-            <a:prstDash val="solid"/>
-            <a:round/>
-          </a:ln>
-        </c:spPr>
-        <c:txPr>
-          <a:bodyPr/>
-          <a:lstStyle/>
-          <a:p>
-            <a:pPr>
-              <a:defRPr sz="1000" b="0" i="0" u="none" strike="noStrike">
-                <a:solidFill>
-                  <a:srgbClr val="5F6B76"/>
-                </a:solidFill>
-                <a:latin typeface="+mn-lt"/>
-              </a:defRPr>
-            </a:pPr>
-            <a:endParaRPr lang="en-US"/>
-          </a:p>
-        </c:txPr>
-        <c:crossAx val="2094734554"/>
-        <c:crosses val="autoZero"/>
-        <c:crossBetween val="between"/>
-      </c:valAx>
+        <c:firstSliceAng val="0"/>
+        <c:holeSize val="62"/>
+      </c:doughnutChart>
       <c:spPr>
         <a:noFill/>
         <a:ln>
@@ -2662,6 +2586,26 @@
         <a:effectLst/>
       </c:spPr>
     </c:plotArea>
+    <c:legend>
+      <c:legendPos val="b"/>
+      <c:overlay val="0"/>
+      <c:txPr>
+        <a:bodyPr/>
+        <a:lstStyle/>
+        <a:p>
+          <a:pPr>
+            <a:defRPr sz="1000">
+              <a:solidFill>
+                <a:srgbClr val="5F6B76"/>
+              </a:solidFill>
+              <a:latin typeface="+mn-lt"/>
+              <a:cs typeface="+mn-lt"/>
+            </a:defRPr>
+          </a:pPr>
+          <a:endParaRPr lang="en-US"/>
+        </a:p>
+      </c:txPr>
+    </c:legend>
     <c:plotVisOnly val="1"/>
     <c:dispBlanksAs val="span"/>
   </c:chart>
@@ -9691,7 +9635,7 @@
                   <a:schemeClr val="tx1"/>
                 </a:solidFill>
               </a:rPr>
-              <a:t>Not for loans: we mostly lend to people KTB's own app loan (Jai-pump) does not serve or turns down. We cannot check savings yet</a:t>
+              <a:t>Not for loans: 78% of our 148K borrowers have no KTB Jai-pump loan, and we approve some people KTB turns down. We cannot check savings yet</a:t>
             </a:r>
             <a:endParaRPr lang="en-US" sz="1600" dirty="0"/>
           </a:p>
@@ -9729,7 +9673,7 @@
                   <a:srgbClr val="6E7C87"/>
                 </a:solidFill>
               </a:rPr>
-              <a:t>Source: KTB and CLICX matched customer data (Oct 2026)</a:t>
+              <a:t>Borrowers = CLICX customers with a loan (Sep 2026). Turned down = rejected by KTB's Jai-pump loan in the last 3 months. Source: KTB and CLICX matched data</a:t>
             </a:r>
             <a:endParaRPr lang="en-US" sz="1000" dirty="0"/>
           </a:p>
@@ -9737,13 +9681,13 @@
       </p:sp>
       <p:graphicFrame>
         <p:nvGraphicFramePr>
-          <p:cNvPr id="6" name="Lending outside KTB" descr=""/>
+          <p:cNvPr id="6" name="Borrowers by KTB loan" descr=""/>
           <p:cNvGraphicFramePr/>
           <p:nvPr/>
         </p:nvGraphicFramePr>
         <p:xfrm>
           <a:off x="457200" y="2148840"/>
-          <a:ext cx="4937760" cy="3977640"/>
+          <a:ext cx="3383280" cy="3977640"/>
         </p:xfrm>
         <a:graphic xmlns:a="http://schemas.openxmlformats.org/drawingml/2006/main">
           <a:graphicData uri="http://schemas.openxmlformats.org/drawingml/2006/chart">
@@ -9753,14 +9697,100 @@
       </p:graphicFrame>
       <p:sp>
         <p:nvSpPr>
-          <p:cNvPr id="7" name="Deposit gap box"/>
+          <p:cNvPr id="7" name="Borrowers total"/>
+          <p:cNvSpPr txBox="1"/>
+          <p:nvPr/>
+        </p:nvSpPr>
+        <p:spPr>
+          <a:xfrm>
+            <a:off x="1463040" y="3794760"/>
+            <a:ext cx="1371600" cy="640080"/>
+          </a:xfrm>
+          <a:prstGeom prst="rect">
+            <a:avLst/>
+          </a:prstGeom>
+          <a:noFill/>
+          <a:ln/>
+        </p:spPr>
+        <p:txBody>
+          <a:bodyPr wrap="square" lIns="0" tIns="0" rIns="0" bIns="0" rtlCol="0" anchor="ctr"/>
+          <a:lstStyle/>
+          <a:p>
+            <a:pPr algn="ctr" indent="0" marL="0">
+              <a:buNone/>
+            </a:pPr>
+            <a:r>
+              <a:rPr lang="en-US" sz="2400" b="1" dirty="0">
+                <a:solidFill>
+                  <a:schemeClr val="tx2"/>
+                </a:solidFill>
+              </a:rPr>
+              <a:t>148K</a:t>
+            </a:r>
+            <a:endParaRPr lang="en-US" sz="2400" dirty="0"/>
+          </a:p>
+          <a:p>
+            <a:pPr algn="ctr" indent="0" marL="0">
+              <a:buNone/>
+            </a:pPr>
+            <a:r>
+              <a:rPr lang="en-US" sz="1000" dirty="0">
+                <a:solidFill>
+                  <a:srgbClr val="5F6B76"/>
+                </a:solidFill>
+              </a:rPr>
+              <a:t>CLICX borrowers</a:t>
+            </a:r>
+            <a:endParaRPr lang="en-US" sz="2400" dirty="0"/>
+          </a:p>
+        </p:txBody>
+      </p:sp>
+      <p:sp>
+        <p:nvSpPr>
+          <p:cNvPr id="8" name="Funnel title"/>
+          <p:cNvSpPr txBox="1"/>
+          <p:nvPr/>
+        </p:nvSpPr>
+        <p:spPr>
+          <a:xfrm>
+            <a:off x="4023360" y="2194560"/>
+            <a:ext cx="4114800" cy="320040"/>
+          </a:xfrm>
+          <a:prstGeom prst="rect">
+            <a:avLst/>
+          </a:prstGeom>
+          <a:noFill/>
+          <a:ln/>
+        </p:spPr>
+        <p:txBody>
+          <a:bodyPr wrap="square" lIns="0" tIns="0" rIns="0" bIns="0" rtlCol="0" anchor="ctr"/>
+          <a:lstStyle/>
+          <a:p>
+            <a:pPr algn="ctr" indent="0" marL="0">
+              <a:buNone/>
+            </a:pPr>
+            <a:r>
+              <a:rPr lang="en-US" sz="1300" b="1" dirty="0">
+                <a:solidFill>
+                  <a:schemeClr val="tx2"/>
+                </a:solidFill>
+              </a:rPr>
+              <a:t>From KTB rejection to CLICX loan (last 3 months)</a:t>
+            </a:r>
+            <a:endParaRPr lang="en-US" sz="1300" dirty="0"/>
+          </a:p>
+        </p:txBody>
+      </p:sp>
+      <p:sp>
+        <p:nvSpPr>
+          <p:cNvPr id="9" name="Funnel stage 1"/>
           <p:cNvSpPr/>
           <p:nvPr/>
         </p:nvSpPr>
         <p:spPr>
           <a:xfrm>
-            <a:off x="5577840" y="2240280"/>
-            <a:ext cx="2560320" cy="3794760"/>
+            <a:off x="4069080" y="2697480"/>
+            <a:ext cx="4023360" cy="777240"/>
           </a:xfrm>
           <a:prstGeom prst="rect">
             <a:avLst/>
@@ -9778,14 +9808,14 @@
       </p:sp>
       <p:sp>
         <p:nvSpPr>
-          <p:cNvPr id="8" name="Deposit gap text"/>
+          <p:cNvPr id="10" name="Funnel stage 1 text"/>
           <p:cNvSpPr txBox="1"/>
           <p:nvPr/>
         </p:nvSpPr>
         <p:spPr>
           <a:xfrm>
-            <a:off x="5760720" y="2423160"/>
-            <a:ext cx="2194560" cy="3474720"/>
+            <a:off x="4069080" y="2697480"/>
+            <a:ext cx="4023360" cy="777240"/>
           </a:xfrm>
           <a:prstGeom prst="rect">
             <a:avLst/>
@@ -9794,83 +9824,253 @@
           <a:ln/>
         </p:spPr>
         <p:txBody>
-          <a:bodyPr wrap="square" lIns="0" tIns="0" rIns="0" bIns="0" rtlCol="0" anchor="t"/>
-          <a:lstStyle/>
-          <a:p>
-            <a:pPr indent="0" marL="0">
-              <a:buNone/>
-            </a:pPr>
-            <a:r>
-              <a:rPr lang="en-US" sz="1100" b="1" spc="100" kern="0" dirty="0">
+          <a:bodyPr wrap="square" lIns="0" tIns="0" rIns="0" bIns="0" rtlCol="0" anchor="ctr"/>
+          <a:lstStyle/>
+          <a:p>
+            <a:pPr algn="ctr" indent="0" marL="0">
+              <a:buNone/>
+            </a:pPr>
+            <a:r>
+              <a:rPr lang="en-US" sz="1200" dirty="0">
+                <a:solidFill>
+                  <a:schemeClr val="tx1"/>
+                </a:solidFill>
+              </a:rPr>
+              <a:t>Turned down by KTB's Jai-pump</a:t>
+            </a:r>
+            <a:endParaRPr lang="en-US" sz="1200" dirty="0"/>
+          </a:p>
+          <a:p>
+            <a:pPr algn="ctr" indent="0" marL="0">
+              <a:buNone/>
+            </a:pPr>
+            <a:r>
+              <a:rPr lang="en-US" sz="1400" b="1" dirty="0">
                 <a:solidFill>
                   <a:schemeClr val="accent5"/>
                 </a:solidFill>
               </a:rPr>
-              <a:t>SAVINGS: NOT KNOWN YET</a:t>
+              <a:t>Total: data to come</a:t>
+            </a:r>
+            <a:endParaRPr lang="en-US" sz="1200" dirty="0"/>
+          </a:p>
+        </p:txBody>
+      </p:sp>
+      <p:sp>
+        <p:nvSpPr>
+          <p:cNvPr id="11" name="Funnel step 1"/>
+          <p:cNvSpPr txBox="1"/>
+          <p:nvPr/>
+        </p:nvSpPr>
+        <p:spPr>
+          <a:xfrm>
+            <a:off x="4023360" y="3493008"/>
+            <a:ext cx="4114800" cy="237744"/>
+          </a:xfrm>
+          <a:prstGeom prst="rect">
+            <a:avLst/>
+          </a:prstGeom>
+          <a:noFill/>
+          <a:ln/>
+        </p:spPr>
+        <p:txBody>
+          <a:bodyPr wrap="square" lIns="0" tIns="0" rIns="0" bIns="0" rtlCol="0" anchor="ctr"/>
+          <a:lstStyle/>
+          <a:p>
+            <a:pPr algn="ctr" indent="0" marL="0">
+              <a:buNone/>
+            </a:pPr>
+            <a:r>
+              <a:rPr lang="en-US" sz="1000" i="1" dirty="0">
+                <a:solidFill>
+                  <a:srgbClr val="5F6B76"/>
+                </a:solidFill>
+              </a:rPr>
+              <a:t>came to CLICX: to be confirmed</a:t>
+            </a:r>
+            <a:endParaRPr lang="en-US" sz="1000" dirty="0"/>
+          </a:p>
+        </p:txBody>
+      </p:sp>
+      <p:sp>
+        <p:nvSpPr>
+          <p:cNvPr id="12" name="Funnel stage 2"/>
+          <p:cNvSpPr/>
+          <p:nvPr/>
+        </p:nvSpPr>
+        <p:spPr>
+          <a:xfrm>
+            <a:off x="4617720" y="3749040"/>
+            <a:ext cx="2926080" cy="777240"/>
+          </a:xfrm>
+          <a:prstGeom prst="rect">
+            <a:avLst/>
+          </a:prstGeom>
+          <a:solidFill>
+            <a:schemeClr val="tx2"/>
+          </a:solidFill>
+          <a:ln/>
+        </p:spPr>
+      </p:sp>
+      <p:sp>
+        <p:nvSpPr>
+          <p:cNvPr id="13" name="Funnel stage 2 text"/>
+          <p:cNvSpPr txBox="1"/>
+          <p:nvPr/>
+        </p:nvSpPr>
+        <p:spPr>
+          <a:xfrm>
+            <a:off x="4069080" y="3749040"/>
+            <a:ext cx="4023360" cy="777240"/>
+          </a:xfrm>
+          <a:prstGeom prst="rect">
+            <a:avLst/>
+          </a:prstGeom>
+          <a:noFill/>
+          <a:ln/>
+        </p:spPr>
+        <p:txBody>
+          <a:bodyPr wrap="square" lIns="0" tIns="0" rIns="0" bIns="0" rtlCol="0" anchor="ctr"/>
+          <a:lstStyle/>
+          <a:p>
+            <a:pPr algn="ctr" indent="0" marL="0">
+              <a:buNone/>
+            </a:pPr>
+            <a:r>
+              <a:rPr lang="en-US" sz="1200" dirty="0">
+                <a:solidFill>
+                  <a:schemeClr val="bg1"/>
+                </a:solidFill>
+              </a:rPr>
+              <a:t>Applied to CLICX</a:t>
+            </a:r>
+            <a:endParaRPr lang="en-US" sz="1200" dirty="0"/>
+          </a:p>
+          <a:p>
+            <a:pPr algn="ctr" indent="0" marL="0">
+              <a:buNone/>
+            </a:pPr>
+            <a:r>
+              <a:rPr lang="en-US" sz="1800" b="1" dirty="0">
+                <a:solidFill>
+                  <a:schemeClr val="bg1"/>
+                </a:solidFill>
+              </a:rPr>
+              <a:t>156K</a:t>
+            </a:r>
+            <a:endParaRPr lang="en-US" sz="1200" dirty="0"/>
+          </a:p>
+        </p:txBody>
+      </p:sp>
+      <p:sp>
+        <p:nvSpPr>
+          <p:cNvPr id="14" name="Funnel step 2"/>
+          <p:cNvSpPr txBox="1"/>
+          <p:nvPr/>
+        </p:nvSpPr>
+        <p:spPr>
+          <a:xfrm>
+            <a:off x="4023360" y="4544568"/>
+            <a:ext cx="4114800" cy="237744"/>
+          </a:xfrm>
+          <a:prstGeom prst="rect">
+            <a:avLst/>
+          </a:prstGeom>
+          <a:noFill/>
+          <a:ln/>
+        </p:spPr>
+        <p:txBody>
+          <a:bodyPr wrap="square" lIns="0" tIns="0" rIns="0" bIns="0" rtlCol="0" anchor="ctr"/>
+          <a:lstStyle/>
+          <a:p>
+            <a:pPr algn="ctr" indent="0" marL="0">
+              <a:buNone/>
+            </a:pPr>
+            <a:r>
+              <a:rPr lang="en-US" sz="1100" b="1" dirty="0">
+                <a:solidFill>
+                  <a:schemeClr val="accent1"/>
+                </a:solidFill>
+              </a:rPr>
+              <a:t>15% approved</a:t>
             </a:r>
             <a:endParaRPr lang="en-US" sz="1100" dirty="0"/>
           </a:p>
-          <a:p>
-            <a:pPr indent="0" marL="0">
-              <a:buNone/>
-            </a:pPr>
-            <a:r>
-              <a:rPr lang="en-US" sz="800" dirty="0">
-                <a:solidFill>
-                  <a:srgbClr val="000000"/>
-                </a:solidFill>
-              </a:rPr>
-              <a:t> </a:t>
-            </a:r>
-            <a:endParaRPr lang="en-US" sz="1100" dirty="0"/>
-          </a:p>
-          <a:p>
-            <a:pPr indent="0" marL="0">
+        </p:txBody>
+      </p:sp>
+      <p:sp>
+        <p:nvSpPr>
+          <p:cNvPr id="15" name="Funnel stage 3"/>
+          <p:cNvSpPr/>
+          <p:nvPr/>
+        </p:nvSpPr>
+        <p:spPr>
+          <a:xfrm>
+            <a:off x="5166360" y="4800600"/>
+            <a:ext cx="1828800" cy="777240"/>
+          </a:xfrm>
+          <a:prstGeom prst="rect">
+            <a:avLst/>
+          </a:prstGeom>
+          <a:solidFill>
+            <a:schemeClr val="accent1"/>
+          </a:solidFill>
+          <a:ln/>
+        </p:spPr>
+      </p:sp>
+      <p:sp>
+        <p:nvSpPr>
+          <p:cNvPr id="16" name="Funnel stage 3 text"/>
+          <p:cNvSpPr txBox="1"/>
+          <p:nvPr/>
+        </p:nvSpPr>
+        <p:spPr>
+          <a:xfrm>
+            <a:off x="4069080" y="4800600"/>
+            <a:ext cx="4023360" cy="777240"/>
+          </a:xfrm>
+          <a:prstGeom prst="rect">
+            <a:avLst/>
+          </a:prstGeom>
+          <a:noFill/>
+          <a:ln/>
+        </p:spPr>
+        <p:txBody>
+          <a:bodyPr wrap="square" lIns="0" tIns="0" rIns="0" bIns="0" rtlCol="0" anchor="ctr"/>
+          <a:lstStyle/>
+          <a:p>
+            <a:pPr algn="ctr" indent="0" marL="0">
               <a:buNone/>
             </a:pPr>
             <a:r>
               <a:rPr lang="en-US" sz="1200" dirty="0">
                 <a:solidFill>
-                  <a:schemeClr val="tx1"/>
-                </a:solidFill>
-              </a:rPr>
-              <a:t>We cannot yet see CLICX balances, so we cannot tell if money is moving out of KTB accounts.</a:t>
-            </a:r>
-            <a:endParaRPr lang="en-US" sz="1100" dirty="0"/>
-          </a:p>
-          <a:p>
-            <a:pPr indent="0" marL="0">
-              <a:buNone/>
-            </a:pPr>
-            <a:r>
-              <a:rPr lang="en-US" sz="800" dirty="0">
-                <a:solidFill>
-                  <a:srgbClr val="000000"/>
-                </a:solidFill>
-              </a:rPr>
-              <a:t> </a:t>
-            </a:r>
-            <a:endParaRPr lang="en-US" sz="1100" dirty="0"/>
-          </a:p>
-          <a:p>
-            <a:pPr indent="0" marL="0">
-              <a:buNone/>
-            </a:pPr>
-            <a:r>
-              <a:rPr lang="en-US" sz="1200" b="1" dirty="0">
-                <a:solidFill>
-                  <a:schemeClr val="tx2"/>
-                </a:solidFill>
-              </a:rPr>
-              <a:t>Next step: once the data is in, compare shared customers' KTB balances before and after they joined CLICX</a:t>
-            </a:r>
-            <a:endParaRPr lang="en-US" sz="1100" dirty="0"/>
-          </a:p>
-        </p:txBody>
-      </p:sp>
-      <p:sp>
-        <p:nvSpPr>
-          <p:cNvPr id="9" name="Insight panel"/>
+                  <a:schemeClr val="bg1"/>
+                </a:solidFill>
+              </a:rPr>
+              <a:t>Got a CLICX loan</a:t>
+            </a:r>
+            <a:endParaRPr lang="en-US" sz="1200" dirty="0"/>
+          </a:p>
+          <a:p>
+            <a:pPr algn="ctr" indent="0" marL="0">
+              <a:buNone/>
+            </a:pPr>
+            <a:r>
+              <a:rPr lang="en-US" sz="1800" b="1" dirty="0">
+                <a:solidFill>
+                  <a:schemeClr val="bg1"/>
+                </a:solidFill>
+              </a:rPr>
+              <a:t>23K</a:t>
+            </a:r>
+            <a:endParaRPr lang="en-US" sz="1200" dirty="0"/>
+          </a:p>
+        </p:txBody>
+      </p:sp>
+      <p:sp>
+        <p:nvSpPr>
+          <p:cNvPr id="17" name="Insight panel"/>
           <p:cNvSpPr/>
           <p:nvPr/>
         </p:nvSpPr>
@@ -9890,7 +10090,7 @@
       </p:sp>
       <p:sp>
         <p:nvSpPr>
-          <p:cNvPr id="10" name="Insight header"/>
+          <p:cNvPr id="18" name="Insight header"/>
           <p:cNvSpPr txBox="1"/>
           <p:nvPr/>
         </p:nvSpPr>
@@ -9926,7 +10126,7 @@
       </p:sp>
       <p:sp>
         <p:nvSpPr>
-          <p:cNvPr id="11" name="Badge 1"/>
+          <p:cNvPr id="19" name="Badge 1"/>
           <p:cNvSpPr/>
           <p:nvPr/>
         </p:nvSpPr>
@@ -9946,7 +10146,7 @@
       </p:sp>
       <p:sp>
         <p:nvSpPr>
-          <p:cNvPr id="12" name="Badge num 1"/>
+          <p:cNvPr id="20" name="Badge num 1"/>
           <p:cNvSpPr txBox="1"/>
           <p:nvPr/>
         </p:nvSpPr>
@@ -9982,7 +10182,7 @@
       </p:sp>
       <p:sp>
         <p:nvSpPr>
-          <p:cNvPr id="13" name="Insight 1"/>
+          <p:cNvPr id="21" name="Insight 1"/>
           <p:cNvSpPr txBox="1"/>
           <p:nvPr/>
         </p:nvSpPr>
@@ -10013,7 +10213,7 @@
                   <a:schemeClr val="tx2"/>
                 </a:solidFill>
               </a:rPr>
-              <a:t>New loans for the group</a:t>
+              <a:t>Mostly new loans for the group</a:t>
             </a:r>
             <a:endParaRPr lang="en-US" sz="1400" dirty="0"/>
           </a:p>
@@ -10030,7 +10230,7 @@
                   <a:schemeClr val="tx1"/>
                 </a:solidFill>
               </a:rPr>
-              <a:t>116K of our borrowers have no KTB Jai-pump loan</a:t>
+              <a:t>116K of our 148K borrowers (78%) have no KTB Jai-pump loan</a:t>
             </a:r>
             <a:endParaRPr lang="en-US" sz="1400" dirty="0"/>
           </a:p>
@@ -10038,7 +10238,7 @@
       </p:sp>
       <p:sp>
         <p:nvSpPr>
-          <p:cNvPr id="14" name="Badge 2"/>
+          <p:cNvPr id="22" name="Badge 2"/>
           <p:cNvSpPr/>
           <p:nvPr/>
         </p:nvSpPr>
@@ -10058,7 +10258,7 @@
       </p:sp>
       <p:sp>
         <p:nvSpPr>
-          <p:cNvPr id="15" name="Badge num 2"/>
+          <p:cNvPr id="23" name="Badge num 2"/>
           <p:cNvSpPr txBox="1"/>
           <p:nvPr/>
         </p:nvSpPr>
@@ -10094,7 +10294,7 @@
       </p:sp>
       <p:sp>
         <p:nvSpPr>
-          <p:cNvPr id="16" name="Insight 2"/>
+          <p:cNvPr id="24" name="Insight 2"/>
           <p:cNvSpPr txBox="1"/>
           <p:nvPr/>
         </p:nvSpPr>
@@ -10125,7 +10325,7 @@
                   <a:schemeClr val="tx2"/>
                 </a:solidFill>
               </a:rPr>
-              <a:t>A safety net for KTB</a:t>
+              <a:t>A safety net for KTB rejects</a:t>
             </a:r>
             <a:endParaRPr lang="en-US" sz="1400" dirty="0"/>
           </a:p>
@@ -10142,7 +10342,7 @@
                   <a:schemeClr val="tx1"/>
                 </a:solidFill>
               </a:rPr>
-              <a:t>156K people KTB turned down in the last 3 months applied to us instead of going to another bank</a:t>
+              <a:t>156K people KTB turned down applied to us; we approved 23K (15%) instead of losing them to other banks</a:t>
             </a:r>
             <a:endParaRPr lang="en-US" sz="1400" dirty="0"/>
           </a:p>
@@ -10150,7 +10350,7 @@
       </p:sp>
       <p:sp>
         <p:nvSpPr>
-          <p:cNvPr id="17" name="Badge 3"/>
+          <p:cNvPr id="25" name="Badge 3"/>
           <p:cNvSpPr/>
           <p:nvPr/>
         </p:nvSpPr>
@@ -10170,7 +10370,7 @@
       </p:sp>
       <p:sp>
         <p:nvSpPr>
-          <p:cNvPr id="18" name="Badge num 3"/>
+          <p:cNvPr id="26" name="Badge num 3"/>
           <p:cNvSpPr txBox="1"/>
           <p:nvPr/>
         </p:nvSpPr>
@@ -10206,7 +10406,7 @@
       </p:sp>
       <p:sp>
         <p:nvSpPr>
-          <p:cNvPr id="19" name="Insight 3"/>
+          <p:cNvPr id="27" name="Insight 3"/>
           <p:cNvSpPr txBox="1"/>
           <p:nvPr/>
         </p:nvSpPr>
@@ -10237,7 +10437,7 @@
                   <a:schemeClr val="tx2"/>
                 </a:solidFill>
               </a:rPr>
-              <a:t>Few loyal KTB users among our best customers</a:t>
+              <a:t>Savings: not known yet</a:t>
             </a:r>
             <a:endParaRPr lang="en-US" sz="1400" dirty="0"/>
           </a:p>
@@ -10254,7 +10454,7 @@
                   <a:schemeClr val="tx1"/>
                 </a:solidFill>
               </a:rPr>
-              <a:t>Only 15% of our most engaged shared customers are loyal to KTB</a:t>
+              <a:t>We cannot see CLICX balances yet. Once we can, compare shared customers' KTB balances before and after joining</a:t>
             </a:r>
             <a:endParaRPr lang="en-US" sz="1400" dirty="0"/>
           </a:p>

</xml_diff>